<commit_message>
Make AI workshop browser-only with GitHub editing and visitor keys
</commit_message>
<xml_diff>
--- a/ai-would-you-rather/slides/Would-You-Rather-Workshop.pptx
+++ b/ai-would-you-rather/slides/Would-You-Rather-Workshop.pptx
@@ -2,18 +2,18 @@
 <file path=ppt/presentation.xml><?xml version="1.0" encoding="utf-8"?>
 <p:presentation xmlns:p="http://schemas.openxmlformats.org/presentationml/2006/main">
   <p:sldMasterIdLst>
-    <p:sldMasterId xmlns:r="http://schemas.openxmlformats.org/officeDocument/2006/relationships" id="2147483648" r:id="Re37893633a9b4bf4"/>
+    <p:sldMasterId xmlns:r="http://schemas.openxmlformats.org/officeDocument/2006/relationships" id="2147483648" r:id="R227f2b1b15084363"/>
   </p:sldMasterIdLst>
   <p:notesMasterIdLst>
-    <p:notesMasterId xmlns:r="http://schemas.openxmlformats.org/officeDocument/2006/relationships" r:id="Rbe711dd56d4f4d96"/>
+    <p:notesMasterId xmlns:r="http://schemas.openxmlformats.org/officeDocument/2006/relationships" r:id="R04eb321dbd5b4e3a"/>
   </p:notesMasterIdLst>
   <p:sldIdLst>
-    <p:sldId xmlns:r="http://schemas.openxmlformats.org/officeDocument/2006/relationships" id="256" r:id="R605c54fb7a3049f0"/>
-    <p:sldId xmlns:r="http://schemas.openxmlformats.org/officeDocument/2006/relationships" id="257" r:id="R7d4cce444acd4303"/>
-    <p:sldId xmlns:r="http://schemas.openxmlformats.org/officeDocument/2006/relationships" id="258" r:id="Ra40cc0272eb84334"/>
-    <p:sldId xmlns:r="http://schemas.openxmlformats.org/officeDocument/2006/relationships" id="259" r:id="Rde8510e025e744da"/>
-    <p:sldId xmlns:r="http://schemas.openxmlformats.org/officeDocument/2006/relationships" id="260" r:id="Rb237104899bf4cd6"/>
-    <p:sldId xmlns:r="http://schemas.openxmlformats.org/officeDocument/2006/relationships" id="261" r:id="R7824bc366aa748d7"/>
+    <p:sldId xmlns:r="http://schemas.openxmlformats.org/officeDocument/2006/relationships" id="256" r:id="R31c45e1f156f4900"/>
+    <p:sldId xmlns:r="http://schemas.openxmlformats.org/officeDocument/2006/relationships" id="257" r:id="Rc7ca75736e96432b"/>
+    <p:sldId xmlns:r="http://schemas.openxmlformats.org/officeDocument/2006/relationships" id="258" r:id="R463590e69267490b"/>
+    <p:sldId xmlns:r="http://schemas.openxmlformats.org/officeDocument/2006/relationships" id="259" r:id="R241c60d8ea7d4fa6"/>
+    <p:sldId xmlns:r="http://schemas.openxmlformats.org/officeDocument/2006/relationships" id="260" r:id="Rf15be88a3309482c"/>
+    <p:sldId xmlns:r="http://schemas.openxmlformats.org/officeDocument/2006/relationships" id="261" r:id="R0caf7c35c4a84f92"/>
   </p:sldIdLst>
   <p:sldSz cx="12192000" cy="6858000"/>
   <p:notesSz cx="6858000" cy="9144000"/>
@@ -447,7 +447,7 @@
           <a:lstStyle xmlns:a="http://schemas.openxmlformats.org/drawingml/2006/main"/>
           <a:p xmlns:a="http://schemas.openxmlformats.org/drawingml/2006/main">
             <a:r>
-              <a:t>Presenter timing: about 2 minutes. Before class, install Node.js 22 or newer, sign into OpenRouter, and download the repository. Show the bot and have the room vote on the two choices. The screenshot is a fixed demo, labeled in the interface. Live mode uses the selected OpenRouter model. Explain: the browser sends a theme to our /api/chat route, the server calls OpenRouter, and the text returns to the browser. This is API integration. Source: https://openrouter.ai/docs/quickstart.</a:t>
+              <a:t>Presenter timing: about 2 minutes. This workshop uses only the browser: GitHub file editing, a static published website, and OpenRouter. Participants sign in to GitHub and OpenRouter in advance. Ideally their static site is already published so build waiting does not consume the activity. Show the fixed demo and have the room vote. The screenshot is a labeled demo, not an AI response. Live mode calls OpenRouter directly from the page using each visitor's own key entered at runtime. We are not sharing an owner key in source code. The full group activity remains approximately 20 minutes after account and hosting preparation. Source: https://openrouter.ai/docs/quickstart.</a:t>
             </a:r>
           </a:p>
         </p:txBody>
@@ -517,7 +517,7 @@
           <a:lstStyle xmlns:a="http://schemas.openxmlformats.org/drawingml/2006/main"/>
           <a:p xmlns:a="http://schemas.openxmlformats.org/drawingml/2006/main">
             <a:r>
-              <a:t>Presenter timing: about 3 minutes. Download the repository using Code &gt; Download ZIP and extract it before the session. Open ai-would-you-rather/project in your editor. At OpenRouter settings/keys, create a key and copy it privately. Copy .env.example to .env, replace paste_your_key_here with the key, and save. Ensure it is not .env.txt. Keep DEMO_MODE=false for real calls. The model is already set to nvidia/nemotron-3-ultra-550b-a55b:free. Never paste a private owner key into browser HTML or commit .env. The .gitignore already excludes it. For offline practice, set DEMO_MODE=true. Sources: https://openrouter.ai/nvidia/nemotron-3-ultra-550b-a55b:free?view=api; https://openrouter.ai/docs/quickstart.</a:t>
+              <a:t>Presenter timing: about 3 minutes if publication is already prepared. Open https://github.com/Casper3211/Static-Page-Demo. Each participant clicks Fork, chooses their own account, keeps the repository name, and clicks Create fork. Existing published copies can skip this. In their own repository, Settings &gt; Pages &gt; Build and deployment &gt; Source: Deploy from a branch. Choose main and /(root), then Save. Wait until Pages reports the site is live and click Visit site. On the homepage click Open the chatbot workshop. A default project URL has the shape https://YOUR-USERNAME.github.io/Static-Page-Demo/ai-would-you-rather/. Use the actual Visit site URL for custom domains or renamed repositories. A source file view on github.com is different from the published page. Participants need their own copy to commit changes. If they already use another static host, keep that existing publishing flow instead. Initial Pages publication can take several minutes; prepare it before the meeting. Source: https://docs.github.com/en/pages/getting-started-with-github-pages/configuring-a-publishing-source-for-your-github-pages-site.</a:t>
             </a:r>
           </a:p>
         </p:txBody>
@@ -587,7 +587,7 @@
           <a:lstStyle xmlns:a="http://schemas.openxmlformats.org/drawingml/2006/main"/>
           <a:p xmlns:a="http://schemas.openxmlformats.org/drawingml/2006/main">
             <a:r>
-              <a:t>Presenter timing: about 4 minutes. In the editor select Terminal &gt; New Terminal and confirm the folder is project. Run node --version to check Node 22 or newer. Run node --env-file=.env server.mjs on one line. No npm install is needed. Open http://127.0.0.1:4320 and check the badge says LIVE MODE. Click the floating button, type a theme and send. In server.mjs show MODEL, SYSTEM_PROMPT, and fetch(ENDPOINT). The endpoint is https://openrouter.ai/api/v1/chat/completions. Authorization: Bearer carries the private key. The messages array includes system instructions and the user theme. The server reads choices[0].message.content and returns {reply}. Stop with Ctrl+C. Source: https://openrouter.ai/docs/quickstart.</a:t>
+              <a:t>Presenter timing: about 3 minutes. In your repository Code tab open ai-would-you-rather, then index.html. Click the pencil icon to edit. If GitHub asks to fork, return to your own fork. Search EDIT 2 in the browser/editor and change the text inside h1 while keeping HTML tags intact. For example Would you rather becomes Pick your weird power. EDIT 1 near the top controls the accent color via --accent. Click Commit changes at the top right, enter a short description, choose Commit directly to the main branch for your own workshop copy, and confirm Commit changes. GitHub stores the edit and the connected static host publishes it. Use the actual publishing status before refreshing the live site. This page also contains BOT CSS, BOT HTML and BOT SCRIPT blocks if students want to copy the entire floating widget into an existing single-file website. Keep all three blocks together. Source: https://docs.github.com/en/repositories/working-with-files/managing-files/editing-files.</a:t>
             </a:r>
           </a:p>
         </p:txBody>
@@ -657,7 +657,7 @@
           <a:lstStyle xmlns:a="http://schemas.openxmlformats.org/drawingml/2006/main"/>
           <a:p xmlns:a="http://schemas.openxmlformats.org/drawingml/2006/main">
             <a:r>
-              <a:t>Presenter timing: about 4 minutes. Work on a copy of an existing single-file website. Copy the complete BOT CSS style block into head. Copy BOT HTML and then BOT SCRIPT before the closing body tag. Save the combined file as project/index.html. Refresh the local server URL and send a theme again. The CSS uses position:fixed, bottom and right for the floating button. The browser sends JSON {message} to /api/chat and displays data.reply as text. The server reads the key from its environment, not from the HTML. Optional full-page layout: /bot. The provided server serves its HTML routes only; multi-file websites require explicit public static-file serving. The current app sends only the latest user message. GitHub Pages is static and needs a separate backend for public live AI. Sources: https://openrouter.ai/docs/quickstart; https://docs.github.com/en/pages/getting-started-with-github-pages/what-is-github-pages.</a:t>
+              <a:t>Presenter timing: about 4 minutes. Open https://openrouter.ai/settings/keys in another tab, sign in, create a key and copy it privately. Return to the published game, open the floating panel, paste into the password field, and click Use my key. Do not paste the key into GitHub's HTML editor. Use my key keeps the value in a JavaScript variable and clears the password field; it does not itself authenticate or spend a request. Send a theme to test the key. The page makes a POST request directly to https://openrouter.ai/api/v1/chat/completions with Authorization: Bearer and JSON model/messages. It reads choices[0].message.content as text. MODEL is nvidia/nemotron-3-ultra-550b-a55b:free. No backend or environment file is involved. Each visitor uses their own quota. The app writes no keys to browser storage. Refresh, page departure, Clear key or Try demo clears the in-memory key. Only paste your own key into code you trust; page scripts can access it while used. Use fictional themes because provider logging applies. Try demo needs no key and produces a labeled fixed question. Sources: https://openrouter.ai/docs/quickstart; https://openrouter.ai/docs/guides/overview/auth/oauth; https://openrouter.ai/nvidia/nemotron-3-ultra-550b-a55b:free?view=api.</a:t>
             </a:r>
           </a:p>
         </p:txBody>
@@ -727,7 +727,7 @@
           <a:lstStyle xmlns:a="http://schemas.openxmlformats.org/drawingml/2006/main"/>
           <a:p xmlns:a="http://schemas.openxmlformats.org/drawingml/2006/main">
             <a:r>
-              <a:t>Presenter timing: about 5 minutes. Pair up: one person edits and the other tests. The default prompt asks for two funny balanced choices labeled A and B, a final question, and under 70 words. Try changing one instruction, such as food-only themes or extremely silly choices. Predict the difference before sending the same theme again. Save, stop with Ctrl+C, and rerun node --env-file=.env server.mjs. HTML label changes need only a refresh. In demo mode the response stays fixed, so test prompt effects in live mode. Keep examples friendly and avoid personal information. Each request is independent. Ask partners whether both options are interesting enough to debate.</a:t>
+              <a:t>Presenter timing: about 5 minutes. In your fork reopen ai-would-you-rather/index.html and click the pencil. Search EDIT 3. Edit the text between the backticks after const INSTRUCTIONS =, keeping both backticks and the semicolon. Choose one change: food-only, extremely silly, or one sentence per choice. The model receives this as the system message. Leave MODEL unchanged to use the selected free endpoint. API_URL is the OpenRouter chat endpoint. The user's theme becomes the user message. Commit the change to main and wait for the host to publish it. Compare the same theme before and after. Prompt edits guide output but do not guarantee it. Demo output stays fixed, so use live mode to evaluate prompt changes. Source: https://openrouter.ai/docs/quickstart.</a:t>
             </a:r>
           </a:p>
         </p:txBody>
@@ -797,7 +797,7 @@
           <a:lstStyle xmlns:a="http://schemas.openxmlformats.org/drawingml/2006/main"/>
           <a:p xmlns:a="http://schemas.openxmlformats.org/drawingml/2006/main">
             <a:r>
-              <a:t>Presenter timing: about 2 minutes. Each pair shows one question and the room votes A or B. Ask which prompt edit made the dilemma more fun. If the request fails, 401 means check the key, 429 means wait or inspect quota, and timeout means retry later or use DEMO_MODE=true and restart. Demo mode is explicitly labeled and does not call AI. No resources slide is needed. Stop the server with Ctrl+C after use. The overall session remains approximately 20 minutes with setup prerequisites complete. Sources for troubleshooting: https://openrouter.ai/docs/api-reference/errors; https://openrouter.ai/docs/api_reference/limits.</a:t>
+              <a:t>Presenter timing: about 3 minutes. Check repository Actions for the Pages build or the existing static host's status, then refresh the published URL. Refresh removes the runtime key, so paste it again and click Use my key. Ask the same theme and compare. One person edits, one tests, and everyone can vote A or B. If the old version appears, confirm the right fork and published path and wait for a successful deployment. 401: key rejected. 429: provider busy or quota exhausted. Slow response: wait or use Try demo. The no-key demo is a fixed example and does not demonstrate prompt changes. The outcome is a published static HTML game editable entirely in GitHub. Sources: https://openrouter.ai/docs/api-reference/errors; https://docs.github.com/en/pages/getting-started-with-github-pages/configuring-a-publishing-source-for-your-github-pages-site.</a:t>
             </a:r>
           </a:p>
         </p:txBody>
@@ -865,7 +865,7 @@
   </p:cSld>
   <p:clrMap bg1="lt1" tx1="dk1" bg2="lt2" tx2="dk2" accent1="accent1" accent2="accent2" accent3="accent3" accent4="accent4" accent5="accent5" accent6="accent6" hlink="hlink" folHlink="folHlink"/>
   <p:sldLayoutIdLst>
-    <p:sldLayoutId xmlns:r="http://schemas.openxmlformats.org/officeDocument/2006/relationships" id="2147483649" r:id="Ra392dd3d624f41bd"/>
+    <p:sldLayoutId xmlns:r="http://schemas.openxmlformats.org/officeDocument/2006/relationships" id="2147483649" r:id="R4b023fa7a0294cf2"/>
   </p:sldLayoutIdLst>
   <p:txStyles>
     <p:titleStyle>
@@ -1580,7 +1580,7 @@
                 <a:ea typeface="Arial"/>
                 <a:cs typeface="Arial"/>
               </a:rPr>
-              <a:t>A small AI game for your website</a:t>
+              <a:t>One HTML file. Edit it on GitHub. Play in your browser.</a:t>
             </a:r>
           </a:p>
         </p:txBody>
@@ -1891,8 +1891,8 @@
         </p:nvSpPr>
         <p:spPr>
           <a:xfrm xmlns:a="http://schemas.openxmlformats.org/drawingml/2006/main">
-            <a:off x="5257800" y="5534025"/>
-            <a:ext cx="6324600" cy="552450"/>
+            <a:off x="5257800" y="5553075"/>
+            <a:ext cx="6324600" cy="542925"/>
           </a:xfrm>
           <a:prstGeom xmlns:a="http://schemas.openxmlformats.org/drawingml/2006/main" prst="rect">
             <a:avLst/>
@@ -1942,13 +1942,13 @@
           <p:nvPr/>
         </p:nvPicPr>
         <p:blipFill>
-          <a:blip xmlns:r="http://schemas.openxmlformats.org/officeDocument/2006/relationships" xmlns:a="http://schemas.openxmlformats.org/drawingml/2006/main" r:embed="R4a8e77505ef04838"/>
+          <a:blip xmlns:r="http://schemas.openxmlformats.org/officeDocument/2006/relationships" xmlns:a="http://schemas.openxmlformats.org/drawingml/2006/main" r:embed="R60e1a01f8e7f464c"/>
           <a:stretch xmlns:a="http://schemas.openxmlformats.org/drawingml/2006/main"/>
         </p:blipFill>
         <p:spPr>
           <a:xfrm xmlns:a="http://schemas.openxmlformats.org/drawingml/2006/main">
-            <a:off x="5991225" y="2381250"/>
-            <a:ext cx="4648200" cy="2905125"/>
+            <a:off x="6249458" y="2381250"/>
+            <a:ext cx="4131733" cy="2905125"/>
           </a:xfrm>
           <a:prstGeom xmlns:a="http://schemas.openxmlformats.org/drawingml/2006/main" prst="rect">
             <a:avLst/>
@@ -2095,7 +2095,7 @@
                 <a:ea typeface="Arial"/>
                 <a:cs typeface="Arial"/>
               </a:rPr>
-              <a:t>1. Your API key</a:t>
+              <a:t>Your GitHub website</a:t>
             </a:r>
           </a:p>
         </p:txBody>
@@ -2153,7 +2153,7 @@
                 <a:ea typeface="Arial"/>
                 <a:cs typeface="Arial"/>
               </a:rPr>
-              <a:t>Open ai-would-you-rather/project in your editor</a:t>
+              <a:t>Already have a published copy? Keep using it.</a:t>
             </a:r>
           </a:p>
         </p:txBody>
@@ -2309,25 +2309,25 @@
           <a:p xmlns:a="http://schemas.openxmlformats.org/drawingml/2006/main">
             <a:pPr algn="l">
               <a:buNone/>
-              <a:defRPr sz="2250" b="1">
-                <a:solidFill>
-                  <a:srgbClr val="142D32"/>
-                </a:solidFill>
-                <a:latin typeface="Arial"/>
-                <a:ea typeface="Arial"/>
-                <a:cs typeface="Arial"/>
-              </a:defRPr>
-            </a:pPr>
-            <a:r>
-              <a:rPr sz="2250" b="1">
-                <a:solidFill>
-                  <a:srgbClr val="142D32"/>
-                </a:solidFill>
-                <a:latin typeface="Arial"/>
-                <a:ea typeface="Arial"/>
-                <a:cs typeface="Arial"/>
-              </a:rPr>
-              <a:t>Create a key</a:t>
+              <a:defRPr sz="2175" b="1">
+                <a:solidFill>
+                  <a:srgbClr val="142D32"/>
+                </a:solidFill>
+                <a:latin typeface="Arial"/>
+                <a:ea typeface="Arial"/>
+                <a:cs typeface="Arial"/>
+              </a:defRPr>
+            </a:pPr>
+            <a:r>
+              <a:rPr sz="2175" b="1">
+                <a:solidFill>
+                  <a:srgbClr val="142D32"/>
+                </a:solidFill>
+                <a:latin typeface="Arial"/>
+                <a:ea typeface="Arial"/>
+                <a:cs typeface="Arial"/>
+              </a:rPr>
+              <a:t>Your own copy</a:t>
             </a:r>
           </a:p>
         </p:txBody>
@@ -2367,7 +2367,7 @@
           <a:p xmlns:a="http://schemas.openxmlformats.org/drawingml/2006/main">
             <a:pPr algn="l">
               <a:buNone/>
-              <a:defRPr sz="2025" b="0">
+              <a:defRPr sz="1875" b="0">
                 <a:solidFill>
                   <a:srgbClr val="53686C"/>
                 </a:solidFill>
@@ -2377,7 +2377,7 @@
               </a:defRPr>
             </a:pPr>
             <a:r>
-              <a:rPr sz="2025" b="0">
+              <a:rPr sz="1875" b="0">
                 <a:solidFill>
                   <a:srgbClr val="53686C"/>
                 </a:solidFill>
@@ -2385,7 +2385,7 @@
                 <a:ea typeface="Arial"/>
                 <a:cs typeface="Arial"/>
               </a:rPr>
-              <a:t>openrouter.ai/settings/keys</a:t>
+              <a:t>Open the demo repository, then Fork.</a:t>
             </a:r>
           </a:p>
         </p:txBody>
@@ -2483,25 +2483,25 @@
           <a:p xmlns:a="http://schemas.openxmlformats.org/drawingml/2006/main">
             <a:pPr algn="l">
               <a:buNone/>
-              <a:defRPr sz="2250" b="1">
-                <a:solidFill>
-                  <a:srgbClr val="142D32"/>
-                </a:solidFill>
-                <a:latin typeface="Arial"/>
-                <a:ea typeface="Arial"/>
-                <a:cs typeface="Arial"/>
-              </a:defRPr>
-            </a:pPr>
-            <a:r>
-              <a:rPr sz="2250" b="1">
-                <a:solidFill>
-                  <a:srgbClr val="142D32"/>
-                </a:solidFill>
-                <a:latin typeface="Arial"/>
-                <a:ea typeface="Arial"/>
-                <a:cs typeface="Arial"/>
-              </a:rPr>
-              <a:t>Copy the file</a:t>
+              <a:defRPr sz="2175" b="1">
+                <a:solidFill>
+                  <a:srgbClr val="142D32"/>
+                </a:solidFill>
+                <a:latin typeface="Arial"/>
+                <a:ea typeface="Arial"/>
+                <a:cs typeface="Arial"/>
+              </a:defRPr>
+            </a:pPr>
+            <a:r>
+              <a:rPr sz="2175" b="1">
+                <a:solidFill>
+                  <a:srgbClr val="142D32"/>
+                </a:solidFill>
+                <a:latin typeface="Arial"/>
+                <a:ea typeface="Arial"/>
+                <a:cs typeface="Arial"/>
+              </a:rPr>
+              <a:t>Pages settings</a:t>
             </a:r>
           </a:p>
         </p:txBody>
@@ -2541,7 +2541,7 @@
           <a:p xmlns:a="http://schemas.openxmlformats.org/drawingml/2006/main">
             <a:pPr algn="l">
               <a:buNone/>
-              <a:defRPr sz="2025" b="0">
+              <a:defRPr sz="1875" b="0">
                 <a:solidFill>
                   <a:srgbClr val="53686C"/>
                 </a:solidFill>
@@ -2551,7 +2551,7 @@
               </a:defRPr>
             </a:pPr>
             <a:r>
-              <a:rPr sz="2025" b="0">
+              <a:rPr sz="1875" b="0">
                 <a:solidFill>
                   <a:srgbClr val="53686C"/>
                 </a:solidFill>
@@ -2559,7 +2559,7 @@
                 <a:ea typeface="Arial"/>
                 <a:cs typeface="Arial"/>
               </a:rPr>
-              <a:t>.env.example becomes .env</a:t>
+              <a:t>Settings &gt; Pages &gt; Deploy from a branch</a:t>
             </a:r>
           </a:p>
         </p:txBody>
@@ -2657,25 +2657,25 @@
           <a:p xmlns:a="http://schemas.openxmlformats.org/drawingml/2006/main">
             <a:pPr algn="l">
               <a:buNone/>
-              <a:defRPr sz="2250" b="1">
-                <a:solidFill>
-                  <a:srgbClr val="142D32"/>
-                </a:solidFill>
-                <a:latin typeface="Arial"/>
-                <a:ea typeface="Arial"/>
-                <a:cs typeface="Arial"/>
-              </a:defRPr>
-            </a:pPr>
-            <a:r>
-              <a:rPr sz="2250" b="1">
-                <a:solidFill>
-                  <a:srgbClr val="142D32"/>
-                </a:solidFill>
-                <a:latin typeface="Arial"/>
-                <a:ea typeface="Arial"/>
-                <a:cs typeface="Arial"/>
-              </a:rPr>
-              <a:t>Add your key</a:t>
+              <a:defRPr sz="2175" b="1">
+                <a:solidFill>
+                  <a:srgbClr val="142D32"/>
+                </a:solidFill>
+                <a:latin typeface="Arial"/>
+                <a:ea typeface="Arial"/>
+                <a:cs typeface="Arial"/>
+              </a:defRPr>
+            </a:pPr>
+            <a:r>
+              <a:rPr sz="2175" b="1">
+                <a:solidFill>
+                  <a:srgbClr val="142D32"/>
+                </a:solidFill>
+                <a:latin typeface="Arial"/>
+                <a:ea typeface="Arial"/>
+                <a:cs typeface="Arial"/>
+              </a:rPr>
+              <a:t>Publish</a:t>
             </a:r>
           </a:p>
         </p:txBody>
@@ -2715,7 +2715,7 @@
           <a:p xmlns:a="http://schemas.openxmlformats.org/drawingml/2006/main">
             <a:pPr algn="l">
               <a:buNone/>
-              <a:defRPr sz="2025" b="0">
+              <a:defRPr sz="1875" b="0">
                 <a:solidFill>
                   <a:srgbClr val="53686C"/>
                 </a:solidFill>
@@ -2725,7 +2725,7 @@
               </a:defRPr>
             </a:pPr>
             <a:r>
-              <a:rPr sz="2025" b="0">
+              <a:rPr sz="1875" b="0">
                 <a:solidFill>
                   <a:srgbClr val="53686C"/>
                 </a:solidFill>
@@ -2733,7 +2733,7 @@
                 <a:ea typeface="Arial"/>
                 <a:cs typeface="Arial"/>
               </a:rPr>
-              <a:t>OPENROUTER_API_KEY=your_key</a:t>
+              <a:t>Choose main and /(root), then Save.</a:t>
             </a:r>
           </a:p>
         </p:txBody>
@@ -2831,25 +2831,25 @@
           <a:p xmlns:a="http://schemas.openxmlformats.org/drawingml/2006/main">
             <a:pPr algn="l">
               <a:buNone/>
-              <a:defRPr sz="2250" b="1">
-                <a:solidFill>
-                  <a:srgbClr val="142D32"/>
-                </a:solidFill>
-                <a:latin typeface="Arial"/>
-                <a:ea typeface="Arial"/>
-                <a:cs typeface="Arial"/>
-              </a:defRPr>
-            </a:pPr>
-            <a:r>
-              <a:rPr sz="2250" b="1">
-                <a:solidFill>
-                  <a:srgbClr val="142D32"/>
-                </a:solidFill>
-                <a:latin typeface="Arial"/>
-                <a:ea typeface="Arial"/>
-                <a:cs typeface="Arial"/>
-              </a:rPr>
-              <a:t>Save</a:t>
+              <a:defRPr sz="2175" b="1">
+                <a:solidFill>
+                  <a:srgbClr val="142D32"/>
+                </a:solidFill>
+                <a:latin typeface="Arial"/>
+                <a:ea typeface="Arial"/>
+                <a:cs typeface="Arial"/>
+              </a:defRPr>
+            </a:pPr>
+            <a:r>
+              <a:rPr sz="2175" b="1">
+                <a:solidFill>
+                  <a:srgbClr val="142D32"/>
+                </a:solidFill>
+                <a:latin typeface="Arial"/>
+                <a:ea typeface="Arial"/>
+                <a:cs typeface="Arial"/>
+              </a:rPr>
+              <a:t>Open the game</a:t>
             </a:r>
           </a:p>
         </p:txBody>
@@ -2889,7 +2889,7 @@
           <a:p xmlns:a="http://schemas.openxmlformats.org/drawingml/2006/main">
             <a:pPr algn="l">
               <a:buNone/>
-              <a:defRPr sz="2025" b="0">
+              <a:defRPr sz="1875" b="0">
                 <a:solidFill>
                   <a:srgbClr val="53686C"/>
                 </a:solidFill>
@@ -2899,7 +2899,7 @@
               </a:defRPr>
             </a:pPr>
             <a:r>
-              <a:rPr sz="2025" b="0">
+              <a:rPr sz="1875" b="0">
                 <a:solidFill>
                   <a:srgbClr val="53686C"/>
                 </a:solidFill>
@@ -2907,7 +2907,7 @@
                 <a:ea typeface="Arial"/>
                 <a:cs typeface="Arial"/>
               </a:rPr>
-              <a:t>.env should say DEMO_MODE=false</a:t>
+              <a:t>Visit site, then click the chatbot workshop.</a:t>
             </a:r>
           </a:p>
         </p:txBody>
@@ -3052,7 +3052,7 @@
                 <a:ea typeface="Arial"/>
                 <a:cs typeface="Arial"/>
               </a:rPr>
-              <a:t>2. Start your bot</a:t>
+              <a:t>Edit one HTML file</a:t>
             </a:r>
           </a:p>
         </p:txBody>
@@ -3110,7 +3110,7 @@
                 <a:ea typeface="Arial"/>
                 <a:cs typeface="Arial"/>
               </a:rPr>
-              <a:t>Open a terminal inside the project folder</a:t>
+              <a:t>Stay on GitHub in your own repository</a:t>
             </a:r>
           </a:p>
         </p:txBody>
@@ -3208,25 +3208,49 @@
           <a:p xmlns:a="http://schemas.openxmlformats.org/drawingml/2006/main">
             <a:pPr algn="l">
               <a:buNone/>
-              <a:defRPr sz="2175" b="1">
-                <a:solidFill>
-                  <a:srgbClr val="142D32"/>
-                </a:solidFill>
-                <a:latin typeface="Arial"/>
-                <a:ea typeface="Arial"/>
-                <a:cs typeface="Arial"/>
-              </a:defRPr>
-            </a:pPr>
-            <a:r>
-              <a:rPr sz="2175" b="1">
-                <a:solidFill>
-                  <a:srgbClr val="142D32"/>
-                </a:solidFill>
-                <a:latin typeface="Arial"/>
-                <a:ea typeface="Arial"/>
-                <a:cs typeface="Arial"/>
-              </a:rPr>
-              <a:t>node --env-file=.env server.mjs</a:t>
+              <a:defRPr sz="2475" b="1">
+                <a:solidFill>
+                  <a:srgbClr val="142D32"/>
+                </a:solidFill>
+                <a:latin typeface="Arial"/>
+                <a:ea typeface="Arial"/>
+                <a:cs typeface="Arial"/>
+              </a:defRPr>
+            </a:pPr>
+            <a:r>
+              <a:rPr sz="2475" b="1">
+                <a:solidFill>
+                  <a:srgbClr val="142D32"/>
+                </a:solidFill>
+                <a:latin typeface="Arial"/>
+                <a:ea typeface="Arial"/>
+                <a:cs typeface="Arial"/>
+              </a:rPr>
+              <a:t>ai-would-you-rather/</a:t>
+            </a:r>
+          </a:p>
+          <a:p xmlns:a="http://schemas.openxmlformats.org/drawingml/2006/main">
+            <a:pPr algn="l">
+              <a:buNone/>
+              <a:defRPr sz="2475" b="1">
+                <a:solidFill>
+                  <a:srgbClr val="142D32"/>
+                </a:solidFill>
+                <a:latin typeface="Arial"/>
+                <a:ea typeface="Arial"/>
+                <a:cs typeface="Arial"/>
+              </a:defRPr>
+            </a:pPr>
+            <a:r>
+              <a:rPr sz="2475" b="1">
+                <a:solidFill>
+                  <a:srgbClr val="142D32"/>
+                </a:solidFill>
+                <a:latin typeface="Arial"/>
+                <a:ea typeface="Arial"/>
+                <a:cs typeface="Arial"/>
+              </a:rPr>
+              <a:t>index.html</a:t>
             </a:r>
           </a:p>
         </p:txBody>
@@ -3266,7 +3290,7 @@
           <a:p xmlns:a="http://schemas.openxmlformats.org/drawingml/2006/main">
             <a:pPr algn="l">
               <a:buNone/>
-              <a:defRPr sz="2025" b="0">
+              <a:defRPr sz="2175" b="0">
                 <a:solidFill>
                   <a:srgbClr val="53686C"/>
                 </a:solidFill>
@@ -3276,7 +3300,7 @@
               </a:defRPr>
             </a:pPr>
             <a:r>
-              <a:rPr sz="2025" b="0">
+              <a:rPr sz="2175" b="0">
                 <a:solidFill>
                   <a:srgbClr val="53686C"/>
                 </a:solidFill>
@@ -3284,7 +3308,31 @@
                 <a:ea typeface="Arial"/>
                 <a:cs typeface="Arial"/>
               </a:rPr>
-              <a:t>Keep the terminal open.</a:t>
+              <a:t>Open the file.</a:t>
+            </a:r>
+          </a:p>
+          <a:p xmlns:a="http://schemas.openxmlformats.org/drawingml/2006/main">
+            <a:pPr algn="l">
+              <a:buNone/>
+              <a:defRPr sz="2175" b="0">
+                <a:solidFill>
+                  <a:srgbClr val="53686C"/>
+                </a:solidFill>
+                <a:latin typeface="Arial"/>
+                <a:ea typeface="Arial"/>
+                <a:cs typeface="Arial"/>
+              </a:defRPr>
+            </a:pPr>
+            <a:r>
+              <a:rPr sz="2175" b="0">
+                <a:solidFill>
+                  <a:srgbClr val="53686C"/>
+                </a:solidFill>
+                <a:latin typeface="Arial"/>
+                <a:ea typeface="Arial"/>
+                <a:cs typeface="Arial"/>
+              </a:rPr>
+              <a:t>Click the pencil icon.</a:t>
             </a:r>
           </a:p>
         </p:txBody>
@@ -3342,7 +3390,7 @@
                 <a:ea typeface="Arial"/>
                 <a:cs typeface="Arial"/>
               </a:rPr>
-              <a:t>THEN OPEN YOUR BROWSER</a:t>
+              <a:t>YOUR FIRST CHANGE</a:t>
             </a:r>
           </a:p>
         </p:txBody>
@@ -3382,97 +3430,73 @@
           <a:p xmlns:a="http://schemas.openxmlformats.org/drawingml/2006/main">
             <a:pPr algn="l">
               <a:buNone/>
-              <a:defRPr sz="2100" b="0">
-                <a:solidFill>
-                  <a:srgbClr val="142D32"/>
-                </a:solidFill>
-                <a:latin typeface="Arial"/>
-                <a:ea typeface="Arial"/>
-                <a:cs typeface="Arial"/>
-              </a:defRPr>
-            </a:pPr>
-            <a:r>
-              <a:rPr sz="2100" b="0">
-                <a:solidFill>
-                  <a:srgbClr val="142D32"/>
-                </a:solidFill>
-                <a:latin typeface="Arial"/>
-                <a:ea typeface="Arial"/>
-                <a:cs typeface="Arial"/>
-              </a:rPr>
-              <a:t>http://127.0.0.1:4320</a:t>
-            </a:r>
-          </a:p>
-          <a:p xmlns:a="http://schemas.openxmlformats.org/drawingml/2006/main">
-            <a:pPr algn="l">
-              <a:buNone/>
-              <a:defRPr sz="2325" b="0">
-                <a:solidFill>
-                  <a:srgbClr val="142D32"/>
-                </a:solidFill>
-                <a:latin typeface="Arial"/>
-                <a:ea typeface="Arial"/>
-                <a:cs typeface="Arial"/>
-              </a:defRPr>
-            </a:pPr>
-            <a:r>
-              <a:rPr sz="2325" b="0">
-                <a:solidFill>
-                  <a:srgbClr val="142D32"/>
-                </a:solidFill>
-                <a:latin typeface="Arial"/>
-                <a:ea typeface="Arial"/>
-                <a:cs typeface="Arial"/>
-              </a:rPr>
-              <a:t/>
-            </a:r>
-          </a:p>
-          <a:p xmlns:a="http://schemas.openxmlformats.org/drawingml/2006/main">
-            <a:pPr algn="l">
-              <a:buNone/>
-              <a:defRPr sz="2100" b="0">
-                <a:solidFill>
-                  <a:srgbClr val="142D32"/>
-                </a:solidFill>
-                <a:latin typeface="Arial"/>
-                <a:ea typeface="Arial"/>
-                <a:cs typeface="Arial"/>
-              </a:defRPr>
-            </a:pPr>
-            <a:r>
-              <a:rPr sz="2100" b="0">
-                <a:solidFill>
-                  <a:srgbClr val="142D32"/>
-                </a:solidFill>
-                <a:latin typeface="Arial"/>
-                <a:ea typeface="Arial"/>
-                <a:cs typeface="Arial"/>
-              </a:rPr>
-              <a:t>Click “Give me a dilemma”</a:t>
-            </a:r>
-          </a:p>
-          <a:p xmlns:a="http://schemas.openxmlformats.org/drawingml/2006/main">
-            <a:pPr algn="l">
-              <a:buNone/>
-              <a:defRPr sz="2100" b="0">
-                <a:solidFill>
-                  <a:srgbClr val="142D32"/>
-                </a:solidFill>
-                <a:latin typeface="Arial"/>
-                <a:ea typeface="Arial"/>
-                <a:cs typeface="Arial"/>
-              </a:defRPr>
-            </a:pPr>
-            <a:r>
-              <a:rPr sz="2100" b="0">
-                <a:solidFill>
-                  <a:srgbClr val="142D32"/>
-                </a:solidFill>
-                <a:latin typeface="Arial"/>
-                <a:ea typeface="Arial"/>
-                <a:cs typeface="Arial"/>
-              </a:rPr>
-              <a:t>and send a theme.</a:t>
+              <a:defRPr sz="2175" b="0">
+                <a:solidFill>
+                  <a:srgbClr val="142D32"/>
+                </a:solidFill>
+                <a:latin typeface="Arial"/>
+                <a:ea typeface="Arial"/>
+                <a:cs typeface="Arial"/>
+              </a:defRPr>
+            </a:pPr>
+            <a:r>
+              <a:rPr sz="2175" b="0">
+                <a:solidFill>
+                  <a:srgbClr val="142D32"/>
+                </a:solidFill>
+                <a:latin typeface="Arial"/>
+                <a:ea typeface="Arial"/>
+                <a:cs typeface="Arial"/>
+              </a:rPr>
+              <a:t>Find EDIT 2.</a:t>
+            </a:r>
+          </a:p>
+          <a:p xmlns:a="http://schemas.openxmlformats.org/drawingml/2006/main">
+            <a:pPr algn="l">
+              <a:buNone/>
+              <a:defRPr sz="2175" b="0">
+                <a:solidFill>
+                  <a:srgbClr val="142D32"/>
+                </a:solidFill>
+                <a:latin typeface="Arial"/>
+                <a:ea typeface="Arial"/>
+                <a:cs typeface="Arial"/>
+              </a:defRPr>
+            </a:pPr>
+            <a:r>
+              <a:rPr sz="2175" b="0">
+                <a:solidFill>
+                  <a:srgbClr val="142D32"/>
+                </a:solidFill>
+                <a:latin typeface="Arial"/>
+                <a:ea typeface="Arial"/>
+                <a:cs typeface="Arial"/>
+              </a:rPr>
+              <a:t>Change the page title.</a:t>
+            </a:r>
+          </a:p>
+          <a:p xmlns:a="http://schemas.openxmlformats.org/drawingml/2006/main">
+            <a:pPr algn="l">
+              <a:buNone/>
+              <a:defRPr sz="2175" b="0">
+                <a:solidFill>
+                  <a:srgbClr val="142D32"/>
+                </a:solidFill>
+                <a:latin typeface="Arial"/>
+                <a:ea typeface="Arial"/>
+                <a:cs typeface="Arial"/>
+              </a:defRPr>
+            </a:pPr>
+            <a:r>
+              <a:rPr sz="2175" b="0">
+                <a:solidFill>
+                  <a:srgbClr val="142D32"/>
+                </a:solidFill>
+                <a:latin typeface="Arial"/>
+                <a:ea typeface="Arial"/>
+                <a:cs typeface="Arial"/>
+              </a:rPr>
+              <a:t>Click Commit changes.</a:t>
             </a:r>
           </a:p>
         </p:txBody>
@@ -3512,7 +3536,7 @@
           <a:p xmlns:a="http://schemas.openxmlformats.org/drawingml/2006/main">
             <a:pPr algn="l">
               <a:buNone/>
-              <a:defRPr sz="1950" b="1">
+              <a:defRPr sz="1800" b="1">
                 <a:solidFill>
                   <a:srgbClr val="087E80"/>
                 </a:solidFill>
@@ -3522,7 +3546,7 @@
               </a:defRPr>
             </a:pPr>
             <a:r>
-              <a:rPr sz="1950" b="1">
+              <a:rPr sz="1800" b="1">
                 <a:solidFill>
                   <a:srgbClr val="087E80"/>
                 </a:solidFill>
@@ -3530,7 +3554,7 @@
                 <a:ea typeface="Arial"/>
                 <a:cs typeface="Arial"/>
               </a:rPr>
-              <a:t>Your first AI reply</a:t>
+              <a:t>You can change EDIT 1’s color too.</a:t>
             </a:r>
           </a:p>
         </p:txBody>
@@ -3566,10 +3590,10 @@
       </p:grpSpPr>
       <p:sp>
         <p:nvSpPr>
-          <p:cNvPr id="14" name="club">
-            <a:extLst xmlns:a="http://schemas.openxmlformats.org/drawingml/2006/main">
-              <a:ext uri="{FF2B5EF4-FFF2-40B4-BE49-F238E27FC236}">
-                <a16:creationId xmlns:a16="http://schemas.microsoft.com/office/drawing/2014/main" id="{B4EC50DC-7F40-4DF0-AD4C-53A03D406637}"/>
+          <p:cNvPr id="21" name="club">
+            <a:extLst xmlns:a="http://schemas.openxmlformats.org/drawingml/2006/main">
+              <a:ext uri="{FF2B5EF4-FFF2-40B4-BE49-F238E27FC236}">
+                <a16:creationId xmlns:a16="http://schemas.microsoft.com/office/drawing/2014/main" id="{366D60CB-0E69-4059-85C5-9B5236F59499}"/>
               </a:ext>
             </a:extLst>
           </p:cNvPr>
@@ -3627,7 +3651,7 @@
           <p:cNvPr id="3" name="title">
             <a:extLst xmlns:a="http://schemas.openxmlformats.org/drawingml/2006/main">
               <a:ext uri="{FF2B5EF4-FFF2-40B4-BE49-F238E27FC236}">
-                <a16:creationId xmlns:a16="http://schemas.microsoft.com/office/drawing/2014/main" id="{03E4BAF3-4E46-4487-B205-3D0C06A0154E}"/>
+                <a16:creationId xmlns:a16="http://schemas.microsoft.com/office/drawing/2014/main" id="{EF48F320-DD91-4BBA-B862-5084F2F45ADE}"/>
               </a:ext>
             </a:extLst>
           </p:cNvPr>
@@ -3675,7 +3699,7 @@
                 <a:ea typeface="Arial"/>
                 <a:cs typeface="Arial"/>
               </a:rPr>
-              <a:t>3. Add it to your website</a:t>
+              <a:t>Connect your OpenRouter key</a:t>
             </a:r>
           </a:p>
         </p:txBody>
@@ -3685,7 +3709,7 @@
           <p:cNvPr id="4" name="subheader">
             <a:extLst xmlns:a="http://schemas.openxmlformats.org/drawingml/2006/main">
               <a:ext uri="{FF2B5EF4-FFF2-40B4-BE49-F238E27FC236}">
-                <a16:creationId xmlns:a16="http://schemas.microsoft.com/office/drawing/2014/main" id="{B4878439-B101-4B99-B8D0-0D10A6A52F83}"/>
+                <a16:creationId xmlns:a16="http://schemas.microsoft.com/office/drawing/2014/main" id="{5D6446FB-4749-41AC-9A7B-5675002E5DC1}"/>
               </a:ext>
             </a:extLst>
           </p:cNvPr>
@@ -3733,7 +3757,7 @@
                 <a:ea typeface="Arial"/>
                 <a:cs typeface="Arial"/>
               </a:rPr>
-              <a:t>Copy the three marked blocks from index.html</a:t>
+              <a:t>Paste the key into the live game page</a:t>
             </a:r>
           </a:p>
         </p:txBody>
@@ -3743,7 +3767,7 @@
           <p:cNvPr id="8" name="footer-page">
             <a:extLst xmlns:a="http://schemas.openxmlformats.org/drawingml/2006/main">
               <a:ext uri="{FF2B5EF4-FFF2-40B4-BE49-F238E27FC236}">
-                <a16:creationId xmlns:a16="http://schemas.microsoft.com/office/drawing/2014/main" id="{008E3D44-4B38-4AF9-A814-FF598E0F2736}"/>
+                <a16:creationId xmlns:a16="http://schemas.microsoft.com/office/drawing/2014/main" id="{C8408FA6-E463-4CDD-B6F5-5DA963C5DA59}"/>
               </a:ext>
             </a:extLst>
           </p:cNvPr>
@@ -3798,22 +3822,80 @@
       </p:sp>
       <p:sp>
         <p:nvSpPr>
-          <p:cNvPr id="9" name="lead">
-            <a:extLst xmlns:a="http://schemas.openxmlformats.org/drawingml/2006/main">
-              <a:ext uri="{FF2B5EF4-FFF2-40B4-BE49-F238E27FC236}">
-                <a16:creationId xmlns:a16="http://schemas.microsoft.com/office/drawing/2014/main" id="{D12E5938-7A26-47FE-BAA6-BA78A948BC97}"/>
-              </a:ext>
-            </a:extLst>
-          </p:cNvPr>
-          <p:cNvSpPr>
-            <a:spLocks xmlns:a="http://schemas.openxmlformats.org/drawingml/2006/main" noGrp="1"/>
-          </p:cNvSpPr>
-          <p:nvPr/>
-        </p:nvSpPr>
-        <p:spPr>
-          <a:xfrm xmlns:a="http://schemas.openxmlformats.org/drawingml/2006/main">
-            <a:off x="609600" y="2781300"/>
-            <a:ext cx="5715000" cy="1809750"/>
+          <p:cNvPr id="9" name="number-0">
+            <a:extLst xmlns:a="http://schemas.openxmlformats.org/drawingml/2006/main">
+              <a:ext uri="{FF2B5EF4-FFF2-40B4-BE49-F238E27FC236}">
+                <a16:creationId xmlns:a16="http://schemas.microsoft.com/office/drawing/2014/main" id="{51BDE694-C556-45C9-8B16-C8598B27536B}"/>
+              </a:ext>
+            </a:extLst>
+          </p:cNvPr>
+          <p:cNvSpPr>
+            <a:spLocks xmlns:a="http://schemas.openxmlformats.org/drawingml/2006/main" noGrp="1"/>
+          </p:cNvSpPr>
+          <p:nvPr/>
+        </p:nvSpPr>
+        <p:spPr>
+          <a:xfrm xmlns:a="http://schemas.openxmlformats.org/drawingml/2006/main">
+            <a:off x="609600" y="2762250"/>
+            <a:ext cx="800100" cy="438150"/>
+          </a:xfrm>
+          <a:prstGeom xmlns:a="http://schemas.openxmlformats.org/drawingml/2006/main" prst="rect">
+            <a:avLst/>
+          </a:prstGeom>
+          <a:noFill xmlns:a="http://schemas.openxmlformats.org/drawingml/2006/main"/>
+          <a:ln xmlns:a="http://schemas.openxmlformats.org/drawingml/2006/main" w="0">
+            <a:noFill/>
+          </a:ln>
+        </p:spPr>
+        <p:txBody>
+          <a:bodyPr xmlns:a="http://schemas.openxmlformats.org/drawingml/2006/main" wrap="none" lIns="0" tIns="0" rIns="0" bIns="0" anchor="t">
+            <a:noAutofit/>
+          </a:bodyPr>
+          <a:lstStyle xmlns:a="http://schemas.openxmlformats.org/drawingml/2006/main"/>
+          <a:p xmlns:a="http://schemas.openxmlformats.org/drawingml/2006/main">
+            <a:pPr algn="l">
+              <a:buNone/>
+              <a:defRPr sz="2400" b="1">
+                <a:solidFill>
+                  <a:srgbClr val="087E80"/>
+                </a:solidFill>
+                <a:latin typeface="Arial"/>
+                <a:ea typeface="Arial"/>
+                <a:cs typeface="Arial"/>
+              </a:defRPr>
+            </a:pPr>
+            <a:r>
+              <a:rPr sz="2400" b="1">
+                <a:solidFill>
+                  <a:srgbClr val="087E80"/>
+                </a:solidFill>
+                <a:latin typeface="Arial"/>
+                <a:ea typeface="Arial"/>
+                <a:cs typeface="Arial"/>
+              </a:rPr>
+              <a:t>01</a:t>
+            </a:r>
+          </a:p>
+        </p:txBody>
+      </p:sp>
+      <p:sp>
+        <p:nvSpPr>
+          <p:cNvPr id="10" name="label-0">
+            <a:extLst xmlns:a="http://schemas.openxmlformats.org/drawingml/2006/main">
+              <a:ext uri="{FF2B5EF4-FFF2-40B4-BE49-F238E27FC236}">
+                <a16:creationId xmlns:a16="http://schemas.microsoft.com/office/drawing/2014/main" id="{E901CE81-5B34-4D37-86AA-33C33C0D7159}"/>
+              </a:ext>
+            </a:extLst>
+          </p:cNvPr>
+          <p:cNvSpPr>
+            <a:spLocks xmlns:a="http://schemas.openxmlformats.org/drawingml/2006/main" noGrp="1"/>
+          </p:cNvSpPr>
+          <p:nvPr/>
+        </p:nvSpPr>
+        <p:spPr>
+          <a:xfrm xmlns:a="http://schemas.openxmlformats.org/drawingml/2006/main">
+            <a:off x="1638300" y="2762250"/>
+            <a:ext cx="2476500" cy="438150"/>
           </a:xfrm>
           <a:prstGeom xmlns:a="http://schemas.openxmlformats.org/drawingml/2006/main" prst="rect">
             <a:avLst/>
@@ -3849,33 +3931,159 @@
                 <a:ea typeface="Arial"/>
                 <a:cs typeface="Arial"/>
               </a:rPr>
-              <a:t>BOT CSS into &lt;head&gt;</a:t>
-            </a:r>
-          </a:p>
-          <a:p xmlns:a="http://schemas.openxmlformats.org/drawingml/2006/main">
-            <a:pPr algn="l">
-              <a:buNone/>
-              <a:defRPr sz="3225" b="1">
-                <a:solidFill>
-                  <a:srgbClr val="142D32"/>
-                </a:solidFill>
-                <a:latin typeface="Arial"/>
-                <a:ea typeface="Arial"/>
-                <a:cs typeface="Arial"/>
-              </a:defRPr>
-            </a:pPr>
-            <a:r>
-              <a:rPr sz="3225" b="1">
-                <a:solidFill>
-                  <a:srgbClr val="142D32"/>
-                </a:solidFill>
-                <a:latin typeface="Arial"/>
-                <a:ea typeface="Arial"/>
-                <a:cs typeface="Arial"/>
-              </a:rPr>
-              <a:t/>
-            </a:r>
-          </a:p>
+              <a:t>Create a key</a:t>
+            </a:r>
+          </a:p>
+        </p:txBody>
+      </p:sp>
+      <p:sp>
+        <p:nvSpPr>
+          <p:cNvPr id="11" name="detail-0">
+            <a:extLst xmlns:a="http://schemas.openxmlformats.org/drawingml/2006/main">
+              <a:ext uri="{FF2B5EF4-FFF2-40B4-BE49-F238E27FC236}">
+                <a16:creationId xmlns:a16="http://schemas.microsoft.com/office/drawing/2014/main" id="{BD0ED1E0-713C-4C6D-929D-E0FBED8AF2E8}"/>
+              </a:ext>
+            </a:extLst>
+          </p:cNvPr>
+          <p:cNvSpPr>
+            <a:spLocks xmlns:a="http://schemas.openxmlformats.org/drawingml/2006/main" noGrp="1"/>
+          </p:cNvSpPr>
+          <p:nvPr/>
+        </p:nvSpPr>
+        <p:spPr>
+          <a:xfrm xmlns:a="http://schemas.openxmlformats.org/drawingml/2006/main">
+            <a:off x="4476750" y="2790825"/>
+            <a:ext cx="7067550" cy="409575"/>
+          </a:xfrm>
+          <a:prstGeom xmlns:a="http://schemas.openxmlformats.org/drawingml/2006/main" prst="rect">
+            <a:avLst/>
+          </a:prstGeom>
+          <a:noFill xmlns:a="http://schemas.openxmlformats.org/drawingml/2006/main"/>
+          <a:ln xmlns:a="http://schemas.openxmlformats.org/drawingml/2006/main" w="0">
+            <a:noFill/>
+          </a:ln>
+        </p:spPr>
+        <p:txBody>
+          <a:bodyPr xmlns:a="http://schemas.openxmlformats.org/drawingml/2006/main" wrap="none" lIns="0" tIns="0" rIns="0" bIns="0" anchor="t">
+            <a:noAutofit/>
+          </a:bodyPr>
+          <a:lstStyle xmlns:a="http://schemas.openxmlformats.org/drawingml/2006/main"/>
+          <a:p xmlns:a="http://schemas.openxmlformats.org/drawingml/2006/main">
+            <a:pPr algn="l">
+              <a:buNone/>
+              <a:defRPr sz="1875" b="0">
+                <a:solidFill>
+                  <a:srgbClr val="53686C"/>
+                </a:solidFill>
+                <a:latin typeface="Arial"/>
+                <a:ea typeface="Arial"/>
+                <a:cs typeface="Arial"/>
+              </a:defRPr>
+            </a:pPr>
+            <a:r>
+              <a:rPr sz="1875" b="0">
+                <a:solidFill>
+                  <a:srgbClr val="53686C"/>
+                </a:solidFill>
+                <a:latin typeface="Arial"/>
+                <a:ea typeface="Arial"/>
+                <a:cs typeface="Arial"/>
+              </a:rPr>
+              <a:t>openrouter.ai/settings/keys &gt; Create Key</a:t>
+            </a:r>
+          </a:p>
+        </p:txBody>
+      </p:sp>
+      <p:sp>
+        <p:nvSpPr>
+          <p:cNvPr id="12" name="number-1">
+            <a:extLst xmlns:a="http://schemas.openxmlformats.org/drawingml/2006/main">
+              <a:ext uri="{FF2B5EF4-FFF2-40B4-BE49-F238E27FC236}">
+                <a16:creationId xmlns:a16="http://schemas.microsoft.com/office/drawing/2014/main" id="{AD5A7334-AE57-4202-9AFA-95A3587926EB}"/>
+              </a:ext>
+            </a:extLst>
+          </p:cNvPr>
+          <p:cNvSpPr>
+            <a:spLocks xmlns:a="http://schemas.openxmlformats.org/drawingml/2006/main" noGrp="1"/>
+          </p:cNvSpPr>
+          <p:nvPr/>
+        </p:nvSpPr>
+        <p:spPr>
+          <a:xfrm xmlns:a="http://schemas.openxmlformats.org/drawingml/2006/main">
+            <a:off x="609600" y="3476625"/>
+            <a:ext cx="800100" cy="438150"/>
+          </a:xfrm>
+          <a:prstGeom xmlns:a="http://schemas.openxmlformats.org/drawingml/2006/main" prst="rect">
+            <a:avLst/>
+          </a:prstGeom>
+          <a:noFill xmlns:a="http://schemas.openxmlformats.org/drawingml/2006/main"/>
+          <a:ln xmlns:a="http://schemas.openxmlformats.org/drawingml/2006/main" w="0">
+            <a:noFill/>
+          </a:ln>
+        </p:spPr>
+        <p:txBody>
+          <a:bodyPr xmlns:a="http://schemas.openxmlformats.org/drawingml/2006/main" wrap="none" lIns="0" tIns="0" rIns="0" bIns="0" anchor="t">
+            <a:noAutofit/>
+          </a:bodyPr>
+          <a:lstStyle xmlns:a="http://schemas.openxmlformats.org/drawingml/2006/main"/>
+          <a:p xmlns:a="http://schemas.openxmlformats.org/drawingml/2006/main">
+            <a:pPr algn="l">
+              <a:buNone/>
+              <a:defRPr sz="2400" b="1">
+                <a:solidFill>
+                  <a:srgbClr val="087E80"/>
+                </a:solidFill>
+                <a:latin typeface="Arial"/>
+                <a:ea typeface="Arial"/>
+                <a:cs typeface="Arial"/>
+              </a:defRPr>
+            </a:pPr>
+            <a:r>
+              <a:rPr sz="2400" b="1">
+                <a:solidFill>
+                  <a:srgbClr val="087E80"/>
+                </a:solidFill>
+                <a:latin typeface="Arial"/>
+                <a:ea typeface="Arial"/>
+                <a:cs typeface="Arial"/>
+              </a:rPr>
+              <a:t>02</a:t>
+            </a:r>
+          </a:p>
+        </p:txBody>
+      </p:sp>
+      <p:sp>
+        <p:nvSpPr>
+          <p:cNvPr id="13" name="label-1">
+            <a:extLst xmlns:a="http://schemas.openxmlformats.org/drawingml/2006/main">
+              <a:ext uri="{FF2B5EF4-FFF2-40B4-BE49-F238E27FC236}">
+                <a16:creationId xmlns:a16="http://schemas.microsoft.com/office/drawing/2014/main" id="{103D2AB4-FD59-4411-8C36-0103588CA6F2}"/>
+              </a:ext>
+            </a:extLst>
+          </p:cNvPr>
+          <p:cNvSpPr>
+            <a:spLocks xmlns:a="http://schemas.openxmlformats.org/drawingml/2006/main" noGrp="1"/>
+          </p:cNvSpPr>
+          <p:nvPr/>
+        </p:nvSpPr>
+        <p:spPr>
+          <a:xfrm xmlns:a="http://schemas.openxmlformats.org/drawingml/2006/main">
+            <a:off x="1638300" y="3476625"/>
+            <a:ext cx="2476500" cy="438150"/>
+          </a:xfrm>
+          <a:prstGeom xmlns:a="http://schemas.openxmlformats.org/drawingml/2006/main" prst="rect">
+            <a:avLst/>
+          </a:prstGeom>
+          <a:noFill xmlns:a="http://schemas.openxmlformats.org/drawingml/2006/main"/>
+          <a:ln xmlns:a="http://schemas.openxmlformats.org/drawingml/2006/main" w="0">
+            <a:noFill/>
+          </a:ln>
+        </p:spPr>
+        <p:txBody>
+          <a:bodyPr xmlns:a="http://schemas.openxmlformats.org/drawingml/2006/main" wrap="none" lIns="0" tIns="0" rIns="0" bIns="0" anchor="t">
+            <a:noAutofit/>
+          </a:bodyPr>
+          <a:lstStyle xmlns:a="http://schemas.openxmlformats.org/drawingml/2006/main"/>
           <a:p xmlns:a="http://schemas.openxmlformats.org/drawingml/2006/main">
             <a:pPr algn="l">
               <a:buNone/>
@@ -3897,9 +4105,159 @@
                 <a:ea typeface="Arial"/>
                 <a:cs typeface="Arial"/>
               </a:rPr>
-              <a:t>BOT HTML + BOT SCRIPT</a:t>
-            </a:r>
-          </a:p>
+              <a:t>Open the bot</a:t>
+            </a:r>
+          </a:p>
+        </p:txBody>
+      </p:sp>
+      <p:sp>
+        <p:nvSpPr>
+          <p:cNvPr id="14" name="detail-1">
+            <a:extLst xmlns:a="http://schemas.openxmlformats.org/drawingml/2006/main">
+              <a:ext uri="{FF2B5EF4-FFF2-40B4-BE49-F238E27FC236}">
+                <a16:creationId xmlns:a16="http://schemas.microsoft.com/office/drawing/2014/main" id="{A5914C25-27E7-47D8-9ACC-EFCE8E16BC3D}"/>
+              </a:ext>
+            </a:extLst>
+          </p:cNvPr>
+          <p:cNvSpPr>
+            <a:spLocks xmlns:a="http://schemas.openxmlformats.org/drawingml/2006/main" noGrp="1"/>
+          </p:cNvSpPr>
+          <p:nvPr/>
+        </p:nvSpPr>
+        <p:spPr>
+          <a:xfrm xmlns:a="http://schemas.openxmlformats.org/drawingml/2006/main">
+            <a:off x="4476750" y="3505200"/>
+            <a:ext cx="7067550" cy="409575"/>
+          </a:xfrm>
+          <a:prstGeom xmlns:a="http://schemas.openxmlformats.org/drawingml/2006/main" prst="rect">
+            <a:avLst/>
+          </a:prstGeom>
+          <a:noFill xmlns:a="http://schemas.openxmlformats.org/drawingml/2006/main"/>
+          <a:ln xmlns:a="http://schemas.openxmlformats.org/drawingml/2006/main" w="0">
+            <a:noFill/>
+          </a:ln>
+        </p:spPr>
+        <p:txBody>
+          <a:bodyPr xmlns:a="http://schemas.openxmlformats.org/drawingml/2006/main" wrap="none" lIns="0" tIns="0" rIns="0" bIns="0" anchor="t">
+            <a:noAutofit/>
+          </a:bodyPr>
+          <a:lstStyle xmlns:a="http://schemas.openxmlformats.org/drawingml/2006/main"/>
+          <a:p xmlns:a="http://schemas.openxmlformats.org/drawingml/2006/main">
+            <a:pPr algn="l">
+              <a:buNone/>
+              <a:defRPr sz="1875" b="0">
+                <a:solidFill>
+                  <a:srgbClr val="53686C"/>
+                </a:solidFill>
+                <a:latin typeface="Arial"/>
+                <a:ea typeface="Arial"/>
+                <a:cs typeface="Arial"/>
+              </a:defRPr>
+            </a:pPr>
+            <a:r>
+              <a:rPr sz="1875" b="0">
+                <a:solidFill>
+                  <a:srgbClr val="53686C"/>
+                </a:solidFill>
+                <a:latin typeface="Arial"/>
+                <a:ea typeface="Arial"/>
+                <a:cs typeface="Arial"/>
+              </a:rPr>
+              <a:t>Click “Give me a dilemma” on your site.</a:t>
+            </a:r>
+          </a:p>
+        </p:txBody>
+      </p:sp>
+      <p:sp>
+        <p:nvSpPr>
+          <p:cNvPr id="15" name="number-2">
+            <a:extLst xmlns:a="http://schemas.openxmlformats.org/drawingml/2006/main">
+              <a:ext uri="{FF2B5EF4-FFF2-40B4-BE49-F238E27FC236}">
+                <a16:creationId xmlns:a16="http://schemas.microsoft.com/office/drawing/2014/main" id="{48C15E34-16CE-4F28-B10B-104872F8D180}"/>
+              </a:ext>
+            </a:extLst>
+          </p:cNvPr>
+          <p:cNvSpPr>
+            <a:spLocks xmlns:a="http://schemas.openxmlformats.org/drawingml/2006/main" noGrp="1"/>
+          </p:cNvSpPr>
+          <p:nvPr/>
+        </p:nvSpPr>
+        <p:spPr>
+          <a:xfrm xmlns:a="http://schemas.openxmlformats.org/drawingml/2006/main">
+            <a:off x="609600" y="4191000"/>
+            <a:ext cx="800100" cy="438150"/>
+          </a:xfrm>
+          <a:prstGeom xmlns:a="http://schemas.openxmlformats.org/drawingml/2006/main" prst="rect">
+            <a:avLst/>
+          </a:prstGeom>
+          <a:noFill xmlns:a="http://schemas.openxmlformats.org/drawingml/2006/main"/>
+          <a:ln xmlns:a="http://schemas.openxmlformats.org/drawingml/2006/main" w="0">
+            <a:noFill/>
+          </a:ln>
+        </p:spPr>
+        <p:txBody>
+          <a:bodyPr xmlns:a="http://schemas.openxmlformats.org/drawingml/2006/main" wrap="none" lIns="0" tIns="0" rIns="0" bIns="0" anchor="t">
+            <a:noAutofit/>
+          </a:bodyPr>
+          <a:lstStyle xmlns:a="http://schemas.openxmlformats.org/drawingml/2006/main"/>
+          <a:p xmlns:a="http://schemas.openxmlformats.org/drawingml/2006/main">
+            <a:pPr algn="l">
+              <a:buNone/>
+              <a:defRPr sz="2400" b="1">
+                <a:solidFill>
+                  <a:srgbClr val="087E80"/>
+                </a:solidFill>
+                <a:latin typeface="Arial"/>
+                <a:ea typeface="Arial"/>
+                <a:cs typeface="Arial"/>
+              </a:defRPr>
+            </a:pPr>
+            <a:r>
+              <a:rPr sz="2400" b="1">
+                <a:solidFill>
+                  <a:srgbClr val="087E80"/>
+                </a:solidFill>
+                <a:latin typeface="Arial"/>
+                <a:ea typeface="Arial"/>
+                <a:cs typeface="Arial"/>
+              </a:rPr>
+              <a:t>03</a:t>
+            </a:r>
+          </a:p>
+        </p:txBody>
+      </p:sp>
+      <p:sp>
+        <p:nvSpPr>
+          <p:cNvPr id="16" name="label-2">
+            <a:extLst xmlns:a="http://schemas.openxmlformats.org/drawingml/2006/main">
+              <a:ext uri="{FF2B5EF4-FFF2-40B4-BE49-F238E27FC236}">
+                <a16:creationId xmlns:a16="http://schemas.microsoft.com/office/drawing/2014/main" id="{2D9E683A-398A-4AB2-AA79-A9276DCE23D4}"/>
+              </a:ext>
+            </a:extLst>
+          </p:cNvPr>
+          <p:cNvSpPr>
+            <a:spLocks xmlns:a="http://schemas.openxmlformats.org/drawingml/2006/main" noGrp="1"/>
+          </p:cNvSpPr>
+          <p:nvPr/>
+        </p:nvSpPr>
+        <p:spPr>
+          <a:xfrm xmlns:a="http://schemas.openxmlformats.org/drawingml/2006/main">
+            <a:off x="1638300" y="4191000"/>
+            <a:ext cx="2476500" cy="438150"/>
+          </a:xfrm>
+          <a:prstGeom xmlns:a="http://schemas.openxmlformats.org/drawingml/2006/main" prst="rect">
+            <a:avLst/>
+          </a:prstGeom>
+          <a:noFill xmlns:a="http://schemas.openxmlformats.org/drawingml/2006/main"/>
+          <a:ln xmlns:a="http://schemas.openxmlformats.org/drawingml/2006/main" w="0">
+            <a:noFill/>
+          </a:ln>
+        </p:spPr>
+        <p:txBody>
+          <a:bodyPr xmlns:a="http://schemas.openxmlformats.org/drawingml/2006/main" wrap="none" lIns="0" tIns="0" rIns="0" bIns="0" anchor="t">
+            <a:noAutofit/>
+          </a:bodyPr>
+          <a:lstStyle xmlns:a="http://schemas.openxmlformats.org/drawingml/2006/main"/>
           <a:p xmlns:a="http://schemas.openxmlformats.org/drawingml/2006/main">
             <a:pPr algn="l">
               <a:buNone/>
@@ -3921,47 +4279,47 @@
                 <a:ea typeface="Arial"/>
                 <a:cs typeface="Arial"/>
               </a:rPr>
-              <a:t>before &lt;/body&gt;</a:t>
-            </a:r>
-          </a:p>
-        </p:txBody>
-      </p:sp>
-      <p:sp>
-        <p:nvSpPr>
-          <p:cNvPr id="10" name="lead-detail">
-            <a:extLst xmlns:a="http://schemas.openxmlformats.org/drawingml/2006/main">
-              <a:ext uri="{FF2B5EF4-FFF2-40B4-BE49-F238E27FC236}">
-                <a16:creationId xmlns:a16="http://schemas.microsoft.com/office/drawing/2014/main" id="{5F71AD43-4046-4D49-B823-17EA0FEC5825}"/>
-              </a:ext>
-            </a:extLst>
-          </p:cNvPr>
-          <p:cNvSpPr>
-            <a:spLocks xmlns:a="http://schemas.openxmlformats.org/drawingml/2006/main" noGrp="1"/>
-          </p:cNvSpPr>
-          <p:nvPr/>
-        </p:nvSpPr>
-        <p:spPr>
-          <a:xfrm xmlns:a="http://schemas.openxmlformats.org/drawingml/2006/main">
-            <a:off x="609600" y="4838700"/>
-            <a:ext cx="5715000" cy="828675"/>
-          </a:xfrm>
-          <a:prstGeom xmlns:a="http://schemas.openxmlformats.org/drawingml/2006/main" prst="rect">
-            <a:avLst/>
-          </a:prstGeom>
-          <a:noFill xmlns:a="http://schemas.openxmlformats.org/drawingml/2006/main"/>
-          <a:ln xmlns:a="http://schemas.openxmlformats.org/drawingml/2006/main" w="0">
-            <a:noFill/>
-          </a:ln>
-        </p:spPr>
-        <p:txBody>
-          <a:bodyPr xmlns:a="http://schemas.openxmlformats.org/drawingml/2006/main" wrap="none" lIns="0" tIns="0" rIns="0" bIns="0" anchor="t">
-            <a:noAutofit/>
-          </a:bodyPr>
-          <a:lstStyle xmlns:a="http://schemas.openxmlformats.org/drawingml/2006/main"/>
-          <a:p xmlns:a="http://schemas.openxmlformats.org/drawingml/2006/main">
-            <a:pPr algn="l">
-              <a:buNone/>
-              <a:defRPr sz="2025" b="0">
+              <a:t>Use your key</a:t>
+            </a:r>
+          </a:p>
+        </p:txBody>
+      </p:sp>
+      <p:sp>
+        <p:nvSpPr>
+          <p:cNvPr id="17" name="detail-2">
+            <a:extLst xmlns:a="http://schemas.openxmlformats.org/drawingml/2006/main">
+              <a:ext uri="{FF2B5EF4-FFF2-40B4-BE49-F238E27FC236}">
+                <a16:creationId xmlns:a16="http://schemas.microsoft.com/office/drawing/2014/main" id="{86AC9DF9-265A-4051-90FA-C86F9F89C9A9}"/>
+              </a:ext>
+            </a:extLst>
+          </p:cNvPr>
+          <p:cNvSpPr>
+            <a:spLocks xmlns:a="http://schemas.openxmlformats.org/drawingml/2006/main" noGrp="1"/>
+          </p:cNvSpPr>
+          <p:nvPr/>
+        </p:nvSpPr>
+        <p:spPr>
+          <a:xfrm xmlns:a="http://schemas.openxmlformats.org/drawingml/2006/main">
+            <a:off x="4476750" y="4219575"/>
+            <a:ext cx="7067550" cy="409575"/>
+          </a:xfrm>
+          <a:prstGeom xmlns:a="http://schemas.openxmlformats.org/drawingml/2006/main" prst="rect">
+            <a:avLst/>
+          </a:prstGeom>
+          <a:noFill xmlns:a="http://schemas.openxmlformats.org/drawingml/2006/main"/>
+          <a:ln xmlns:a="http://schemas.openxmlformats.org/drawingml/2006/main" w="0">
+            <a:noFill/>
+          </a:ln>
+        </p:spPr>
+        <p:txBody>
+          <a:bodyPr xmlns:a="http://schemas.openxmlformats.org/drawingml/2006/main" wrap="none" lIns="0" tIns="0" rIns="0" bIns="0" anchor="t">
+            <a:noAutofit/>
+          </a:bodyPr>
+          <a:lstStyle xmlns:a="http://schemas.openxmlformats.org/drawingml/2006/main"/>
+          <a:p xmlns:a="http://schemas.openxmlformats.org/drawingml/2006/main">
+            <a:pPr algn="l">
+              <a:buNone/>
+              <a:defRPr sz="1875" b="0">
                 <a:solidFill>
                   <a:srgbClr val="53686C"/>
                 </a:solidFill>
@@ -3971,7 +4329,7 @@
               </a:defRPr>
             </a:pPr>
             <a:r>
-              <a:rPr sz="2025" b="0">
+              <a:rPr sz="1875" b="0">
                 <a:solidFill>
                   <a:srgbClr val="53686C"/>
                 </a:solidFill>
@@ -3979,13 +4337,163 @@
                 <a:ea typeface="Arial"/>
                 <a:cs typeface="Arial"/>
               </a:rPr>
-              <a:t>Save as project/index.html.</a:t>
-            </a:r>
-          </a:p>
-          <a:p xmlns:a="http://schemas.openxmlformats.org/drawingml/2006/main">
-            <a:pPr algn="l">
-              <a:buNone/>
-              <a:defRPr sz="2025" b="0">
+              <a:t>Paste into the key field. Click Use my key.</a:t>
+            </a:r>
+          </a:p>
+        </p:txBody>
+      </p:sp>
+      <p:sp>
+        <p:nvSpPr>
+          <p:cNvPr id="18" name="number-3">
+            <a:extLst xmlns:a="http://schemas.openxmlformats.org/drawingml/2006/main">
+              <a:ext uri="{FF2B5EF4-FFF2-40B4-BE49-F238E27FC236}">
+                <a16:creationId xmlns:a16="http://schemas.microsoft.com/office/drawing/2014/main" id="{B815891C-F9E3-4E7E-9B17-326932EE6564}"/>
+              </a:ext>
+            </a:extLst>
+          </p:cNvPr>
+          <p:cNvSpPr>
+            <a:spLocks xmlns:a="http://schemas.openxmlformats.org/drawingml/2006/main" noGrp="1"/>
+          </p:cNvSpPr>
+          <p:nvPr/>
+        </p:nvSpPr>
+        <p:spPr>
+          <a:xfrm xmlns:a="http://schemas.openxmlformats.org/drawingml/2006/main">
+            <a:off x="609600" y="4905375"/>
+            <a:ext cx="800100" cy="438150"/>
+          </a:xfrm>
+          <a:prstGeom xmlns:a="http://schemas.openxmlformats.org/drawingml/2006/main" prst="rect">
+            <a:avLst/>
+          </a:prstGeom>
+          <a:noFill xmlns:a="http://schemas.openxmlformats.org/drawingml/2006/main"/>
+          <a:ln xmlns:a="http://schemas.openxmlformats.org/drawingml/2006/main" w="0">
+            <a:noFill/>
+          </a:ln>
+        </p:spPr>
+        <p:txBody>
+          <a:bodyPr xmlns:a="http://schemas.openxmlformats.org/drawingml/2006/main" wrap="none" lIns="0" tIns="0" rIns="0" bIns="0" anchor="t">
+            <a:noAutofit/>
+          </a:bodyPr>
+          <a:lstStyle xmlns:a="http://schemas.openxmlformats.org/drawingml/2006/main"/>
+          <a:p xmlns:a="http://schemas.openxmlformats.org/drawingml/2006/main">
+            <a:pPr algn="l">
+              <a:buNone/>
+              <a:defRPr sz="2400" b="1">
+                <a:solidFill>
+                  <a:srgbClr val="087E80"/>
+                </a:solidFill>
+                <a:latin typeface="Arial"/>
+                <a:ea typeface="Arial"/>
+                <a:cs typeface="Arial"/>
+              </a:defRPr>
+            </a:pPr>
+            <a:r>
+              <a:rPr sz="2400" b="1">
+                <a:solidFill>
+                  <a:srgbClr val="087E80"/>
+                </a:solidFill>
+                <a:latin typeface="Arial"/>
+                <a:ea typeface="Arial"/>
+                <a:cs typeface="Arial"/>
+              </a:rPr>
+              <a:t>04</a:t>
+            </a:r>
+          </a:p>
+        </p:txBody>
+      </p:sp>
+      <p:sp>
+        <p:nvSpPr>
+          <p:cNvPr id="19" name="label-3">
+            <a:extLst xmlns:a="http://schemas.openxmlformats.org/drawingml/2006/main">
+              <a:ext uri="{FF2B5EF4-FFF2-40B4-BE49-F238E27FC236}">
+                <a16:creationId xmlns:a16="http://schemas.microsoft.com/office/drawing/2014/main" id="{D16D2124-C19D-4287-BA72-4BAFA52DD5C6}"/>
+              </a:ext>
+            </a:extLst>
+          </p:cNvPr>
+          <p:cNvSpPr>
+            <a:spLocks xmlns:a="http://schemas.openxmlformats.org/drawingml/2006/main" noGrp="1"/>
+          </p:cNvSpPr>
+          <p:nvPr/>
+        </p:nvSpPr>
+        <p:spPr>
+          <a:xfrm xmlns:a="http://schemas.openxmlformats.org/drawingml/2006/main">
+            <a:off x="1638300" y="4905375"/>
+            <a:ext cx="2476500" cy="438150"/>
+          </a:xfrm>
+          <a:prstGeom xmlns:a="http://schemas.openxmlformats.org/drawingml/2006/main" prst="rect">
+            <a:avLst/>
+          </a:prstGeom>
+          <a:noFill xmlns:a="http://schemas.openxmlformats.org/drawingml/2006/main"/>
+          <a:ln xmlns:a="http://schemas.openxmlformats.org/drawingml/2006/main" w="0">
+            <a:noFill/>
+          </a:ln>
+        </p:spPr>
+        <p:txBody>
+          <a:bodyPr xmlns:a="http://schemas.openxmlformats.org/drawingml/2006/main" wrap="none" lIns="0" tIns="0" rIns="0" bIns="0" anchor="t">
+            <a:noAutofit/>
+          </a:bodyPr>
+          <a:lstStyle xmlns:a="http://schemas.openxmlformats.org/drawingml/2006/main"/>
+          <a:p xmlns:a="http://schemas.openxmlformats.org/drawingml/2006/main">
+            <a:pPr algn="l">
+              <a:buNone/>
+              <a:defRPr sz="2175" b="1">
+                <a:solidFill>
+                  <a:srgbClr val="142D32"/>
+                </a:solidFill>
+                <a:latin typeface="Arial"/>
+                <a:ea typeface="Arial"/>
+                <a:cs typeface="Arial"/>
+              </a:defRPr>
+            </a:pPr>
+            <a:r>
+              <a:rPr sz="2175" b="1">
+                <a:solidFill>
+                  <a:srgbClr val="142D32"/>
+                </a:solidFill>
+                <a:latin typeface="Arial"/>
+                <a:ea typeface="Arial"/>
+                <a:cs typeface="Arial"/>
+              </a:rPr>
+              <a:t>Send a theme</a:t>
+            </a:r>
+          </a:p>
+        </p:txBody>
+      </p:sp>
+      <p:sp>
+        <p:nvSpPr>
+          <p:cNvPr id="20" name="detail-3">
+            <a:extLst xmlns:a="http://schemas.openxmlformats.org/drawingml/2006/main">
+              <a:ext uri="{FF2B5EF4-FFF2-40B4-BE49-F238E27FC236}">
+                <a16:creationId xmlns:a16="http://schemas.microsoft.com/office/drawing/2014/main" id="{9219B99F-90F8-4C32-9F2B-5F01F554F722}"/>
+              </a:ext>
+            </a:extLst>
+          </p:cNvPr>
+          <p:cNvSpPr>
+            <a:spLocks xmlns:a="http://schemas.openxmlformats.org/drawingml/2006/main" noGrp="1"/>
+          </p:cNvSpPr>
+          <p:nvPr/>
+        </p:nvSpPr>
+        <p:spPr>
+          <a:xfrm xmlns:a="http://schemas.openxmlformats.org/drawingml/2006/main">
+            <a:off x="4476750" y="4933950"/>
+            <a:ext cx="7067550" cy="409575"/>
+          </a:xfrm>
+          <a:prstGeom xmlns:a="http://schemas.openxmlformats.org/drawingml/2006/main" prst="rect">
+            <a:avLst/>
+          </a:prstGeom>
+          <a:noFill xmlns:a="http://schemas.openxmlformats.org/drawingml/2006/main"/>
+          <a:ln xmlns:a="http://schemas.openxmlformats.org/drawingml/2006/main" w="0">
+            <a:noFill/>
+          </a:ln>
+        </p:spPr>
+        <p:txBody>
+          <a:bodyPr xmlns:a="http://schemas.openxmlformats.org/drawingml/2006/main" wrap="none" lIns="0" tIns="0" rIns="0" bIns="0" anchor="t">
+            <a:noAutofit/>
+          </a:bodyPr>
+          <a:lstStyle xmlns:a="http://schemas.openxmlformats.org/drawingml/2006/main"/>
+          <a:p xmlns:a="http://schemas.openxmlformats.org/drawingml/2006/main">
+            <a:pPr algn="l">
+              <a:buNone/>
+              <a:defRPr sz="1875" b="0">
                 <a:solidFill>
                   <a:srgbClr val="53686C"/>
                 </a:solidFill>
@@ -3995,7 +4503,7 @@
               </a:defRPr>
             </a:pPr>
             <a:r>
-              <a:rPr sz="2025" b="0">
+              <a:rPr sz="1875" b="0">
                 <a:solidFill>
                   <a:srgbClr val="53686C"/>
                 </a:solidFill>
@@ -4003,301 +4511,7 @@
                 <a:ea typeface="Arial"/>
                 <a:cs typeface="Arial"/>
               </a:rPr>
-              <a:t>Refresh your browser.</a:t>
-            </a:r>
-          </a:p>
-        </p:txBody>
-      </p:sp>
-      <p:sp>
-        <p:nvSpPr>
-          <p:cNvPr id="11" name="example-label">
-            <a:extLst xmlns:a="http://schemas.openxmlformats.org/drawingml/2006/main">
-              <a:ext uri="{FF2B5EF4-FFF2-40B4-BE49-F238E27FC236}">
-                <a16:creationId xmlns:a16="http://schemas.microsoft.com/office/drawing/2014/main" id="{C0F0E3A6-C0BA-4812-A71E-EE33593570EC}"/>
-              </a:ext>
-            </a:extLst>
-          </p:cNvPr>
-          <p:cNvSpPr>
-            <a:spLocks xmlns:a="http://schemas.openxmlformats.org/drawingml/2006/main" noGrp="1"/>
-          </p:cNvSpPr>
-          <p:nvPr/>
-        </p:nvSpPr>
-        <p:spPr>
-          <a:xfrm xmlns:a="http://schemas.openxmlformats.org/drawingml/2006/main">
-            <a:off x="6838950" y="2743200"/>
-            <a:ext cx="4476750" cy="323850"/>
-          </a:xfrm>
-          <a:prstGeom xmlns:a="http://schemas.openxmlformats.org/drawingml/2006/main" prst="rect">
-            <a:avLst/>
-          </a:prstGeom>
-          <a:noFill xmlns:a="http://schemas.openxmlformats.org/drawingml/2006/main"/>
-          <a:ln xmlns:a="http://schemas.openxmlformats.org/drawingml/2006/main" w="0">
-            <a:noFill/>
-          </a:ln>
-        </p:spPr>
-        <p:txBody>
-          <a:bodyPr xmlns:a="http://schemas.openxmlformats.org/drawingml/2006/main" wrap="none" lIns="0" tIns="0" rIns="0" bIns="0" anchor="t">
-            <a:noAutofit/>
-          </a:bodyPr>
-          <a:lstStyle xmlns:a="http://schemas.openxmlformats.org/drawingml/2006/main"/>
-          <a:p xmlns:a="http://schemas.openxmlformats.org/drawingml/2006/main">
-            <a:pPr algn="l">
-              <a:buNone/>
-              <a:defRPr sz="1350" b="1">
-                <a:solidFill>
-                  <a:srgbClr val="087E80"/>
-                </a:solidFill>
-                <a:latin typeface="Arial"/>
-                <a:ea typeface="Arial"/>
-                <a:cs typeface="Arial"/>
-              </a:defRPr>
-            </a:pPr>
-            <a:r>
-              <a:rPr sz="1350" b="1">
-                <a:solidFill>
-                  <a:srgbClr val="087E80"/>
-                </a:solidFill>
-                <a:latin typeface="Arial"/>
-                <a:ea typeface="Arial"/>
-                <a:cs typeface="Arial"/>
-              </a:rPr>
-              <a:t>THE BROWSER CALLS YOUR ROUTE</a:t>
-            </a:r>
-          </a:p>
-        </p:txBody>
-      </p:sp>
-      <p:sp>
-        <p:nvSpPr>
-          <p:cNvPr id="12" name="example">
-            <a:extLst xmlns:a="http://schemas.openxmlformats.org/drawingml/2006/main">
-              <a:ext uri="{FF2B5EF4-FFF2-40B4-BE49-F238E27FC236}">
-                <a16:creationId xmlns:a16="http://schemas.microsoft.com/office/drawing/2014/main" id="{65C7B07F-0842-498C-AF6D-0DEAB040E8FF}"/>
-              </a:ext>
-            </a:extLst>
-          </p:cNvPr>
-          <p:cNvSpPr>
-            <a:spLocks xmlns:a="http://schemas.openxmlformats.org/drawingml/2006/main" noGrp="1"/>
-          </p:cNvSpPr>
-          <p:nvPr/>
-        </p:nvSpPr>
-        <p:spPr>
-          <a:xfrm xmlns:a="http://schemas.openxmlformats.org/drawingml/2006/main">
-            <a:off x="6838950" y="3238500"/>
-            <a:ext cx="4743450" cy="1762125"/>
-          </a:xfrm>
-          <a:prstGeom xmlns:a="http://schemas.openxmlformats.org/drawingml/2006/main" prst="rect">
-            <a:avLst/>
-          </a:prstGeom>
-          <a:noFill xmlns:a="http://schemas.openxmlformats.org/drawingml/2006/main"/>
-          <a:ln xmlns:a="http://schemas.openxmlformats.org/drawingml/2006/main" w="0">
-            <a:noFill/>
-          </a:ln>
-        </p:spPr>
-        <p:txBody>
-          <a:bodyPr xmlns:a="http://schemas.openxmlformats.org/drawingml/2006/main" wrap="none" lIns="0" tIns="0" rIns="0" bIns="0" anchor="t">
-            <a:noAutofit/>
-          </a:bodyPr>
-          <a:lstStyle xmlns:a="http://schemas.openxmlformats.org/drawingml/2006/main"/>
-          <a:p xmlns:a="http://schemas.openxmlformats.org/drawingml/2006/main">
-            <a:pPr algn="l">
-              <a:buNone/>
-              <a:defRPr sz="1650" b="0">
-                <a:solidFill>
-                  <a:srgbClr val="142D32"/>
-                </a:solidFill>
-                <a:latin typeface="Arial"/>
-                <a:ea typeface="Arial"/>
-                <a:cs typeface="Arial"/>
-              </a:defRPr>
-            </a:pPr>
-            <a:r>
-              <a:rPr sz="1650" b="0">
-                <a:solidFill>
-                  <a:srgbClr val="142D32"/>
-                </a:solidFill>
-                <a:latin typeface="Arial"/>
-                <a:ea typeface="Arial"/>
-                <a:cs typeface="Arial"/>
-              </a:rPr>
-              <a:t>fetch('/api/chat', {</a:t>
-            </a:r>
-          </a:p>
-          <a:p xmlns:a="http://schemas.openxmlformats.org/drawingml/2006/main">
-            <a:pPr algn="l">
-              <a:buNone/>
-              <a:defRPr sz="1650" b="0">
-                <a:solidFill>
-                  <a:srgbClr val="142D32"/>
-                </a:solidFill>
-                <a:latin typeface="Arial"/>
-                <a:ea typeface="Arial"/>
-                <a:cs typeface="Arial"/>
-              </a:defRPr>
-            </a:pPr>
-            <a:r>
-              <a:rPr sz="1650" b="0">
-                <a:solidFill>
-                  <a:srgbClr val="142D32"/>
-                </a:solidFill>
-                <a:latin typeface="Arial"/>
-                <a:ea typeface="Arial"/>
-                <a:cs typeface="Arial"/>
-              </a:rPr>
-              <a:t>  method: 'POST',</a:t>
-            </a:r>
-          </a:p>
-          <a:p xmlns:a="http://schemas.openxmlformats.org/drawingml/2006/main">
-            <a:pPr algn="l">
-              <a:buNone/>
-              <a:defRPr sz="1650" b="0">
-                <a:solidFill>
-                  <a:srgbClr val="142D32"/>
-                </a:solidFill>
-                <a:latin typeface="Arial"/>
-                <a:ea typeface="Arial"/>
-                <a:cs typeface="Arial"/>
-              </a:defRPr>
-            </a:pPr>
-            <a:r>
-              <a:rPr sz="1650" b="0">
-                <a:solidFill>
-                  <a:srgbClr val="142D32"/>
-                </a:solidFill>
-                <a:latin typeface="Arial"/>
-                <a:ea typeface="Arial"/>
-                <a:cs typeface="Arial"/>
-              </a:rPr>
-              <a:t>  headers: {'Content-Type':</a:t>
-            </a:r>
-          </a:p>
-          <a:p xmlns:a="http://schemas.openxmlformats.org/drawingml/2006/main">
-            <a:pPr algn="l">
-              <a:buNone/>
-              <a:defRPr sz="1650" b="0">
-                <a:solidFill>
-                  <a:srgbClr val="142D32"/>
-                </a:solidFill>
-                <a:latin typeface="Arial"/>
-                <a:ea typeface="Arial"/>
-                <a:cs typeface="Arial"/>
-              </a:defRPr>
-            </a:pPr>
-            <a:r>
-              <a:rPr sz="1650" b="0">
-                <a:solidFill>
-                  <a:srgbClr val="142D32"/>
-                </a:solidFill>
-                <a:latin typeface="Arial"/>
-                <a:ea typeface="Arial"/>
-                <a:cs typeface="Arial"/>
-              </a:rPr>
-              <a:t>    'application/json'},</a:t>
-            </a:r>
-          </a:p>
-          <a:p xmlns:a="http://schemas.openxmlformats.org/drawingml/2006/main">
-            <a:pPr algn="l">
-              <a:buNone/>
-              <a:defRPr sz="1650" b="0">
-                <a:solidFill>
-                  <a:srgbClr val="142D32"/>
-                </a:solidFill>
-                <a:latin typeface="Arial"/>
-                <a:ea typeface="Arial"/>
-                <a:cs typeface="Arial"/>
-              </a:defRPr>
-            </a:pPr>
-            <a:r>
-              <a:rPr sz="1650" b="0">
-                <a:solidFill>
-                  <a:srgbClr val="142D32"/>
-                </a:solidFill>
-                <a:latin typeface="Arial"/>
-                <a:ea typeface="Arial"/>
-                <a:cs typeface="Arial"/>
-              </a:rPr>
-              <a:t>  body: JSON.stringify({message})</a:t>
-            </a:r>
-          </a:p>
-          <a:p xmlns:a="http://schemas.openxmlformats.org/drawingml/2006/main">
-            <a:pPr algn="l">
-              <a:buNone/>
-              <a:defRPr sz="1650" b="0">
-                <a:solidFill>
-                  <a:srgbClr val="142D32"/>
-                </a:solidFill>
-                <a:latin typeface="Arial"/>
-                <a:ea typeface="Arial"/>
-                <a:cs typeface="Arial"/>
-              </a:defRPr>
-            </a:pPr>
-            <a:r>
-              <a:rPr sz="1650" b="0">
-                <a:solidFill>
-                  <a:srgbClr val="142D32"/>
-                </a:solidFill>
-                <a:latin typeface="Arial"/>
-                <a:ea typeface="Arial"/>
-                <a:cs typeface="Arial"/>
-              </a:rPr>
-              <a:t>})</a:t>
-            </a:r>
-          </a:p>
-        </p:txBody>
-      </p:sp>
-      <p:sp>
-        <p:nvSpPr>
-          <p:cNvPr id="13" name="example-caption">
-            <a:extLst xmlns:a="http://schemas.openxmlformats.org/drawingml/2006/main">
-              <a:ext uri="{FF2B5EF4-FFF2-40B4-BE49-F238E27FC236}">
-                <a16:creationId xmlns:a16="http://schemas.microsoft.com/office/drawing/2014/main" id="{CDE9539E-CA88-4C9C-B91C-E62AD49DED18}"/>
-              </a:ext>
-            </a:extLst>
-          </p:cNvPr>
-          <p:cNvSpPr>
-            <a:spLocks xmlns:a="http://schemas.openxmlformats.org/drawingml/2006/main" noGrp="1"/>
-          </p:cNvSpPr>
-          <p:nvPr/>
-        </p:nvSpPr>
-        <p:spPr>
-          <a:xfrm xmlns:a="http://schemas.openxmlformats.org/drawingml/2006/main">
-            <a:off x="6838950" y="5248275"/>
-            <a:ext cx="4743450" cy="371475"/>
-          </a:xfrm>
-          <a:prstGeom xmlns:a="http://schemas.openxmlformats.org/drawingml/2006/main" prst="rect">
-            <a:avLst/>
-          </a:prstGeom>
-          <a:noFill xmlns:a="http://schemas.openxmlformats.org/drawingml/2006/main"/>
-          <a:ln xmlns:a="http://schemas.openxmlformats.org/drawingml/2006/main" w="0">
-            <a:noFill/>
-          </a:ln>
-        </p:spPr>
-        <p:txBody>
-          <a:bodyPr xmlns:a="http://schemas.openxmlformats.org/drawingml/2006/main" wrap="none" lIns="0" tIns="0" rIns="0" bIns="0" anchor="t">
-            <a:noAutofit/>
-          </a:bodyPr>
-          <a:lstStyle xmlns:a="http://schemas.openxmlformats.org/drawingml/2006/main"/>
-          <a:p xmlns:a="http://schemas.openxmlformats.org/drawingml/2006/main">
-            <a:pPr algn="l">
-              <a:buNone/>
-              <a:defRPr sz="1875" b="1">
-                <a:solidFill>
-                  <a:srgbClr val="087E80"/>
-                </a:solidFill>
-                <a:latin typeface="Arial"/>
-                <a:ea typeface="Arial"/>
-                <a:cs typeface="Arial"/>
-              </a:defRPr>
-            </a:pPr>
-            <a:r>
-              <a:rPr sz="1875" b="1">
-                <a:solidFill>
-                  <a:srgbClr val="087E80"/>
-                </a:solidFill>
-                <a:latin typeface="Arial"/>
-                <a:ea typeface="Arial"/>
-                <a:cs typeface="Arial"/>
-              </a:rPr>
-              <a:t>Your key stays on the server.</a:t>
+              <a:t>Try “superpowers”, then press Send.</a:t>
             </a:r>
           </a:p>
         </p:txBody>
@@ -4305,7 +4519,7 @@
     </p:spTree>
     <p:extLst>
       <p:ext uri="{BB962C8B-B14F-4D97-AF65-F5344CB8AC3E}">
-        <p14:creationId xmlns:p14="http://schemas.microsoft.com/office/powerpoint/2010/main" val="22625506"/>
+        <p14:creationId xmlns:p14="http://schemas.microsoft.com/office/powerpoint/2010/main" val="398891925"/>
       </p:ext>
     </p:extLst>
   </p:cSld>
@@ -4442,7 +4656,7 @@
                 <a:ea typeface="Arial"/>
                 <a:cs typeface="Arial"/>
               </a:rPr>
-              <a:t>4. Make it your own</a:t>
+              <a:t>Change the bot instructions</a:t>
             </a:r>
           </a:p>
         </p:txBody>
@@ -4500,7 +4714,7 @@
                 <a:ea typeface="Arial"/>
                 <a:cs typeface="Arial"/>
               </a:rPr>
-              <a:t>Change SYSTEM_PROMPT in server.mjs</a:t>
+              <a:t>Back on GitHub, edit the same index.html</a:t>
             </a:r>
           </a:p>
         </p:txBody>
@@ -4616,7 +4830,7 @@
                 <a:ea typeface="Arial"/>
                 <a:cs typeface="Arial"/>
               </a:rPr>
-              <a:t>TRY A DIFFERENT STYLE</a:t>
+              <a:t>FIND EDIT 3</a:t>
             </a:r>
           </a:p>
         </p:txBody>
@@ -4638,7 +4852,7 @@
         <p:spPr>
           <a:xfrm xmlns:a="http://schemas.openxmlformats.org/drawingml/2006/main">
             <a:off x="609600" y="3314700"/>
-            <a:ext cx="5238750" cy="1638300"/>
+            <a:ext cx="5238750" cy="1733550"/>
           </a:xfrm>
           <a:prstGeom xmlns:a="http://schemas.openxmlformats.org/drawingml/2006/main" prst="rect">
             <a:avLst/>
@@ -4791,26 +5005,26 @@
         </p:nvSpPr>
         <p:spPr>
           <a:xfrm xmlns:a="http://schemas.openxmlformats.org/drawingml/2006/main">
-            <a:off x="609600" y="5495925"/>
-            <a:ext cx="5143500" cy="571500"/>
-          </a:xfrm>
-          <a:prstGeom xmlns:a="http://schemas.openxmlformats.org/drawingml/2006/main" prst="rect">
-            <a:avLst/>
-          </a:prstGeom>
-          <a:noFill xmlns:a="http://schemas.openxmlformats.org/drawingml/2006/main"/>
-          <a:ln xmlns:a="http://schemas.openxmlformats.org/drawingml/2006/main" w="0">
-            <a:noFill/>
-          </a:ln>
-        </p:spPr>
-        <p:txBody>
-          <a:bodyPr xmlns:a="http://schemas.openxmlformats.org/drawingml/2006/main" wrap="none" lIns="0" tIns="0" rIns="0" bIns="0" anchor="t">
-            <a:noAutofit/>
-          </a:bodyPr>
-          <a:lstStyle xmlns:a="http://schemas.openxmlformats.org/drawingml/2006/main"/>
-          <a:p xmlns:a="http://schemas.openxmlformats.org/drawingml/2006/main">
-            <a:pPr algn="l">
-              <a:buNone/>
-              <a:defRPr sz="1875" b="0">
+            <a:off x="609600" y="5524500"/>
+            <a:ext cx="5334000" cy="542925"/>
+          </a:xfrm>
+          <a:prstGeom xmlns:a="http://schemas.openxmlformats.org/drawingml/2006/main" prst="rect">
+            <a:avLst/>
+          </a:prstGeom>
+          <a:noFill xmlns:a="http://schemas.openxmlformats.org/drawingml/2006/main"/>
+          <a:ln xmlns:a="http://schemas.openxmlformats.org/drawingml/2006/main" w="0">
+            <a:noFill/>
+          </a:ln>
+        </p:spPr>
+        <p:txBody>
+          <a:bodyPr xmlns:a="http://schemas.openxmlformats.org/drawingml/2006/main" wrap="none" lIns="0" tIns="0" rIns="0" bIns="0" anchor="t">
+            <a:noAutofit/>
+          </a:bodyPr>
+          <a:lstStyle xmlns:a="http://schemas.openxmlformats.org/drawingml/2006/main"/>
+          <a:p xmlns:a="http://schemas.openxmlformats.org/drawingml/2006/main">
+            <a:pPr algn="l">
+              <a:buNone/>
+              <a:defRPr sz="1800" b="0">
                 <a:solidFill>
                   <a:srgbClr val="53686C"/>
                 </a:solidFill>
@@ -4820,7 +5034,7 @@
               </a:defRPr>
             </a:pPr>
             <a:r>
-              <a:rPr sz="1875" b="0">
+              <a:rPr sz="1800" b="0">
                 <a:solidFill>
                   <a:srgbClr val="53686C"/>
                 </a:solidFill>
@@ -4828,7 +5042,7 @@
                 <a:ea typeface="Arial"/>
                 <a:cs typeface="Arial"/>
               </a:rPr>
-              <a:t>Predict how the answer will change.</a:t>
+              <a:t>Change the text inside INSTRUCTIONS.</a:t>
             </a:r>
           </a:p>
         </p:txBody>
@@ -4886,7 +5100,7 @@
                 <a:ea typeface="Arial"/>
                 <a:cs typeface="Arial"/>
               </a:rPr>
-              <a:t>SAVE AND TRY AGAIN</a:t>
+              <a:t>KEEP THE CODE AROUND IT</a:t>
             </a:r>
           </a:p>
         </p:txBody>
@@ -4926,97 +5140,73 @@
           <a:p xmlns:a="http://schemas.openxmlformats.org/drawingml/2006/main">
             <a:pPr algn="l">
               <a:buNone/>
-              <a:defRPr sz="2100" b="1">
-                <a:solidFill>
-                  <a:srgbClr val="142D32"/>
-                </a:solidFill>
-                <a:latin typeface="Arial"/>
-                <a:ea typeface="Arial"/>
-                <a:cs typeface="Arial"/>
-              </a:defRPr>
-            </a:pPr>
-            <a:r>
-              <a:rPr sz="2100" b="1">
-                <a:solidFill>
-                  <a:srgbClr val="142D32"/>
-                </a:solidFill>
-                <a:latin typeface="Arial"/>
-                <a:ea typeface="Arial"/>
-                <a:cs typeface="Arial"/>
-              </a:rPr>
-              <a:t>Save the file.</a:t>
-            </a:r>
-          </a:p>
-          <a:p xmlns:a="http://schemas.openxmlformats.org/drawingml/2006/main">
-            <a:pPr algn="l">
-              <a:buNone/>
-              <a:defRPr sz="2100" b="1">
-                <a:solidFill>
-                  <a:srgbClr val="142D32"/>
-                </a:solidFill>
-                <a:latin typeface="Arial"/>
-                <a:ea typeface="Arial"/>
-                <a:cs typeface="Arial"/>
-              </a:defRPr>
-            </a:pPr>
-            <a:r>
-              <a:rPr sz="2100" b="1">
-                <a:solidFill>
-                  <a:srgbClr val="142D32"/>
-                </a:solidFill>
-                <a:latin typeface="Arial"/>
-                <a:ea typeface="Arial"/>
-                <a:cs typeface="Arial"/>
-              </a:rPr>
-              <a:t>Stop with Ctrl+C.</a:t>
-            </a:r>
-          </a:p>
-          <a:p xmlns:a="http://schemas.openxmlformats.org/drawingml/2006/main">
-            <a:pPr algn="l">
-              <a:buNone/>
-              <a:defRPr sz="2100" b="1">
-                <a:solidFill>
-                  <a:srgbClr val="142D32"/>
-                </a:solidFill>
-                <a:latin typeface="Arial"/>
-                <a:ea typeface="Arial"/>
-                <a:cs typeface="Arial"/>
-              </a:defRPr>
-            </a:pPr>
-            <a:r>
-              <a:rPr sz="2100" b="1">
-                <a:solidFill>
-                  <a:srgbClr val="142D32"/>
-                </a:solidFill>
-                <a:latin typeface="Arial"/>
-                <a:ea typeface="Arial"/>
-                <a:cs typeface="Arial"/>
-              </a:rPr>
-              <a:t>Run the command again.</a:t>
-            </a:r>
-          </a:p>
-          <a:p xmlns:a="http://schemas.openxmlformats.org/drawingml/2006/main">
-            <a:pPr algn="l">
-              <a:buNone/>
-              <a:defRPr sz="2100" b="1">
-                <a:solidFill>
-                  <a:srgbClr val="142D32"/>
-                </a:solidFill>
-                <a:latin typeface="Arial"/>
-                <a:ea typeface="Arial"/>
-                <a:cs typeface="Arial"/>
-              </a:defRPr>
-            </a:pPr>
-            <a:r>
-              <a:rPr sz="2100" b="1">
-                <a:solidFill>
-                  <a:srgbClr val="142D32"/>
-                </a:solidFill>
-                <a:latin typeface="Arial"/>
-                <a:ea typeface="Arial"/>
-                <a:cs typeface="Arial"/>
-              </a:rPr>
-              <a:t>Send the same theme.</a:t>
+              <a:defRPr sz="2175" b="1">
+                <a:solidFill>
+                  <a:srgbClr val="142D32"/>
+                </a:solidFill>
+                <a:latin typeface="Arial"/>
+                <a:ea typeface="Arial"/>
+                <a:cs typeface="Arial"/>
+              </a:defRPr>
+            </a:pPr>
+            <a:r>
+              <a:rPr sz="2175" b="1">
+                <a:solidFill>
+                  <a:srgbClr val="142D32"/>
+                </a:solidFill>
+                <a:latin typeface="Arial"/>
+                <a:ea typeface="Arial"/>
+                <a:cs typeface="Arial"/>
+              </a:rPr>
+              <a:t>Keep the backticks.</a:t>
+            </a:r>
+          </a:p>
+          <a:p xmlns:a="http://schemas.openxmlformats.org/drawingml/2006/main">
+            <a:pPr algn="l">
+              <a:buNone/>
+              <a:defRPr sz="2175" b="1">
+                <a:solidFill>
+                  <a:srgbClr val="142D32"/>
+                </a:solidFill>
+                <a:latin typeface="Arial"/>
+                <a:ea typeface="Arial"/>
+                <a:cs typeface="Arial"/>
+              </a:defRPr>
+            </a:pPr>
+            <a:r>
+              <a:rPr sz="2175" b="1">
+                <a:solidFill>
+                  <a:srgbClr val="142D32"/>
+                </a:solidFill>
+                <a:latin typeface="Arial"/>
+                <a:ea typeface="Arial"/>
+                <a:cs typeface="Arial"/>
+              </a:rPr>
+              <a:t>Edit the instruction text.</a:t>
+            </a:r>
+          </a:p>
+          <a:p xmlns:a="http://schemas.openxmlformats.org/drawingml/2006/main">
+            <a:pPr algn="l">
+              <a:buNone/>
+              <a:defRPr sz="2175" b="1">
+                <a:solidFill>
+                  <a:srgbClr val="142D32"/>
+                </a:solidFill>
+                <a:latin typeface="Arial"/>
+                <a:ea typeface="Arial"/>
+                <a:cs typeface="Arial"/>
+              </a:defRPr>
+            </a:pPr>
+            <a:r>
+              <a:rPr sz="2175" b="1">
+                <a:solidFill>
+                  <a:srgbClr val="142D32"/>
+                </a:solidFill>
+                <a:latin typeface="Arial"/>
+                <a:ea typeface="Arial"/>
+                <a:cs typeface="Arial"/>
+              </a:rPr>
+              <a:t>Click Commit changes.</a:t>
             </a:r>
           </a:p>
         </p:txBody>
@@ -5037,26 +5227,26 @@
         </p:nvSpPr>
         <p:spPr>
           <a:xfrm xmlns:a="http://schemas.openxmlformats.org/drawingml/2006/main">
-            <a:off x="6610350" y="5495925"/>
-            <a:ext cx="4972050" cy="571500"/>
-          </a:xfrm>
-          <a:prstGeom xmlns:a="http://schemas.openxmlformats.org/drawingml/2006/main" prst="rect">
-            <a:avLst/>
-          </a:prstGeom>
-          <a:noFill xmlns:a="http://schemas.openxmlformats.org/drawingml/2006/main"/>
-          <a:ln xmlns:a="http://schemas.openxmlformats.org/drawingml/2006/main" w="0">
-            <a:noFill/>
-          </a:ln>
-        </p:spPr>
-        <p:txBody>
-          <a:bodyPr xmlns:a="http://schemas.openxmlformats.org/drawingml/2006/main" wrap="none" lIns="0" tIns="0" rIns="0" bIns="0" anchor="t">
-            <a:noAutofit/>
-          </a:bodyPr>
-          <a:lstStyle xmlns:a="http://schemas.openxmlformats.org/drawingml/2006/main"/>
-          <a:p xmlns:a="http://schemas.openxmlformats.org/drawingml/2006/main">
-            <a:pPr algn="l">
-              <a:buNone/>
-              <a:defRPr sz="1875" b="0">
+            <a:off x="6610350" y="5524500"/>
+            <a:ext cx="4972050" cy="542925"/>
+          </a:xfrm>
+          <a:prstGeom xmlns:a="http://schemas.openxmlformats.org/drawingml/2006/main" prst="rect">
+            <a:avLst/>
+          </a:prstGeom>
+          <a:noFill xmlns:a="http://schemas.openxmlformats.org/drawingml/2006/main"/>
+          <a:ln xmlns:a="http://schemas.openxmlformats.org/drawingml/2006/main" w="0">
+            <a:noFill/>
+          </a:ln>
+        </p:spPr>
+        <p:txBody>
+          <a:bodyPr xmlns:a="http://schemas.openxmlformats.org/drawingml/2006/main" wrap="none" lIns="0" tIns="0" rIns="0" bIns="0" anchor="t">
+            <a:noAutofit/>
+          </a:bodyPr>
+          <a:lstStyle xmlns:a="http://schemas.openxmlformats.org/drawingml/2006/main"/>
+          <a:p xmlns:a="http://schemas.openxmlformats.org/drawingml/2006/main">
+            <a:pPr algn="l">
+              <a:buNone/>
+              <a:defRPr sz="1800" b="0">
                 <a:solidFill>
                   <a:srgbClr val="53686C"/>
                 </a:solidFill>
@@ -5066,7 +5256,7 @@
               </a:defRPr>
             </a:pPr>
             <a:r>
-              <a:rPr sz="1875" b="0">
+              <a:rPr sz="1800" b="0">
                 <a:solidFill>
                   <a:srgbClr val="53686C"/>
                 </a:solidFill>
@@ -5074,7 +5264,7 @@
                 <a:ea typeface="Arial"/>
                 <a:cs typeface="Arial"/>
               </a:rPr>
-              <a:t>You can rename the button, too.</a:t>
+              <a:t>Predict how the answer will change.</a:t>
             </a:r>
           </a:p>
         </p:txBody>
@@ -5219,7 +5409,7 @@
                 <a:ea typeface="Arial"/>
                 <a:cs typeface="Arial"/>
               </a:rPr>
-              <a:t>Try it together</a:t>
+              <a:t>Your updated game</a:t>
             </a:r>
           </a:p>
         </p:txBody>
@@ -5277,7 +5467,7 @@
                 <a:ea typeface="Arial"/>
                 <a:cs typeface="Arial"/>
               </a:rPr>
-              <a:t>Give everyone the same theme</a:t>
+              <a:t>Wait for publishing, then refresh the live page</a:t>
             </a:r>
           </a:p>
         </p:txBody>
@@ -5417,7 +5607,7 @@
                 <a:ea typeface="Arial"/>
                 <a:cs typeface="Arial"/>
               </a:rPr>
-              <a:t>What made it a good question?</a:t>
+              <a:t>Did your edit make it more fun?</a:t>
             </a:r>
           </a:p>
         </p:txBody>
@@ -5457,7 +5647,7 @@
           <a:p xmlns:a="http://schemas.openxmlformats.org/drawingml/2006/main">
             <a:pPr algn="l">
               <a:buNone/>
-              <a:defRPr sz="2175" b="1">
+              <a:defRPr sz="2025" b="1">
                 <a:solidFill>
                   <a:srgbClr val="087E80"/>
                 </a:solidFill>
@@ -5467,7 +5657,7 @@
               </a:defRPr>
             </a:pPr>
             <a:r>
-              <a:rPr sz="2175" b="1">
+              <a:rPr sz="2025" b="1">
                 <a:solidFill>
                   <a:srgbClr val="087E80"/>
                 </a:solidFill>
@@ -5475,7 +5665,7 @@
                 <a:ea typeface="Arial"/>
                 <a:cs typeface="Arial"/>
               </a:rPr>
-              <a:t>Try “food”, “superpowers”, or “college life”.</a:t>
+              <a:t>Refresh clears your key. Paste it again to use AI.</a:t>
             </a:r>
           </a:p>
         </p:txBody>

</xml_diff>

<commit_message>
Teach private OpenRouter API deployment with GitHub Secrets
</commit_message>
<xml_diff>
--- a/ai-would-you-rather/slides/Would-You-Rather-Workshop.pptx
+++ b/ai-would-you-rather/slides/Would-You-Rather-Workshop.pptx
@@ -2,18 +2,18 @@
 <file path=ppt/presentation.xml><?xml version="1.0" encoding="utf-8"?>
 <p:presentation xmlns:p="http://schemas.openxmlformats.org/presentationml/2006/main">
   <p:sldMasterIdLst>
-    <p:sldMasterId xmlns:r="http://schemas.openxmlformats.org/officeDocument/2006/relationships" id="2147483648" r:id="R227f2b1b15084363"/>
+    <p:sldMasterId xmlns:r="http://schemas.openxmlformats.org/officeDocument/2006/relationships" id="2147483648" r:id="R13ea795daeab4d96"/>
   </p:sldMasterIdLst>
   <p:notesMasterIdLst>
-    <p:notesMasterId xmlns:r="http://schemas.openxmlformats.org/officeDocument/2006/relationships" r:id="R04eb321dbd5b4e3a"/>
+    <p:notesMasterId xmlns:r="http://schemas.openxmlformats.org/officeDocument/2006/relationships" r:id="Rcfd2c0a11af64ac5"/>
   </p:notesMasterIdLst>
   <p:sldIdLst>
-    <p:sldId xmlns:r="http://schemas.openxmlformats.org/officeDocument/2006/relationships" id="256" r:id="R31c45e1f156f4900"/>
-    <p:sldId xmlns:r="http://schemas.openxmlformats.org/officeDocument/2006/relationships" id="257" r:id="Rc7ca75736e96432b"/>
-    <p:sldId xmlns:r="http://schemas.openxmlformats.org/officeDocument/2006/relationships" id="258" r:id="R463590e69267490b"/>
-    <p:sldId xmlns:r="http://schemas.openxmlformats.org/officeDocument/2006/relationships" id="259" r:id="R241c60d8ea7d4fa6"/>
-    <p:sldId xmlns:r="http://schemas.openxmlformats.org/officeDocument/2006/relationships" id="260" r:id="Rf15be88a3309482c"/>
-    <p:sldId xmlns:r="http://schemas.openxmlformats.org/officeDocument/2006/relationships" id="261" r:id="R0caf7c35c4a84f92"/>
+    <p:sldId xmlns:r="http://schemas.openxmlformats.org/officeDocument/2006/relationships" id="256" r:id="R3b6c7634dd36463d"/>
+    <p:sldId xmlns:r="http://schemas.openxmlformats.org/officeDocument/2006/relationships" id="257" r:id="Rfadb232f3e33482f"/>
+    <p:sldId xmlns:r="http://schemas.openxmlformats.org/officeDocument/2006/relationships" id="258" r:id="R666a2cefd8ec41f7"/>
+    <p:sldId xmlns:r="http://schemas.openxmlformats.org/officeDocument/2006/relationships" id="259" r:id="Ra7810506c0ad42e9"/>
+    <p:sldId xmlns:r="http://schemas.openxmlformats.org/officeDocument/2006/relationships" id="260" r:id="R974debf9e80446ef"/>
+    <p:sldId xmlns:r="http://schemas.openxmlformats.org/officeDocument/2006/relationships" id="261" r:id="R91f089da18ad4f33"/>
   </p:sldIdLst>
   <p:sldSz cx="12192000" cy="6858000"/>
   <p:notesSz cx="6858000" cy="9144000"/>
@@ -447,7 +447,7 @@
           <a:lstStyle xmlns:a="http://schemas.openxmlformats.org/drawingml/2006/main"/>
           <a:p xmlns:a="http://schemas.openxmlformats.org/drawingml/2006/main">
             <a:r>
-              <a:t>Presenter timing: about 2 minutes. This workshop uses only the browser: GitHub file editing, a static published website, and OpenRouter. Participants sign in to GitHub and OpenRouter in advance. Ideally their static site is already published so build waiting does not consume the activity. Show the fixed demo and have the room vote. The screenshot is a labeled demo, not an AI response. Live mode calls OpenRouter directly from the page using each visitor's own key entered at runtime. We are not sharing an owner key in source code. The full group activity remains approximately 20 minutes after account and hosting preparation. Source: https://openrouter.ai/docs/quickstart.</a:t>
+              <a:t>Show the fixed demo and vote. Plan approximately 20 minutes with sign-ins and initial Pages publication prepared; account verification may take longer. GitHub Pages serves the public HTML. A Cloudflare Worker runs the API with a private key. GitHub Secrets feeds the deployment workflow, not browser JavaScript. The screenshot is a fixed demo, not live inference. Complete click-by-click guide: ai-would-you-rather/README.md in the repository.</a:t>
             </a:r>
           </a:p>
         </p:txBody>
@@ -517,7 +517,7 @@
           <a:lstStyle xmlns:a="http://schemas.openxmlformats.org/drawingml/2006/main"/>
           <a:p xmlns:a="http://schemas.openxmlformats.org/drawingml/2006/main">
             <a:r>
-              <a:t>Presenter timing: about 3 minutes if publication is already prepared. Open https://github.com/Casper3211/Static-Page-Demo. Each participant clicks Fork, chooses their own account, keeps the repository name, and clicks Create fork. Existing published copies can skip this. In their own repository, Settings &gt; Pages &gt; Build and deployment &gt; Source: Deploy from a branch. Choose main and /(root), then Save. Wait until Pages reports the site is live and click Visit site. On the homepage click Open the chatbot workshop. A default project URL has the shape https://YOUR-USERNAME.github.io/Static-Page-Demo/ai-would-you-rather/. Use the actual Visit site URL for custom domains or renamed repositories. A source file view on github.com is different from the published page. Participants need their own copy to commit changes. If they already use another static host, keep that existing publishing flow instead. Initial Pages publication can take several minutes; prepare it before the meeting. Source: https://docs.github.com/en/pages/getting-started-with-github-pages/configuring-a-publishing-source-for-your-github-pages-site.</a:t>
+              <a:t>Fork the repository into your own account. The fork includes all necessary files. For an existing website, copy ai-would-you-rather/ and .github/workflows/deploy-bot.yml, keeping paths. GitHub Add file &gt; Create new file can create the hidden workflow path. If Pages is already enabled, skip enabling it. Record the published site hostname. Open ai-would-you-rather/ after the site base URL. For a local folder, the GitHub Desktop route is on the final slide and detailed in README. Source: https://docs.github.com/en/pages/getting-started-with-github-pages/configuring-a-publishing-source-for-your-github-pages-site</a:t>
             </a:r>
           </a:p>
         </p:txBody>
@@ -587,7 +587,7 @@
           <a:lstStyle xmlns:a="http://schemas.openxmlformats.org/drawingml/2006/main"/>
           <a:p xmlns:a="http://schemas.openxmlformats.org/drawingml/2006/main">
             <a:r>
-              <a:t>Presenter timing: about 3 minutes. In your repository Code tab open ai-would-you-rather, then index.html. Click the pencil icon to edit. If GitHub asks to fork, return to your own fork. Search EDIT 2 in the browser/editor and change the text inside h1 while keeping HTML tags intact. For example Would you rather becomes Pick your weird power. EDIT 1 near the top controls the accent color via --accent. Click Commit changes at the top right, enter a short description, choose Commit directly to the main branch for your own workshop copy, and confirm Commit changes. GitHub stores the edit and the connected static host publishes it. Use the actual publishing status before refreshing the live site. This page also contains BOT CSS, BOT HTML and BOT SCRIPT blocks if students want to copy the entire floating widget into an existing single-file website. Keep all three blocks together. Source: https://docs.github.com/en/repositories/working-with-files/managing-files/editing-files.</a:t>
+              <a:t>Open https://openrouter.ai/settings/keys after creating an account. Create a workshop key and copy it privately. GitHub Settings &gt; Secrets and variables &gt; Actions &gt; New repository secret: OPENROUTER_API_KEY. In Cloudflare finish Workers onboarding and select a workers.dev subdomain if prompted. Copy Account ID from the account dashboard. My Profile &gt; API Tokens &gt; Create Token &gt; Edit Cloudflare Workers; scope to your account. Create and copy token. Save CLOUDFLARE_API_TOKEN and CLOUDFLARE_ACCOUNT_ID as separate repository secrets in GitHub. Never paste credentials into code or slides. The provided workflow uses repository secrets; environment secrets require an environment on the workflow job. Forks do not inherit secrets. Source: https://github.com/cloudflare/wrangler-action</a:t>
             </a:r>
           </a:p>
         </p:txBody>
@@ -657,7 +657,7 @@
           <a:lstStyle xmlns:a="http://schemas.openxmlformats.org/drawingml/2006/main"/>
           <a:p xmlns:a="http://schemas.openxmlformats.org/drawingml/2006/main">
             <a:r>
-              <a:t>Presenter timing: about 4 minutes. Open https://openrouter.ai/settings/keys in another tab, sign in, create a key and copy it privately. Return to the published game, open the floating panel, paste into the password field, and click Use my key. Do not paste the key into GitHub's HTML editor. Use my key keeps the value in a JavaScript variable and clears the password field; it does not itself authenticate or spend a request. Send a theme to test the key. The page makes a POST request directly to https://openrouter.ai/api/v1/chat/completions with Authorization: Bearer and JSON model/messages. It reads choices[0].message.content as text. MODEL is nvidia/nemotron-3-ultra-550b-a55b:free. No backend or environment file is involved. Each visitor uses their own quota. The app writes no keys to browser storage. Refresh, page departure, Clear key or Try demo clears the in-memory key. Only paste your own key into code you trust; page scripts can access it while used. Use fictional themes because provider logging applies. Try demo needs no key and produces a labeled fixed question. Sources: https://openrouter.ai/docs/quickstart; https://openrouter.ai/docs/guides/overview/auth/oauth; https://openrouter.ai/nvidia/nemotron-3-ultra-550b-a55b:free?view=api.</a:t>
+              <a:t>File paths on this slide are inside ai-would-you-rather/. Edit api/wrangler.jsonc. ALLOWED_ORIGIN must be your exact published origin: scheme plus hostname, no repository path or trailing slash. Custom domains use their actual origin. Change name if ai-club-game would overwrite an unrelated existing Worker in your account. Commit. In a fork enable Actions if prompted. Choose Deploy AI bot &gt; Run workflow &gt; main &gt; Run workflow. Wait for green. Cloudflare Workers &amp; Pages &gt; ai-club-game shows its workers.dev URL. GitHub Actions installs deployment tooling remotely and copies OPENROUTER_API_KEY to the Worker private environment. Participants run no terminal commands. Later api/ changes redeploy automatically. CORS is not authentication; this public demo shares the owner quota. Remove Worker or revoke key after the workshop. Sources: https://github.com/cloudflare/wrangler-action and https://developers.cloudflare.com/workers/configuration/secrets/</a:t>
             </a:r>
           </a:p>
         </p:txBody>
@@ -727,7 +727,7 @@
           <a:lstStyle xmlns:a="http://schemas.openxmlformats.org/drawingml/2006/main"/>
           <a:p xmlns:a="http://schemas.openxmlformats.org/drawingml/2006/main">
             <a:r>
-              <a:t>Presenter timing: about 5 minutes. In your fork reopen ai-would-you-rather/index.html and click the pencil. Search EDIT 3. Edit the text between the backticks after const INSTRUCTIONS =, keeping both backticks and the semicolon. Choose one change: food-only, extremely silly, or one sentence per choice. The model receives this as the system message. Leave MODEL unchanged to use the selected free endpoint. API_URL is the OpenRouter chat endpoint. The user's theme becomes the user message. Commit the change to main and wait for the host to publish it. Compare the same theme before and after. Prompt edits guide output but do not guarantee it. Demo output stays fixed, so use live mode to evaluate prompt changes. Source: https://openrouter.ai/docs/quickstart.</a:t>
+              <a:t>Replace only the quoted API_URL placeholder. Example shape: https://ai-club-game.YOUR-SUBDOMAIN.workers.dev/api/chat. This is a public URL, not a secret. Keep quotes and semicolon. Commit changes and wait for the Pages publication. Open the published site and send superpowers. The full-page link uses ?view=bot; it is the same HTML and same backend. Try demo sends no API request and returns a fixed labeled example. Use AI switches back. No key is entered on the website. Missing configuration shows a setup message. Provider busy/quota errors: wait or use demo. A network/CORS error means check API_URL and ALLOWED_ORIGIN. Selected model: nvidia/nemotron-3-ultra-550b-a55b:free, no paid fallback. Live inference needs your configured account. Source: https://openrouter.ai/nvidia/nemotron-3-ultra-550b-a55b:free?view=api</a:t>
             </a:r>
           </a:p>
         </p:txBody>
@@ -797,7 +797,7 @@
           <a:lstStyle xmlns:a="http://schemas.openxmlformats.org/drawingml/2006/main"/>
           <a:p xmlns:a="http://schemas.openxmlformats.org/drawingml/2006/main">
             <a:r>
-              <a:t>Presenter timing: about 3 minutes. Check repository Actions for the Pages build or the existing static host's status, then refresh the published URL. Refresh removes the runtime key, so paste it again and click Use my key. Ask the same theme and compare. One person edits, one tests, and everyone can vote A or B. If the old version appears, confirm the right fork and published path and wait for a successful deployment. 401: key rejected. 429: provider busy or quota exhausted. Slow response: wait or use Try demo. The no-key demo is a fixed example and does not demonstrate prompt changes. The outcome is a published static HTML game editable entirely in GitHub. Sources: https://openrouter.ai/docs/api-reference/errors; https://docs.github.com/en/pages/getting-started-with-github-pages/configuring-a-publishing-source-for-your-github-pages-site.</a:t>
+              <a:t>Paths are inside ai-would-you-rather/. For AI instructions edit text between the backticks after INSTRUCTIONS in api/worker.mjs. Keep backticks and semicolon. Wait for Deploy AI bot to finish; HTML changes wait for Pages. GitHub Desktop: sign in &gt; File &gt; Clone repository &gt; select your fork and local folder. Edit in your editor, save, return to Desktop, review changes, type a summary, Commit to main &gt; Push origin. Fetch/Pull first if you also edited on GitHub. Existing local folder: File &gt; Add local repository; if not a repository use create a repository here. Put site and demo files in that folder including .github/workflows, commit, Publish repository, then configure Pages and secrets. Never store keys in the folder. Local double-click supports layout and fixed demo; live AI should be tested at the published HTTPS origin. Ask the same theme before and after the prompt change. Everyone votes; no terminal needed. Full detailed instructions and troubleshooting are in the repository README.</a:t>
             </a:r>
           </a:p>
         </p:txBody>
@@ -865,7 +865,7 @@
   </p:cSld>
   <p:clrMap bg1="lt1" tx1="dk1" bg2="lt2" tx2="dk2" accent1="accent1" accent2="accent2" accent3="accent3" accent4="accent4" accent5="accent5" accent6="accent6" hlink="hlink" folHlink="folHlink"/>
   <p:sldLayoutIdLst>
-    <p:sldLayoutId xmlns:r="http://schemas.openxmlformats.org/officeDocument/2006/relationships" id="2147483649" r:id="R4b023fa7a0294cf2"/>
+    <p:sldLayoutId xmlns:r="http://schemas.openxmlformats.org/officeDocument/2006/relationships" id="2147483649" r:id="R44f100c9bfe647ca"/>
   </p:sldLayoutIdLst>
   <p:txStyles>
     <p:titleStyle>
@@ -1580,7 +1580,7 @@
                 <a:ea typeface="Arial"/>
                 <a:cs typeface="Arial"/>
               </a:rPr>
-              <a:t>One HTML file. Edit it on GitHub. Play in your browser.</a:t>
+              <a:t>Build a game on your website. Keep the AI key private.</a:t>
             </a:r>
           </a:p>
         </p:txBody>
@@ -1696,7 +1696,7 @@
                 <a:ea typeface="Arial"/>
                 <a:cs typeface="Arial"/>
               </a:rPr>
-              <a:t>THE IDEA</a:t>
+              <a:t>PICK A THEME</a:t>
             </a:r>
           </a:p>
         </p:txBody>
@@ -1754,7 +1754,7 @@
                 <a:ea typeface="Arial"/>
                 <a:cs typeface="Arial"/>
               </a:rPr>
-              <a:t>Pick a theme.</a:t>
+              <a:t>Get two funny choices.</a:t>
             </a:r>
           </a:p>
           <a:p xmlns:a="http://schemas.openxmlformats.org/drawingml/2006/main">
@@ -1783,7 +1783,7 @@
                 <a:ea typeface="Arial"/>
                 <a:cs typeface="Arial"/>
               </a:rPr>
-              <a:t>Get two funny choices.</a:t>
+              <a:t>Vote A or B.</a:t>
             </a:r>
           </a:p>
           <a:p xmlns:a="http://schemas.openxmlformats.org/drawingml/2006/main">
@@ -1812,7 +1812,7 @@
                 <a:ea typeface="Arial"/>
                 <a:cs typeface="Arial"/>
               </a:rPr>
-              <a:t>Choose one and explain why.</a:t>
+              <a:t>Defend your answer.</a:t>
             </a:r>
           </a:p>
         </p:txBody>
@@ -1910,7 +1910,7 @@
           <a:p xmlns:a="http://schemas.openxmlformats.org/drawingml/2006/main">
             <a:pPr algn="l">
               <a:buNone/>
-              <a:defRPr sz="1800" b="1">
+              <a:defRPr sz="1725" b="1">
                 <a:solidFill>
                   <a:srgbClr val="087E80"/>
                 </a:solidFill>
@@ -1920,7 +1920,7 @@
               </a:defRPr>
             </a:pPr>
             <a:r>
-              <a:rPr sz="1800" b="1">
+              <a:rPr sz="1725" b="1">
                 <a:solidFill>
                   <a:srgbClr val="087E80"/>
                 </a:solidFill>
@@ -1928,7 +1928,7 @@
                 <a:ea typeface="Arial"/>
                 <a:cs typeface="Arial"/>
               </a:rPr>
-              <a:t>Try: “Give me a question about superpowers.”</a:t>
+              <a:t>Floating chat button or full-page game — same API.</a:t>
             </a:r>
           </a:p>
         </p:txBody>
@@ -1942,7 +1942,7 @@
           <p:nvPr/>
         </p:nvPicPr>
         <p:blipFill>
-          <a:blip xmlns:r="http://schemas.openxmlformats.org/officeDocument/2006/relationships" xmlns:a="http://schemas.openxmlformats.org/drawingml/2006/main" r:embed="R60e1a01f8e7f464c"/>
+          <a:blip xmlns:r="http://schemas.openxmlformats.org/officeDocument/2006/relationships" xmlns:a="http://schemas.openxmlformats.org/drawingml/2006/main" r:embed="Rd0672ce32cdd4587"/>
           <a:stretch xmlns:a="http://schemas.openxmlformats.org/drawingml/2006/main"/>
         </p:blipFill>
         <p:spPr>
@@ -2095,7 +2095,7 @@
                 <a:ea typeface="Arial"/>
                 <a:cs typeface="Arial"/>
               </a:rPr>
-              <a:t>Your GitHub website</a:t>
+              <a:t>Start with your GitHub website</a:t>
             </a:r>
           </a:p>
         </p:txBody>
@@ -2153,7 +2153,7 @@
                 <a:ea typeface="Arial"/>
                 <a:cs typeface="Arial"/>
               </a:rPr>
-              <a:t>Already have a published copy? Keep using it.</a:t>
+              <a:t>Already published? Keep your site and add the demo files.</a:t>
             </a:r>
           </a:p>
         </p:txBody>
@@ -2309,25 +2309,25 @@
           <a:p xmlns:a="http://schemas.openxmlformats.org/drawingml/2006/main">
             <a:pPr algn="l">
               <a:buNone/>
-              <a:defRPr sz="2175" b="1">
-                <a:solidFill>
-                  <a:srgbClr val="142D32"/>
-                </a:solidFill>
-                <a:latin typeface="Arial"/>
-                <a:ea typeface="Arial"/>
-                <a:cs typeface="Arial"/>
-              </a:defRPr>
-            </a:pPr>
-            <a:r>
-              <a:rPr sz="2175" b="1">
-                <a:solidFill>
-                  <a:srgbClr val="142D32"/>
-                </a:solidFill>
-                <a:latin typeface="Arial"/>
-                <a:ea typeface="Arial"/>
-                <a:cs typeface="Arial"/>
-              </a:rPr>
-              <a:t>Your own copy</a:t>
+              <a:defRPr sz="1950" b="1">
+                <a:solidFill>
+                  <a:srgbClr val="142D32"/>
+                </a:solidFill>
+                <a:latin typeface="Arial"/>
+                <a:ea typeface="Arial"/>
+                <a:cs typeface="Arial"/>
+              </a:defRPr>
+            </a:pPr>
+            <a:r>
+              <a:rPr sz="1950" b="1">
+                <a:solidFill>
+                  <a:srgbClr val="142D32"/>
+                </a:solidFill>
+                <a:latin typeface="Arial"/>
+                <a:ea typeface="Arial"/>
+                <a:cs typeface="Arial"/>
+              </a:rPr>
+              <a:t>Get the demo</a:t>
             </a:r>
           </a:p>
         </p:txBody>
@@ -2367,7 +2367,7 @@
           <a:p xmlns:a="http://schemas.openxmlformats.org/drawingml/2006/main">
             <a:pPr algn="l">
               <a:buNone/>
-              <a:defRPr sz="1875" b="0">
+              <a:defRPr sz="1800" b="0">
                 <a:solidFill>
                   <a:srgbClr val="53686C"/>
                 </a:solidFill>
@@ -2377,7 +2377,7 @@
               </a:defRPr>
             </a:pPr>
             <a:r>
-              <a:rPr sz="1875" b="0">
+              <a:rPr sz="1800" b="0">
                 <a:solidFill>
                   <a:srgbClr val="53686C"/>
                 </a:solidFill>
@@ -2385,7 +2385,7 @@
                 <a:ea typeface="Arial"/>
                 <a:cs typeface="Arial"/>
               </a:rPr>
-              <a:t>Open the demo repository, then Fork.</a:t>
+              <a:t>github.com/Casper3211/Static-Page-Demo → Fork</a:t>
             </a:r>
           </a:p>
         </p:txBody>
@@ -2483,25 +2483,25 @@
           <a:p xmlns:a="http://schemas.openxmlformats.org/drawingml/2006/main">
             <a:pPr algn="l">
               <a:buNone/>
-              <a:defRPr sz="2175" b="1">
-                <a:solidFill>
-                  <a:srgbClr val="142D32"/>
-                </a:solidFill>
-                <a:latin typeface="Arial"/>
-                <a:ea typeface="Arial"/>
-                <a:cs typeface="Arial"/>
-              </a:defRPr>
-            </a:pPr>
-            <a:r>
-              <a:rPr sz="2175" b="1">
-                <a:solidFill>
-                  <a:srgbClr val="142D32"/>
-                </a:solidFill>
-                <a:latin typeface="Arial"/>
-                <a:ea typeface="Arial"/>
-                <a:cs typeface="Arial"/>
-              </a:rPr>
-              <a:t>Pages settings</a:t>
+              <a:defRPr sz="1950" b="1">
+                <a:solidFill>
+                  <a:srgbClr val="142D32"/>
+                </a:solidFill>
+                <a:latin typeface="Arial"/>
+                <a:ea typeface="Arial"/>
+                <a:cs typeface="Arial"/>
+              </a:defRPr>
+            </a:pPr>
+            <a:r>
+              <a:rPr sz="1950" b="1">
+                <a:solidFill>
+                  <a:srgbClr val="142D32"/>
+                </a:solidFill>
+                <a:latin typeface="Arial"/>
+                <a:ea typeface="Arial"/>
+                <a:cs typeface="Arial"/>
+              </a:rPr>
+              <a:t>Existing website</a:t>
             </a:r>
           </a:p>
         </p:txBody>
@@ -2541,7 +2541,7 @@
           <a:p xmlns:a="http://schemas.openxmlformats.org/drawingml/2006/main">
             <a:pPr algn="l">
               <a:buNone/>
-              <a:defRPr sz="1875" b="0">
+              <a:defRPr sz="1800" b="0">
                 <a:solidFill>
                   <a:srgbClr val="53686C"/>
                 </a:solidFill>
@@ -2551,7 +2551,7 @@
               </a:defRPr>
             </a:pPr>
             <a:r>
-              <a:rPr sz="1875" b="0">
+              <a:rPr sz="1800" b="0">
                 <a:solidFill>
                   <a:srgbClr val="53686C"/>
                 </a:solidFill>
@@ -2559,7 +2559,7 @@
                 <a:ea typeface="Arial"/>
                 <a:cs typeface="Arial"/>
               </a:rPr>
-              <a:t>Settings &gt; Pages &gt; Deploy from a branch</a:t>
+              <a:t>Copy ai-would-you-rather/ and .github/workflows/</a:t>
             </a:r>
           </a:p>
         </p:txBody>
@@ -2657,25 +2657,25 @@
           <a:p xmlns:a="http://schemas.openxmlformats.org/drawingml/2006/main">
             <a:pPr algn="l">
               <a:buNone/>
-              <a:defRPr sz="2175" b="1">
-                <a:solidFill>
-                  <a:srgbClr val="142D32"/>
-                </a:solidFill>
-                <a:latin typeface="Arial"/>
-                <a:ea typeface="Arial"/>
-                <a:cs typeface="Arial"/>
-              </a:defRPr>
-            </a:pPr>
-            <a:r>
-              <a:rPr sz="2175" b="1">
-                <a:solidFill>
-                  <a:srgbClr val="142D32"/>
-                </a:solidFill>
-                <a:latin typeface="Arial"/>
-                <a:ea typeface="Arial"/>
-                <a:cs typeface="Arial"/>
-              </a:rPr>
-              <a:t>Publish</a:t>
+              <a:defRPr sz="1950" b="1">
+                <a:solidFill>
+                  <a:srgbClr val="142D32"/>
+                </a:solidFill>
+                <a:latin typeface="Arial"/>
+                <a:ea typeface="Arial"/>
+                <a:cs typeface="Arial"/>
+              </a:defRPr>
+            </a:pPr>
+            <a:r>
+              <a:rPr sz="1950" b="1">
+                <a:solidFill>
+                  <a:srgbClr val="142D32"/>
+                </a:solidFill>
+                <a:latin typeface="Arial"/>
+                <a:ea typeface="Arial"/>
+                <a:cs typeface="Arial"/>
+              </a:rPr>
+              <a:t>Enable Pages</a:t>
             </a:r>
           </a:p>
         </p:txBody>
@@ -2715,7 +2715,7 @@
           <a:p xmlns:a="http://schemas.openxmlformats.org/drawingml/2006/main">
             <a:pPr algn="l">
               <a:buNone/>
-              <a:defRPr sz="1875" b="0">
+              <a:defRPr sz="1800" b="0">
                 <a:solidFill>
                   <a:srgbClr val="53686C"/>
                 </a:solidFill>
@@ -2725,7 +2725,7 @@
               </a:defRPr>
             </a:pPr>
             <a:r>
-              <a:rPr sz="1875" b="0">
+              <a:rPr sz="1800" b="0">
                 <a:solidFill>
                   <a:srgbClr val="53686C"/>
                 </a:solidFill>
@@ -2733,7 +2733,7 @@
                 <a:ea typeface="Arial"/>
                 <a:cs typeface="Arial"/>
               </a:rPr>
-              <a:t>Choose main and /(root), then Save.</a:t>
+              <a:t>Settings → Pages → Deploy from a branch</a:t>
             </a:r>
           </a:p>
         </p:txBody>
@@ -2831,25 +2831,25 @@
           <a:p xmlns:a="http://schemas.openxmlformats.org/drawingml/2006/main">
             <a:pPr algn="l">
               <a:buNone/>
-              <a:defRPr sz="2175" b="1">
-                <a:solidFill>
-                  <a:srgbClr val="142D32"/>
-                </a:solidFill>
-                <a:latin typeface="Arial"/>
-                <a:ea typeface="Arial"/>
-                <a:cs typeface="Arial"/>
-              </a:defRPr>
-            </a:pPr>
-            <a:r>
-              <a:rPr sz="2175" b="1">
-                <a:solidFill>
-                  <a:srgbClr val="142D32"/>
-                </a:solidFill>
-                <a:latin typeface="Arial"/>
-                <a:ea typeface="Arial"/>
-                <a:cs typeface="Arial"/>
-              </a:rPr>
-              <a:t>Open the game</a:t>
+              <a:defRPr sz="1950" b="1">
+                <a:solidFill>
+                  <a:srgbClr val="142D32"/>
+                </a:solidFill>
+                <a:latin typeface="Arial"/>
+                <a:ea typeface="Arial"/>
+                <a:cs typeface="Arial"/>
+              </a:defRPr>
+            </a:pPr>
+            <a:r>
+              <a:rPr sz="1950" b="1">
+                <a:solidFill>
+                  <a:srgbClr val="142D32"/>
+                </a:solidFill>
+                <a:latin typeface="Arial"/>
+                <a:ea typeface="Arial"/>
+                <a:cs typeface="Arial"/>
+              </a:rPr>
+              <a:t>Publish</a:t>
             </a:r>
           </a:p>
         </p:txBody>
@@ -2889,7 +2889,7 @@
           <a:p xmlns:a="http://schemas.openxmlformats.org/drawingml/2006/main">
             <a:pPr algn="l">
               <a:buNone/>
-              <a:defRPr sz="1875" b="0">
+              <a:defRPr sz="1800" b="0">
                 <a:solidFill>
                   <a:srgbClr val="53686C"/>
                 </a:solidFill>
@@ -2899,7 +2899,7 @@
               </a:defRPr>
             </a:pPr>
             <a:r>
-              <a:rPr sz="1875" b="0">
+              <a:rPr sz="1800" b="0">
                 <a:solidFill>
                   <a:srgbClr val="53686C"/>
                 </a:solidFill>
@@ -2907,7 +2907,7 @@
                 <a:ea typeface="Arial"/>
                 <a:cs typeface="Arial"/>
               </a:rPr>
-              <a:t>Visit site, then click the chatbot workshop.</a:t>
+              <a:t>main → /(root) → Save → wait → Visit site</a:t>
             </a:r>
           </a:p>
         </p:txBody>
@@ -2943,10 +2943,10 @@
       </p:grpSpPr>
       <p:sp>
         <p:nvSpPr>
-          <p:cNvPr id="14" name="club">
-            <a:extLst xmlns:a="http://schemas.openxmlformats.org/drawingml/2006/main">
-              <a:ext uri="{FF2B5EF4-FFF2-40B4-BE49-F238E27FC236}">
-                <a16:creationId xmlns:a16="http://schemas.microsoft.com/office/drawing/2014/main" id="{B4EC50DC-7F40-4DF0-AD4C-53A03D406637}"/>
+          <p:cNvPr id="21" name="club">
+            <a:extLst xmlns:a="http://schemas.openxmlformats.org/drawingml/2006/main">
+              <a:ext uri="{FF2B5EF4-FFF2-40B4-BE49-F238E27FC236}">
+                <a16:creationId xmlns:a16="http://schemas.microsoft.com/office/drawing/2014/main" id="{366D60CB-0E69-4059-85C5-9B5236F59499}"/>
               </a:ext>
             </a:extLst>
           </p:cNvPr>
@@ -3004,7 +3004,7 @@
           <p:cNvPr id="3" name="title">
             <a:extLst xmlns:a="http://schemas.openxmlformats.org/drawingml/2006/main">
               <a:ext uri="{FF2B5EF4-FFF2-40B4-BE49-F238E27FC236}">
-                <a16:creationId xmlns:a16="http://schemas.microsoft.com/office/drawing/2014/main" id="{03E4BAF3-4E46-4487-B205-3D0C06A0154E}"/>
+                <a16:creationId xmlns:a16="http://schemas.microsoft.com/office/drawing/2014/main" id="{EF48F320-DD91-4BBA-B862-5084F2F45ADE}"/>
               </a:ext>
             </a:extLst>
           </p:cNvPr>
@@ -3052,7 +3052,7 @@
                 <a:ea typeface="Arial"/>
                 <a:cs typeface="Arial"/>
               </a:rPr>
-              <a:t>Edit one HTML file</a:t>
+              <a:t>Create accounts and save the keys</a:t>
             </a:r>
           </a:p>
         </p:txBody>
@@ -3062,7 +3062,7 @@
           <p:cNvPr id="4" name="subheader">
             <a:extLst xmlns:a="http://schemas.openxmlformats.org/drawingml/2006/main">
               <a:ext uri="{FF2B5EF4-FFF2-40B4-BE49-F238E27FC236}">
-                <a16:creationId xmlns:a16="http://schemas.microsoft.com/office/drawing/2014/main" id="{B4878439-B101-4B99-B8D0-0D10A6A52F83}"/>
+                <a16:creationId xmlns:a16="http://schemas.microsoft.com/office/drawing/2014/main" id="{5D6446FB-4749-41AC-9A7B-5675002E5DC1}"/>
               </a:ext>
             </a:extLst>
           </p:cNvPr>
@@ -3110,7 +3110,7 @@
                 <a:ea typeface="Arial"/>
                 <a:cs typeface="Arial"/>
               </a:rPr>
-              <a:t>Stay on GitHub in your own repository</a:t>
+              <a:t>GitHub → Settings → Secrets and variables → Actions</a:t>
             </a:r>
           </a:p>
         </p:txBody>
@@ -3120,7 +3120,7 @@
           <p:cNvPr id="8" name="footer-page">
             <a:extLst xmlns:a="http://schemas.openxmlformats.org/drawingml/2006/main">
               <a:ext uri="{FF2B5EF4-FFF2-40B4-BE49-F238E27FC236}">
-                <a16:creationId xmlns:a16="http://schemas.microsoft.com/office/drawing/2014/main" id="{008E3D44-4B38-4AF9-A814-FF598E0F2736}"/>
+                <a16:creationId xmlns:a16="http://schemas.microsoft.com/office/drawing/2014/main" id="{C8408FA6-E463-4CDD-B6F5-5DA963C5DA59}"/>
               </a:ext>
             </a:extLst>
           </p:cNvPr>
@@ -3175,122 +3175,156 @@
       </p:sp>
       <p:sp>
         <p:nvSpPr>
-          <p:cNvPr id="9" name="lead">
-            <a:extLst xmlns:a="http://schemas.openxmlformats.org/drawingml/2006/main">
-              <a:ext uri="{FF2B5EF4-FFF2-40B4-BE49-F238E27FC236}">
-                <a16:creationId xmlns:a16="http://schemas.microsoft.com/office/drawing/2014/main" id="{D12E5938-7A26-47FE-BAA6-BA78A948BC97}"/>
-              </a:ext>
-            </a:extLst>
-          </p:cNvPr>
-          <p:cNvSpPr>
-            <a:spLocks xmlns:a="http://schemas.openxmlformats.org/drawingml/2006/main" noGrp="1"/>
-          </p:cNvSpPr>
-          <p:nvPr/>
-        </p:nvSpPr>
-        <p:spPr>
-          <a:xfrm xmlns:a="http://schemas.openxmlformats.org/drawingml/2006/main">
-            <a:off x="609600" y="2914650"/>
-            <a:ext cx="5762625" cy="1190625"/>
-          </a:xfrm>
-          <a:prstGeom xmlns:a="http://schemas.openxmlformats.org/drawingml/2006/main" prst="rect">
-            <a:avLst/>
-          </a:prstGeom>
-          <a:noFill xmlns:a="http://schemas.openxmlformats.org/drawingml/2006/main"/>
-          <a:ln xmlns:a="http://schemas.openxmlformats.org/drawingml/2006/main" w="0">
-            <a:noFill/>
-          </a:ln>
-        </p:spPr>
-        <p:txBody>
-          <a:bodyPr xmlns:a="http://schemas.openxmlformats.org/drawingml/2006/main" wrap="none" lIns="0" tIns="0" rIns="0" bIns="0" anchor="t">
-            <a:noAutofit/>
-          </a:bodyPr>
-          <a:lstStyle xmlns:a="http://schemas.openxmlformats.org/drawingml/2006/main"/>
-          <a:p xmlns:a="http://schemas.openxmlformats.org/drawingml/2006/main">
-            <a:pPr algn="l">
-              <a:buNone/>
-              <a:defRPr sz="2475" b="1">
-                <a:solidFill>
-                  <a:srgbClr val="142D32"/>
-                </a:solidFill>
-                <a:latin typeface="Arial"/>
-                <a:ea typeface="Arial"/>
-                <a:cs typeface="Arial"/>
-              </a:defRPr>
-            </a:pPr>
-            <a:r>
-              <a:rPr sz="2475" b="1">
-                <a:solidFill>
-                  <a:srgbClr val="142D32"/>
-                </a:solidFill>
-                <a:latin typeface="Arial"/>
-                <a:ea typeface="Arial"/>
-                <a:cs typeface="Arial"/>
-              </a:rPr>
-              <a:t>ai-would-you-rather/</a:t>
-            </a:r>
-          </a:p>
-          <a:p xmlns:a="http://schemas.openxmlformats.org/drawingml/2006/main">
-            <a:pPr algn="l">
-              <a:buNone/>
-              <a:defRPr sz="2475" b="1">
-                <a:solidFill>
-                  <a:srgbClr val="142D32"/>
-                </a:solidFill>
-                <a:latin typeface="Arial"/>
-                <a:ea typeface="Arial"/>
-                <a:cs typeface="Arial"/>
-              </a:defRPr>
-            </a:pPr>
-            <a:r>
-              <a:rPr sz="2475" b="1">
-                <a:solidFill>
-                  <a:srgbClr val="142D32"/>
-                </a:solidFill>
-                <a:latin typeface="Arial"/>
-                <a:ea typeface="Arial"/>
-                <a:cs typeface="Arial"/>
-              </a:rPr>
-              <a:t>index.html</a:t>
-            </a:r>
-          </a:p>
-        </p:txBody>
-      </p:sp>
-      <p:sp>
-        <p:nvSpPr>
-          <p:cNvPr id="10" name="lead-detail">
-            <a:extLst xmlns:a="http://schemas.openxmlformats.org/drawingml/2006/main">
-              <a:ext uri="{FF2B5EF4-FFF2-40B4-BE49-F238E27FC236}">
-                <a16:creationId xmlns:a16="http://schemas.microsoft.com/office/drawing/2014/main" id="{5F71AD43-4046-4D49-B823-17EA0FEC5825}"/>
-              </a:ext>
-            </a:extLst>
-          </p:cNvPr>
-          <p:cNvSpPr>
-            <a:spLocks xmlns:a="http://schemas.openxmlformats.org/drawingml/2006/main" noGrp="1"/>
-          </p:cNvSpPr>
-          <p:nvPr/>
-        </p:nvSpPr>
-        <p:spPr>
-          <a:xfrm xmlns:a="http://schemas.openxmlformats.org/drawingml/2006/main">
-            <a:off x="609600" y="4448175"/>
-            <a:ext cx="5391150" cy="876300"/>
-          </a:xfrm>
-          <a:prstGeom xmlns:a="http://schemas.openxmlformats.org/drawingml/2006/main" prst="rect">
-            <a:avLst/>
-          </a:prstGeom>
-          <a:noFill xmlns:a="http://schemas.openxmlformats.org/drawingml/2006/main"/>
-          <a:ln xmlns:a="http://schemas.openxmlformats.org/drawingml/2006/main" w="0">
-            <a:noFill/>
-          </a:ln>
-        </p:spPr>
-        <p:txBody>
-          <a:bodyPr xmlns:a="http://schemas.openxmlformats.org/drawingml/2006/main" wrap="none" lIns="0" tIns="0" rIns="0" bIns="0" anchor="t">
-            <a:noAutofit/>
-          </a:bodyPr>
-          <a:lstStyle xmlns:a="http://schemas.openxmlformats.org/drawingml/2006/main"/>
-          <a:p xmlns:a="http://schemas.openxmlformats.org/drawingml/2006/main">
-            <a:pPr algn="l">
-              <a:buNone/>
-              <a:defRPr sz="2175" b="0">
+          <p:cNvPr id="9" name="number-0">
+            <a:extLst xmlns:a="http://schemas.openxmlformats.org/drawingml/2006/main">
+              <a:ext uri="{FF2B5EF4-FFF2-40B4-BE49-F238E27FC236}">
+                <a16:creationId xmlns:a16="http://schemas.microsoft.com/office/drawing/2014/main" id="{51BDE694-C556-45C9-8B16-C8598B27536B}"/>
+              </a:ext>
+            </a:extLst>
+          </p:cNvPr>
+          <p:cNvSpPr>
+            <a:spLocks xmlns:a="http://schemas.openxmlformats.org/drawingml/2006/main" noGrp="1"/>
+          </p:cNvSpPr>
+          <p:nvPr/>
+        </p:nvSpPr>
+        <p:spPr>
+          <a:xfrm xmlns:a="http://schemas.openxmlformats.org/drawingml/2006/main">
+            <a:off x="609600" y="2762250"/>
+            <a:ext cx="800100" cy="438150"/>
+          </a:xfrm>
+          <a:prstGeom xmlns:a="http://schemas.openxmlformats.org/drawingml/2006/main" prst="rect">
+            <a:avLst/>
+          </a:prstGeom>
+          <a:noFill xmlns:a="http://schemas.openxmlformats.org/drawingml/2006/main"/>
+          <a:ln xmlns:a="http://schemas.openxmlformats.org/drawingml/2006/main" w="0">
+            <a:noFill/>
+          </a:ln>
+        </p:spPr>
+        <p:txBody>
+          <a:bodyPr xmlns:a="http://schemas.openxmlformats.org/drawingml/2006/main" wrap="none" lIns="0" tIns="0" rIns="0" bIns="0" anchor="t">
+            <a:noAutofit/>
+          </a:bodyPr>
+          <a:lstStyle xmlns:a="http://schemas.openxmlformats.org/drawingml/2006/main"/>
+          <a:p xmlns:a="http://schemas.openxmlformats.org/drawingml/2006/main">
+            <a:pPr algn="l">
+              <a:buNone/>
+              <a:defRPr sz="2400" b="1">
+                <a:solidFill>
+                  <a:srgbClr val="087E80"/>
+                </a:solidFill>
+                <a:latin typeface="Arial"/>
+                <a:ea typeface="Arial"/>
+                <a:cs typeface="Arial"/>
+              </a:defRPr>
+            </a:pPr>
+            <a:r>
+              <a:rPr sz="2400" b="1">
+                <a:solidFill>
+                  <a:srgbClr val="087E80"/>
+                </a:solidFill>
+                <a:latin typeface="Arial"/>
+                <a:ea typeface="Arial"/>
+                <a:cs typeface="Arial"/>
+              </a:rPr>
+              <a:t>01</a:t>
+            </a:r>
+          </a:p>
+        </p:txBody>
+      </p:sp>
+      <p:sp>
+        <p:nvSpPr>
+          <p:cNvPr id="10" name="label-0">
+            <a:extLst xmlns:a="http://schemas.openxmlformats.org/drawingml/2006/main">
+              <a:ext uri="{FF2B5EF4-FFF2-40B4-BE49-F238E27FC236}">
+                <a16:creationId xmlns:a16="http://schemas.microsoft.com/office/drawing/2014/main" id="{E901CE81-5B34-4D37-86AA-33C33C0D7159}"/>
+              </a:ext>
+            </a:extLst>
+          </p:cNvPr>
+          <p:cNvSpPr>
+            <a:spLocks xmlns:a="http://schemas.openxmlformats.org/drawingml/2006/main" noGrp="1"/>
+          </p:cNvSpPr>
+          <p:nvPr/>
+        </p:nvSpPr>
+        <p:spPr>
+          <a:xfrm xmlns:a="http://schemas.openxmlformats.org/drawingml/2006/main">
+            <a:off x="1638300" y="2762250"/>
+            <a:ext cx="2476500" cy="438150"/>
+          </a:xfrm>
+          <a:prstGeom xmlns:a="http://schemas.openxmlformats.org/drawingml/2006/main" prst="rect">
+            <a:avLst/>
+          </a:prstGeom>
+          <a:noFill xmlns:a="http://schemas.openxmlformats.org/drawingml/2006/main"/>
+          <a:ln xmlns:a="http://schemas.openxmlformats.org/drawingml/2006/main" w="0">
+            <a:noFill/>
+          </a:ln>
+        </p:spPr>
+        <p:txBody>
+          <a:bodyPr xmlns:a="http://schemas.openxmlformats.org/drawingml/2006/main" wrap="none" lIns="0" tIns="0" rIns="0" bIns="0" anchor="t">
+            <a:noAutofit/>
+          </a:bodyPr>
+          <a:lstStyle xmlns:a="http://schemas.openxmlformats.org/drawingml/2006/main"/>
+          <a:p xmlns:a="http://schemas.openxmlformats.org/drawingml/2006/main">
+            <a:pPr algn="l">
+              <a:buNone/>
+              <a:defRPr sz="1950" b="1">
+                <a:solidFill>
+                  <a:srgbClr val="142D32"/>
+                </a:solidFill>
+                <a:latin typeface="Arial"/>
+                <a:ea typeface="Arial"/>
+                <a:cs typeface="Arial"/>
+              </a:defRPr>
+            </a:pPr>
+            <a:r>
+              <a:rPr sz="1950" b="1">
+                <a:solidFill>
+                  <a:srgbClr val="142D32"/>
+                </a:solidFill>
+                <a:latin typeface="Arial"/>
+                <a:ea typeface="Arial"/>
+                <a:cs typeface="Arial"/>
+              </a:rPr>
+              <a:t>OpenRouter</a:t>
+            </a:r>
+          </a:p>
+        </p:txBody>
+      </p:sp>
+      <p:sp>
+        <p:nvSpPr>
+          <p:cNvPr id="11" name="detail-0">
+            <a:extLst xmlns:a="http://schemas.openxmlformats.org/drawingml/2006/main">
+              <a:ext uri="{FF2B5EF4-FFF2-40B4-BE49-F238E27FC236}">
+                <a16:creationId xmlns:a16="http://schemas.microsoft.com/office/drawing/2014/main" id="{BD0ED1E0-713C-4C6D-929D-E0FBED8AF2E8}"/>
+              </a:ext>
+            </a:extLst>
+          </p:cNvPr>
+          <p:cNvSpPr>
+            <a:spLocks xmlns:a="http://schemas.openxmlformats.org/drawingml/2006/main" noGrp="1"/>
+          </p:cNvSpPr>
+          <p:nvPr/>
+        </p:nvSpPr>
+        <p:spPr>
+          <a:xfrm xmlns:a="http://schemas.openxmlformats.org/drawingml/2006/main">
+            <a:off x="4476750" y="2790825"/>
+            <a:ext cx="7067550" cy="409575"/>
+          </a:xfrm>
+          <a:prstGeom xmlns:a="http://schemas.openxmlformats.org/drawingml/2006/main" prst="rect">
+            <a:avLst/>
+          </a:prstGeom>
+          <a:noFill xmlns:a="http://schemas.openxmlformats.org/drawingml/2006/main"/>
+          <a:ln xmlns:a="http://schemas.openxmlformats.org/drawingml/2006/main" w="0">
+            <a:noFill/>
+          </a:ln>
+        </p:spPr>
+        <p:txBody>
+          <a:bodyPr xmlns:a="http://schemas.openxmlformats.org/drawingml/2006/main" wrap="none" lIns="0" tIns="0" rIns="0" bIns="0" anchor="t">
+            <a:noAutofit/>
+          </a:bodyPr>
+          <a:lstStyle xmlns:a="http://schemas.openxmlformats.org/drawingml/2006/main"/>
+          <a:p xmlns:a="http://schemas.openxmlformats.org/drawingml/2006/main">
+            <a:pPr algn="l">
+              <a:buNone/>
+              <a:defRPr sz="1800" b="0">
                 <a:solidFill>
                   <a:srgbClr val="53686C"/>
                 </a:solidFill>
@@ -3300,7 +3334,7 @@
               </a:defRPr>
             </a:pPr>
             <a:r>
-              <a:rPr sz="2175" b="0">
+              <a:rPr sz="1800" b="0">
                 <a:solidFill>
                   <a:srgbClr val="53686C"/>
                 </a:solidFill>
@@ -3308,13 +3342,163 @@
                 <a:ea typeface="Arial"/>
                 <a:cs typeface="Arial"/>
               </a:rPr>
-              <a:t>Open the file.</a:t>
-            </a:r>
-          </a:p>
-          <a:p xmlns:a="http://schemas.openxmlformats.org/drawingml/2006/main">
-            <a:pPr algn="l">
-              <a:buNone/>
-              <a:defRPr sz="2175" b="0">
+              <a:t>Sign up → settings/keys → Create Key</a:t>
+            </a:r>
+          </a:p>
+        </p:txBody>
+      </p:sp>
+      <p:sp>
+        <p:nvSpPr>
+          <p:cNvPr id="12" name="number-1">
+            <a:extLst xmlns:a="http://schemas.openxmlformats.org/drawingml/2006/main">
+              <a:ext uri="{FF2B5EF4-FFF2-40B4-BE49-F238E27FC236}">
+                <a16:creationId xmlns:a16="http://schemas.microsoft.com/office/drawing/2014/main" id="{AD5A7334-AE57-4202-9AFA-95A3587926EB}"/>
+              </a:ext>
+            </a:extLst>
+          </p:cNvPr>
+          <p:cNvSpPr>
+            <a:spLocks xmlns:a="http://schemas.openxmlformats.org/drawingml/2006/main" noGrp="1"/>
+          </p:cNvSpPr>
+          <p:nvPr/>
+        </p:nvSpPr>
+        <p:spPr>
+          <a:xfrm xmlns:a="http://schemas.openxmlformats.org/drawingml/2006/main">
+            <a:off x="609600" y="3476625"/>
+            <a:ext cx="800100" cy="438150"/>
+          </a:xfrm>
+          <a:prstGeom xmlns:a="http://schemas.openxmlformats.org/drawingml/2006/main" prst="rect">
+            <a:avLst/>
+          </a:prstGeom>
+          <a:noFill xmlns:a="http://schemas.openxmlformats.org/drawingml/2006/main"/>
+          <a:ln xmlns:a="http://schemas.openxmlformats.org/drawingml/2006/main" w="0">
+            <a:noFill/>
+          </a:ln>
+        </p:spPr>
+        <p:txBody>
+          <a:bodyPr xmlns:a="http://schemas.openxmlformats.org/drawingml/2006/main" wrap="none" lIns="0" tIns="0" rIns="0" bIns="0" anchor="t">
+            <a:noAutofit/>
+          </a:bodyPr>
+          <a:lstStyle xmlns:a="http://schemas.openxmlformats.org/drawingml/2006/main"/>
+          <a:p xmlns:a="http://schemas.openxmlformats.org/drawingml/2006/main">
+            <a:pPr algn="l">
+              <a:buNone/>
+              <a:defRPr sz="2400" b="1">
+                <a:solidFill>
+                  <a:srgbClr val="087E80"/>
+                </a:solidFill>
+                <a:latin typeface="Arial"/>
+                <a:ea typeface="Arial"/>
+                <a:cs typeface="Arial"/>
+              </a:defRPr>
+            </a:pPr>
+            <a:r>
+              <a:rPr sz="2400" b="1">
+                <a:solidFill>
+                  <a:srgbClr val="087E80"/>
+                </a:solidFill>
+                <a:latin typeface="Arial"/>
+                <a:ea typeface="Arial"/>
+                <a:cs typeface="Arial"/>
+              </a:rPr>
+              <a:t>02</a:t>
+            </a:r>
+          </a:p>
+        </p:txBody>
+      </p:sp>
+      <p:sp>
+        <p:nvSpPr>
+          <p:cNvPr id="13" name="label-1">
+            <a:extLst xmlns:a="http://schemas.openxmlformats.org/drawingml/2006/main">
+              <a:ext uri="{FF2B5EF4-FFF2-40B4-BE49-F238E27FC236}">
+                <a16:creationId xmlns:a16="http://schemas.microsoft.com/office/drawing/2014/main" id="{103D2AB4-FD59-4411-8C36-0103588CA6F2}"/>
+              </a:ext>
+            </a:extLst>
+          </p:cNvPr>
+          <p:cNvSpPr>
+            <a:spLocks xmlns:a="http://schemas.openxmlformats.org/drawingml/2006/main" noGrp="1"/>
+          </p:cNvSpPr>
+          <p:nvPr/>
+        </p:nvSpPr>
+        <p:spPr>
+          <a:xfrm xmlns:a="http://schemas.openxmlformats.org/drawingml/2006/main">
+            <a:off x="1638300" y="3476625"/>
+            <a:ext cx="2476500" cy="438150"/>
+          </a:xfrm>
+          <a:prstGeom xmlns:a="http://schemas.openxmlformats.org/drawingml/2006/main" prst="rect">
+            <a:avLst/>
+          </a:prstGeom>
+          <a:noFill xmlns:a="http://schemas.openxmlformats.org/drawingml/2006/main"/>
+          <a:ln xmlns:a="http://schemas.openxmlformats.org/drawingml/2006/main" w="0">
+            <a:noFill/>
+          </a:ln>
+        </p:spPr>
+        <p:txBody>
+          <a:bodyPr xmlns:a="http://schemas.openxmlformats.org/drawingml/2006/main" wrap="none" lIns="0" tIns="0" rIns="0" bIns="0" anchor="t">
+            <a:noAutofit/>
+          </a:bodyPr>
+          <a:lstStyle xmlns:a="http://schemas.openxmlformats.org/drawingml/2006/main"/>
+          <a:p xmlns:a="http://schemas.openxmlformats.org/drawingml/2006/main">
+            <a:pPr algn="l">
+              <a:buNone/>
+              <a:defRPr sz="1950" b="1">
+                <a:solidFill>
+                  <a:srgbClr val="142D32"/>
+                </a:solidFill>
+                <a:latin typeface="Arial"/>
+                <a:ea typeface="Arial"/>
+                <a:cs typeface="Arial"/>
+              </a:defRPr>
+            </a:pPr>
+            <a:r>
+              <a:rPr sz="1950" b="1">
+                <a:solidFill>
+                  <a:srgbClr val="142D32"/>
+                </a:solidFill>
+                <a:latin typeface="Arial"/>
+                <a:ea typeface="Arial"/>
+                <a:cs typeface="Arial"/>
+              </a:rPr>
+              <a:t>Save its key</a:t>
+            </a:r>
+          </a:p>
+        </p:txBody>
+      </p:sp>
+      <p:sp>
+        <p:nvSpPr>
+          <p:cNvPr id="14" name="detail-1">
+            <a:extLst xmlns:a="http://schemas.openxmlformats.org/drawingml/2006/main">
+              <a:ext uri="{FF2B5EF4-FFF2-40B4-BE49-F238E27FC236}">
+                <a16:creationId xmlns:a16="http://schemas.microsoft.com/office/drawing/2014/main" id="{A5914C25-27E7-47D8-9ACC-EFCE8E16BC3D}"/>
+              </a:ext>
+            </a:extLst>
+          </p:cNvPr>
+          <p:cNvSpPr>
+            <a:spLocks xmlns:a="http://schemas.openxmlformats.org/drawingml/2006/main" noGrp="1"/>
+          </p:cNvSpPr>
+          <p:nvPr/>
+        </p:nvSpPr>
+        <p:spPr>
+          <a:xfrm xmlns:a="http://schemas.openxmlformats.org/drawingml/2006/main">
+            <a:off x="4476750" y="3505200"/>
+            <a:ext cx="7067550" cy="409575"/>
+          </a:xfrm>
+          <a:prstGeom xmlns:a="http://schemas.openxmlformats.org/drawingml/2006/main" prst="rect">
+            <a:avLst/>
+          </a:prstGeom>
+          <a:noFill xmlns:a="http://schemas.openxmlformats.org/drawingml/2006/main"/>
+          <a:ln xmlns:a="http://schemas.openxmlformats.org/drawingml/2006/main" w="0">
+            <a:noFill/>
+          </a:ln>
+        </p:spPr>
+        <p:txBody>
+          <a:bodyPr xmlns:a="http://schemas.openxmlformats.org/drawingml/2006/main" wrap="none" lIns="0" tIns="0" rIns="0" bIns="0" anchor="t">
+            <a:noAutofit/>
+          </a:bodyPr>
+          <a:lstStyle xmlns:a="http://schemas.openxmlformats.org/drawingml/2006/main"/>
+          <a:p xmlns:a="http://schemas.openxmlformats.org/drawingml/2006/main">
+            <a:pPr algn="l">
+              <a:buNone/>
+              <a:defRPr sz="1800" b="0">
                 <a:solidFill>
                   <a:srgbClr val="53686C"/>
                 </a:solidFill>
@@ -3324,7 +3508,7 @@
               </a:defRPr>
             </a:pPr>
             <a:r>
-              <a:rPr sz="2175" b="0">
+              <a:rPr sz="1800" b="0">
                 <a:solidFill>
                   <a:srgbClr val="53686C"/>
                 </a:solidFill>
@@ -3332,47 +3516,47 @@
                 <a:ea typeface="Arial"/>
                 <a:cs typeface="Arial"/>
               </a:rPr>
-              <a:t>Click the pencil icon.</a:t>
-            </a:r>
-          </a:p>
-        </p:txBody>
-      </p:sp>
-      <p:sp>
-        <p:nvSpPr>
-          <p:cNvPr id="11" name="example-label">
-            <a:extLst xmlns:a="http://schemas.openxmlformats.org/drawingml/2006/main">
-              <a:ext uri="{FF2B5EF4-FFF2-40B4-BE49-F238E27FC236}">
-                <a16:creationId xmlns:a16="http://schemas.microsoft.com/office/drawing/2014/main" id="{C0F0E3A6-C0BA-4812-A71E-EE33593570EC}"/>
-              </a:ext>
-            </a:extLst>
-          </p:cNvPr>
-          <p:cNvSpPr>
-            <a:spLocks xmlns:a="http://schemas.openxmlformats.org/drawingml/2006/main" noGrp="1"/>
-          </p:cNvSpPr>
-          <p:nvPr/>
-        </p:nvSpPr>
-        <p:spPr>
-          <a:xfrm xmlns:a="http://schemas.openxmlformats.org/drawingml/2006/main">
-            <a:off x="6838950" y="2743200"/>
-            <a:ext cx="4476750" cy="323850"/>
-          </a:xfrm>
-          <a:prstGeom xmlns:a="http://schemas.openxmlformats.org/drawingml/2006/main" prst="rect">
-            <a:avLst/>
-          </a:prstGeom>
-          <a:noFill xmlns:a="http://schemas.openxmlformats.org/drawingml/2006/main"/>
-          <a:ln xmlns:a="http://schemas.openxmlformats.org/drawingml/2006/main" w="0">
-            <a:noFill/>
-          </a:ln>
-        </p:spPr>
-        <p:txBody>
-          <a:bodyPr xmlns:a="http://schemas.openxmlformats.org/drawingml/2006/main" wrap="none" lIns="0" tIns="0" rIns="0" bIns="0" anchor="t">
-            <a:noAutofit/>
-          </a:bodyPr>
-          <a:lstStyle xmlns:a="http://schemas.openxmlformats.org/drawingml/2006/main"/>
-          <a:p xmlns:a="http://schemas.openxmlformats.org/drawingml/2006/main">
-            <a:pPr algn="l">
-              <a:buNone/>
-              <a:defRPr sz="1350" b="1">
+              <a:t>New repository secret: OPENROUTER_API_KEY</a:t>
+            </a:r>
+          </a:p>
+        </p:txBody>
+      </p:sp>
+      <p:sp>
+        <p:nvSpPr>
+          <p:cNvPr id="15" name="number-2">
+            <a:extLst xmlns:a="http://schemas.openxmlformats.org/drawingml/2006/main">
+              <a:ext uri="{FF2B5EF4-FFF2-40B4-BE49-F238E27FC236}">
+                <a16:creationId xmlns:a16="http://schemas.microsoft.com/office/drawing/2014/main" id="{48C15E34-16CE-4F28-B10B-104872F8D180}"/>
+              </a:ext>
+            </a:extLst>
+          </p:cNvPr>
+          <p:cNvSpPr>
+            <a:spLocks xmlns:a="http://schemas.openxmlformats.org/drawingml/2006/main" noGrp="1"/>
+          </p:cNvSpPr>
+          <p:nvPr/>
+        </p:nvSpPr>
+        <p:spPr>
+          <a:xfrm xmlns:a="http://schemas.openxmlformats.org/drawingml/2006/main">
+            <a:off x="609600" y="4191000"/>
+            <a:ext cx="800100" cy="438150"/>
+          </a:xfrm>
+          <a:prstGeom xmlns:a="http://schemas.openxmlformats.org/drawingml/2006/main" prst="rect">
+            <a:avLst/>
+          </a:prstGeom>
+          <a:noFill xmlns:a="http://schemas.openxmlformats.org/drawingml/2006/main"/>
+          <a:ln xmlns:a="http://schemas.openxmlformats.org/drawingml/2006/main" w="0">
+            <a:noFill/>
+          </a:ln>
+        </p:spPr>
+        <p:txBody>
+          <a:bodyPr xmlns:a="http://schemas.openxmlformats.org/drawingml/2006/main" wrap="none" lIns="0" tIns="0" rIns="0" bIns="0" anchor="t">
+            <a:noAutofit/>
+          </a:bodyPr>
+          <a:lstStyle xmlns:a="http://schemas.openxmlformats.org/drawingml/2006/main"/>
+          <a:p xmlns:a="http://schemas.openxmlformats.org/drawingml/2006/main">
+            <a:pPr algn="l">
+              <a:buNone/>
+              <a:defRPr sz="2400" b="1">
                 <a:solidFill>
                   <a:srgbClr val="087E80"/>
                 </a:solidFill>
@@ -3382,7 +3566,7 @@
               </a:defRPr>
             </a:pPr>
             <a:r>
-              <a:rPr sz="1350" b="1">
+              <a:rPr sz="2400" b="1">
                 <a:solidFill>
                   <a:srgbClr val="087E80"/>
                 </a:solidFill>
@@ -3390,153 +3574,163 @@
                 <a:ea typeface="Arial"/>
                 <a:cs typeface="Arial"/>
               </a:rPr>
-              <a:t>YOUR FIRST CHANGE</a:t>
-            </a:r>
-          </a:p>
-        </p:txBody>
-      </p:sp>
-      <p:sp>
-        <p:nvSpPr>
-          <p:cNvPr id="12" name="example">
-            <a:extLst xmlns:a="http://schemas.openxmlformats.org/drawingml/2006/main">
-              <a:ext uri="{FF2B5EF4-FFF2-40B4-BE49-F238E27FC236}">
-                <a16:creationId xmlns:a16="http://schemas.microsoft.com/office/drawing/2014/main" id="{65C7B07F-0842-498C-AF6D-0DEAB040E8FF}"/>
-              </a:ext>
-            </a:extLst>
-          </p:cNvPr>
-          <p:cNvSpPr>
-            <a:spLocks xmlns:a="http://schemas.openxmlformats.org/drawingml/2006/main" noGrp="1"/>
-          </p:cNvSpPr>
-          <p:nvPr/>
-        </p:nvSpPr>
-        <p:spPr>
-          <a:xfrm xmlns:a="http://schemas.openxmlformats.org/drawingml/2006/main">
-            <a:off x="6838950" y="3286125"/>
-            <a:ext cx="4743450" cy="1647825"/>
-          </a:xfrm>
-          <a:prstGeom xmlns:a="http://schemas.openxmlformats.org/drawingml/2006/main" prst="rect">
-            <a:avLst/>
-          </a:prstGeom>
-          <a:noFill xmlns:a="http://schemas.openxmlformats.org/drawingml/2006/main"/>
-          <a:ln xmlns:a="http://schemas.openxmlformats.org/drawingml/2006/main" w="0">
-            <a:noFill/>
-          </a:ln>
-        </p:spPr>
-        <p:txBody>
-          <a:bodyPr xmlns:a="http://schemas.openxmlformats.org/drawingml/2006/main" wrap="none" lIns="0" tIns="0" rIns="0" bIns="0" anchor="t">
-            <a:noAutofit/>
-          </a:bodyPr>
-          <a:lstStyle xmlns:a="http://schemas.openxmlformats.org/drawingml/2006/main"/>
-          <a:p xmlns:a="http://schemas.openxmlformats.org/drawingml/2006/main">
-            <a:pPr algn="l">
-              <a:buNone/>
-              <a:defRPr sz="2175" b="0">
-                <a:solidFill>
-                  <a:srgbClr val="142D32"/>
-                </a:solidFill>
-                <a:latin typeface="Arial"/>
-                <a:ea typeface="Arial"/>
-                <a:cs typeface="Arial"/>
-              </a:defRPr>
-            </a:pPr>
-            <a:r>
-              <a:rPr sz="2175" b="0">
-                <a:solidFill>
-                  <a:srgbClr val="142D32"/>
-                </a:solidFill>
-                <a:latin typeface="Arial"/>
-                <a:ea typeface="Arial"/>
-                <a:cs typeface="Arial"/>
-              </a:rPr>
-              <a:t>Find EDIT 2.</a:t>
-            </a:r>
-          </a:p>
-          <a:p xmlns:a="http://schemas.openxmlformats.org/drawingml/2006/main">
-            <a:pPr algn="l">
-              <a:buNone/>
-              <a:defRPr sz="2175" b="0">
-                <a:solidFill>
-                  <a:srgbClr val="142D32"/>
-                </a:solidFill>
-                <a:latin typeface="Arial"/>
-                <a:ea typeface="Arial"/>
-                <a:cs typeface="Arial"/>
-              </a:defRPr>
-            </a:pPr>
-            <a:r>
-              <a:rPr sz="2175" b="0">
-                <a:solidFill>
-                  <a:srgbClr val="142D32"/>
-                </a:solidFill>
-                <a:latin typeface="Arial"/>
-                <a:ea typeface="Arial"/>
-                <a:cs typeface="Arial"/>
-              </a:rPr>
-              <a:t>Change the page title.</a:t>
-            </a:r>
-          </a:p>
-          <a:p xmlns:a="http://schemas.openxmlformats.org/drawingml/2006/main">
-            <a:pPr algn="l">
-              <a:buNone/>
-              <a:defRPr sz="2175" b="0">
-                <a:solidFill>
-                  <a:srgbClr val="142D32"/>
-                </a:solidFill>
-                <a:latin typeface="Arial"/>
-                <a:ea typeface="Arial"/>
-                <a:cs typeface="Arial"/>
-              </a:defRPr>
-            </a:pPr>
-            <a:r>
-              <a:rPr sz="2175" b="0">
-                <a:solidFill>
-                  <a:srgbClr val="142D32"/>
-                </a:solidFill>
-                <a:latin typeface="Arial"/>
-                <a:ea typeface="Arial"/>
-                <a:cs typeface="Arial"/>
-              </a:rPr>
-              <a:t>Click Commit changes.</a:t>
-            </a:r>
-          </a:p>
-        </p:txBody>
-      </p:sp>
-      <p:sp>
-        <p:nvSpPr>
-          <p:cNvPr id="13" name="example-caption">
-            <a:extLst xmlns:a="http://schemas.openxmlformats.org/drawingml/2006/main">
-              <a:ext uri="{FF2B5EF4-FFF2-40B4-BE49-F238E27FC236}">
-                <a16:creationId xmlns:a16="http://schemas.microsoft.com/office/drawing/2014/main" id="{CDE9539E-CA88-4C9C-B91C-E62AD49DED18}"/>
-              </a:ext>
-            </a:extLst>
-          </p:cNvPr>
-          <p:cNvSpPr>
-            <a:spLocks xmlns:a="http://schemas.openxmlformats.org/drawingml/2006/main" noGrp="1"/>
-          </p:cNvSpPr>
-          <p:nvPr/>
-        </p:nvSpPr>
-        <p:spPr>
-          <a:xfrm xmlns:a="http://schemas.openxmlformats.org/drawingml/2006/main">
-            <a:off x="6838950" y="5248275"/>
-            <a:ext cx="4743450" cy="371475"/>
-          </a:xfrm>
-          <a:prstGeom xmlns:a="http://schemas.openxmlformats.org/drawingml/2006/main" prst="rect">
-            <a:avLst/>
-          </a:prstGeom>
-          <a:noFill xmlns:a="http://schemas.openxmlformats.org/drawingml/2006/main"/>
-          <a:ln xmlns:a="http://schemas.openxmlformats.org/drawingml/2006/main" w="0">
-            <a:noFill/>
-          </a:ln>
-        </p:spPr>
-        <p:txBody>
-          <a:bodyPr xmlns:a="http://schemas.openxmlformats.org/drawingml/2006/main" wrap="none" lIns="0" tIns="0" rIns="0" bIns="0" anchor="t">
-            <a:noAutofit/>
-          </a:bodyPr>
-          <a:lstStyle xmlns:a="http://schemas.openxmlformats.org/drawingml/2006/main"/>
-          <a:p xmlns:a="http://schemas.openxmlformats.org/drawingml/2006/main">
-            <a:pPr algn="l">
-              <a:buNone/>
-              <a:defRPr sz="1800" b="1">
+              <a:t>03</a:t>
+            </a:r>
+          </a:p>
+        </p:txBody>
+      </p:sp>
+      <p:sp>
+        <p:nvSpPr>
+          <p:cNvPr id="16" name="label-2">
+            <a:extLst xmlns:a="http://schemas.openxmlformats.org/drawingml/2006/main">
+              <a:ext uri="{FF2B5EF4-FFF2-40B4-BE49-F238E27FC236}">
+                <a16:creationId xmlns:a16="http://schemas.microsoft.com/office/drawing/2014/main" id="{2D9E683A-398A-4AB2-AA79-A9276DCE23D4}"/>
+              </a:ext>
+            </a:extLst>
+          </p:cNvPr>
+          <p:cNvSpPr>
+            <a:spLocks xmlns:a="http://schemas.openxmlformats.org/drawingml/2006/main" noGrp="1"/>
+          </p:cNvSpPr>
+          <p:nvPr/>
+        </p:nvSpPr>
+        <p:spPr>
+          <a:xfrm xmlns:a="http://schemas.openxmlformats.org/drawingml/2006/main">
+            <a:off x="1638300" y="4191000"/>
+            <a:ext cx="2476500" cy="438150"/>
+          </a:xfrm>
+          <a:prstGeom xmlns:a="http://schemas.openxmlformats.org/drawingml/2006/main" prst="rect">
+            <a:avLst/>
+          </a:prstGeom>
+          <a:noFill xmlns:a="http://schemas.openxmlformats.org/drawingml/2006/main"/>
+          <a:ln xmlns:a="http://schemas.openxmlformats.org/drawingml/2006/main" w="0">
+            <a:noFill/>
+          </a:ln>
+        </p:spPr>
+        <p:txBody>
+          <a:bodyPr xmlns:a="http://schemas.openxmlformats.org/drawingml/2006/main" wrap="none" lIns="0" tIns="0" rIns="0" bIns="0" anchor="t">
+            <a:noAutofit/>
+          </a:bodyPr>
+          <a:lstStyle xmlns:a="http://schemas.openxmlformats.org/drawingml/2006/main"/>
+          <a:p xmlns:a="http://schemas.openxmlformats.org/drawingml/2006/main">
+            <a:pPr algn="l">
+              <a:buNone/>
+              <a:defRPr sz="1950" b="1">
+                <a:solidFill>
+                  <a:srgbClr val="142D32"/>
+                </a:solidFill>
+                <a:latin typeface="Arial"/>
+                <a:ea typeface="Arial"/>
+                <a:cs typeface="Arial"/>
+              </a:defRPr>
+            </a:pPr>
+            <a:r>
+              <a:rPr sz="1950" b="1">
+                <a:solidFill>
+                  <a:srgbClr val="142D32"/>
+                </a:solidFill>
+                <a:latin typeface="Arial"/>
+                <a:ea typeface="Arial"/>
+                <a:cs typeface="Arial"/>
+              </a:rPr>
+              <a:t>Cloudflare</a:t>
+            </a:r>
+          </a:p>
+        </p:txBody>
+      </p:sp>
+      <p:sp>
+        <p:nvSpPr>
+          <p:cNvPr id="17" name="detail-2">
+            <a:extLst xmlns:a="http://schemas.openxmlformats.org/drawingml/2006/main">
+              <a:ext uri="{FF2B5EF4-FFF2-40B4-BE49-F238E27FC236}">
+                <a16:creationId xmlns:a16="http://schemas.microsoft.com/office/drawing/2014/main" id="{86AC9DF9-265A-4051-90FA-C86F9F89C9A9}"/>
+              </a:ext>
+            </a:extLst>
+          </p:cNvPr>
+          <p:cNvSpPr>
+            <a:spLocks xmlns:a="http://schemas.openxmlformats.org/drawingml/2006/main" noGrp="1"/>
+          </p:cNvSpPr>
+          <p:nvPr/>
+        </p:nvSpPr>
+        <p:spPr>
+          <a:xfrm xmlns:a="http://schemas.openxmlformats.org/drawingml/2006/main">
+            <a:off x="4476750" y="4219575"/>
+            <a:ext cx="7067550" cy="409575"/>
+          </a:xfrm>
+          <a:prstGeom xmlns:a="http://schemas.openxmlformats.org/drawingml/2006/main" prst="rect">
+            <a:avLst/>
+          </a:prstGeom>
+          <a:noFill xmlns:a="http://schemas.openxmlformats.org/drawingml/2006/main"/>
+          <a:ln xmlns:a="http://schemas.openxmlformats.org/drawingml/2006/main" w="0">
+            <a:noFill/>
+          </a:ln>
+        </p:spPr>
+        <p:txBody>
+          <a:bodyPr xmlns:a="http://schemas.openxmlformats.org/drawingml/2006/main" wrap="none" lIns="0" tIns="0" rIns="0" bIns="0" anchor="t">
+            <a:noAutofit/>
+          </a:bodyPr>
+          <a:lstStyle xmlns:a="http://schemas.openxmlformats.org/drawingml/2006/main"/>
+          <a:p xmlns:a="http://schemas.openxmlformats.org/drawingml/2006/main">
+            <a:pPr algn="l">
+              <a:buNone/>
+              <a:defRPr sz="1800" b="0">
+                <a:solidFill>
+                  <a:srgbClr val="53686C"/>
+                </a:solidFill>
+                <a:latin typeface="Arial"/>
+                <a:ea typeface="Arial"/>
+                <a:cs typeface="Arial"/>
+              </a:defRPr>
+            </a:pPr>
+            <a:r>
+              <a:rPr sz="1800" b="0">
+                <a:solidFill>
+                  <a:srgbClr val="53686C"/>
+                </a:solidFill>
+                <a:latin typeface="Arial"/>
+                <a:ea typeface="Arial"/>
+                <a:cs typeface="Arial"/>
+              </a:rPr>
+              <a:t>Profile → API Tokens → Edit Cloudflare Workers</a:t>
+            </a:r>
+          </a:p>
+        </p:txBody>
+      </p:sp>
+      <p:sp>
+        <p:nvSpPr>
+          <p:cNvPr id="18" name="number-3">
+            <a:extLst xmlns:a="http://schemas.openxmlformats.org/drawingml/2006/main">
+              <a:ext uri="{FF2B5EF4-FFF2-40B4-BE49-F238E27FC236}">
+                <a16:creationId xmlns:a16="http://schemas.microsoft.com/office/drawing/2014/main" id="{B815891C-F9E3-4E7E-9B17-326932EE6564}"/>
+              </a:ext>
+            </a:extLst>
+          </p:cNvPr>
+          <p:cNvSpPr>
+            <a:spLocks xmlns:a="http://schemas.openxmlformats.org/drawingml/2006/main" noGrp="1"/>
+          </p:cNvSpPr>
+          <p:nvPr/>
+        </p:nvSpPr>
+        <p:spPr>
+          <a:xfrm xmlns:a="http://schemas.openxmlformats.org/drawingml/2006/main">
+            <a:off x="609600" y="4905375"/>
+            <a:ext cx="800100" cy="438150"/>
+          </a:xfrm>
+          <a:prstGeom xmlns:a="http://schemas.openxmlformats.org/drawingml/2006/main" prst="rect">
+            <a:avLst/>
+          </a:prstGeom>
+          <a:noFill xmlns:a="http://schemas.openxmlformats.org/drawingml/2006/main"/>
+          <a:ln xmlns:a="http://schemas.openxmlformats.org/drawingml/2006/main" w="0">
+            <a:noFill/>
+          </a:ln>
+        </p:spPr>
+        <p:txBody>
+          <a:bodyPr xmlns:a="http://schemas.openxmlformats.org/drawingml/2006/main" wrap="none" lIns="0" tIns="0" rIns="0" bIns="0" anchor="t">
+            <a:noAutofit/>
+          </a:bodyPr>
+          <a:lstStyle xmlns:a="http://schemas.openxmlformats.org/drawingml/2006/main"/>
+          <a:p xmlns:a="http://schemas.openxmlformats.org/drawingml/2006/main">
+            <a:pPr algn="l">
+              <a:buNone/>
+              <a:defRPr sz="2400" b="1">
                 <a:solidFill>
                   <a:srgbClr val="087E80"/>
                 </a:solidFill>
@@ -3546,7 +3740,7 @@
               </a:defRPr>
             </a:pPr>
             <a:r>
-              <a:rPr sz="1800" b="1">
+              <a:rPr sz="2400" b="1">
                 <a:solidFill>
                   <a:srgbClr val="087E80"/>
                 </a:solidFill>
@@ -3554,7 +3748,123 @@
                 <a:ea typeface="Arial"/>
                 <a:cs typeface="Arial"/>
               </a:rPr>
-              <a:t>You can change EDIT 1’s color too.</a:t>
+              <a:t>04</a:t>
+            </a:r>
+          </a:p>
+        </p:txBody>
+      </p:sp>
+      <p:sp>
+        <p:nvSpPr>
+          <p:cNvPr id="19" name="label-3">
+            <a:extLst xmlns:a="http://schemas.openxmlformats.org/drawingml/2006/main">
+              <a:ext uri="{FF2B5EF4-FFF2-40B4-BE49-F238E27FC236}">
+                <a16:creationId xmlns:a16="http://schemas.microsoft.com/office/drawing/2014/main" id="{D16D2124-C19D-4287-BA72-4BAFA52DD5C6}"/>
+              </a:ext>
+            </a:extLst>
+          </p:cNvPr>
+          <p:cNvSpPr>
+            <a:spLocks xmlns:a="http://schemas.openxmlformats.org/drawingml/2006/main" noGrp="1"/>
+          </p:cNvSpPr>
+          <p:nvPr/>
+        </p:nvSpPr>
+        <p:spPr>
+          <a:xfrm xmlns:a="http://schemas.openxmlformats.org/drawingml/2006/main">
+            <a:off x="1638300" y="4905375"/>
+            <a:ext cx="2476500" cy="438150"/>
+          </a:xfrm>
+          <a:prstGeom xmlns:a="http://schemas.openxmlformats.org/drawingml/2006/main" prst="rect">
+            <a:avLst/>
+          </a:prstGeom>
+          <a:noFill xmlns:a="http://schemas.openxmlformats.org/drawingml/2006/main"/>
+          <a:ln xmlns:a="http://schemas.openxmlformats.org/drawingml/2006/main" w="0">
+            <a:noFill/>
+          </a:ln>
+        </p:spPr>
+        <p:txBody>
+          <a:bodyPr xmlns:a="http://schemas.openxmlformats.org/drawingml/2006/main" wrap="none" lIns="0" tIns="0" rIns="0" bIns="0" anchor="t">
+            <a:noAutofit/>
+          </a:bodyPr>
+          <a:lstStyle xmlns:a="http://schemas.openxmlformats.org/drawingml/2006/main"/>
+          <a:p xmlns:a="http://schemas.openxmlformats.org/drawingml/2006/main">
+            <a:pPr algn="l">
+              <a:buNone/>
+              <a:defRPr sz="1950" b="1">
+                <a:solidFill>
+                  <a:srgbClr val="142D32"/>
+                </a:solidFill>
+                <a:latin typeface="Arial"/>
+                <a:ea typeface="Arial"/>
+                <a:cs typeface="Arial"/>
+              </a:defRPr>
+            </a:pPr>
+            <a:r>
+              <a:rPr sz="1950" b="1">
+                <a:solidFill>
+                  <a:srgbClr val="142D32"/>
+                </a:solidFill>
+                <a:latin typeface="Arial"/>
+                <a:ea typeface="Arial"/>
+                <a:cs typeface="Arial"/>
+              </a:rPr>
+              <a:t>Save two more</a:t>
+            </a:r>
+          </a:p>
+        </p:txBody>
+      </p:sp>
+      <p:sp>
+        <p:nvSpPr>
+          <p:cNvPr id="20" name="detail-3">
+            <a:extLst xmlns:a="http://schemas.openxmlformats.org/drawingml/2006/main">
+              <a:ext uri="{FF2B5EF4-FFF2-40B4-BE49-F238E27FC236}">
+                <a16:creationId xmlns:a16="http://schemas.microsoft.com/office/drawing/2014/main" id="{9219B99F-90F8-4C32-9F2B-5F01F554F722}"/>
+              </a:ext>
+            </a:extLst>
+          </p:cNvPr>
+          <p:cNvSpPr>
+            <a:spLocks xmlns:a="http://schemas.openxmlformats.org/drawingml/2006/main" noGrp="1"/>
+          </p:cNvSpPr>
+          <p:nvPr/>
+        </p:nvSpPr>
+        <p:spPr>
+          <a:xfrm xmlns:a="http://schemas.openxmlformats.org/drawingml/2006/main">
+            <a:off x="4476750" y="4933950"/>
+            <a:ext cx="7067550" cy="409575"/>
+          </a:xfrm>
+          <a:prstGeom xmlns:a="http://schemas.openxmlformats.org/drawingml/2006/main" prst="rect">
+            <a:avLst/>
+          </a:prstGeom>
+          <a:noFill xmlns:a="http://schemas.openxmlformats.org/drawingml/2006/main"/>
+          <a:ln xmlns:a="http://schemas.openxmlformats.org/drawingml/2006/main" w="0">
+            <a:noFill/>
+          </a:ln>
+        </p:spPr>
+        <p:txBody>
+          <a:bodyPr xmlns:a="http://schemas.openxmlformats.org/drawingml/2006/main" wrap="none" lIns="0" tIns="0" rIns="0" bIns="0" anchor="t">
+            <a:noAutofit/>
+          </a:bodyPr>
+          <a:lstStyle xmlns:a="http://schemas.openxmlformats.org/drawingml/2006/main"/>
+          <a:p xmlns:a="http://schemas.openxmlformats.org/drawingml/2006/main">
+            <a:pPr algn="l">
+              <a:buNone/>
+              <a:defRPr sz="1800" b="0">
+                <a:solidFill>
+                  <a:srgbClr val="53686C"/>
+                </a:solidFill>
+                <a:latin typeface="Arial"/>
+                <a:ea typeface="Arial"/>
+                <a:cs typeface="Arial"/>
+              </a:defRPr>
+            </a:pPr>
+            <a:r>
+              <a:rPr sz="1800" b="0">
+                <a:solidFill>
+                  <a:srgbClr val="53686C"/>
+                </a:solidFill>
+                <a:latin typeface="Arial"/>
+                <a:ea typeface="Arial"/>
+                <a:cs typeface="Arial"/>
+              </a:rPr>
+              <a:t>CLOUDFLARE_API_TOKEN + CLOUDFLARE_ACCOUNT_ID</a:t>
             </a:r>
           </a:p>
         </p:txBody>
@@ -3562,7 +3872,7 @@
     </p:spTree>
     <p:extLst>
       <p:ext uri="{BB962C8B-B14F-4D97-AF65-F5344CB8AC3E}">
-        <p14:creationId xmlns:p14="http://schemas.microsoft.com/office/powerpoint/2010/main" val="22625506"/>
+        <p14:creationId xmlns:p14="http://schemas.microsoft.com/office/powerpoint/2010/main" val="398891925"/>
       </p:ext>
     </p:extLst>
   </p:cSld>
@@ -3699,7 +4009,7 @@
                 <a:ea typeface="Arial"/>
                 <a:cs typeface="Arial"/>
               </a:rPr>
-              <a:t>Connect your OpenRouter key</a:t>
+              <a:t>Deploy the private API</a:t>
             </a:r>
           </a:p>
         </p:txBody>
@@ -3757,7 +4067,7 @@
                 <a:ea typeface="Arial"/>
                 <a:cs typeface="Arial"/>
               </a:rPr>
-              <a:t>Paste the key into the live game page</a:t>
+              <a:t>Open each file on GitHub → pencil → edit → Commit changes</a:t>
             </a:r>
           </a:p>
         </p:txBody>
@@ -3913,25 +4223,25 @@
           <a:p xmlns:a="http://schemas.openxmlformats.org/drawingml/2006/main">
             <a:pPr algn="l">
               <a:buNone/>
-              <a:defRPr sz="2175" b="1">
-                <a:solidFill>
-                  <a:srgbClr val="142D32"/>
-                </a:solidFill>
-                <a:latin typeface="Arial"/>
-                <a:ea typeface="Arial"/>
-                <a:cs typeface="Arial"/>
-              </a:defRPr>
-            </a:pPr>
-            <a:r>
-              <a:rPr sz="2175" b="1">
-                <a:solidFill>
-                  <a:srgbClr val="142D32"/>
-                </a:solidFill>
-                <a:latin typeface="Arial"/>
-                <a:ea typeface="Arial"/>
-                <a:cs typeface="Arial"/>
-              </a:rPr>
-              <a:t>Create a key</a:t>
+              <a:defRPr sz="1950" b="1">
+                <a:solidFill>
+                  <a:srgbClr val="142D32"/>
+                </a:solidFill>
+                <a:latin typeface="Arial"/>
+                <a:ea typeface="Arial"/>
+                <a:cs typeface="Arial"/>
+              </a:defRPr>
+            </a:pPr>
+            <a:r>
+              <a:rPr sz="1950" b="1">
+                <a:solidFill>
+                  <a:srgbClr val="142D32"/>
+                </a:solidFill>
+                <a:latin typeface="Arial"/>
+                <a:ea typeface="Arial"/>
+                <a:cs typeface="Arial"/>
+              </a:rPr>
+              <a:t>Allow your site</a:t>
             </a:r>
           </a:p>
         </p:txBody>
@@ -3971,7 +4281,7 @@
           <a:p xmlns:a="http://schemas.openxmlformats.org/drawingml/2006/main">
             <a:pPr algn="l">
               <a:buNone/>
-              <a:defRPr sz="1875" b="0">
+              <a:defRPr sz="1800" b="0">
                 <a:solidFill>
                   <a:srgbClr val="53686C"/>
                 </a:solidFill>
@@ -3981,7 +4291,7 @@
               </a:defRPr>
             </a:pPr>
             <a:r>
-              <a:rPr sz="1875" b="0">
+              <a:rPr sz="1800" b="0">
                 <a:solidFill>
                   <a:srgbClr val="53686C"/>
                 </a:solidFill>
@@ -3989,7 +4299,7 @@
                 <a:ea typeface="Arial"/>
                 <a:cs typeface="Arial"/>
               </a:rPr>
-              <a:t>openrouter.ai/settings/keys &gt; Create Key</a:t>
+              <a:t>api/wrangler.jsonc → change ALLOWED_ORIGIN</a:t>
             </a:r>
           </a:p>
         </p:txBody>
@@ -4087,25 +4397,25 @@
           <a:p xmlns:a="http://schemas.openxmlformats.org/drawingml/2006/main">
             <a:pPr algn="l">
               <a:buNone/>
-              <a:defRPr sz="2175" b="1">
-                <a:solidFill>
-                  <a:srgbClr val="142D32"/>
-                </a:solidFill>
-                <a:latin typeface="Arial"/>
-                <a:ea typeface="Arial"/>
-                <a:cs typeface="Arial"/>
-              </a:defRPr>
-            </a:pPr>
-            <a:r>
-              <a:rPr sz="2175" b="1">
-                <a:solidFill>
-                  <a:srgbClr val="142D32"/>
-                </a:solidFill>
-                <a:latin typeface="Arial"/>
-                <a:ea typeface="Arial"/>
-                <a:cs typeface="Arial"/>
-              </a:rPr>
-              <a:t>Open the bot</a:t>
+              <a:defRPr sz="1950" b="1">
+                <a:solidFill>
+                  <a:srgbClr val="142D32"/>
+                </a:solidFill>
+                <a:latin typeface="Arial"/>
+                <a:ea typeface="Arial"/>
+                <a:cs typeface="Arial"/>
+              </a:defRPr>
+            </a:pPr>
+            <a:r>
+              <a:rPr sz="1950" b="1">
+                <a:solidFill>
+                  <a:srgbClr val="142D32"/>
+                </a:solidFill>
+                <a:latin typeface="Arial"/>
+                <a:ea typeface="Arial"/>
+                <a:cs typeface="Arial"/>
+              </a:rPr>
+              <a:t>Use its hostname</a:t>
             </a:r>
           </a:p>
         </p:txBody>
@@ -4145,7 +4455,7 @@
           <a:p xmlns:a="http://schemas.openxmlformats.org/drawingml/2006/main">
             <a:pPr algn="l">
               <a:buNone/>
-              <a:defRPr sz="1875" b="0">
+              <a:defRPr sz="1800" b="0">
                 <a:solidFill>
                   <a:srgbClr val="53686C"/>
                 </a:solidFill>
@@ -4155,7 +4465,7 @@
               </a:defRPr>
             </a:pPr>
             <a:r>
-              <a:rPr sz="1875" b="0">
+              <a:rPr sz="1800" b="0">
                 <a:solidFill>
                   <a:srgbClr val="53686C"/>
                 </a:solidFill>
@@ -4163,7 +4473,7 @@
                 <a:ea typeface="Arial"/>
                 <a:cs typeface="Arial"/>
               </a:rPr>
-              <a:t>Click “Give me a dilemma” on your site.</a:t>
+              <a:t>https://YOUR-USERNAME.github.io — no path</a:t>
             </a:r>
           </a:p>
         </p:txBody>
@@ -4261,25 +4571,25 @@
           <a:p xmlns:a="http://schemas.openxmlformats.org/drawingml/2006/main">
             <a:pPr algn="l">
               <a:buNone/>
-              <a:defRPr sz="2175" b="1">
-                <a:solidFill>
-                  <a:srgbClr val="142D32"/>
-                </a:solidFill>
-                <a:latin typeface="Arial"/>
-                <a:ea typeface="Arial"/>
-                <a:cs typeface="Arial"/>
-              </a:defRPr>
-            </a:pPr>
-            <a:r>
-              <a:rPr sz="2175" b="1">
-                <a:solidFill>
-                  <a:srgbClr val="142D32"/>
-                </a:solidFill>
-                <a:latin typeface="Arial"/>
-                <a:ea typeface="Arial"/>
-                <a:cs typeface="Arial"/>
-              </a:rPr>
-              <a:t>Use your key</a:t>
+              <a:defRPr sz="1950" b="1">
+                <a:solidFill>
+                  <a:srgbClr val="142D32"/>
+                </a:solidFill>
+                <a:latin typeface="Arial"/>
+                <a:ea typeface="Arial"/>
+                <a:cs typeface="Arial"/>
+              </a:defRPr>
+            </a:pPr>
+            <a:r>
+              <a:rPr sz="1950" b="1">
+                <a:solidFill>
+                  <a:srgbClr val="142D32"/>
+                </a:solidFill>
+                <a:latin typeface="Arial"/>
+                <a:ea typeface="Arial"/>
+                <a:cs typeface="Arial"/>
+              </a:rPr>
+              <a:t>Run deployment</a:t>
             </a:r>
           </a:p>
         </p:txBody>
@@ -4319,7 +4629,7 @@
           <a:p xmlns:a="http://schemas.openxmlformats.org/drawingml/2006/main">
             <a:pPr algn="l">
               <a:buNone/>
-              <a:defRPr sz="1875" b="0">
+              <a:defRPr sz="1800" b="0">
                 <a:solidFill>
                   <a:srgbClr val="53686C"/>
                 </a:solidFill>
@@ -4329,7 +4639,7 @@
               </a:defRPr>
             </a:pPr>
             <a:r>
-              <a:rPr sz="1875" b="0">
+              <a:rPr sz="1800" b="0">
                 <a:solidFill>
                   <a:srgbClr val="53686C"/>
                 </a:solidFill>
@@ -4337,7 +4647,7 @@
                 <a:ea typeface="Arial"/>
                 <a:cs typeface="Arial"/>
               </a:rPr>
-              <a:t>Paste into the key field. Click Use my key.</a:t>
+              <a:t>Actions → Deploy AI bot → Run workflow</a:t>
             </a:r>
           </a:p>
         </p:txBody>
@@ -4435,25 +4745,25 @@
           <a:p xmlns:a="http://schemas.openxmlformats.org/drawingml/2006/main">
             <a:pPr algn="l">
               <a:buNone/>
-              <a:defRPr sz="2175" b="1">
-                <a:solidFill>
-                  <a:srgbClr val="142D32"/>
-                </a:solidFill>
-                <a:latin typeface="Arial"/>
-                <a:ea typeface="Arial"/>
-                <a:cs typeface="Arial"/>
-              </a:defRPr>
-            </a:pPr>
-            <a:r>
-              <a:rPr sz="2175" b="1">
-                <a:solidFill>
-                  <a:srgbClr val="142D32"/>
-                </a:solidFill>
-                <a:latin typeface="Arial"/>
-                <a:ea typeface="Arial"/>
-                <a:cs typeface="Arial"/>
-              </a:rPr>
-              <a:t>Send a theme</a:t>
+              <a:defRPr sz="1950" b="1">
+                <a:solidFill>
+                  <a:srgbClr val="142D32"/>
+                </a:solidFill>
+                <a:latin typeface="Arial"/>
+                <a:ea typeface="Arial"/>
+                <a:cs typeface="Arial"/>
+              </a:defRPr>
+            </a:pPr>
+            <a:r>
+              <a:rPr sz="1950" b="1">
+                <a:solidFill>
+                  <a:srgbClr val="142D32"/>
+                </a:solidFill>
+                <a:latin typeface="Arial"/>
+                <a:ea typeface="Arial"/>
+                <a:cs typeface="Arial"/>
+              </a:rPr>
+              <a:t>Copy the API URL</a:t>
             </a:r>
           </a:p>
         </p:txBody>
@@ -4493,7 +4803,7 @@
           <a:p xmlns:a="http://schemas.openxmlformats.org/drawingml/2006/main">
             <a:pPr algn="l">
               <a:buNone/>
-              <a:defRPr sz="1875" b="0">
+              <a:defRPr sz="1800" b="0">
                 <a:solidFill>
                   <a:srgbClr val="53686C"/>
                 </a:solidFill>
@@ -4503,7 +4813,7 @@
               </a:defRPr>
             </a:pPr>
             <a:r>
-              <a:rPr sz="1875" b="0">
+              <a:rPr sz="1800" b="0">
                 <a:solidFill>
                   <a:srgbClr val="53686C"/>
                 </a:solidFill>
@@ -4511,7 +4821,7 @@
                 <a:ea typeface="Arial"/>
                 <a:cs typeface="Arial"/>
               </a:rPr>
-              <a:t>Try “superpowers”, then press Send.</a:t>
+              <a:t>Cloudflare → ai-club-game → workers.dev URL</a:t>
             </a:r>
           </a:p>
         </p:txBody>
@@ -4547,10 +4857,10 @@
       </p:grpSpPr>
       <p:sp>
         <p:nvSpPr>
-          <p:cNvPr id="15" name="club">
-            <a:extLst xmlns:a="http://schemas.openxmlformats.org/drawingml/2006/main">
-              <a:ext uri="{FF2B5EF4-FFF2-40B4-BE49-F238E27FC236}">
-                <a16:creationId xmlns:a16="http://schemas.microsoft.com/office/drawing/2014/main" id="{9E83BF3D-4E04-49A2-A99B-2303192D1937}"/>
+          <p:cNvPr id="21" name="club">
+            <a:extLst xmlns:a="http://schemas.openxmlformats.org/drawingml/2006/main">
+              <a:ext uri="{FF2B5EF4-FFF2-40B4-BE49-F238E27FC236}">
+                <a16:creationId xmlns:a16="http://schemas.microsoft.com/office/drawing/2014/main" id="{366D60CB-0E69-4059-85C5-9B5236F59499}"/>
               </a:ext>
             </a:extLst>
           </p:cNvPr>
@@ -4608,7 +4918,7 @@
           <p:cNvPr id="3" name="title">
             <a:extLst xmlns:a="http://schemas.openxmlformats.org/drawingml/2006/main">
               <a:ext uri="{FF2B5EF4-FFF2-40B4-BE49-F238E27FC236}">
-                <a16:creationId xmlns:a16="http://schemas.microsoft.com/office/drawing/2014/main" id="{A66A34A4-4A81-42D5-B58A-9B73C21546DF}"/>
+                <a16:creationId xmlns:a16="http://schemas.microsoft.com/office/drawing/2014/main" id="{EF48F320-DD91-4BBA-B862-5084F2F45ADE}"/>
               </a:ext>
             </a:extLst>
           </p:cNvPr>
@@ -4656,7 +4966,7 @@
                 <a:ea typeface="Arial"/>
                 <a:cs typeface="Arial"/>
               </a:rPr>
-              <a:t>Change the bot instructions</a:t>
+              <a:t>Connect the page and play</a:t>
             </a:r>
           </a:p>
         </p:txBody>
@@ -4666,7 +4976,7 @@
           <p:cNvPr id="4" name="subheader">
             <a:extLst xmlns:a="http://schemas.openxmlformats.org/drawingml/2006/main">
               <a:ext uri="{FF2B5EF4-FFF2-40B4-BE49-F238E27FC236}">
-                <a16:creationId xmlns:a16="http://schemas.microsoft.com/office/drawing/2014/main" id="{C1B0794C-E341-4380-9A7B-1FBF40F989AC}"/>
+                <a16:creationId xmlns:a16="http://schemas.microsoft.com/office/drawing/2014/main" id="{5D6446FB-4749-41AC-9A7B-5675002E5DC1}"/>
               </a:ext>
             </a:extLst>
           </p:cNvPr>
@@ -4714,7 +5024,7 @@
                 <a:ea typeface="Arial"/>
                 <a:cs typeface="Arial"/>
               </a:rPr>
-              <a:t>Back on GitHub, edit the same index.html</a:t>
+              <a:t>In ai-would-you-rather/index.html, find const API_URL</a:t>
             </a:r>
           </a:p>
         </p:txBody>
@@ -4724,7 +5034,7 @@
           <p:cNvPr id="8" name="footer-page">
             <a:extLst xmlns:a="http://schemas.openxmlformats.org/drawingml/2006/main">
               <a:ext uri="{FF2B5EF4-FFF2-40B4-BE49-F238E27FC236}">
-                <a16:creationId xmlns:a16="http://schemas.microsoft.com/office/drawing/2014/main" id="{28852A21-0BEF-4D32-B0EF-ED940BEFFFA1}"/>
+                <a16:creationId xmlns:a16="http://schemas.microsoft.com/office/drawing/2014/main" id="{C8408FA6-E463-4CDD-B6F5-5DA963C5DA59}"/>
               </a:ext>
             </a:extLst>
           </p:cNvPr>
@@ -4779,40 +5089,156 @@
       </p:sp>
       <p:sp>
         <p:nvSpPr>
-          <p:cNvPr id="9" name="left-label">
-            <a:extLst xmlns:a="http://schemas.openxmlformats.org/drawingml/2006/main">
-              <a:ext uri="{FF2B5EF4-FFF2-40B4-BE49-F238E27FC236}">
-                <a16:creationId xmlns:a16="http://schemas.microsoft.com/office/drawing/2014/main" id="{14E39621-3B97-4313-AF9C-62C6D82598D7}"/>
-              </a:ext>
-            </a:extLst>
-          </p:cNvPr>
-          <p:cNvSpPr>
-            <a:spLocks xmlns:a="http://schemas.openxmlformats.org/drawingml/2006/main" noGrp="1"/>
-          </p:cNvSpPr>
-          <p:nvPr/>
-        </p:nvSpPr>
-        <p:spPr>
-          <a:xfrm xmlns:a="http://schemas.openxmlformats.org/drawingml/2006/main">
-            <a:off x="609600" y="2752725"/>
-            <a:ext cx="4991100" cy="304800"/>
-          </a:xfrm>
-          <a:prstGeom xmlns:a="http://schemas.openxmlformats.org/drawingml/2006/main" prst="rect">
-            <a:avLst/>
-          </a:prstGeom>
-          <a:noFill xmlns:a="http://schemas.openxmlformats.org/drawingml/2006/main"/>
-          <a:ln xmlns:a="http://schemas.openxmlformats.org/drawingml/2006/main" w="0">
-            <a:noFill/>
-          </a:ln>
-        </p:spPr>
-        <p:txBody>
-          <a:bodyPr xmlns:a="http://schemas.openxmlformats.org/drawingml/2006/main" wrap="none" lIns="0" tIns="0" rIns="0" bIns="0" anchor="t">
-            <a:noAutofit/>
-          </a:bodyPr>
-          <a:lstStyle xmlns:a="http://schemas.openxmlformats.org/drawingml/2006/main"/>
-          <a:p xmlns:a="http://schemas.openxmlformats.org/drawingml/2006/main">
-            <a:pPr algn="l">
-              <a:buNone/>
-              <a:defRPr sz="1425" b="1">
+          <p:cNvPr id="9" name="number-0">
+            <a:extLst xmlns:a="http://schemas.openxmlformats.org/drawingml/2006/main">
+              <a:ext uri="{FF2B5EF4-FFF2-40B4-BE49-F238E27FC236}">
+                <a16:creationId xmlns:a16="http://schemas.microsoft.com/office/drawing/2014/main" id="{51BDE694-C556-45C9-8B16-C8598B27536B}"/>
+              </a:ext>
+            </a:extLst>
+          </p:cNvPr>
+          <p:cNvSpPr>
+            <a:spLocks xmlns:a="http://schemas.openxmlformats.org/drawingml/2006/main" noGrp="1"/>
+          </p:cNvSpPr>
+          <p:nvPr/>
+        </p:nvSpPr>
+        <p:spPr>
+          <a:xfrm xmlns:a="http://schemas.openxmlformats.org/drawingml/2006/main">
+            <a:off x="609600" y="2762250"/>
+            <a:ext cx="800100" cy="438150"/>
+          </a:xfrm>
+          <a:prstGeom xmlns:a="http://schemas.openxmlformats.org/drawingml/2006/main" prst="rect">
+            <a:avLst/>
+          </a:prstGeom>
+          <a:noFill xmlns:a="http://schemas.openxmlformats.org/drawingml/2006/main"/>
+          <a:ln xmlns:a="http://schemas.openxmlformats.org/drawingml/2006/main" w="0">
+            <a:noFill/>
+          </a:ln>
+        </p:spPr>
+        <p:txBody>
+          <a:bodyPr xmlns:a="http://schemas.openxmlformats.org/drawingml/2006/main" wrap="none" lIns="0" tIns="0" rIns="0" bIns="0" anchor="t">
+            <a:noAutofit/>
+          </a:bodyPr>
+          <a:lstStyle xmlns:a="http://schemas.openxmlformats.org/drawingml/2006/main"/>
+          <a:p xmlns:a="http://schemas.openxmlformats.org/drawingml/2006/main">
+            <a:pPr algn="l">
+              <a:buNone/>
+              <a:defRPr sz="2400" b="1">
+                <a:solidFill>
+                  <a:srgbClr val="087E80"/>
+                </a:solidFill>
+                <a:latin typeface="Arial"/>
+                <a:ea typeface="Arial"/>
+                <a:cs typeface="Arial"/>
+              </a:defRPr>
+            </a:pPr>
+            <a:r>
+              <a:rPr sz="2400" b="1">
+                <a:solidFill>
+                  <a:srgbClr val="087E80"/>
+                </a:solidFill>
+                <a:latin typeface="Arial"/>
+                <a:ea typeface="Arial"/>
+                <a:cs typeface="Arial"/>
+              </a:rPr>
+              <a:t>01</a:t>
+            </a:r>
+          </a:p>
+        </p:txBody>
+      </p:sp>
+      <p:sp>
+        <p:nvSpPr>
+          <p:cNvPr id="10" name="label-0">
+            <a:extLst xmlns:a="http://schemas.openxmlformats.org/drawingml/2006/main">
+              <a:ext uri="{FF2B5EF4-FFF2-40B4-BE49-F238E27FC236}">
+                <a16:creationId xmlns:a16="http://schemas.microsoft.com/office/drawing/2014/main" id="{E901CE81-5B34-4D37-86AA-33C33C0D7159}"/>
+              </a:ext>
+            </a:extLst>
+          </p:cNvPr>
+          <p:cNvSpPr>
+            <a:spLocks xmlns:a="http://schemas.openxmlformats.org/drawingml/2006/main" noGrp="1"/>
+          </p:cNvSpPr>
+          <p:nvPr/>
+        </p:nvSpPr>
+        <p:spPr>
+          <a:xfrm xmlns:a="http://schemas.openxmlformats.org/drawingml/2006/main">
+            <a:off x="1638300" y="2762250"/>
+            <a:ext cx="2476500" cy="438150"/>
+          </a:xfrm>
+          <a:prstGeom xmlns:a="http://schemas.openxmlformats.org/drawingml/2006/main" prst="rect">
+            <a:avLst/>
+          </a:prstGeom>
+          <a:noFill xmlns:a="http://schemas.openxmlformats.org/drawingml/2006/main"/>
+          <a:ln xmlns:a="http://schemas.openxmlformats.org/drawingml/2006/main" w="0">
+            <a:noFill/>
+          </a:ln>
+        </p:spPr>
+        <p:txBody>
+          <a:bodyPr xmlns:a="http://schemas.openxmlformats.org/drawingml/2006/main" wrap="none" lIns="0" tIns="0" rIns="0" bIns="0" anchor="t">
+            <a:noAutofit/>
+          </a:bodyPr>
+          <a:lstStyle xmlns:a="http://schemas.openxmlformats.org/drawingml/2006/main"/>
+          <a:p xmlns:a="http://schemas.openxmlformats.org/drawingml/2006/main">
+            <a:pPr algn="l">
+              <a:buNone/>
+              <a:defRPr sz="1950" b="1">
+                <a:solidFill>
+                  <a:srgbClr val="142D32"/>
+                </a:solidFill>
+                <a:latin typeface="Arial"/>
+                <a:ea typeface="Arial"/>
+                <a:cs typeface="Arial"/>
+              </a:defRPr>
+            </a:pPr>
+            <a:r>
+              <a:rPr sz="1950" b="1">
+                <a:solidFill>
+                  <a:srgbClr val="142D32"/>
+                </a:solidFill>
+                <a:latin typeface="Arial"/>
+                <a:ea typeface="Arial"/>
+                <a:cs typeface="Arial"/>
+              </a:rPr>
+              <a:t>Paste the URL</a:t>
+            </a:r>
+          </a:p>
+        </p:txBody>
+      </p:sp>
+      <p:sp>
+        <p:nvSpPr>
+          <p:cNvPr id="11" name="detail-0">
+            <a:extLst xmlns:a="http://schemas.openxmlformats.org/drawingml/2006/main">
+              <a:ext uri="{FF2B5EF4-FFF2-40B4-BE49-F238E27FC236}">
+                <a16:creationId xmlns:a16="http://schemas.microsoft.com/office/drawing/2014/main" id="{BD0ED1E0-713C-4C6D-929D-E0FBED8AF2E8}"/>
+              </a:ext>
+            </a:extLst>
+          </p:cNvPr>
+          <p:cNvSpPr>
+            <a:spLocks xmlns:a="http://schemas.openxmlformats.org/drawingml/2006/main" noGrp="1"/>
+          </p:cNvSpPr>
+          <p:nvPr/>
+        </p:nvSpPr>
+        <p:spPr>
+          <a:xfrm xmlns:a="http://schemas.openxmlformats.org/drawingml/2006/main">
+            <a:off x="4476750" y="2790825"/>
+            <a:ext cx="7067550" cy="409575"/>
+          </a:xfrm>
+          <a:prstGeom xmlns:a="http://schemas.openxmlformats.org/drawingml/2006/main" prst="rect">
+            <a:avLst/>
+          </a:prstGeom>
+          <a:noFill xmlns:a="http://schemas.openxmlformats.org/drawingml/2006/main"/>
+          <a:ln xmlns:a="http://schemas.openxmlformats.org/drawingml/2006/main" w="0">
+            <a:noFill/>
+          </a:ln>
+        </p:spPr>
+        <p:txBody>
+          <a:bodyPr xmlns:a="http://schemas.openxmlformats.org/drawingml/2006/main" wrap="none" lIns="0" tIns="0" rIns="0" bIns="0" anchor="t">
+            <a:noAutofit/>
+          </a:bodyPr>
+          <a:lstStyle xmlns:a="http://schemas.openxmlformats.org/drawingml/2006/main"/>
+          <a:p xmlns:a="http://schemas.openxmlformats.org/drawingml/2006/main">
+            <a:pPr algn="l">
+              <a:buNone/>
+              <a:defRPr sz="1800" b="0">
                 <a:solidFill>
                   <a:srgbClr val="53686C"/>
                 </a:solidFill>
@@ -4822,7 +5248,7 @@
               </a:defRPr>
             </a:pPr>
             <a:r>
-              <a:rPr sz="1425" b="1">
+              <a:rPr sz="1800" b="0">
                 <a:solidFill>
                   <a:srgbClr val="53686C"/>
                 </a:solidFill>
@@ -4830,183 +5256,145 @@
                 <a:ea typeface="Arial"/>
                 <a:cs typeface="Arial"/>
               </a:rPr>
-              <a:t>FIND EDIT 3</a:t>
-            </a:r>
-          </a:p>
-        </p:txBody>
-      </p:sp>
-      <p:sp>
-        <p:nvSpPr>
-          <p:cNvPr id="10" name="left-prompt">
-            <a:extLst xmlns:a="http://schemas.openxmlformats.org/drawingml/2006/main">
-              <a:ext uri="{FF2B5EF4-FFF2-40B4-BE49-F238E27FC236}">
-                <a16:creationId xmlns:a16="http://schemas.microsoft.com/office/drawing/2014/main" id="{F5C4BD44-0293-4300-88D1-582D0C509FBE}"/>
-              </a:ext>
-            </a:extLst>
-          </p:cNvPr>
-          <p:cNvSpPr>
-            <a:spLocks xmlns:a="http://schemas.openxmlformats.org/drawingml/2006/main" noGrp="1"/>
-          </p:cNvSpPr>
-          <p:nvPr/>
-        </p:nvSpPr>
-        <p:spPr>
-          <a:xfrm xmlns:a="http://schemas.openxmlformats.org/drawingml/2006/main">
-            <a:off x="609600" y="3314700"/>
-            <a:ext cx="5238750" cy="1733550"/>
-          </a:xfrm>
-          <a:prstGeom xmlns:a="http://schemas.openxmlformats.org/drawingml/2006/main" prst="rect">
-            <a:avLst/>
-          </a:prstGeom>
-          <a:noFill xmlns:a="http://schemas.openxmlformats.org/drawingml/2006/main"/>
-          <a:ln xmlns:a="http://schemas.openxmlformats.org/drawingml/2006/main" w="0">
-            <a:noFill/>
-          </a:ln>
-        </p:spPr>
-        <p:txBody>
-          <a:bodyPr xmlns:a="http://schemas.openxmlformats.org/drawingml/2006/main" wrap="none" lIns="0" tIns="0" rIns="0" bIns="0" anchor="t">
-            <a:noAutofit/>
-          </a:bodyPr>
-          <a:lstStyle xmlns:a="http://schemas.openxmlformats.org/drawingml/2006/main"/>
-          <a:p xmlns:a="http://schemas.openxmlformats.org/drawingml/2006/main">
-            <a:pPr algn="l">
-              <a:buNone/>
-              <a:defRPr sz="2100" b="1">
-                <a:solidFill>
-                  <a:srgbClr val="142D32"/>
-                </a:solidFill>
-                <a:latin typeface="Arial"/>
-                <a:ea typeface="Arial"/>
-                <a:cs typeface="Arial"/>
-              </a:defRPr>
-            </a:pPr>
-            <a:r>
-              <a:rPr sz="2100" b="1">
-                <a:solidFill>
-                  <a:srgbClr val="142D32"/>
-                </a:solidFill>
-                <a:latin typeface="Arial"/>
-                <a:ea typeface="Arial"/>
-                <a:cs typeface="Arial"/>
-              </a:rPr>
-              <a:t>Only use food themes.</a:t>
-            </a:r>
-          </a:p>
-          <a:p xmlns:a="http://schemas.openxmlformats.org/drawingml/2006/main">
-            <a:pPr algn="l">
-              <a:buNone/>
-              <a:defRPr sz="2700" b="1">
-                <a:solidFill>
-                  <a:srgbClr val="142D32"/>
-                </a:solidFill>
-                <a:latin typeface="Arial"/>
-                <a:ea typeface="Arial"/>
-                <a:cs typeface="Arial"/>
-              </a:defRPr>
-            </a:pPr>
-            <a:r>
-              <a:rPr sz="2700" b="1">
-                <a:solidFill>
-                  <a:srgbClr val="142D32"/>
-                </a:solidFill>
-                <a:latin typeface="Arial"/>
-                <a:ea typeface="Arial"/>
-                <a:cs typeface="Arial"/>
-              </a:rPr>
-              <a:t/>
-            </a:r>
-          </a:p>
-          <a:p xmlns:a="http://schemas.openxmlformats.org/drawingml/2006/main">
-            <a:pPr algn="l">
-              <a:buNone/>
-              <a:defRPr sz="2100" b="1">
-                <a:solidFill>
-                  <a:srgbClr val="142D32"/>
-                </a:solidFill>
-                <a:latin typeface="Arial"/>
-                <a:ea typeface="Arial"/>
-                <a:cs typeface="Arial"/>
-              </a:defRPr>
-            </a:pPr>
-            <a:r>
-              <a:rPr sz="2100" b="1">
-                <a:solidFill>
-                  <a:srgbClr val="142D32"/>
-                </a:solidFill>
-                <a:latin typeface="Arial"/>
-                <a:ea typeface="Arial"/>
-                <a:cs typeface="Arial"/>
-              </a:rPr>
-              <a:t>Make both choices ridiculous.</a:t>
-            </a:r>
-          </a:p>
-          <a:p xmlns:a="http://schemas.openxmlformats.org/drawingml/2006/main">
-            <a:pPr algn="l">
-              <a:buNone/>
-              <a:defRPr sz="2700" b="1">
-                <a:solidFill>
-                  <a:srgbClr val="142D32"/>
-                </a:solidFill>
-                <a:latin typeface="Arial"/>
-                <a:ea typeface="Arial"/>
-                <a:cs typeface="Arial"/>
-              </a:defRPr>
-            </a:pPr>
-            <a:r>
-              <a:rPr sz="2700" b="1">
-                <a:solidFill>
-                  <a:srgbClr val="142D32"/>
-                </a:solidFill>
-                <a:latin typeface="Arial"/>
-                <a:ea typeface="Arial"/>
-                <a:cs typeface="Arial"/>
-              </a:rPr>
-              <a:t/>
-            </a:r>
-          </a:p>
-          <a:p xmlns:a="http://schemas.openxmlformats.org/drawingml/2006/main">
-            <a:pPr algn="l">
-              <a:buNone/>
-              <a:defRPr sz="2100" b="1">
-                <a:solidFill>
-                  <a:srgbClr val="142D32"/>
-                </a:solidFill>
-                <a:latin typeface="Arial"/>
-                <a:ea typeface="Arial"/>
-                <a:cs typeface="Arial"/>
-              </a:defRPr>
-            </a:pPr>
-            <a:r>
-              <a:rPr sz="2100" b="1">
-                <a:solidFill>
-                  <a:srgbClr val="142D32"/>
-                </a:solidFill>
-                <a:latin typeface="Arial"/>
-                <a:ea typeface="Arial"/>
-                <a:cs typeface="Arial"/>
-              </a:rPr>
-              <a:t>Keep each choice one sentence.</a:t>
-            </a:r>
-          </a:p>
-        </p:txBody>
-      </p:sp>
-      <p:sp>
-        <p:nvSpPr>
-          <p:cNvPr id="11" name="left-caption">
-            <a:extLst xmlns:a="http://schemas.openxmlformats.org/drawingml/2006/main">
-              <a:ext uri="{FF2B5EF4-FFF2-40B4-BE49-F238E27FC236}">
-                <a16:creationId xmlns:a16="http://schemas.microsoft.com/office/drawing/2014/main" id="{25D8FBD5-2925-42B1-A10D-32015BA93D47}"/>
-              </a:ext>
-            </a:extLst>
-          </p:cNvPr>
-          <p:cNvSpPr>
-            <a:spLocks xmlns:a="http://schemas.openxmlformats.org/drawingml/2006/main" noGrp="1"/>
-          </p:cNvSpPr>
-          <p:nvPr/>
-        </p:nvSpPr>
-        <p:spPr>
-          <a:xfrm xmlns:a="http://schemas.openxmlformats.org/drawingml/2006/main">
-            <a:off x="609600" y="5524500"/>
-            <a:ext cx="5334000" cy="542925"/>
+              <a:t>Your workers.dev URL + /api/chat</a:t>
+            </a:r>
+          </a:p>
+        </p:txBody>
+      </p:sp>
+      <p:sp>
+        <p:nvSpPr>
+          <p:cNvPr id="12" name="number-1">
+            <a:extLst xmlns:a="http://schemas.openxmlformats.org/drawingml/2006/main">
+              <a:ext uri="{FF2B5EF4-FFF2-40B4-BE49-F238E27FC236}">
+                <a16:creationId xmlns:a16="http://schemas.microsoft.com/office/drawing/2014/main" id="{AD5A7334-AE57-4202-9AFA-95A3587926EB}"/>
+              </a:ext>
+            </a:extLst>
+          </p:cNvPr>
+          <p:cNvSpPr>
+            <a:spLocks xmlns:a="http://schemas.openxmlformats.org/drawingml/2006/main" noGrp="1"/>
+          </p:cNvSpPr>
+          <p:nvPr/>
+        </p:nvSpPr>
+        <p:spPr>
+          <a:xfrm xmlns:a="http://schemas.openxmlformats.org/drawingml/2006/main">
+            <a:off x="609600" y="3476625"/>
+            <a:ext cx="800100" cy="438150"/>
+          </a:xfrm>
+          <a:prstGeom xmlns:a="http://schemas.openxmlformats.org/drawingml/2006/main" prst="rect">
+            <a:avLst/>
+          </a:prstGeom>
+          <a:noFill xmlns:a="http://schemas.openxmlformats.org/drawingml/2006/main"/>
+          <a:ln xmlns:a="http://schemas.openxmlformats.org/drawingml/2006/main" w="0">
+            <a:noFill/>
+          </a:ln>
+        </p:spPr>
+        <p:txBody>
+          <a:bodyPr xmlns:a="http://schemas.openxmlformats.org/drawingml/2006/main" wrap="none" lIns="0" tIns="0" rIns="0" bIns="0" anchor="t">
+            <a:noAutofit/>
+          </a:bodyPr>
+          <a:lstStyle xmlns:a="http://schemas.openxmlformats.org/drawingml/2006/main"/>
+          <a:p xmlns:a="http://schemas.openxmlformats.org/drawingml/2006/main">
+            <a:pPr algn="l">
+              <a:buNone/>
+              <a:defRPr sz="2400" b="1">
+                <a:solidFill>
+                  <a:srgbClr val="087E80"/>
+                </a:solidFill>
+                <a:latin typeface="Arial"/>
+                <a:ea typeface="Arial"/>
+                <a:cs typeface="Arial"/>
+              </a:defRPr>
+            </a:pPr>
+            <a:r>
+              <a:rPr sz="2400" b="1">
+                <a:solidFill>
+                  <a:srgbClr val="087E80"/>
+                </a:solidFill>
+                <a:latin typeface="Arial"/>
+                <a:ea typeface="Arial"/>
+                <a:cs typeface="Arial"/>
+              </a:rPr>
+              <a:t>02</a:t>
+            </a:r>
+          </a:p>
+        </p:txBody>
+      </p:sp>
+      <p:sp>
+        <p:nvSpPr>
+          <p:cNvPr id="13" name="label-1">
+            <a:extLst xmlns:a="http://schemas.openxmlformats.org/drawingml/2006/main">
+              <a:ext uri="{FF2B5EF4-FFF2-40B4-BE49-F238E27FC236}">
+                <a16:creationId xmlns:a16="http://schemas.microsoft.com/office/drawing/2014/main" id="{103D2AB4-FD59-4411-8C36-0103588CA6F2}"/>
+              </a:ext>
+            </a:extLst>
+          </p:cNvPr>
+          <p:cNvSpPr>
+            <a:spLocks xmlns:a="http://schemas.openxmlformats.org/drawingml/2006/main" noGrp="1"/>
+          </p:cNvSpPr>
+          <p:nvPr/>
+        </p:nvSpPr>
+        <p:spPr>
+          <a:xfrm xmlns:a="http://schemas.openxmlformats.org/drawingml/2006/main">
+            <a:off x="1638300" y="3476625"/>
+            <a:ext cx="2476500" cy="438150"/>
+          </a:xfrm>
+          <a:prstGeom xmlns:a="http://schemas.openxmlformats.org/drawingml/2006/main" prst="rect">
+            <a:avLst/>
+          </a:prstGeom>
+          <a:noFill xmlns:a="http://schemas.openxmlformats.org/drawingml/2006/main"/>
+          <a:ln xmlns:a="http://schemas.openxmlformats.org/drawingml/2006/main" w="0">
+            <a:noFill/>
+          </a:ln>
+        </p:spPr>
+        <p:txBody>
+          <a:bodyPr xmlns:a="http://schemas.openxmlformats.org/drawingml/2006/main" wrap="none" lIns="0" tIns="0" rIns="0" bIns="0" anchor="t">
+            <a:noAutofit/>
+          </a:bodyPr>
+          <a:lstStyle xmlns:a="http://schemas.openxmlformats.org/drawingml/2006/main"/>
+          <a:p xmlns:a="http://schemas.openxmlformats.org/drawingml/2006/main">
+            <a:pPr algn="l">
+              <a:buNone/>
+              <a:defRPr sz="1950" b="1">
+                <a:solidFill>
+                  <a:srgbClr val="142D32"/>
+                </a:solidFill>
+                <a:latin typeface="Arial"/>
+                <a:ea typeface="Arial"/>
+                <a:cs typeface="Arial"/>
+              </a:defRPr>
+            </a:pPr>
+            <a:r>
+              <a:rPr sz="1950" b="1">
+                <a:solidFill>
+                  <a:srgbClr val="142D32"/>
+                </a:solidFill>
+                <a:latin typeface="Arial"/>
+                <a:ea typeface="Arial"/>
+                <a:cs typeface="Arial"/>
+              </a:rPr>
+              <a:t>Publish the edit</a:t>
+            </a:r>
+          </a:p>
+        </p:txBody>
+      </p:sp>
+      <p:sp>
+        <p:nvSpPr>
+          <p:cNvPr id="14" name="detail-1">
+            <a:extLst xmlns:a="http://schemas.openxmlformats.org/drawingml/2006/main">
+              <a:ext uri="{FF2B5EF4-FFF2-40B4-BE49-F238E27FC236}">
+                <a16:creationId xmlns:a16="http://schemas.microsoft.com/office/drawing/2014/main" id="{A5914C25-27E7-47D8-9ACC-EFCE8E16BC3D}"/>
+              </a:ext>
+            </a:extLst>
+          </p:cNvPr>
+          <p:cNvSpPr>
+            <a:spLocks xmlns:a="http://schemas.openxmlformats.org/drawingml/2006/main" noGrp="1"/>
+          </p:cNvSpPr>
+          <p:nvPr/>
+        </p:nvSpPr>
+        <p:spPr>
+          <a:xfrm xmlns:a="http://schemas.openxmlformats.org/drawingml/2006/main">
+            <a:off x="4476750" y="3505200"/>
+            <a:ext cx="7067550" cy="409575"/>
           </a:xfrm>
           <a:prstGeom xmlns:a="http://schemas.openxmlformats.org/drawingml/2006/main" prst="rect">
             <a:avLst/>
@@ -5042,47 +5430,47 @@
                 <a:ea typeface="Arial"/>
                 <a:cs typeface="Arial"/>
               </a:rPr>
-              <a:t>Change the text inside INSTRUCTIONS.</a:t>
-            </a:r>
-          </a:p>
-        </p:txBody>
-      </p:sp>
-      <p:sp>
-        <p:nvSpPr>
-          <p:cNvPr id="12" name="right-label">
-            <a:extLst xmlns:a="http://schemas.openxmlformats.org/drawingml/2006/main">
-              <a:ext uri="{FF2B5EF4-FFF2-40B4-BE49-F238E27FC236}">
-                <a16:creationId xmlns:a16="http://schemas.microsoft.com/office/drawing/2014/main" id="{03B0C3C5-AB47-47C5-86F9-888C436E1B3E}"/>
-              </a:ext>
-            </a:extLst>
-          </p:cNvPr>
-          <p:cNvSpPr>
-            <a:spLocks xmlns:a="http://schemas.openxmlformats.org/drawingml/2006/main" noGrp="1"/>
-          </p:cNvSpPr>
-          <p:nvPr/>
-        </p:nvSpPr>
-        <p:spPr>
-          <a:xfrm xmlns:a="http://schemas.openxmlformats.org/drawingml/2006/main">
-            <a:off x="6610350" y="2752725"/>
-            <a:ext cx="4972050" cy="304800"/>
-          </a:xfrm>
-          <a:prstGeom xmlns:a="http://schemas.openxmlformats.org/drawingml/2006/main" prst="rect">
-            <a:avLst/>
-          </a:prstGeom>
-          <a:noFill xmlns:a="http://schemas.openxmlformats.org/drawingml/2006/main"/>
-          <a:ln xmlns:a="http://schemas.openxmlformats.org/drawingml/2006/main" w="0">
-            <a:noFill/>
-          </a:ln>
-        </p:spPr>
-        <p:txBody>
-          <a:bodyPr xmlns:a="http://schemas.openxmlformats.org/drawingml/2006/main" wrap="none" lIns="0" tIns="0" rIns="0" bIns="0" anchor="t">
-            <a:noAutofit/>
-          </a:bodyPr>
-          <a:lstStyle xmlns:a="http://schemas.openxmlformats.org/drawingml/2006/main"/>
-          <a:p xmlns:a="http://schemas.openxmlformats.org/drawingml/2006/main">
-            <a:pPr algn="l">
-              <a:buNone/>
-              <a:defRPr sz="1425" b="1">
+              <a:t>Commit changes → wait for Pages → refresh</a:t>
+            </a:r>
+          </a:p>
+        </p:txBody>
+      </p:sp>
+      <p:sp>
+        <p:nvSpPr>
+          <p:cNvPr id="15" name="number-2">
+            <a:extLst xmlns:a="http://schemas.openxmlformats.org/drawingml/2006/main">
+              <a:ext uri="{FF2B5EF4-FFF2-40B4-BE49-F238E27FC236}">
+                <a16:creationId xmlns:a16="http://schemas.microsoft.com/office/drawing/2014/main" id="{48C15E34-16CE-4F28-B10B-104872F8D180}"/>
+              </a:ext>
+            </a:extLst>
+          </p:cNvPr>
+          <p:cNvSpPr>
+            <a:spLocks xmlns:a="http://schemas.openxmlformats.org/drawingml/2006/main" noGrp="1"/>
+          </p:cNvSpPr>
+          <p:nvPr/>
+        </p:nvSpPr>
+        <p:spPr>
+          <a:xfrm xmlns:a="http://schemas.openxmlformats.org/drawingml/2006/main">
+            <a:off x="609600" y="4191000"/>
+            <a:ext cx="800100" cy="438150"/>
+          </a:xfrm>
+          <a:prstGeom xmlns:a="http://schemas.openxmlformats.org/drawingml/2006/main" prst="rect">
+            <a:avLst/>
+          </a:prstGeom>
+          <a:noFill xmlns:a="http://schemas.openxmlformats.org/drawingml/2006/main"/>
+          <a:ln xmlns:a="http://schemas.openxmlformats.org/drawingml/2006/main" w="0">
+            <a:noFill/>
+          </a:ln>
+        </p:spPr>
+        <p:txBody>
+          <a:bodyPr xmlns:a="http://schemas.openxmlformats.org/drawingml/2006/main" wrap="none" lIns="0" tIns="0" rIns="0" bIns="0" anchor="t">
+            <a:noAutofit/>
+          </a:bodyPr>
+          <a:lstStyle xmlns:a="http://schemas.openxmlformats.org/drawingml/2006/main"/>
+          <a:p xmlns:a="http://schemas.openxmlformats.org/drawingml/2006/main">
+            <a:pPr algn="l">
+              <a:buNone/>
+              <a:defRPr sz="2400" b="1">
                 <a:solidFill>
                   <a:srgbClr val="087E80"/>
                 </a:solidFill>
@@ -5092,7 +5480,7 @@
               </a:defRPr>
             </a:pPr>
             <a:r>
-              <a:rPr sz="1425" b="1">
+              <a:rPr sz="2400" b="1">
                 <a:solidFill>
                   <a:srgbClr val="087E80"/>
                 </a:solidFill>
@@ -5100,135 +5488,87 @@
                 <a:ea typeface="Arial"/>
                 <a:cs typeface="Arial"/>
               </a:rPr>
-              <a:t>KEEP THE CODE AROUND IT</a:t>
-            </a:r>
-          </a:p>
-        </p:txBody>
-      </p:sp>
-      <p:sp>
-        <p:nvSpPr>
-          <p:cNvPr id="13" name="right-prompt">
-            <a:extLst xmlns:a="http://schemas.openxmlformats.org/drawingml/2006/main">
-              <a:ext uri="{FF2B5EF4-FFF2-40B4-BE49-F238E27FC236}">
-                <a16:creationId xmlns:a16="http://schemas.microsoft.com/office/drawing/2014/main" id="{59F90D52-9B1C-4538-8AA2-B3B63DC2FB4F}"/>
-              </a:ext>
-            </a:extLst>
-          </p:cNvPr>
-          <p:cNvSpPr>
-            <a:spLocks xmlns:a="http://schemas.openxmlformats.org/drawingml/2006/main" noGrp="1"/>
-          </p:cNvSpPr>
-          <p:nvPr/>
-        </p:nvSpPr>
-        <p:spPr>
-          <a:xfrm xmlns:a="http://schemas.openxmlformats.org/drawingml/2006/main">
-            <a:off x="6610350" y="3314700"/>
-            <a:ext cx="4972050" cy="1571625"/>
-          </a:xfrm>
-          <a:prstGeom xmlns:a="http://schemas.openxmlformats.org/drawingml/2006/main" prst="rect">
-            <a:avLst/>
-          </a:prstGeom>
-          <a:noFill xmlns:a="http://schemas.openxmlformats.org/drawingml/2006/main"/>
-          <a:ln xmlns:a="http://schemas.openxmlformats.org/drawingml/2006/main" w="0">
-            <a:noFill/>
-          </a:ln>
-        </p:spPr>
-        <p:txBody>
-          <a:bodyPr xmlns:a="http://schemas.openxmlformats.org/drawingml/2006/main" wrap="none" lIns="0" tIns="0" rIns="0" bIns="0" anchor="t">
-            <a:noAutofit/>
-          </a:bodyPr>
-          <a:lstStyle xmlns:a="http://schemas.openxmlformats.org/drawingml/2006/main"/>
-          <a:p xmlns:a="http://schemas.openxmlformats.org/drawingml/2006/main">
-            <a:pPr algn="l">
-              <a:buNone/>
-              <a:defRPr sz="2175" b="1">
-                <a:solidFill>
-                  <a:srgbClr val="142D32"/>
-                </a:solidFill>
-                <a:latin typeface="Arial"/>
-                <a:ea typeface="Arial"/>
-                <a:cs typeface="Arial"/>
-              </a:defRPr>
-            </a:pPr>
-            <a:r>
-              <a:rPr sz="2175" b="1">
-                <a:solidFill>
-                  <a:srgbClr val="142D32"/>
-                </a:solidFill>
-                <a:latin typeface="Arial"/>
-                <a:ea typeface="Arial"/>
-                <a:cs typeface="Arial"/>
-              </a:rPr>
-              <a:t>Keep the backticks.</a:t>
-            </a:r>
-          </a:p>
-          <a:p xmlns:a="http://schemas.openxmlformats.org/drawingml/2006/main">
-            <a:pPr algn="l">
-              <a:buNone/>
-              <a:defRPr sz="2175" b="1">
-                <a:solidFill>
-                  <a:srgbClr val="142D32"/>
-                </a:solidFill>
-                <a:latin typeface="Arial"/>
-                <a:ea typeface="Arial"/>
-                <a:cs typeface="Arial"/>
-              </a:defRPr>
-            </a:pPr>
-            <a:r>
-              <a:rPr sz="2175" b="1">
-                <a:solidFill>
-                  <a:srgbClr val="142D32"/>
-                </a:solidFill>
-                <a:latin typeface="Arial"/>
-                <a:ea typeface="Arial"/>
-                <a:cs typeface="Arial"/>
-              </a:rPr>
-              <a:t>Edit the instruction text.</a:t>
-            </a:r>
-          </a:p>
-          <a:p xmlns:a="http://schemas.openxmlformats.org/drawingml/2006/main">
-            <a:pPr algn="l">
-              <a:buNone/>
-              <a:defRPr sz="2175" b="1">
-                <a:solidFill>
-                  <a:srgbClr val="142D32"/>
-                </a:solidFill>
-                <a:latin typeface="Arial"/>
-                <a:ea typeface="Arial"/>
-                <a:cs typeface="Arial"/>
-              </a:defRPr>
-            </a:pPr>
-            <a:r>
-              <a:rPr sz="2175" b="1">
-                <a:solidFill>
-                  <a:srgbClr val="142D32"/>
-                </a:solidFill>
-                <a:latin typeface="Arial"/>
-                <a:ea typeface="Arial"/>
-                <a:cs typeface="Arial"/>
-              </a:rPr>
-              <a:t>Click Commit changes.</a:t>
-            </a:r>
-          </a:p>
-        </p:txBody>
-      </p:sp>
-      <p:sp>
-        <p:nvSpPr>
-          <p:cNvPr id="14" name="right-caption">
-            <a:extLst xmlns:a="http://schemas.openxmlformats.org/drawingml/2006/main">
-              <a:ext uri="{FF2B5EF4-FFF2-40B4-BE49-F238E27FC236}">
-                <a16:creationId xmlns:a16="http://schemas.microsoft.com/office/drawing/2014/main" id="{5B07DFD3-E43F-4008-8F22-CC5D5DF20D5C}"/>
-              </a:ext>
-            </a:extLst>
-          </p:cNvPr>
-          <p:cNvSpPr>
-            <a:spLocks xmlns:a="http://schemas.openxmlformats.org/drawingml/2006/main" noGrp="1"/>
-          </p:cNvSpPr>
-          <p:nvPr/>
-        </p:nvSpPr>
-        <p:spPr>
-          <a:xfrm xmlns:a="http://schemas.openxmlformats.org/drawingml/2006/main">
-            <a:off x="6610350" y="5524500"/>
-            <a:ext cx="4972050" cy="542925"/>
+              <a:t>03</a:t>
+            </a:r>
+          </a:p>
+        </p:txBody>
+      </p:sp>
+      <p:sp>
+        <p:nvSpPr>
+          <p:cNvPr id="16" name="label-2">
+            <a:extLst xmlns:a="http://schemas.openxmlformats.org/drawingml/2006/main">
+              <a:ext uri="{FF2B5EF4-FFF2-40B4-BE49-F238E27FC236}">
+                <a16:creationId xmlns:a16="http://schemas.microsoft.com/office/drawing/2014/main" id="{2D9E683A-398A-4AB2-AA79-A9276DCE23D4}"/>
+              </a:ext>
+            </a:extLst>
+          </p:cNvPr>
+          <p:cNvSpPr>
+            <a:spLocks xmlns:a="http://schemas.openxmlformats.org/drawingml/2006/main" noGrp="1"/>
+          </p:cNvSpPr>
+          <p:nvPr/>
+        </p:nvSpPr>
+        <p:spPr>
+          <a:xfrm xmlns:a="http://schemas.openxmlformats.org/drawingml/2006/main">
+            <a:off x="1638300" y="4191000"/>
+            <a:ext cx="2476500" cy="438150"/>
+          </a:xfrm>
+          <a:prstGeom xmlns:a="http://schemas.openxmlformats.org/drawingml/2006/main" prst="rect">
+            <a:avLst/>
+          </a:prstGeom>
+          <a:noFill xmlns:a="http://schemas.openxmlformats.org/drawingml/2006/main"/>
+          <a:ln xmlns:a="http://schemas.openxmlformats.org/drawingml/2006/main" w="0">
+            <a:noFill/>
+          </a:ln>
+        </p:spPr>
+        <p:txBody>
+          <a:bodyPr xmlns:a="http://schemas.openxmlformats.org/drawingml/2006/main" wrap="none" lIns="0" tIns="0" rIns="0" bIns="0" anchor="t">
+            <a:noAutofit/>
+          </a:bodyPr>
+          <a:lstStyle xmlns:a="http://schemas.openxmlformats.org/drawingml/2006/main"/>
+          <a:p xmlns:a="http://schemas.openxmlformats.org/drawingml/2006/main">
+            <a:pPr algn="l">
+              <a:buNone/>
+              <a:defRPr sz="1950" b="1">
+                <a:solidFill>
+                  <a:srgbClr val="142D32"/>
+                </a:solidFill>
+                <a:latin typeface="Arial"/>
+                <a:ea typeface="Arial"/>
+                <a:cs typeface="Arial"/>
+              </a:defRPr>
+            </a:pPr>
+            <a:r>
+              <a:rPr sz="1950" b="1">
+                <a:solidFill>
+                  <a:srgbClr val="142D32"/>
+                </a:solidFill>
+                <a:latin typeface="Arial"/>
+                <a:ea typeface="Arial"/>
+                <a:cs typeface="Arial"/>
+              </a:rPr>
+              <a:t>Try your bot</a:t>
+            </a:r>
+          </a:p>
+        </p:txBody>
+      </p:sp>
+      <p:sp>
+        <p:nvSpPr>
+          <p:cNvPr id="17" name="detail-2">
+            <a:extLst xmlns:a="http://schemas.openxmlformats.org/drawingml/2006/main">
+              <a:ext uri="{FF2B5EF4-FFF2-40B4-BE49-F238E27FC236}">
+                <a16:creationId xmlns:a16="http://schemas.microsoft.com/office/drawing/2014/main" id="{86AC9DF9-265A-4051-90FA-C86F9F89C9A9}"/>
+              </a:ext>
+            </a:extLst>
+          </p:cNvPr>
+          <p:cNvSpPr>
+            <a:spLocks xmlns:a="http://schemas.openxmlformats.org/drawingml/2006/main" noGrp="1"/>
+          </p:cNvSpPr>
+          <p:nvPr/>
+        </p:nvSpPr>
+        <p:spPr>
+          <a:xfrm xmlns:a="http://schemas.openxmlformats.org/drawingml/2006/main">
+            <a:off x="4476750" y="4219575"/>
+            <a:ext cx="7067550" cy="409575"/>
           </a:xfrm>
           <a:prstGeom xmlns:a="http://schemas.openxmlformats.org/drawingml/2006/main" prst="rect">
             <a:avLst/>
@@ -5264,7 +5604,181 @@
                 <a:ea typeface="Arial"/>
                 <a:cs typeface="Arial"/>
               </a:rPr>
-              <a:t>Predict how the answer will change.</a:t>
+              <a:t>Give me a dilemma → type superpowers → Send</a:t>
+            </a:r>
+          </a:p>
+        </p:txBody>
+      </p:sp>
+      <p:sp>
+        <p:nvSpPr>
+          <p:cNvPr id="18" name="number-3">
+            <a:extLst xmlns:a="http://schemas.openxmlformats.org/drawingml/2006/main">
+              <a:ext uri="{FF2B5EF4-FFF2-40B4-BE49-F238E27FC236}">
+                <a16:creationId xmlns:a16="http://schemas.microsoft.com/office/drawing/2014/main" id="{B815891C-F9E3-4E7E-9B17-326932EE6564}"/>
+              </a:ext>
+            </a:extLst>
+          </p:cNvPr>
+          <p:cNvSpPr>
+            <a:spLocks xmlns:a="http://schemas.openxmlformats.org/drawingml/2006/main" noGrp="1"/>
+          </p:cNvSpPr>
+          <p:nvPr/>
+        </p:nvSpPr>
+        <p:spPr>
+          <a:xfrm xmlns:a="http://schemas.openxmlformats.org/drawingml/2006/main">
+            <a:off x="609600" y="4905375"/>
+            <a:ext cx="800100" cy="438150"/>
+          </a:xfrm>
+          <a:prstGeom xmlns:a="http://schemas.openxmlformats.org/drawingml/2006/main" prst="rect">
+            <a:avLst/>
+          </a:prstGeom>
+          <a:noFill xmlns:a="http://schemas.openxmlformats.org/drawingml/2006/main"/>
+          <a:ln xmlns:a="http://schemas.openxmlformats.org/drawingml/2006/main" w="0">
+            <a:noFill/>
+          </a:ln>
+        </p:spPr>
+        <p:txBody>
+          <a:bodyPr xmlns:a="http://schemas.openxmlformats.org/drawingml/2006/main" wrap="none" lIns="0" tIns="0" rIns="0" bIns="0" anchor="t">
+            <a:noAutofit/>
+          </a:bodyPr>
+          <a:lstStyle xmlns:a="http://schemas.openxmlformats.org/drawingml/2006/main"/>
+          <a:p xmlns:a="http://schemas.openxmlformats.org/drawingml/2006/main">
+            <a:pPr algn="l">
+              <a:buNone/>
+              <a:defRPr sz="2400" b="1">
+                <a:solidFill>
+                  <a:srgbClr val="087E80"/>
+                </a:solidFill>
+                <a:latin typeface="Arial"/>
+                <a:ea typeface="Arial"/>
+                <a:cs typeface="Arial"/>
+              </a:defRPr>
+            </a:pPr>
+            <a:r>
+              <a:rPr sz="2400" b="1">
+                <a:solidFill>
+                  <a:srgbClr val="087E80"/>
+                </a:solidFill>
+                <a:latin typeface="Arial"/>
+                <a:ea typeface="Arial"/>
+                <a:cs typeface="Arial"/>
+              </a:rPr>
+              <a:t>04</a:t>
+            </a:r>
+          </a:p>
+        </p:txBody>
+      </p:sp>
+      <p:sp>
+        <p:nvSpPr>
+          <p:cNvPr id="19" name="label-3">
+            <a:extLst xmlns:a="http://schemas.openxmlformats.org/drawingml/2006/main">
+              <a:ext uri="{FF2B5EF4-FFF2-40B4-BE49-F238E27FC236}">
+                <a16:creationId xmlns:a16="http://schemas.microsoft.com/office/drawing/2014/main" id="{D16D2124-C19D-4287-BA72-4BAFA52DD5C6}"/>
+              </a:ext>
+            </a:extLst>
+          </p:cNvPr>
+          <p:cNvSpPr>
+            <a:spLocks xmlns:a="http://schemas.openxmlformats.org/drawingml/2006/main" noGrp="1"/>
+          </p:cNvSpPr>
+          <p:nvPr/>
+        </p:nvSpPr>
+        <p:spPr>
+          <a:xfrm xmlns:a="http://schemas.openxmlformats.org/drawingml/2006/main">
+            <a:off x="1638300" y="4905375"/>
+            <a:ext cx="2476500" cy="438150"/>
+          </a:xfrm>
+          <a:prstGeom xmlns:a="http://schemas.openxmlformats.org/drawingml/2006/main" prst="rect">
+            <a:avLst/>
+          </a:prstGeom>
+          <a:noFill xmlns:a="http://schemas.openxmlformats.org/drawingml/2006/main"/>
+          <a:ln xmlns:a="http://schemas.openxmlformats.org/drawingml/2006/main" w="0">
+            <a:noFill/>
+          </a:ln>
+        </p:spPr>
+        <p:txBody>
+          <a:bodyPr xmlns:a="http://schemas.openxmlformats.org/drawingml/2006/main" wrap="none" lIns="0" tIns="0" rIns="0" bIns="0" anchor="t">
+            <a:noAutofit/>
+          </a:bodyPr>
+          <a:lstStyle xmlns:a="http://schemas.openxmlformats.org/drawingml/2006/main"/>
+          <a:p xmlns:a="http://schemas.openxmlformats.org/drawingml/2006/main">
+            <a:pPr algn="l">
+              <a:buNone/>
+              <a:defRPr sz="1950" b="1">
+                <a:solidFill>
+                  <a:srgbClr val="142D32"/>
+                </a:solidFill>
+                <a:latin typeface="Arial"/>
+                <a:ea typeface="Arial"/>
+                <a:cs typeface="Arial"/>
+              </a:defRPr>
+            </a:pPr>
+            <a:r>
+              <a:rPr sz="1950" b="1">
+                <a:solidFill>
+                  <a:srgbClr val="142D32"/>
+                </a:solidFill>
+                <a:latin typeface="Arial"/>
+                <a:ea typeface="Arial"/>
+                <a:cs typeface="Arial"/>
+              </a:rPr>
+              <a:t>Try both layouts</a:t>
+            </a:r>
+          </a:p>
+        </p:txBody>
+      </p:sp>
+      <p:sp>
+        <p:nvSpPr>
+          <p:cNvPr id="20" name="detail-3">
+            <a:extLst xmlns:a="http://schemas.openxmlformats.org/drawingml/2006/main">
+              <a:ext uri="{FF2B5EF4-FFF2-40B4-BE49-F238E27FC236}">
+                <a16:creationId xmlns:a16="http://schemas.microsoft.com/office/drawing/2014/main" id="{9219B99F-90F8-4C32-9F2B-5F01F554F722}"/>
+              </a:ext>
+            </a:extLst>
+          </p:cNvPr>
+          <p:cNvSpPr>
+            <a:spLocks xmlns:a="http://schemas.openxmlformats.org/drawingml/2006/main" noGrp="1"/>
+          </p:cNvSpPr>
+          <p:nvPr/>
+        </p:nvSpPr>
+        <p:spPr>
+          <a:xfrm xmlns:a="http://schemas.openxmlformats.org/drawingml/2006/main">
+            <a:off x="4476750" y="4933950"/>
+            <a:ext cx="7067550" cy="409575"/>
+          </a:xfrm>
+          <a:prstGeom xmlns:a="http://schemas.openxmlformats.org/drawingml/2006/main" prst="rect">
+            <a:avLst/>
+          </a:prstGeom>
+          <a:noFill xmlns:a="http://schemas.openxmlformats.org/drawingml/2006/main"/>
+          <a:ln xmlns:a="http://schemas.openxmlformats.org/drawingml/2006/main" w="0">
+            <a:noFill/>
+          </a:ln>
+        </p:spPr>
+        <p:txBody>
+          <a:bodyPr xmlns:a="http://schemas.openxmlformats.org/drawingml/2006/main" wrap="none" lIns="0" tIns="0" rIns="0" bIns="0" anchor="t">
+            <a:noAutofit/>
+          </a:bodyPr>
+          <a:lstStyle xmlns:a="http://schemas.openxmlformats.org/drawingml/2006/main"/>
+          <a:p xmlns:a="http://schemas.openxmlformats.org/drawingml/2006/main">
+            <a:pPr algn="l">
+              <a:buNone/>
+              <a:defRPr sz="1800" b="0">
+                <a:solidFill>
+                  <a:srgbClr val="53686C"/>
+                </a:solidFill>
+                <a:latin typeface="Arial"/>
+                <a:ea typeface="Arial"/>
+                <a:cs typeface="Arial"/>
+              </a:defRPr>
+            </a:pPr>
+            <a:r>
+              <a:rPr sz="1800" b="0">
+                <a:solidFill>
+                  <a:srgbClr val="53686C"/>
+                </a:solidFill>
+                <a:latin typeface="Arial"/>
+                <a:ea typeface="Arial"/>
+                <a:cs typeface="Arial"/>
+              </a:rPr>
+              <a:t>Floating button or the Full-page game link</a:t>
             </a:r>
           </a:p>
         </p:txBody>
@@ -5272,7 +5786,7 @@
     </p:spTree>
     <p:extLst>
       <p:ext uri="{BB962C8B-B14F-4D97-AF65-F5344CB8AC3E}">
-        <p14:creationId xmlns:p14="http://schemas.microsoft.com/office/powerpoint/2010/main" val="1499610271"/>
+        <p14:creationId xmlns:p14="http://schemas.microsoft.com/office/powerpoint/2010/main" val="398891925"/>
       </p:ext>
     </p:extLst>
   </p:cSld>
@@ -5300,10 +5814,10 @@
       </p:grpSpPr>
       <p:sp>
         <p:nvSpPr>
-          <p:cNvPr id="11" name="club">
-            <a:extLst xmlns:a="http://schemas.openxmlformats.org/drawingml/2006/main">
-              <a:ext uri="{FF2B5EF4-FFF2-40B4-BE49-F238E27FC236}">
-                <a16:creationId xmlns:a16="http://schemas.microsoft.com/office/drawing/2014/main" id="{30F3744F-9046-463F-9D84-F322F7F45C2F}"/>
+          <p:cNvPr id="15" name="club">
+            <a:extLst xmlns:a="http://schemas.openxmlformats.org/drawingml/2006/main">
+              <a:ext uri="{FF2B5EF4-FFF2-40B4-BE49-F238E27FC236}">
+                <a16:creationId xmlns:a16="http://schemas.microsoft.com/office/drawing/2014/main" id="{9E83BF3D-4E04-49A2-A99B-2303192D1937}"/>
               </a:ext>
             </a:extLst>
           </p:cNvPr>
@@ -5361,7 +5875,7 @@
           <p:cNvPr id="3" name="title">
             <a:extLst xmlns:a="http://schemas.openxmlformats.org/drawingml/2006/main">
               <a:ext uri="{FF2B5EF4-FFF2-40B4-BE49-F238E27FC236}">
-                <a16:creationId xmlns:a16="http://schemas.microsoft.com/office/drawing/2014/main" id="{8B46E0BB-21F9-4F6E-9206-F8237D0B2A5A}"/>
+                <a16:creationId xmlns:a16="http://schemas.microsoft.com/office/drawing/2014/main" id="{A66A34A4-4A81-42D5-B58A-9B73C21546DF}"/>
               </a:ext>
             </a:extLst>
           </p:cNvPr>
@@ -5409,7 +5923,7 @@
                 <a:ea typeface="Arial"/>
                 <a:cs typeface="Arial"/>
               </a:rPr>
-              <a:t>Your updated game</a:t>
+              <a:t>Make the game yours</a:t>
             </a:r>
           </a:p>
         </p:txBody>
@@ -5419,7 +5933,7 @@
           <p:cNvPr id="4" name="subheader">
             <a:extLst xmlns:a="http://schemas.openxmlformats.org/drawingml/2006/main">
               <a:ext uri="{FF2B5EF4-FFF2-40B4-BE49-F238E27FC236}">
-                <a16:creationId xmlns:a16="http://schemas.microsoft.com/office/drawing/2014/main" id="{C71F0A53-F290-49BB-BABC-015CF06D9A95}"/>
+                <a16:creationId xmlns:a16="http://schemas.microsoft.com/office/drawing/2014/main" id="{C1B0794C-E341-4380-9A7B-1FBF40F989AC}"/>
               </a:ext>
             </a:extLst>
           </p:cNvPr>
@@ -5467,7 +5981,7 @@
                 <a:ea typeface="Arial"/>
                 <a:cs typeface="Arial"/>
               </a:rPr>
-              <a:t>Wait for publishing, then refresh the live page</a:t>
+              <a:t>Change the title in index.html or INSTRUCTIONS in api/worker.mjs</a:t>
             </a:r>
           </a:p>
         </p:txBody>
@@ -5477,7 +5991,7 @@
           <p:cNvPr id="8" name="footer-page">
             <a:extLst xmlns:a="http://schemas.openxmlformats.org/drawingml/2006/main">
               <a:ext uri="{FF2B5EF4-FFF2-40B4-BE49-F238E27FC236}">
-                <a16:creationId xmlns:a16="http://schemas.microsoft.com/office/drawing/2014/main" id="{CCD84621-7C73-4823-A9C6-1F09A22F351D}"/>
+                <a16:creationId xmlns:a16="http://schemas.microsoft.com/office/drawing/2014/main" id="{28852A21-0BEF-4D32-B0EF-ED940BEFFFA1}"/>
               </a:ext>
             </a:extLst>
           </p:cNvPr>
@@ -5532,104 +6046,80 @@
       </p:sp>
       <p:sp>
         <p:nvSpPr>
-          <p:cNvPr id="9" name="reflection-question">
-            <a:extLst xmlns:a="http://schemas.openxmlformats.org/drawingml/2006/main">
-              <a:ext uri="{FF2B5EF4-FFF2-40B4-BE49-F238E27FC236}">
-                <a16:creationId xmlns:a16="http://schemas.microsoft.com/office/drawing/2014/main" id="{8F356028-E54E-4957-A85C-A4E198C06721}"/>
-              </a:ext>
-            </a:extLst>
-          </p:cNvPr>
-          <p:cNvSpPr>
-            <a:spLocks xmlns:a="http://schemas.openxmlformats.org/drawingml/2006/main" noGrp="1"/>
-          </p:cNvSpPr>
-          <p:nvPr/>
-        </p:nvSpPr>
-        <p:spPr>
-          <a:xfrm xmlns:a="http://schemas.openxmlformats.org/drawingml/2006/main">
-            <a:off x="609600" y="2847975"/>
-            <a:ext cx="10972800" cy="1457325"/>
-          </a:xfrm>
-          <a:prstGeom xmlns:a="http://schemas.openxmlformats.org/drawingml/2006/main" prst="rect">
-            <a:avLst/>
-          </a:prstGeom>
-          <a:noFill xmlns:a="http://schemas.openxmlformats.org/drawingml/2006/main"/>
-          <a:ln xmlns:a="http://schemas.openxmlformats.org/drawingml/2006/main" w="0">
-            <a:noFill/>
-          </a:ln>
-        </p:spPr>
-        <p:txBody>
-          <a:bodyPr xmlns:a="http://schemas.openxmlformats.org/drawingml/2006/main" wrap="none" lIns="0" tIns="0" rIns="0" bIns="0" anchor="t">
-            <a:noAutofit/>
-          </a:bodyPr>
-          <a:lstStyle xmlns:a="http://schemas.openxmlformats.org/drawingml/2006/main"/>
-          <a:p xmlns:a="http://schemas.openxmlformats.org/drawingml/2006/main">
-            <a:pPr algn="l">
-              <a:buNone/>
-              <a:defRPr sz="3300" b="1">
-                <a:solidFill>
-                  <a:srgbClr val="142D32"/>
-                </a:solidFill>
-                <a:latin typeface="Arial"/>
-                <a:ea typeface="Arial"/>
-                <a:cs typeface="Arial"/>
-              </a:defRPr>
-            </a:pPr>
-            <a:r>
-              <a:rPr sz="3300" b="1">
-                <a:solidFill>
-                  <a:srgbClr val="142D32"/>
-                </a:solidFill>
-                <a:latin typeface="Arial"/>
-                <a:ea typeface="Arial"/>
-                <a:cs typeface="Arial"/>
-              </a:rPr>
-              <a:t>Which would you choose?</a:t>
-            </a:r>
-          </a:p>
-          <a:p xmlns:a="http://schemas.openxmlformats.org/drawingml/2006/main">
-            <a:pPr algn="l">
-              <a:buNone/>
-              <a:defRPr sz="3300" b="1">
-                <a:solidFill>
-                  <a:srgbClr val="142D32"/>
-                </a:solidFill>
-                <a:latin typeface="Arial"/>
-                <a:ea typeface="Arial"/>
-                <a:cs typeface="Arial"/>
-              </a:defRPr>
-            </a:pPr>
-            <a:r>
-              <a:rPr sz="3300" b="1">
-                <a:solidFill>
-                  <a:srgbClr val="142D32"/>
-                </a:solidFill>
-                <a:latin typeface="Arial"/>
-                <a:ea typeface="Arial"/>
-                <a:cs typeface="Arial"/>
-              </a:rPr>
-              <a:t>Did your edit make it more fun?</a:t>
-            </a:r>
-          </a:p>
-        </p:txBody>
-      </p:sp>
-      <p:sp>
-        <p:nvSpPr>
-          <p:cNvPr id="10" name="reflection-next">
-            <a:extLst xmlns:a="http://schemas.openxmlformats.org/drawingml/2006/main">
-              <a:ext uri="{FF2B5EF4-FFF2-40B4-BE49-F238E27FC236}">
-                <a16:creationId xmlns:a16="http://schemas.microsoft.com/office/drawing/2014/main" id="{3B7A4D94-60A1-4091-8FB4-FA4060EB0668}"/>
-              </a:ext>
-            </a:extLst>
-          </p:cNvPr>
-          <p:cNvSpPr>
-            <a:spLocks xmlns:a="http://schemas.openxmlformats.org/drawingml/2006/main" noGrp="1"/>
-          </p:cNvSpPr>
-          <p:nvPr/>
-        </p:nvSpPr>
-        <p:spPr>
-          <a:xfrm xmlns:a="http://schemas.openxmlformats.org/drawingml/2006/main">
-            <a:off x="638175" y="4781550"/>
-            <a:ext cx="10944225" cy="609600"/>
+          <p:cNvPr id="9" name="left-label">
+            <a:extLst xmlns:a="http://schemas.openxmlformats.org/drawingml/2006/main">
+              <a:ext uri="{FF2B5EF4-FFF2-40B4-BE49-F238E27FC236}">
+                <a16:creationId xmlns:a16="http://schemas.microsoft.com/office/drawing/2014/main" id="{14E39621-3B97-4313-AF9C-62C6D82598D7}"/>
+              </a:ext>
+            </a:extLst>
+          </p:cNvPr>
+          <p:cNvSpPr>
+            <a:spLocks xmlns:a="http://schemas.openxmlformats.org/drawingml/2006/main" noGrp="1"/>
+          </p:cNvSpPr>
+          <p:nvPr/>
+        </p:nvSpPr>
+        <p:spPr>
+          <a:xfrm xmlns:a="http://schemas.openxmlformats.org/drawingml/2006/main">
+            <a:off x="609600" y="2752725"/>
+            <a:ext cx="4991100" cy="304800"/>
+          </a:xfrm>
+          <a:prstGeom xmlns:a="http://schemas.openxmlformats.org/drawingml/2006/main" prst="rect">
+            <a:avLst/>
+          </a:prstGeom>
+          <a:noFill xmlns:a="http://schemas.openxmlformats.org/drawingml/2006/main"/>
+          <a:ln xmlns:a="http://schemas.openxmlformats.org/drawingml/2006/main" w="0">
+            <a:noFill/>
+          </a:ln>
+        </p:spPr>
+        <p:txBody>
+          <a:bodyPr xmlns:a="http://schemas.openxmlformats.org/drawingml/2006/main" wrap="none" lIns="0" tIns="0" rIns="0" bIns="0" anchor="t">
+            <a:noAutofit/>
+          </a:bodyPr>
+          <a:lstStyle xmlns:a="http://schemas.openxmlformats.org/drawingml/2006/main"/>
+          <a:p xmlns:a="http://schemas.openxmlformats.org/drawingml/2006/main">
+            <a:pPr algn="l">
+              <a:buNone/>
+              <a:defRPr sz="1425" b="1">
+                <a:solidFill>
+                  <a:srgbClr val="53686C"/>
+                </a:solidFill>
+                <a:latin typeface="Arial"/>
+                <a:ea typeface="Arial"/>
+                <a:cs typeface="Arial"/>
+              </a:defRPr>
+            </a:pPr>
+            <a:r>
+              <a:rPr sz="1425" b="1">
+                <a:solidFill>
+                  <a:srgbClr val="53686C"/>
+                </a:solidFill>
+                <a:latin typeface="Arial"/>
+                <a:ea typeface="Arial"/>
+                <a:cs typeface="Arial"/>
+              </a:rPr>
+              <a:t>EDIT ON GITHUB</a:t>
+            </a:r>
+          </a:p>
+        </p:txBody>
+      </p:sp>
+      <p:sp>
+        <p:nvSpPr>
+          <p:cNvPr id="10" name="left-prompt">
+            <a:extLst xmlns:a="http://schemas.openxmlformats.org/drawingml/2006/main">
+              <a:ext uri="{FF2B5EF4-FFF2-40B4-BE49-F238E27FC236}">
+                <a16:creationId xmlns:a16="http://schemas.microsoft.com/office/drawing/2014/main" id="{F5C4BD44-0293-4300-88D1-582D0C509FBE}"/>
+              </a:ext>
+            </a:extLst>
+          </p:cNvPr>
+          <p:cNvSpPr>
+            <a:spLocks xmlns:a="http://schemas.openxmlformats.org/drawingml/2006/main" noGrp="1"/>
+          </p:cNvSpPr>
+          <p:nvPr/>
+        </p:nvSpPr>
+        <p:spPr>
+          <a:xfrm xmlns:a="http://schemas.openxmlformats.org/drawingml/2006/main">
+            <a:off x="609600" y="3314700"/>
+            <a:ext cx="5238750" cy="1733550"/>
           </a:xfrm>
           <a:prstGeom xmlns:a="http://schemas.openxmlformats.org/drawingml/2006/main" prst="rect">
             <a:avLst/>
@@ -5649,6 +6139,218 @@
               <a:buNone/>
               <a:defRPr sz="2025" b="1">
                 <a:solidFill>
+                  <a:srgbClr val="142D32"/>
+                </a:solidFill>
+                <a:latin typeface="Arial"/>
+                <a:ea typeface="Arial"/>
+                <a:cs typeface="Arial"/>
+              </a:defRPr>
+            </a:pPr>
+            <a:r>
+              <a:rPr sz="2025" b="1">
+                <a:solidFill>
+                  <a:srgbClr val="142D32"/>
+                </a:solidFill>
+                <a:latin typeface="Arial"/>
+                <a:ea typeface="Arial"/>
+                <a:cs typeface="Arial"/>
+              </a:rPr>
+              <a:t>Open the file → pencil</a:t>
+            </a:r>
+          </a:p>
+          <a:p xmlns:a="http://schemas.openxmlformats.org/drawingml/2006/main">
+            <a:pPr algn="l">
+              <a:buNone/>
+              <a:defRPr sz="2700" b="1">
+                <a:solidFill>
+                  <a:srgbClr val="142D32"/>
+                </a:solidFill>
+                <a:latin typeface="Arial"/>
+                <a:ea typeface="Arial"/>
+                <a:cs typeface="Arial"/>
+              </a:defRPr>
+            </a:pPr>
+            <a:r>
+              <a:rPr sz="2700" b="1">
+                <a:solidFill>
+                  <a:srgbClr val="142D32"/>
+                </a:solidFill>
+                <a:latin typeface="Arial"/>
+                <a:ea typeface="Arial"/>
+                <a:cs typeface="Arial"/>
+              </a:rPr>
+              <a:t/>
+            </a:r>
+          </a:p>
+          <a:p xmlns:a="http://schemas.openxmlformats.org/drawingml/2006/main">
+            <a:pPr algn="l">
+              <a:buNone/>
+              <a:defRPr sz="2025" b="1">
+                <a:solidFill>
+                  <a:srgbClr val="142D32"/>
+                </a:solidFill>
+                <a:latin typeface="Arial"/>
+                <a:ea typeface="Arial"/>
+                <a:cs typeface="Arial"/>
+              </a:defRPr>
+            </a:pPr>
+            <a:r>
+              <a:rPr sz="2025" b="1">
+                <a:solidFill>
+                  <a:srgbClr val="142D32"/>
+                </a:solidFill>
+                <a:latin typeface="Arial"/>
+                <a:ea typeface="Arial"/>
+                <a:cs typeface="Arial"/>
+              </a:rPr>
+              <a:t>Try: “Only use food themes.”</a:t>
+            </a:r>
+          </a:p>
+          <a:p xmlns:a="http://schemas.openxmlformats.org/drawingml/2006/main">
+            <a:pPr algn="l">
+              <a:buNone/>
+              <a:defRPr sz="2700" b="1">
+                <a:solidFill>
+                  <a:srgbClr val="142D32"/>
+                </a:solidFill>
+                <a:latin typeface="Arial"/>
+                <a:ea typeface="Arial"/>
+                <a:cs typeface="Arial"/>
+              </a:defRPr>
+            </a:pPr>
+            <a:r>
+              <a:rPr sz="2700" b="1">
+                <a:solidFill>
+                  <a:srgbClr val="142D32"/>
+                </a:solidFill>
+                <a:latin typeface="Arial"/>
+                <a:ea typeface="Arial"/>
+                <a:cs typeface="Arial"/>
+              </a:rPr>
+              <a:t/>
+            </a:r>
+          </a:p>
+          <a:p xmlns:a="http://schemas.openxmlformats.org/drawingml/2006/main">
+            <a:pPr algn="l">
+              <a:buNone/>
+              <a:defRPr sz="2025" b="1">
+                <a:solidFill>
+                  <a:srgbClr val="142D32"/>
+                </a:solidFill>
+                <a:latin typeface="Arial"/>
+                <a:ea typeface="Arial"/>
+                <a:cs typeface="Arial"/>
+              </a:defRPr>
+            </a:pPr>
+            <a:r>
+              <a:rPr sz="2025" b="1">
+                <a:solidFill>
+                  <a:srgbClr val="142D32"/>
+                </a:solidFill>
+                <a:latin typeface="Arial"/>
+                <a:ea typeface="Arial"/>
+                <a:cs typeface="Arial"/>
+              </a:rPr>
+              <a:t>Commit changes</a:t>
+            </a:r>
+          </a:p>
+        </p:txBody>
+      </p:sp>
+      <p:sp>
+        <p:nvSpPr>
+          <p:cNvPr id="11" name="left-caption">
+            <a:extLst xmlns:a="http://schemas.openxmlformats.org/drawingml/2006/main">
+              <a:ext uri="{FF2B5EF4-FFF2-40B4-BE49-F238E27FC236}">
+                <a16:creationId xmlns:a16="http://schemas.microsoft.com/office/drawing/2014/main" id="{25D8FBD5-2925-42B1-A10D-32015BA93D47}"/>
+              </a:ext>
+            </a:extLst>
+          </p:cNvPr>
+          <p:cNvSpPr>
+            <a:spLocks xmlns:a="http://schemas.openxmlformats.org/drawingml/2006/main" noGrp="1"/>
+          </p:cNvSpPr>
+          <p:nvPr/>
+        </p:nvSpPr>
+        <p:spPr>
+          <a:xfrm xmlns:a="http://schemas.openxmlformats.org/drawingml/2006/main">
+            <a:off x="609600" y="5524500"/>
+            <a:ext cx="5334000" cy="542925"/>
+          </a:xfrm>
+          <a:prstGeom xmlns:a="http://schemas.openxmlformats.org/drawingml/2006/main" prst="rect">
+            <a:avLst/>
+          </a:prstGeom>
+          <a:noFill xmlns:a="http://schemas.openxmlformats.org/drawingml/2006/main"/>
+          <a:ln xmlns:a="http://schemas.openxmlformats.org/drawingml/2006/main" w="0">
+            <a:noFill/>
+          </a:ln>
+        </p:spPr>
+        <p:txBody>
+          <a:bodyPr xmlns:a="http://schemas.openxmlformats.org/drawingml/2006/main" wrap="none" lIns="0" tIns="0" rIns="0" bIns="0" anchor="t">
+            <a:noAutofit/>
+          </a:bodyPr>
+          <a:lstStyle xmlns:a="http://schemas.openxmlformats.org/drawingml/2006/main"/>
+          <a:p xmlns:a="http://schemas.openxmlformats.org/drawingml/2006/main">
+            <a:pPr algn="l">
+              <a:buNone/>
+              <a:defRPr sz="1725" b="0">
+                <a:solidFill>
+                  <a:srgbClr val="53686C"/>
+                </a:solidFill>
+                <a:latin typeface="Arial"/>
+                <a:ea typeface="Arial"/>
+                <a:cs typeface="Arial"/>
+              </a:defRPr>
+            </a:pPr>
+            <a:r>
+              <a:rPr sz="1725" b="0">
+                <a:solidFill>
+                  <a:srgbClr val="53686C"/>
+                </a:solidFill>
+                <a:latin typeface="Arial"/>
+                <a:ea typeface="Arial"/>
+                <a:cs typeface="Arial"/>
+              </a:rPr>
+              <a:t>Wait for deployment. Ask the same theme again.</a:t>
+            </a:r>
+          </a:p>
+        </p:txBody>
+      </p:sp>
+      <p:sp>
+        <p:nvSpPr>
+          <p:cNvPr id="12" name="right-label">
+            <a:extLst xmlns:a="http://schemas.openxmlformats.org/drawingml/2006/main">
+              <a:ext uri="{FF2B5EF4-FFF2-40B4-BE49-F238E27FC236}">
+                <a16:creationId xmlns:a16="http://schemas.microsoft.com/office/drawing/2014/main" id="{03B0C3C5-AB47-47C5-86F9-888C436E1B3E}"/>
+              </a:ext>
+            </a:extLst>
+          </p:cNvPr>
+          <p:cNvSpPr>
+            <a:spLocks xmlns:a="http://schemas.openxmlformats.org/drawingml/2006/main" noGrp="1"/>
+          </p:cNvSpPr>
+          <p:nvPr/>
+        </p:nvSpPr>
+        <p:spPr>
+          <a:xfrm xmlns:a="http://schemas.openxmlformats.org/drawingml/2006/main">
+            <a:off x="6610350" y="2752725"/>
+            <a:ext cx="4972050" cy="304800"/>
+          </a:xfrm>
+          <a:prstGeom xmlns:a="http://schemas.openxmlformats.org/drawingml/2006/main" prst="rect">
+            <a:avLst/>
+          </a:prstGeom>
+          <a:noFill xmlns:a="http://schemas.openxmlformats.org/drawingml/2006/main"/>
+          <a:ln xmlns:a="http://schemas.openxmlformats.org/drawingml/2006/main" w="0">
+            <a:noFill/>
+          </a:ln>
+        </p:spPr>
+        <p:txBody>
+          <a:bodyPr xmlns:a="http://schemas.openxmlformats.org/drawingml/2006/main" wrap="none" lIns="0" tIns="0" rIns="0" bIns="0" anchor="t">
+            <a:noAutofit/>
+          </a:bodyPr>
+          <a:lstStyle xmlns:a="http://schemas.openxmlformats.org/drawingml/2006/main"/>
+          <a:p xmlns:a="http://schemas.openxmlformats.org/drawingml/2006/main">
+            <a:pPr algn="l">
+              <a:buNone/>
+              <a:defRPr sz="1425" b="1">
+                <a:solidFill>
                   <a:srgbClr val="087E80"/>
                 </a:solidFill>
                 <a:latin typeface="Arial"/>
@@ -5657,7 +6359,7 @@
               </a:defRPr>
             </a:pPr>
             <a:r>
-              <a:rPr sz="2025" b="1">
+              <a:rPr sz="1425" b="1">
                 <a:solidFill>
                   <a:srgbClr val="087E80"/>
                 </a:solidFill>
@@ -5665,7 +6367,219 @@
                 <a:ea typeface="Arial"/>
                 <a:cs typeface="Arial"/>
               </a:rPr>
-              <a:t>Refresh clears your key. Paste it again to use AI.</a:t>
+              <a:t>OR USE A LOCAL FOLDER</a:t>
+            </a:r>
+          </a:p>
+        </p:txBody>
+      </p:sp>
+      <p:sp>
+        <p:nvSpPr>
+          <p:cNvPr id="13" name="right-prompt">
+            <a:extLst xmlns:a="http://schemas.openxmlformats.org/drawingml/2006/main">
+              <a:ext uri="{FF2B5EF4-FFF2-40B4-BE49-F238E27FC236}">
+                <a16:creationId xmlns:a16="http://schemas.microsoft.com/office/drawing/2014/main" id="{59F90D52-9B1C-4538-8AA2-B3B63DC2FB4F}"/>
+              </a:ext>
+            </a:extLst>
+          </p:cNvPr>
+          <p:cNvSpPr>
+            <a:spLocks xmlns:a="http://schemas.openxmlformats.org/drawingml/2006/main" noGrp="1"/>
+          </p:cNvSpPr>
+          <p:nvPr/>
+        </p:nvSpPr>
+        <p:spPr>
+          <a:xfrm xmlns:a="http://schemas.openxmlformats.org/drawingml/2006/main">
+            <a:off x="6610350" y="3314700"/>
+            <a:ext cx="4972050" cy="1733550"/>
+          </a:xfrm>
+          <a:prstGeom xmlns:a="http://schemas.openxmlformats.org/drawingml/2006/main" prst="rect">
+            <a:avLst/>
+          </a:prstGeom>
+          <a:noFill xmlns:a="http://schemas.openxmlformats.org/drawingml/2006/main"/>
+          <a:ln xmlns:a="http://schemas.openxmlformats.org/drawingml/2006/main" w="0">
+            <a:noFill/>
+          </a:ln>
+        </p:spPr>
+        <p:txBody>
+          <a:bodyPr xmlns:a="http://schemas.openxmlformats.org/drawingml/2006/main" wrap="none" lIns="0" tIns="0" rIns="0" bIns="0" anchor="t">
+            <a:noAutofit/>
+          </a:bodyPr>
+          <a:lstStyle xmlns:a="http://schemas.openxmlformats.org/drawingml/2006/main"/>
+          <a:p xmlns:a="http://schemas.openxmlformats.org/drawingml/2006/main">
+            <a:pPr algn="l">
+              <a:buNone/>
+              <a:defRPr sz="1875" b="1">
+                <a:solidFill>
+                  <a:srgbClr val="142D32"/>
+                </a:solidFill>
+                <a:latin typeface="Arial"/>
+                <a:ea typeface="Arial"/>
+                <a:cs typeface="Arial"/>
+              </a:defRPr>
+            </a:pPr>
+            <a:r>
+              <a:rPr sz="1875" b="1">
+                <a:solidFill>
+                  <a:srgbClr val="142D32"/>
+                </a:solidFill>
+                <a:latin typeface="Arial"/>
+                <a:ea typeface="Arial"/>
+                <a:cs typeface="Arial"/>
+              </a:rPr>
+              <a:t>GitHub Desktop → Clone your fork</a:t>
+            </a:r>
+          </a:p>
+          <a:p xmlns:a="http://schemas.openxmlformats.org/drawingml/2006/main">
+            <a:pPr algn="l">
+              <a:buNone/>
+              <a:defRPr sz="2400" b="1">
+                <a:solidFill>
+                  <a:srgbClr val="142D32"/>
+                </a:solidFill>
+                <a:latin typeface="Arial"/>
+                <a:ea typeface="Arial"/>
+                <a:cs typeface="Arial"/>
+              </a:defRPr>
+            </a:pPr>
+            <a:r>
+              <a:rPr sz="2400" b="1">
+                <a:solidFill>
+                  <a:srgbClr val="142D32"/>
+                </a:solidFill>
+                <a:latin typeface="Arial"/>
+                <a:ea typeface="Arial"/>
+                <a:cs typeface="Arial"/>
+              </a:rPr>
+              <a:t/>
+            </a:r>
+          </a:p>
+          <a:p xmlns:a="http://schemas.openxmlformats.org/drawingml/2006/main">
+            <a:pPr algn="l">
+              <a:buNone/>
+              <a:defRPr sz="1875" b="1">
+                <a:solidFill>
+                  <a:srgbClr val="142D32"/>
+                </a:solidFill>
+                <a:latin typeface="Arial"/>
+                <a:ea typeface="Arial"/>
+                <a:cs typeface="Arial"/>
+              </a:defRPr>
+            </a:pPr>
+            <a:r>
+              <a:rPr sz="1875" b="1">
+                <a:solidFill>
+                  <a:srgbClr val="142D32"/>
+                </a:solidFill>
+                <a:latin typeface="Arial"/>
+                <a:ea typeface="Arial"/>
+                <a:cs typeface="Arial"/>
+              </a:rPr>
+              <a:t>Edit the file in your folder → Save</a:t>
+            </a:r>
+          </a:p>
+          <a:p xmlns:a="http://schemas.openxmlformats.org/drawingml/2006/main">
+            <a:pPr algn="l">
+              <a:buNone/>
+              <a:defRPr sz="2400" b="1">
+                <a:solidFill>
+                  <a:srgbClr val="142D32"/>
+                </a:solidFill>
+                <a:latin typeface="Arial"/>
+                <a:ea typeface="Arial"/>
+                <a:cs typeface="Arial"/>
+              </a:defRPr>
+            </a:pPr>
+            <a:r>
+              <a:rPr sz="2400" b="1">
+                <a:solidFill>
+                  <a:srgbClr val="142D32"/>
+                </a:solidFill>
+                <a:latin typeface="Arial"/>
+                <a:ea typeface="Arial"/>
+                <a:cs typeface="Arial"/>
+              </a:rPr>
+              <a:t/>
+            </a:r>
+          </a:p>
+          <a:p xmlns:a="http://schemas.openxmlformats.org/drawingml/2006/main">
+            <a:pPr algn="l">
+              <a:buNone/>
+              <a:defRPr sz="1875" b="1">
+                <a:solidFill>
+                  <a:srgbClr val="142D32"/>
+                </a:solidFill>
+                <a:latin typeface="Arial"/>
+                <a:ea typeface="Arial"/>
+                <a:cs typeface="Arial"/>
+              </a:defRPr>
+            </a:pPr>
+            <a:r>
+              <a:rPr sz="1875" b="1">
+                <a:solidFill>
+                  <a:srgbClr val="142D32"/>
+                </a:solidFill>
+                <a:latin typeface="Arial"/>
+                <a:ea typeface="Arial"/>
+                <a:cs typeface="Arial"/>
+              </a:rPr>
+              <a:t>Commit to main → Push origin</a:t>
+            </a:r>
+          </a:p>
+        </p:txBody>
+      </p:sp>
+      <p:sp>
+        <p:nvSpPr>
+          <p:cNvPr id="14" name="right-caption">
+            <a:extLst xmlns:a="http://schemas.openxmlformats.org/drawingml/2006/main">
+              <a:ext uri="{FF2B5EF4-FFF2-40B4-BE49-F238E27FC236}">
+                <a16:creationId xmlns:a16="http://schemas.microsoft.com/office/drawing/2014/main" id="{5B07DFD3-E43F-4008-8F22-CC5D5DF20D5C}"/>
+              </a:ext>
+            </a:extLst>
+          </p:cNvPr>
+          <p:cNvSpPr>
+            <a:spLocks xmlns:a="http://schemas.openxmlformats.org/drawingml/2006/main" noGrp="1"/>
+          </p:cNvSpPr>
+          <p:nvPr/>
+        </p:nvSpPr>
+        <p:spPr>
+          <a:xfrm xmlns:a="http://schemas.openxmlformats.org/drawingml/2006/main">
+            <a:off x="6610350" y="5524500"/>
+            <a:ext cx="4972050" cy="542925"/>
+          </a:xfrm>
+          <a:prstGeom xmlns:a="http://schemas.openxmlformats.org/drawingml/2006/main" prst="rect">
+            <a:avLst/>
+          </a:prstGeom>
+          <a:noFill xmlns:a="http://schemas.openxmlformats.org/drawingml/2006/main"/>
+          <a:ln xmlns:a="http://schemas.openxmlformats.org/drawingml/2006/main" w="0">
+            <a:noFill/>
+          </a:ln>
+        </p:spPr>
+        <p:txBody>
+          <a:bodyPr xmlns:a="http://schemas.openxmlformats.org/drawingml/2006/main" wrap="none" lIns="0" tIns="0" rIns="0" bIns="0" anchor="t">
+            <a:noAutofit/>
+          </a:bodyPr>
+          <a:lstStyle xmlns:a="http://schemas.openxmlformats.org/drawingml/2006/main"/>
+          <a:p xmlns:a="http://schemas.openxmlformats.org/drawingml/2006/main">
+            <a:pPr algn="l">
+              <a:buNone/>
+              <a:defRPr sz="1725" b="0">
+                <a:solidFill>
+                  <a:srgbClr val="53686C"/>
+                </a:solidFill>
+                <a:latin typeface="Arial"/>
+                <a:ea typeface="Arial"/>
+                <a:cs typeface="Arial"/>
+              </a:defRPr>
+            </a:pPr>
+            <a:r>
+              <a:rPr sz="1725" b="0">
+                <a:solidFill>
+                  <a:srgbClr val="53686C"/>
+                </a:solidFill>
+                <a:latin typeface="Arial"/>
+                <a:ea typeface="Arial"/>
+                <a:cs typeface="Arial"/>
+              </a:rPr>
+              <a:t>New folder? Add local repository → Publish repository.</a:t>
             </a:r>
           </a:p>
         </p:txBody>
@@ -5673,7 +6587,7 @@
     </p:spTree>
     <p:extLst>
       <p:ext uri="{BB962C8B-B14F-4D97-AF65-F5344CB8AC3E}">
-        <p14:creationId xmlns:p14="http://schemas.microsoft.com/office/powerpoint/2010/main" val="2070937391"/>
+        <p14:creationId xmlns:p14="http://schemas.microsoft.com/office/powerpoint/2010/main" val="1499610271"/>
       </p:ext>
     </p:extLst>
   </p:cSld>

</xml_diff>

<commit_message>
Simplify UConn workshop with static game and optional AI route
</commit_message>
<xml_diff>
--- a/ai-would-you-rather/slides/Would-You-Rather-Workshop.pptx
+++ b/ai-would-you-rather/slides/Would-You-Rather-Workshop.pptx
@@ -2,18 +2,18 @@
 <file path=ppt/presentation.xml><?xml version="1.0" encoding="utf-8"?>
 <p:presentation xmlns:p="http://schemas.openxmlformats.org/presentationml/2006/main">
   <p:sldMasterIdLst>
-    <p:sldMasterId xmlns:r="http://schemas.openxmlformats.org/officeDocument/2006/relationships" id="2147483648" r:id="R13ea795daeab4d96"/>
+    <p:sldMasterId xmlns:r="http://schemas.openxmlformats.org/officeDocument/2006/relationships" id="2147483648" r:id="Rf1d2650c470c47fa"/>
   </p:sldMasterIdLst>
   <p:notesMasterIdLst>
-    <p:notesMasterId xmlns:r="http://schemas.openxmlformats.org/officeDocument/2006/relationships" r:id="Rcfd2c0a11af64ac5"/>
+    <p:notesMasterId xmlns:r="http://schemas.openxmlformats.org/officeDocument/2006/relationships" r:id="R2fca263ded0e4aa8"/>
   </p:notesMasterIdLst>
   <p:sldIdLst>
-    <p:sldId xmlns:r="http://schemas.openxmlformats.org/officeDocument/2006/relationships" id="256" r:id="R3b6c7634dd36463d"/>
-    <p:sldId xmlns:r="http://schemas.openxmlformats.org/officeDocument/2006/relationships" id="257" r:id="Rfadb232f3e33482f"/>
-    <p:sldId xmlns:r="http://schemas.openxmlformats.org/officeDocument/2006/relationships" id="258" r:id="R666a2cefd8ec41f7"/>
-    <p:sldId xmlns:r="http://schemas.openxmlformats.org/officeDocument/2006/relationships" id="259" r:id="Ra7810506c0ad42e9"/>
-    <p:sldId xmlns:r="http://schemas.openxmlformats.org/officeDocument/2006/relationships" id="260" r:id="R974debf9e80446ef"/>
-    <p:sldId xmlns:r="http://schemas.openxmlformats.org/officeDocument/2006/relationships" id="261" r:id="R91f089da18ad4f33"/>
+    <p:sldId xmlns:r="http://schemas.openxmlformats.org/officeDocument/2006/relationships" id="256" r:id="R515fd91bdfe940f3"/>
+    <p:sldId xmlns:r="http://schemas.openxmlformats.org/officeDocument/2006/relationships" id="257" r:id="R4358c52b5c7b43eb"/>
+    <p:sldId xmlns:r="http://schemas.openxmlformats.org/officeDocument/2006/relationships" id="258" r:id="R684f15a3e0a04053"/>
+    <p:sldId xmlns:r="http://schemas.openxmlformats.org/officeDocument/2006/relationships" id="259" r:id="Rb2a6b8bfcb034c82"/>
+    <p:sldId xmlns:r="http://schemas.openxmlformats.org/officeDocument/2006/relationships" id="260" r:id="Rca0871017c9c4734"/>
+    <p:sldId xmlns:r="http://schemas.openxmlformats.org/officeDocument/2006/relationships" id="261" r:id="Rb986d3a1357948b5"/>
   </p:sldIdLst>
   <p:sldSz cx="12192000" cy="6858000"/>
   <p:notesSz cx="6858000" cy="9144000"/>
@@ -447,7 +447,7 @@
           <a:lstStyle xmlns:a="http://schemas.openxmlformats.org/drawingml/2006/main"/>
           <a:p xmlns:a="http://schemas.openxmlformats.org/drawingml/2006/main">
             <a:r>
-              <a:t>Show the fixed demo and vote. Plan approximately 20 minutes with sign-ins and initial Pages publication prepared; account verification may take longer. GitHub Pages serves the public HTML. A Cloudflare Worker runs the API with a private key. GitHub Secrets feeds the deployment workflow, not browser JavaScript. The screenshot is a fixed demo, not live inference. Complete click-by-click guide: ai-would-you-rather/README.md in the repository.</a:t>
+              <a:t>Main activity uses GitHub Pages only. The simple game uses built-in questions, not AI. The advanced example has a fixed demo and can later connect to an API. Keep roughly 20 minutes for editing and testing with sign-in and initial publication prepared.</a:t>
             </a:r>
           </a:p>
         </p:txBody>
@@ -517,7 +517,7 @@
           <a:lstStyle xmlns:a="http://schemas.openxmlformats.org/drawingml/2006/main"/>
           <a:p xmlns:a="http://schemas.openxmlformats.org/drawingml/2006/main">
             <a:r>
-              <a:t>Fork the repository into your own account. The fork includes all necessary files. For an existing website, copy ai-would-you-rather/ and .github/workflows/deploy-bot.yml, keeping paths. GitHub Add file &gt; Create new file can create the hidden workflow path. If Pages is already enabled, skip enabling it. Record the published site hostname. Open ai-would-you-rather/ after the site base URL. For a local folder, the GitHub Desktop route is on the final slide and detailed in README. Source: https://docs.github.com/en/pages/getting-started-with-github-pages/configuring-a-publishing-source-for-your-github-pages-site</a:t>
+              <a:t>Use your own fork. Project-site URLs include the repository name. Source: https://docs.github.com/en/pages/getting-started-with-github-pages/what-is-github-pages</a:t>
             </a:r>
           </a:p>
         </p:txBody>
@@ -587,7 +587,7 @@
           <a:lstStyle xmlns:a="http://schemas.openxmlformats.org/drawingml/2006/main"/>
           <a:p xmlns:a="http://schemas.openxmlformats.org/drawingml/2006/main">
             <a:r>
-              <a:t>Open https://openrouter.ai/settings/keys after creating an account. Create a workshop key and copy it privately. GitHub Settings &gt; Secrets and variables &gt; Actions &gt; New repository secret: OPENROUTER_API_KEY. In Cloudflare finish Workers onboarding and select a workers.dev subdomain if prompted. Copy Account ID from the account dashboard. My Profile &gt; API Tokens &gt; Create Token &gt; Edit Cloudflare Workers; scope to your account. Create and copy token. Save CLOUDFLARE_API_TOKEN and CLOUDFLARE_ACCOUNT_ID as separate repository secrets in GitHub. Never paste credentials into code or slides. The provided workflow uses repository secrets; environment secrets require an environment on the workflow job. Forks do not inherit secrets. Source: https://github.com/cloudflare/wrangler-action</a:t>
+              <a:t>Keep the original page working. The button counts clicks in browser memory and resets on refresh. The published site is different from the GitHub code view.</a:t>
             </a:r>
           </a:p>
         </p:txBody>
@@ -657,7 +657,7 @@
           <a:lstStyle xmlns:a="http://schemas.openxmlformats.org/drawingml/2006/main"/>
           <a:p xmlns:a="http://schemas.openxmlformats.org/drawingml/2006/main">
             <a:r>
-              <a:t>File paths on this slide are inside ai-would-you-rather/. Edit api/wrangler.jsonc. ALLOWED_ORIGIN must be your exact published origin: scheme plus hostname, no repository path or trailing slash. Custom domains use their actual origin. Change name if ai-club-game would overwrite an unrelated existing Worker in your account. Commit. In a fork enable Actions if prompted. Choose Deploy AI bot &gt; Run workflow &gt; main &gt; Run workflow. Wait for green. Cloudflare Workers &amp; Pages &gt; ai-club-game shows its workers.dev URL. GitHub Actions installs deployment tooling remotely and copies OPENROUTER_API_KEY to the Worker private environment. Participants run no terminal commands. Later api/ changes redeploy automatically. CORS is not authentication; this public demo shares the owner quota. Remove Worker or revoke key after the workshop. Sources: https://github.com/cloudflare/wrangler-action and https://developers.cloudflare.com/workers/configuration/secrets/</a:t>
+              <a:t>Built-in questions work without accounts or network requests. Next question cycles through the selected theme. Changing theme resets the question. Everyone can propose a pair and explain their vote.</a:t>
             </a:r>
           </a:p>
         </p:txBody>
@@ -727,7 +727,7 @@
           <a:lstStyle xmlns:a="http://schemas.openxmlformats.org/drawingml/2006/main"/>
           <a:p xmlns:a="http://schemas.openxmlformats.org/drawingml/2006/main">
             <a:r>
-              <a:t>Replace only the quoted API_URL placeholder. Example shape: https://ai-club-game.YOUR-SUBDOMAIN.workers.dev/api/chat. This is a public URL, not a secret. Keep quotes and semicolon. Commit changes and wait for the Pages publication. Open the published site and send superpowers. The full-page link uses ?view=bot; it is the same HTML and same backend. Try demo sends no API request and returns a fixed labeled example. Use AI switches back. No key is entered on the website. Missing configuration shows a setup message. Provider busy/quota errors: wait or use demo. A network/CORS error means check API_URL and ALLOWED_ORIGIN. Selected model: nvidia/nemotron-3-ultra-550b-a55b:free, no paid fallback. Live inference needs your configured account. Source: https://openrouter.ai/nvidia/nemotron-3-ultra-550b-a55b:free?view=api</a:t>
+              <a:t>Use ../ for a link home from the child page. Root-relative links such as /my-page/ skip the repository prefix on GitHub project sites; use my-page/ from the root page. This is a static page route, not a server API endpoint. Adjust copied links when moving a page into a subfolder.</a:t>
             </a:r>
           </a:p>
         </p:txBody>
@@ -797,7 +797,7 @@
           <a:lstStyle xmlns:a="http://schemas.openxmlformats.org/drawingml/2006/main"/>
           <a:p xmlns:a="http://schemas.openxmlformats.org/drawingml/2006/main">
             <a:r>
-              <a:t>Paths are inside ai-would-you-rather/. For AI instructions edit text between the backticks after INSTRUCTIONS in api/worker.mjs. Keep backticks and semicolon. Wait for Deploy AI bot to finish; HTML changes wait for Pages. GitHub Desktop: sign in &gt; File &gt; Clone repository &gt; select your fork and local folder. Edit in your editor, save, return to Desktop, review changes, type a summary, Commit to main &gt; Push origin. Fetch/Pull first if you also edited on GitHub. Existing local folder: File &gt; Add local repository; if not a repository use create a repository here. Put site and demo files in that folder including .github/workflows, commit, Publish repository, then configure Pages and secrets. Never store keys in the folder. Local double-click supports layout and fixed demo; live AI should be tested at the published HTTPS origin. Ask the same theme before and after the prompt change. Everyone votes; no terminal needed. Full detailed instructions and troubleshooting are in the repository README.</a:t>
+              <a:t>The advanced demo is fixed and labeled. Real AI needs a private backend on a provider of your choice. GitHub Pages alone cannot privately use an API key or execute a live API route. The optional advanced README contains one backend example; it is not required for this workshop. For a new local folder use GitHub Desktop Add local repository, create a repository here if needed, then Publish repository. The root README includes complete instructions.</a:t>
             </a:r>
           </a:p>
         </p:txBody>
@@ -865,7 +865,7 @@
   </p:cSld>
   <p:clrMap bg1="lt1" tx1="dk1" bg2="lt2" tx2="dk2" accent1="accent1" accent2="accent2" accent3="accent3" accent4="accent4" accent5="accent5" accent6="accent6" hlink="hlink" folHlink="folHlink"/>
   <p:sldLayoutIdLst>
-    <p:sldLayoutId xmlns:r="http://schemas.openxmlformats.org/officeDocument/2006/relationships" id="2147483649" r:id="R44f100c9bfe647ca"/>
+    <p:sldLayoutId xmlns:r="http://schemas.openxmlformats.org/officeDocument/2006/relationships" id="2147483649" r:id="R23f167f64fa845d1"/>
   </p:sldLayoutIdLst>
   <p:txStyles>
     <p:titleStyle>
@@ -1413,10 +1413,10 @@
       </p:grpSpPr>
       <p:sp>
         <p:nvSpPr>
-          <p:cNvPr id="13" name="club">
-            <a:extLst xmlns:a="http://schemas.openxmlformats.org/drawingml/2006/main">
-              <a:ext uri="{FF2B5EF4-FFF2-40B4-BE49-F238E27FC236}">
-                <a16:creationId xmlns:a16="http://schemas.microsoft.com/office/drawing/2014/main" id="{A9215153-0FD5-4F3F-8162-09A1F0DEBC35}"/>
+          <p:cNvPr id="21" name="club">
+            <a:extLst xmlns:a="http://schemas.openxmlformats.org/drawingml/2006/main">
+              <a:ext uri="{FF2B5EF4-FFF2-40B4-BE49-F238E27FC236}">
+                <a16:creationId xmlns:a16="http://schemas.microsoft.com/office/drawing/2014/main" id="{366D60CB-0E69-4059-85C5-9B5236F59499}"/>
               </a:ext>
             </a:extLst>
           </p:cNvPr>
@@ -1464,7 +1464,7 @@
                 <a:ea typeface="Arial"/>
                 <a:cs typeface="Arial"/>
               </a:rPr>
-              <a:t>AI CLUB</a:t>
+              <a:t>UConn AI Club</a:t>
             </a:r>
           </a:p>
         </p:txBody>
@@ -1474,7 +1474,7 @@
           <p:cNvPr id="3" name="title">
             <a:extLst xmlns:a="http://schemas.openxmlformats.org/drawingml/2006/main">
               <a:ext uri="{FF2B5EF4-FFF2-40B4-BE49-F238E27FC236}">
-                <a16:creationId xmlns:a16="http://schemas.microsoft.com/office/drawing/2014/main" id="{BD7D82B6-E7A8-45D2-A5D4-7721C5DD9A58}"/>
+                <a16:creationId xmlns:a16="http://schemas.microsoft.com/office/drawing/2014/main" id="{EF48F320-DD91-4BBA-B862-5084F2F45ADE}"/>
               </a:ext>
             </a:extLst>
           </p:cNvPr>
@@ -1504,7 +1504,7 @@
           <a:p xmlns:a="http://schemas.openxmlformats.org/drawingml/2006/main">
             <a:pPr algn="l">
               <a:buNone/>
-              <a:defRPr sz="3600" b="1">
+              <a:defRPr sz="3450" b="1">
                 <a:solidFill>
                   <a:srgbClr val="142D32"/>
                 </a:solidFill>
@@ -1514,7 +1514,7 @@
               </a:defRPr>
             </a:pPr>
             <a:r>
-              <a:rPr sz="3600" b="1">
+              <a:rPr sz="3450" b="1">
                 <a:solidFill>
                   <a:srgbClr val="142D32"/>
                 </a:solidFill>
@@ -1522,7 +1522,7 @@
                 <a:ea typeface="Arial"/>
                 <a:cs typeface="Arial"/>
               </a:rPr>
-              <a:t>Would you rather…?</a:t>
+              <a:t>Your website, with room to explore</a:t>
             </a:r>
           </a:p>
         </p:txBody>
@@ -1532,7 +1532,7 @@
           <p:cNvPr id="4" name="subheader">
             <a:extLst xmlns:a="http://schemas.openxmlformats.org/drawingml/2006/main">
               <a:ext uri="{FF2B5EF4-FFF2-40B4-BE49-F238E27FC236}">
-                <a16:creationId xmlns:a16="http://schemas.microsoft.com/office/drawing/2014/main" id="{5EDF28EE-6694-41DA-BB96-8E431C8D7D72}"/>
+                <a16:creationId xmlns:a16="http://schemas.microsoft.com/office/drawing/2014/main" id="{5D6446FB-4749-41AC-9A7B-5675002E5DC1}"/>
               </a:ext>
             </a:extLst>
           </p:cNvPr>
@@ -1580,7 +1580,7 @@
                 <a:ea typeface="Arial"/>
                 <a:cs typeface="Arial"/>
               </a:rPr>
-              <a:t>Build a game on your website. Keep the AI key private.</a:t>
+              <a:t>One GitHub repository. Three pages. No terminal needed.</a:t>
             </a:r>
           </a:p>
         </p:txBody>
@@ -1590,7 +1590,7 @@
           <p:cNvPr id="8" name="footer-page">
             <a:extLst xmlns:a="http://schemas.openxmlformats.org/drawingml/2006/main">
               <a:ext uri="{FF2B5EF4-FFF2-40B4-BE49-F238E27FC236}">
-                <a16:creationId xmlns:a16="http://schemas.microsoft.com/office/drawing/2014/main" id="{647787DC-8A38-4C7C-AA3A-9F55F3C6208B}"/>
+                <a16:creationId xmlns:a16="http://schemas.microsoft.com/office/drawing/2014/main" id="{C8408FA6-E463-4CDD-B6F5-5DA963C5DA59}"/>
               </a:ext>
             </a:extLst>
           </p:cNvPr>
@@ -1620,7 +1620,7 @@
           <a:p xmlns:a="http://schemas.openxmlformats.org/drawingml/2006/main">
             <a:pPr algn="r">
               <a:buNone/>
-              <a:defRPr sz="1350" b="0">
+              <a:defRPr sz="1200" b="0">
                 <a:solidFill>
                   <a:srgbClr val="53686C"/>
                 </a:solidFill>
@@ -1630,7 +1630,7 @@
               </a:defRPr>
             </a:pPr>
             <a:r>
-              <a:rPr sz="1350" b="0">
+              <a:rPr sz="1200" b="0">
                 <a:solidFill>
                   <a:srgbClr val="53686C"/>
                 </a:solidFill>
@@ -1645,40 +1645,40 @@
       </p:sp>
       <p:sp>
         <p:nvSpPr>
-          <p:cNvPr id="9" name="demo-steps-title">
-            <a:extLst xmlns:a="http://schemas.openxmlformats.org/drawingml/2006/main">
-              <a:ext uri="{FF2B5EF4-FFF2-40B4-BE49-F238E27FC236}">
-                <a16:creationId xmlns:a16="http://schemas.microsoft.com/office/drawing/2014/main" id="{7569D73F-4681-4595-B0AF-71953D026774}"/>
-              </a:ext>
-            </a:extLst>
-          </p:cNvPr>
-          <p:cNvSpPr>
-            <a:spLocks xmlns:a="http://schemas.openxmlformats.org/drawingml/2006/main" noGrp="1"/>
-          </p:cNvSpPr>
-          <p:nvPr/>
-        </p:nvSpPr>
-        <p:spPr>
-          <a:xfrm xmlns:a="http://schemas.openxmlformats.org/drawingml/2006/main">
-            <a:off x="609600" y="2819400"/>
-            <a:ext cx="3981450" cy="304800"/>
-          </a:xfrm>
-          <a:prstGeom xmlns:a="http://schemas.openxmlformats.org/drawingml/2006/main" prst="rect">
-            <a:avLst/>
-          </a:prstGeom>
-          <a:noFill xmlns:a="http://schemas.openxmlformats.org/drawingml/2006/main"/>
-          <a:ln xmlns:a="http://schemas.openxmlformats.org/drawingml/2006/main" w="0">
-            <a:noFill/>
-          </a:ln>
-        </p:spPr>
-        <p:txBody>
-          <a:bodyPr xmlns:a="http://schemas.openxmlformats.org/drawingml/2006/main" wrap="none" lIns="0" tIns="0" rIns="0" bIns="0" anchor="t">
-            <a:noAutofit/>
-          </a:bodyPr>
-          <a:lstStyle xmlns:a="http://schemas.openxmlformats.org/drawingml/2006/main"/>
-          <a:p xmlns:a="http://schemas.openxmlformats.org/drawingml/2006/main">
-            <a:pPr algn="l">
-              <a:buNone/>
-              <a:defRPr sz="1425" b="1">
+          <p:cNvPr id="9" name="number-0">
+            <a:extLst xmlns:a="http://schemas.openxmlformats.org/drawingml/2006/main">
+              <a:ext uri="{FF2B5EF4-FFF2-40B4-BE49-F238E27FC236}">
+                <a16:creationId xmlns:a16="http://schemas.microsoft.com/office/drawing/2014/main" id="{51BDE694-C556-45C9-8B16-C8598B27536B}"/>
+              </a:ext>
+            </a:extLst>
+          </p:cNvPr>
+          <p:cNvSpPr>
+            <a:spLocks xmlns:a="http://schemas.openxmlformats.org/drawingml/2006/main" noGrp="1"/>
+          </p:cNvSpPr>
+          <p:nvPr/>
+        </p:nvSpPr>
+        <p:spPr>
+          <a:xfrm xmlns:a="http://schemas.openxmlformats.org/drawingml/2006/main">
+            <a:off x="609600" y="2762250"/>
+            <a:ext cx="800100" cy="438150"/>
+          </a:xfrm>
+          <a:prstGeom xmlns:a="http://schemas.openxmlformats.org/drawingml/2006/main" prst="rect">
+            <a:avLst/>
+          </a:prstGeom>
+          <a:noFill xmlns:a="http://schemas.openxmlformats.org/drawingml/2006/main"/>
+          <a:ln xmlns:a="http://schemas.openxmlformats.org/drawingml/2006/main" w="0">
+            <a:noFill/>
+          </a:ln>
+        </p:spPr>
+        <p:txBody>
+          <a:bodyPr xmlns:a="http://schemas.openxmlformats.org/drawingml/2006/main" wrap="none" lIns="0" tIns="0" rIns="0" bIns="0" anchor="t">
+            <a:noAutofit/>
+          </a:bodyPr>
+          <a:lstStyle xmlns:a="http://schemas.openxmlformats.org/drawingml/2006/main"/>
+          <a:p xmlns:a="http://schemas.openxmlformats.org/drawingml/2006/main">
+            <a:pPr algn="l">
+              <a:buNone/>
+              <a:defRPr sz="2400" b="1">
                 <a:solidFill>
                   <a:srgbClr val="087E80"/>
                 </a:solidFill>
@@ -1688,7 +1688,7 @@
               </a:defRPr>
             </a:pPr>
             <a:r>
-              <a:rPr sz="1425" b="1">
+              <a:rPr sz="2400" b="1">
                 <a:solidFill>
                   <a:srgbClr val="087E80"/>
                 </a:solidFill>
@@ -1696,47 +1696,47 @@
                 <a:ea typeface="Arial"/>
                 <a:cs typeface="Arial"/>
               </a:rPr>
-              <a:t>PICK A THEME</a:t>
-            </a:r>
-          </a:p>
-        </p:txBody>
-      </p:sp>
-      <p:sp>
-        <p:nvSpPr>
-          <p:cNvPr id="10" name="demo-steps">
-            <a:extLst xmlns:a="http://schemas.openxmlformats.org/drawingml/2006/main">
-              <a:ext uri="{FF2B5EF4-FFF2-40B4-BE49-F238E27FC236}">
-                <a16:creationId xmlns:a16="http://schemas.microsoft.com/office/drawing/2014/main" id="{7526CBD2-FA9F-4747-8CF9-8D7E5F87AFFB}"/>
-              </a:ext>
-            </a:extLst>
-          </p:cNvPr>
-          <p:cNvSpPr>
-            <a:spLocks xmlns:a="http://schemas.openxmlformats.org/drawingml/2006/main" noGrp="1"/>
-          </p:cNvSpPr>
-          <p:nvPr/>
-        </p:nvSpPr>
-        <p:spPr>
-          <a:xfrm xmlns:a="http://schemas.openxmlformats.org/drawingml/2006/main">
-            <a:off x="609600" y="3429000"/>
-            <a:ext cx="4162425" cy="2076450"/>
-          </a:xfrm>
-          <a:prstGeom xmlns:a="http://schemas.openxmlformats.org/drawingml/2006/main" prst="rect">
-            <a:avLst/>
-          </a:prstGeom>
-          <a:noFill xmlns:a="http://schemas.openxmlformats.org/drawingml/2006/main"/>
-          <a:ln xmlns:a="http://schemas.openxmlformats.org/drawingml/2006/main" w="0">
-            <a:noFill/>
-          </a:ln>
-        </p:spPr>
-        <p:txBody>
-          <a:bodyPr xmlns:a="http://schemas.openxmlformats.org/drawingml/2006/main" wrap="none" lIns="0" tIns="0" rIns="0" bIns="0" anchor="t">
-            <a:noAutofit/>
-          </a:bodyPr>
-          <a:lstStyle xmlns:a="http://schemas.openxmlformats.org/drawingml/2006/main"/>
-          <a:p xmlns:a="http://schemas.openxmlformats.org/drawingml/2006/main">
-            <a:pPr algn="l">
-              <a:buNone/>
-              <a:defRPr sz="2175" b="0">
+              <a:t>01</a:t>
+            </a:r>
+          </a:p>
+        </p:txBody>
+      </p:sp>
+      <p:sp>
+        <p:nvSpPr>
+          <p:cNvPr id="10" name="label-0">
+            <a:extLst xmlns:a="http://schemas.openxmlformats.org/drawingml/2006/main">
+              <a:ext uri="{FF2B5EF4-FFF2-40B4-BE49-F238E27FC236}">
+                <a16:creationId xmlns:a16="http://schemas.microsoft.com/office/drawing/2014/main" id="{E901CE81-5B34-4D37-86AA-33C33C0D7159}"/>
+              </a:ext>
+            </a:extLst>
+          </p:cNvPr>
+          <p:cNvSpPr>
+            <a:spLocks xmlns:a="http://schemas.openxmlformats.org/drawingml/2006/main" noGrp="1"/>
+          </p:cNvSpPr>
+          <p:nvPr/>
+        </p:nvSpPr>
+        <p:spPr>
+          <a:xfrm xmlns:a="http://schemas.openxmlformats.org/drawingml/2006/main">
+            <a:off x="1638300" y="2762250"/>
+            <a:ext cx="2476500" cy="438150"/>
+          </a:xfrm>
+          <a:prstGeom xmlns:a="http://schemas.openxmlformats.org/drawingml/2006/main" prst="rect">
+            <a:avLst/>
+          </a:prstGeom>
+          <a:noFill xmlns:a="http://schemas.openxmlformats.org/drawingml/2006/main"/>
+          <a:ln xmlns:a="http://schemas.openxmlformats.org/drawingml/2006/main" w="0">
+            <a:noFill/>
+          </a:ln>
+        </p:spPr>
+        <p:txBody>
+          <a:bodyPr xmlns:a="http://schemas.openxmlformats.org/drawingml/2006/main" wrap="none" lIns="0" tIns="0" rIns="0" bIns="0" anchor="t">
+            <a:noAutofit/>
+          </a:bodyPr>
+          <a:lstStyle xmlns:a="http://schemas.openxmlformats.org/drawingml/2006/main"/>
+          <a:p xmlns:a="http://schemas.openxmlformats.org/drawingml/2006/main">
+            <a:pPr algn="l">
+              <a:buNone/>
+              <a:defRPr sz="1875" b="1">
                 <a:solidFill>
                   <a:srgbClr val="142D32"/>
                 </a:solidFill>
@@ -1746,7 +1746,7 @@
               </a:defRPr>
             </a:pPr>
             <a:r>
-              <a:rPr sz="2175" b="0">
+              <a:rPr sz="1875" b="1">
                 <a:solidFill>
                   <a:srgbClr val="142D32"/>
                 </a:solidFill>
@@ -1754,18 +1754,163 @@
                 <a:ea typeface="Arial"/>
                 <a:cs typeface="Arial"/>
               </a:rPr>
-              <a:t>Get two funny choices.</a:t>
-            </a:r>
-          </a:p>
-          <a:p xmlns:a="http://schemas.openxmlformats.org/drawingml/2006/main">
-            <a:r>
-              <a:t/>
-            </a:r>
-          </a:p>
-          <a:p xmlns:a="http://schemas.openxmlformats.org/drawingml/2006/main">
-            <a:pPr algn="l">
-              <a:buNone/>
-              <a:defRPr sz="2175" b="0">
+              <a:t>Original page</a:t>
+            </a:r>
+          </a:p>
+        </p:txBody>
+      </p:sp>
+      <p:sp>
+        <p:nvSpPr>
+          <p:cNvPr id="11" name="detail-0">
+            <a:extLst xmlns:a="http://schemas.openxmlformats.org/drawingml/2006/main">
+              <a:ext uri="{FF2B5EF4-FFF2-40B4-BE49-F238E27FC236}">
+                <a16:creationId xmlns:a16="http://schemas.microsoft.com/office/drawing/2014/main" id="{BD0ED1E0-713C-4C6D-929D-E0FBED8AF2E8}"/>
+              </a:ext>
+            </a:extLst>
+          </p:cNvPr>
+          <p:cNvSpPr>
+            <a:spLocks xmlns:a="http://schemas.openxmlformats.org/drawingml/2006/main" noGrp="1"/>
+          </p:cNvSpPr>
+          <p:nvPr/>
+        </p:nvSpPr>
+        <p:spPr>
+          <a:xfrm xmlns:a="http://schemas.openxmlformats.org/drawingml/2006/main">
+            <a:off x="4476750" y="2790825"/>
+            <a:ext cx="7067550" cy="409575"/>
+          </a:xfrm>
+          <a:prstGeom xmlns:a="http://schemas.openxmlformats.org/drawingml/2006/main" prst="rect">
+            <a:avLst/>
+          </a:prstGeom>
+          <a:noFill xmlns:a="http://schemas.openxmlformats.org/drawingml/2006/main"/>
+          <a:ln xmlns:a="http://schemas.openxmlformats.org/drawingml/2006/main" w="0">
+            <a:noFill/>
+          </a:ln>
+        </p:spPr>
+        <p:txBody>
+          <a:bodyPr xmlns:a="http://schemas.openxmlformats.org/drawingml/2006/main" wrap="none" lIns="0" tIns="0" rIns="0" bIns="0" anchor="t">
+            <a:noAutofit/>
+          </a:bodyPr>
+          <a:lstStyle xmlns:a="http://schemas.openxmlformats.org/drawingml/2006/main"/>
+          <a:p xmlns:a="http://schemas.openxmlformats.org/drawingml/2006/main">
+            <a:pPr algn="l">
+              <a:buNone/>
+              <a:defRPr sz="1725" b="0">
+                <a:solidFill>
+                  <a:srgbClr val="53686C"/>
+                </a:solidFill>
+                <a:latin typeface="Arial"/>
+                <a:ea typeface="Arial"/>
+                <a:cs typeface="Arial"/>
+              </a:defRPr>
+            </a:pPr>
+            <a:r>
+              <a:rPr sz="1725" b="0">
+                <a:solidFill>
+                  <a:srgbClr val="53686C"/>
+                </a:solidFill>
+                <a:latin typeface="Arial"/>
+                <a:ea typeface="Arial"/>
+                <a:cs typeface="Arial"/>
+              </a:rPr>
+              <a:t>index.html → heading, colors, and a click counter</a:t>
+            </a:r>
+          </a:p>
+        </p:txBody>
+      </p:sp>
+      <p:sp>
+        <p:nvSpPr>
+          <p:cNvPr id="12" name="number-1">
+            <a:extLst xmlns:a="http://schemas.openxmlformats.org/drawingml/2006/main">
+              <a:ext uri="{FF2B5EF4-FFF2-40B4-BE49-F238E27FC236}">
+                <a16:creationId xmlns:a16="http://schemas.microsoft.com/office/drawing/2014/main" id="{AD5A7334-AE57-4202-9AFA-95A3587926EB}"/>
+              </a:ext>
+            </a:extLst>
+          </p:cNvPr>
+          <p:cNvSpPr>
+            <a:spLocks xmlns:a="http://schemas.openxmlformats.org/drawingml/2006/main" noGrp="1"/>
+          </p:cNvSpPr>
+          <p:nvPr/>
+        </p:nvSpPr>
+        <p:spPr>
+          <a:xfrm xmlns:a="http://schemas.openxmlformats.org/drawingml/2006/main">
+            <a:off x="609600" y="3476625"/>
+            <a:ext cx="800100" cy="438150"/>
+          </a:xfrm>
+          <a:prstGeom xmlns:a="http://schemas.openxmlformats.org/drawingml/2006/main" prst="rect">
+            <a:avLst/>
+          </a:prstGeom>
+          <a:noFill xmlns:a="http://schemas.openxmlformats.org/drawingml/2006/main"/>
+          <a:ln xmlns:a="http://schemas.openxmlformats.org/drawingml/2006/main" w="0">
+            <a:noFill/>
+          </a:ln>
+        </p:spPr>
+        <p:txBody>
+          <a:bodyPr xmlns:a="http://schemas.openxmlformats.org/drawingml/2006/main" wrap="none" lIns="0" tIns="0" rIns="0" bIns="0" anchor="t">
+            <a:noAutofit/>
+          </a:bodyPr>
+          <a:lstStyle xmlns:a="http://schemas.openxmlformats.org/drawingml/2006/main"/>
+          <a:p xmlns:a="http://schemas.openxmlformats.org/drawingml/2006/main">
+            <a:pPr algn="l">
+              <a:buNone/>
+              <a:defRPr sz="2400" b="1">
+                <a:solidFill>
+                  <a:srgbClr val="087E80"/>
+                </a:solidFill>
+                <a:latin typeface="Arial"/>
+                <a:ea typeface="Arial"/>
+                <a:cs typeface="Arial"/>
+              </a:defRPr>
+            </a:pPr>
+            <a:r>
+              <a:rPr sz="2400" b="1">
+                <a:solidFill>
+                  <a:srgbClr val="087E80"/>
+                </a:solidFill>
+                <a:latin typeface="Arial"/>
+                <a:ea typeface="Arial"/>
+                <a:cs typeface="Arial"/>
+              </a:rPr>
+              <a:t>02</a:t>
+            </a:r>
+          </a:p>
+        </p:txBody>
+      </p:sp>
+      <p:sp>
+        <p:nvSpPr>
+          <p:cNvPr id="13" name="label-1">
+            <a:extLst xmlns:a="http://schemas.openxmlformats.org/drawingml/2006/main">
+              <a:ext uri="{FF2B5EF4-FFF2-40B4-BE49-F238E27FC236}">
+                <a16:creationId xmlns:a16="http://schemas.microsoft.com/office/drawing/2014/main" id="{103D2AB4-FD59-4411-8C36-0103588CA6F2}"/>
+              </a:ext>
+            </a:extLst>
+          </p:cNvPr>
+          <p:cNvSpPr>
+            <a:spLocks xmlns:a="http://schemas.openxmlformats.org/drawingml/2006/main" noGrp="1"/>
+          </p:cNvSpPr>
+          <p:nvPr/>
+        </p:nvSpPr>
+        <p:spPr>
+          <a:xfrm xmlns:a="http://schemas.openxmlformats.org/drawingml/2006/main">
+            <a:off x="1638300" y="3476625"/>
+            <a:ext cx="2476500" cy="438150"/>
+          </a:xfrm>
+          <a:prstGeom xmlns:a="http://schemas.openxmlformats.org/drawingml/2006/main" prst="rect">
+            <a:avLst/>
+          </a:prstGeom>
+          <a:noFill xmlns:a="http://schemas.openxmlformats.org/drawingml/2006/main"/>
+          <a:ln xmlns:a="http://schemas.openxmlformats.org/drawingml/2006/main" w="0">
+            <a:noFill/>
+          </a:ln>
+        </p:spPr>
+        <p:txBody>
+          <a:bodyPr xmlns:a="http://schemas.openxmlformats.org/drawingml/2006/main" wrap="none" lIns="0" tIns="0" rIns="0" bIns="0" anchor="t">
+            <a:noAutofit/>
+          </a:bodyPr>
+          <a:lstStyle xmlns:a="http://schemas.openxmlformats.org/drawingml/2006/main"/>
+          <a:p xmlns:a="http://schemas.openxmlformats.org/drawingml/2006/main">
+            <a:pPr algn="l">
+              <a:buNone/>
+              <a:defRPr sz="1875" b="1">
                 <a:solidFill>
                   <a:srgbClr val="142D32"/>
                 </a:solidFill>
@@ -1775,7 +1920,7 @@
               </a:defRPr>
             </a:pPr>
             <a:r>
-              <a:rPr sz="2175" b="0">
+              <a:rPr sz="1875" b="1">
                 <a:solidFill>
                   <a:srgbClr val="142D32"/>
                 </a:solidFill>
@@ -1783,18 +1928,163 @@
                 <a:ea typeface="Arial"/>
                 <a:cs typeface="Arial"/>
               </a:rPr>
-              <a:t>Vote A or B.</a:t>
-            </a:r>
-          </a:p>
-          <a:p xmlns:a="http://schemas.openxmlformats.org/drawingml/2006/main">
-            <a:r>
-              <a:t/>
-            </a:r>
-          </a:p>
-          <a:p xmlns:a="http://schemas.openxmlformats.org/drawingml/2006/main">
-            <a:pPr algn="l">
-              <a:buNone/>
-              <a:defRPr sz="2175" b="0">
+              <a:t>Simple game</a:t>
+            </a:r>
+          </a:p>
+        </p:txBody>
+      </p:sp>
+      <p:sp>
+        <p:nvSpPr>
+          <p:cNvPr id="14" name="detail-1">
+            <a:extLst xmlns:a="http://schemas.openxmlformats.org/drawingml/2006/main">
+              <a:ext uri="{FF2B5EF4-FFF2-40B4-BE49-F238E27FC236}">
+                <a16:creationId xmlns:a16="http://schemas.microsoft.com/office/drawing/2014/main" id="{A5914C25-27E7-47D8-9ACC-EFCE8E16BC3D}"/>
+              </a:ext>
+            </a:extLst>
+          </p:cNvPr>
+          <p:cNvSpPr>
+            <a:spLocks xmlns:a="http://schemas.openxmlformats.org/drawingml/2006/main" noGrp="1"/>
+          </p:cNvSpPr>
+          <p:nvPr/>
+        </p:nvSpPr>
+        <p:spPr>
+          <a:xfrm xmlns:a="http://schemas.openxmlformats.org/drawingml/2006/main">
+            <a:off x="4476750" y="3505200"/>
+            <a:ext cx="7067550" cy="409575"/>
+          </a:xfrm>
+          <a:prstGeom xmlns:a="http://schemas.openxmlformats.org/drawingml/2006/main" prst="rect">
+            <a:avLst/>
+          </a:prstGeom>
+          <a:noFill xmlns:a="http://schemas.openxmlformats.org/drawingml/2006/main"/>
+          <a:ln xmlns:a="http://schemas.openxmlformats.org/drawingml/2006/main" w="0">
+            <a:noFill/>
+          </a:ln>
+        </p:spPr>
+        <p:txBody>
+          <a:bodyPr xmlns:a="http://schemas.openxmlformats.org/drawingml/2006/main" wrap="none" lIns="0" tIns="0" rIns="0" bIns="0" anchor="t">
+            <a:noAutofit/>
+          </a:bodyPr>
+          <a:lstStyle xmlns:a="http://schemas.openxmlformats.org/drawingml/2006/main"/>
+          <a:p xmlns:a="http://schemas.openxmlformats.org/drawingml/2006/main">
+            <a:pPr algn="l">
+              <a:buNone/>
+              <a:defRPr sz="1725" b="0">
+                <a:solidFill>
+                  <a:srgbClr val="53686C"/>
+                </a:solidFill>
+                <a:latin typeface="Arial"/>
+                <a:ea typeface="Arial"/>
+                <a:cs typeface="Arial"/>
+              </a:defRPr>
+            </a:pPr>
+            <a:r>
+              <a:rPr sz="1725" b="0">
+                <a:solidFill>
+                  <a:srgbClr val="53686C"/>
+                </a:solidFill>
+                <a:latin typeface="Arial"/>
+                <a:ea typeface="Arial"/>
+                <a:cs typeface="Arial"/>
+              </a:rPr>
+              <a:t>game/index.html → pick a theme and vote</a:t>
+            </a:r>
+          </a:p>
+        </p:txBody>
+      </p:sp>
+      <p:sp>
+        <p:nvSpPr>
+          <p:cNvPr id="15" name="number-2">
+            <a:extLst xmlns:a="http://schemas.openxmlformats.org/drawingml/2006/main">
+              <a:ext uri="{FF2B5EF4-FFF2-40B4-BE49-F238E27FC236}">
+                <a16:creationId xmlns:a16="http://schemas.microsoft.com/office/drawing/2014/main" id="{48C15E34-16CE-4F28-B10B-104872F8D180}"/>
+              </a:ext>
+            </a:extLst>
+          </p:cNvPr>
+          <p:cNvSpPr>
+            <a:spLocks xmlns:a="http://schemas.openxmlformats.org/drawingml/2006/main" noGrp="1"/>
+          </p:cNvSpPr>
+          <p:nvPr/>
+        </p:nvSpPr>
+        <p:spPr>
+          <a:xfrm xmlns:a="http://schemas.openxmlformats.org/drawingml/2006/main">
+            <a:off x="609600" y="4191000"/>
+            <a:ext cx="800100" cy="438150"/>
+          </a:xfrm>
+          <a:prstGeom xmlns:a="http://schemas.openxmlformats.org/drawingml/2006/main" prst="rect">
+            <a:avLst/>
+          </a:prstGeom>
+          <a:noFill xmlns:a="http://schemas.openxmlformats.org/drawingml/2006/main"/>
+          <a:ln xmlns:a="http://schemas.openxmlformats.org/drawingml/2006/main" w="0">
+            <a:noFill/>
+          </a:ln>
+        </p:spPr>
+        <p:txBody>
+          <a:bodyPr xmlns:a="http://schemas.openxmlformats.org/drawingml/2006/main" wrap="none" lIns="0" tIns="0" rIns="0" bIns="0" anchor="t">
+            <a:noAutofit/>
+          </a:bodyPr>
+          <a:lstStyle xmlns:a="http://schemas.openxmlformats.org/drawingml/2006/main"/>
+          <a:p xmlns:a="http://schemas.openxmlformats.org/drawingml/2006/main">
+            <a:pPr algn="l">
+              <a:buNone/>
+              <a:defRPr sz="2400" b="1">
+                <a:solidFill>
+                  <a:srgbClr val="087E80"/>
+                </a:solidFill>
+                <a:latin typeface="Arial"/>
+                <a:ea typeface="Arial"/>
+                <a:cs typeface="Arial"/>
+              </a:defRPr>
+            </a:pPr>
+            <a:r>
+              <a:rPr sz="2400" b="1">
+                <a:solidFill>
+                  <a:srgbClr val="087E80"/>
+                </a:solidFill>
+                <a:latin typeface="Arial"/>
+                <a:ea typeface="Arial"/>
+                <a:cs typeface="Arial"/>
+              </a:rPr>
+              <a:t>03</a:t>
+            </a:r>
+          </a:p>
+        </p:txBody>
+      </p:sp>
+      <p:sp>
+        <p:nvSpPr>
+          <p:cNvPr id="16" name="label-2">
+            <a:extLst xmlns:a="http://schemas.openxmlformats.org/drawingml/2006/main">
+              <a:ext uri="{FF2B5EF4-FFF2-40B4-BE49-F238E27FC236}">
+                <a16:creationId xmlns:a16="http://schemas.microsoft.com/office/drawing/2014/main" id="{2D9E683A-398A-4AB2-AA79-A9276DCE23D4}"/>
+              </a:ext>
+            </a:extLst>
+          </p:cNvPr>
+          <p:cNvSpPr>
+            <a:spLocks xmlns:a="http://schemas.openxmlformats.org/drawingml/2006/main" noGrp="1"/>
+          </p:cNvSpPr>
+          <p:nvPr/>
+        </p:nvSpPr>
+        <p:spPr>
+          <a:xfrm xmlns:a="http://schemas.openxmlformats.org/drawingml/2006/main">
+            <a:off x="1638300" y="4191000"/>
+            <a:ext cx="2476500" cy="438150"/>
+          </a:xfrm>
+          <a:prstGeom xmlns:a="http://schemas.openxmlformats.org/drawingml/2006/main" prst="rect">
+            <a:avLst/>
+          </a:prstGeom>
+          <a:noFill xmlns:a="http://schemas.openxmlformats.org/drawingml/2006/main"/>
+          <a:ln xmlns:a="http://schemas.openxmlformats.org/drawingml/2006/main" w="0">
+            <a:noFill/>
+          </a:ln>
+        </p:spPr>
+        <p:txBody>
+          <a:bodyPr xmlns:a="http://schemas.openxmlformats.org/drawingml/2006/main" wrap="none" lIns="0" tIns="0" rIns="0" bIns="0" anchor="t">
+            <a:noAutofit/>
+          </a:bodyPr>
+          <a:lstStyle xmlns:a="http://schemas.openxmlformats.org/drawingml/2006/main"/>
+          <a:p xmlns:a="http://schemas.openxmlformats.org/drawingml/2006/main">
+            <a:pPr algn="l">
+              <a:buNone/>
+              <a:defRPr sz="1875" b="1">
                 <a:solidFill>
                   <a:srgbClr val="142D32"/>
                 </a:solidFill>
@@ -1804,7 +2094,7 @@
               </a:defRPr>
             </a:pPr>
             <a:r>
-              <a:rPr sz="2175" b="0">
+              <a:rPr sz="1875" b="1">
                 <a:solidFill>
                   <a:srgbClr val="142D32"/>
                 </a:solidFill>
@@ -1812,47 +2102,47 @@
                 <a:ea typeface="Arial"/>
                 <a:cs typeface="Arial"/>
               </a:rPr>
-              <a:t>Defend your answer.</a:t>
-            </a:r>
-          </a:p>
-        </p:txBody>
-      </p:sp>
-      <p:sp>
-        <p:nvSpPr>
-          <p:cNvPr id="11" name="demo-area">
-            <a:extLst xmlns:a="http://schemas.openxmlformats.org/drawingml/2006/main">
-              <a:ext uri="{FF2B5EF4-FFF2-40B4-BE49-F238E27FC236}">
-                <a16:creationId xmlns:a16="http://schemas.microsoft.com/office/drawing/2014/main" id="{C01B722D-1CED-414A-A9F2-64160398C822}"/>
-              </a:ext>
-            </a:extLst>
-          </p:cNvPr>
-          <p:cNvSpPr>
-            <a:spLocks xmlns:a="http://schemas.openxmlformats.org/drawingml/2006/main" noGrp="1"/>
-          </p:cNvSpPr>
-          <p:nvPr/>
-        </p:nvSpPr>
-        <p:spPr>
-          <a:xfrm xmlns:a="http://schemas.openxmlformats.org/drawingml/2006/main">
-            <a:off x="5257800" y="2857500"/>
-            <a:ext cx="6324600" cy="2000250"/>
-          </a:xfrm>
-          <a:prstGeom xmlns:a="http://schemas.openxmlformats.org/drawingml/2006/main" prst="rect">
-            <a:avLst/>
-          </a:prstGeom>
-          <a:noFill xmlns:a="http://schemas.openxmlformats.org/drawingml/2006/main"/>
-          <a:ln xmlns:a="http://schemas.openxmlformats.org/drawingml/2006/main" w="0">
-            <a:noFill/>
-          </a:ln>
-        </p:spPr>
-        <p:txBody>
-          <a:bodyPr xmlns:a="http://schemas.openxmlformats.org/drawingml/2006/main" wrap="none" lIns="0" tIns="0" rIns="0" bIns="0" anchor="t">
-            <a:noAutofit/>
-          </a:bodyPr>
-          <a:lstStyle xmlns:a="http://schemas.openxmlformats.org/drawingml/2006/main"/>
-          <a:p xmlns:a="http://schemas.openxmlformats.org/drawingml/2006/main">
-            <a:pPr algn="l">
-              <a:buNone/>
-              <a:defRPr sz="2175" b="0">
+              <a:t>Advanced example</a:t>
+            </a:r>
+          </a:p>
+        </p:txBody>
+      </p:sp>
+      <p:sp>
+        <p:nvSpPr>
+          <p:cNvPr id="17" name="detail-2">
+            <a:extLst xmlns:a="http://schemas.openxmlformats.org/drawingml/2006/main">
+              <a:ext uri="{FF2B5EF4-FFF2-40B4-BE49-F238E27FC236}">
+                <a16:creationId xmlns:a16="http://schemas.microsoft.com/office/drawing/2014/main" id="{86AC9DF9-265A-4051-90FA-C86F9F89C9A9}"/>
+              </a:ext>
+            </a:extLst>
+          </p:cNvPr>
+          <p:cNvSpPr>
+            <a:spLocks xmlns:a="http://schemas.openxmlformats.org/drawingml/2006/main" noGrp="1"/>
+          </p:cNvSpPr>
+          <p:nvPr/>
+        </p:nvSpPr>
+        <p:spPr>
+          <a:xfrm xmlns:a="http://schemas.openxmlformats.org/drawingml/2006/main">
+            <a:off x="4476750" y="4219575"/>
+            <a:ext cx="7067550" cy="409575"/>
+          </a:xfrm>
+          <a:prstGeom xmlns:a="http://schemas.openxmlformats.org/drawingml/2006/main" prst="rect">
+            <a:avLst/>
+          </a:prstGeom>
+          <a:noFill xmlns:a="http://schemas.openxmlformats.org/drawingml/2006/main"/>
+          <a:ln xmlns:a="http://schemas.openxmlformats.org/drawingml/2006/main" w="0">
+            <a:noFill/>
+          </a:ln>
+        </p:spPr>
+        <p:txBody>
+          <a:bodyPr xmlns:a="http://schemas.openxmlformats.org/drawingml/2006/main" wrap="none" lIns="0" tIns="0" rIns="0" bIns="0" anchor="t">
+            <a:noAutofit/>
+          </a:bodyPr>
+          <a:lstStyle xmlns:a="http://schemas.openxmlformats.org/drawingml/2006/main"/>
+          <a:p xmlns:a="http://schemas.openxmlformats.org/drawingml/2006/main">
+            <a:pPr algn="l">
+              <a:buNone/>
+              <a:defRPr sz="1725" b="0">
                 <a:solidFill>
                   <a:srgbClr val="53686C"/>
                 </a:solidFill>
@@ -1862,7 +2152,7 @@
               </a:defRPr>
             </a:pPr>
             <a:r>
-              <a:rPr sz="2175" b="0">
+              <a:rPr sz="1725" b="0">
                 <a:solidFill>
                   <a:srgbClr val="53686C"/>
                 </a:solidFill>
@@ -1870,47 +2160,47 @@
                 <a:ea typeface="Arial"/>
                 <a:cs typeface="Arial"/>
               </a:rPr>
-              <a:t/>
-            </a:r>
-          </a:p>
-        </p:txBody>
-      </p:sp>
-      <p:sp>
-        <p:nvSpPr>
-          <p:cNvPr id="12" name="demo-question">
-            <a:extLst xmlns:a="http://schemas.openxmlformats.org/drawingml/2006/main">
-              <a:ext uri="{FF2B5EF4-FFF2-40B4-BE49-F238E27FC236}">
-                <a16:creationId xmlns:a16="http://schemas.microsoft.com/office/drawing/2014/main" id="{DF230DE5-B487-426F-8BFE-64401CA74FD7}"/>
-              </a:ext>
-            </a:extLst>
-          </p:cNvPr>
-          <p:cNvSpPr>
-            <a:spLocks xmlns:a="http://schemas.openxmlformats.org/drawingml/2006/main" noGrp="1"/>
-          </p:cNvSpPr>
-          <p:nvPr/>
-        </p:nvSpPr>
-        <p:spPr>
-          <a:xfrm xmlns:a="http://schemas.openxmlformats.org/drawingml/2006/main">
-            <a:off x="5257800" y="5553075"/>
-            <a:ext cx="6324600" cy="542925"/>
-          </a:xfrm>
-          <a:prstGeom xmlns:a="http://schemas.openxmlformats.org/drawingml/2006/main" prst="rect">
-            <a:avLst/>
-          </a:prstGeom>
-          <a:noFill xmlns:a="http://schemas.openxmlformats.org/drawingml/2006/main"/>
-          <a:ln xmlns:a="http://schemas.openxmlformats.org/drawingml/2006/main" w="0">
-            <a:noFill/>
-          </a:ln>
-        </p:spPr>
-        <p:txBody>
-          <a:bodyPr xmlns:a="http://schemas.openxmlformats.org/drawingml/2006/main" wrap="none" lIns="0" tIns="0" rIns="0" bIns="0" anchor="t">
-            <a:noAutofit/>
-          </a:bodyPr>
-          <a:lstStyle xmlns:a="http://schemas.openxmlformats.org/drawingml/2006/main"/>
-          <a:p xmlns:a="http://schemas.openxmlformats.org/drawingml/2006/main">
-            <a:pPr algn="l">
-              <a:buNone/>
-              <a:defRPr sz="1725" b="1">
+              <a:t>ai-would-you-rather/index.html → chatbot demo</a:t>
+            </a:r>
+          </a:p>
+        </p:txBody>
+      </p:sp>
+      <p:sp>
+        <p:nvSpPr>
+          <p:cNvPr id="18" name="number-3">
+            <a:extLst xmlns:a="http://schemas.openxmlformats.org/drawingml/2006/main">
+              <a:ext uri="{FF2B5EF4-FFF2-40B4-BE49-F238E27FC236}">
+                <a16:creationId xmlns:a16="http://schemas.microsoft.com/office/drawing/2014/main" id="{B815891C-F9E3-4E7E-9B17-326932EE6564}"/>
+              </a:ext>
+            </a:extLst>
+          </p:cNvPr>
+          <p:cNvSpPr>
+            <a:spLocks xmlns:a="http://schemas.openxmlformats.org/drawingml/2006/main" noGrp="1"/>
+          </p:cNvSpPr>
+          <p:nvPr/>
+        </p:nvSpPr>
+        <p:spPr>
+          <a:xfrm xmlns:a="http://schemas.openxmlformats.org/drawingml/2006/main">
+            <a:off x="609600" y="4905375"/>
+            <a:ext cx="800100" cy="438150"/>
+          </a:xfrm>
+          <a:prstGeom xmlns:a="http://schemas.openxmlformats.org/drawingml/2006/main" prst="rect">
+            <a:avLst/>
+          </a:prstGeom>
+          <a:noFill xmlns:a="http://schemas.openxmlformats.org/drawingml/2006/main"/>
+          <a:ln xmlns:a="http://schemas.openxmlformats.org/drawingml/2006/main" w="0">
+            <a:noFill/>
+          </a:ln>
+        </p:spPr>
+        <p:txBody>
+          <a:bodyPr xmlns:a="http://schemas.openxmlformats.org/drawingml/2006/main" wrap="none" lIns="0" tIns="0" rIns="0" bIns="0" anchor="t">
+            <a:noAutofit/>
+          </a:bodyPr>
+          <a:lstStyle xmlns:a="http://schemas.openxmlformats.org/drawingml/2006/main"/>
+          <a:p xmlns:a="http://schemas.openxmlformats.org/drawingml/2006/main">
+            <a:pPr algn="l">
+              <a:buNone/>
+              <a:defRPr sz="2400" b="1">
                 <a:solidFill>
                   <a:srgbClr val="087E80"/>
                 </a:solidFill>
@@ -1920,7 +2210,7 @@
               </a:defRPr>
             </a:pPr>
             <a:r>
-              <a:rPr sz="1725" b="1">
+              <a:rPr sz="2400" b="1">
                 <a:solidFill>
                   <a:srgbClr val="087E80"/>
                 </a:solidFill>
@@ -1928,37 +2218,131 @@
                 <a:ea typeface="Arial"/>
                 <a:cs typeface="Arial"/>
               </a:rPr>
-              <a:t>Floating chat button or full-page game — same API.</a:t>
-            </a:r>
-          </a:p>
-        </p:txBody>
-      </p:sp>
-      <p:pic>
-        <p:nvPicPr>
-          <p:cNvPr id="27" name=""/>
-          <p:cNvPicPr>
-            <a:picLocks xmlns:a="http://schemas.openxmlformats.org/drawingml/2006/main" noChangeAspect="1"/>
-          </p:cNvPicPr>
-          <p:nvPr/>
-        </p:nvPicPr>
-        <p:blipFill>
-          <a:blip xmlns:r="http://schemas.openxmlformats.org/officeDocument/2006/relationships" xmlns:a="http://schemas.openxmlformats.org/drawingml/2006/main" r:embed="Rd0672ce32cdd4587"/>
-          <a:stretch xmlns:a="http://schemas.openxmlformats.org/drawingml/2006/main"/>
-        </p:blipFill>
-        <p:spPr>
-          <a:xfrm xmlns:a="http://schemas.openxmlformats.org/drawingml/2006/main">
-            <a:off x="6249458" y="2381250"/>
-            <a:ext cx="4131733" cy="2905125"/>
-          </a:xfrm>
-          <a:prstGeom xmlns:a="http://schemas.openxmlformats.org/drawingml/2006/main" prst="rect">
-            <a:avLst/>
-          </a:prstGeom>
-        </p:spPr>
-      </p:pic>
+              <a:t>04</a:t>
+            </a:r>
+          </a:p>
+        </p:txBody>
+      </p:sp>
+      <p:sp>
+        <p:nvSpPr>
+          <p:cNvPr id="19" name="label-3">
+            <a:extLst xmlns:a="http://schemas.openxmlformats.org/drawingml/2006/main">
+              <a:ext uri="{FF2B5EF4-FFF2-40B4-BE49-F238E27FC236}">
+                <a16:creationId xmlns:a16="http://schemas.microsoft.com/office/drawing/2014/main" id="{D16D2124-C19D-4287-BA72-4BAFA52DD5C6}"/>
+              </a:ext>
+            </a:extLst>
+          </p:cNvPr>
+          <p:cNvSpPr>
+            <a:spLocks xmlns:a="http://schemas.openxmlformats.org/drawingml/2006/main" noGrp="1"/>
+          </p:cNvSpPr>
+          <p:nvPr/>
+        </p:nvSpPr>
+        <p:spPr>
+          <a:xfrm xmlns:a="http://schemas.openxmlformats.org/drawingml/2006/main">
+            <a:off x="1638300" y="4905375"/>
+            <a:ext cx="2476500" cy="438150"/>
+          </a:xfrm>
+          <a:prstGeom xmlns:a="http://schemas.openxmlformats.org/drawingml/2006/main" prst="rect">
+            <a:avLst/>
+          </a:prstGeom>
+          <a:noFill xmlns:a="http://schemas.openxmlformats.org/drawingml/2006/main"/>
+          <a:ln xmlns:a="http://schemas.openxmlformats.org/drawingml/2006/main" w="0">
+            <a:noFill/>
+          </a:ln>
+        </p:spPr>
+        <p:txBody>
+          <a:bodyPr xmlns:a="http://schemas.openxmlformats.org/drawingml/2006/main" wrap="none" lIns="0" tIns="0" rIns="0" bIns="0" anchor="t">
+            <a:noAutofit/>
+          </a:bodyPr>
+          <a:lstStyle xmlns:a="http://schemas.openxmlformats.org/drawingml/2006/main"/>
+          <a:p xmlns:a="http://schemas.openxmlformats.org/drawingml/2006/main">
+            <a:pPr algn="l">
+              <a:buNone/>
+              <a:defRPr sz="1875" b="1">
+                <a:solidFill>
+                  <a:srgbClr val="142D32"/>
+                </a:solidFill>
+                <a:latin typeface="Arial"/>
+                <a:ea typeface="Arial"/>
+                <a:cs typeface="Arial"/>
+              </a:defRPr>
+            </a:pPr>
+            <a:r>
+              <a:rPr sz="1875" b="1">
+                <a:solidFill>
+                  <a:srgbClr val="142D32"/>
+                </a:solidFill>
+                <a:latin typeface="Arial"/>
+                <a:ea typeface="Arial"/>
+                <a:cs typeface="Arial"/>
+              </a:rPr>
+              <a:t>Your next page</a:t>
+            </a:r>
+          </a:p>
+        </p:txBody>
+      </p:sp>
+      <p:sp>
+        <p:nvSpPr>
+          <p:cNvPr id="20" name="detail-3">
+            <a:extLst xmlns:a="http://schemas.openxmlformats.org/drawingml/2006/main">
+              <a:ext uri="{FF2B5EF4-FFF2-40B4-BE49-F238E27FC236}">
+                <a16:creationId xmlns:a16="http://schemas.microsoft.com/office/drawing/2014/main" id="{9219B99F-90F8-4C32-9F2B-5F01F554F722}"/>
+              </a:ext>
+            </a:extLst>
+          </p:cNvPr>
+          <p:cNvSpPr>
+            <a:spLocks xmlns:a="http://schemas.openxmlformats.org/drawingml/2006/main" noGrp="1"/>
+          </p:cNvSpPr>
+          <p:nvPr/>
+        </p:nvSpPr>
+        <p:spPr>
+          <a:xfrm xmlns:a="http://schemas.openxmlformats.org/drawingml/2006/main">
+            <a:off x="4476750" y="4933950"/>
+            <a:ext cx="7067550" cy="409575"/>
+          </a:xfrm>
+          <a:prstGeom xmlns:a="http://schemas.openxmlformats.org/drawingml/2006/main" prst="rect">
+            <a:avLst/>
+          </a:prstGeom>
+          <a:noFill xmlns:a="http://schemas.openxmlformats.org/drawingml/2006/main"/>
+          <a:ln xmlns:a="http://schemas.openxmlformats.org/drawingml/2006/main" w="0">
+            <a:noFill/>
+          </a:ln>
+        </p:spPr>
+        <p:txBody>
+          <a:bodyPr xmlns:a="http://schemas.openxmlformats.org/drawingml/2006/main" wrap="none" lIns="0" tIns="0" rIns="0" bIns="0" anchor="t">
+            <a:noAutofit/>
+          </a:bodyPr>
+          <a:lstStyle xmlns:a="http://schemas.openxmlformats.org/drawingml/2006/main"/>
+          <a:p xmlns:a="http://schemas.openxmlformats.org/drawingml/2006/main">
+            <a:pPr algn="l">
+              <a:buNone/>
+              <a:defRPr sz="1725" b="0">
+                <a:solidFill>
+                  <a:srgbClr val="53686C"/>
+                </a:solidFill>
+                <a:latin typeface="Arial"/>
+                <a:ea typeface="Arial"/>
+                <a:cs typeface="Arial"/>
+              </a:defRPr>
+            </a:pPr>
+            <a:r>
+              <a:rPr sz="1725" b="0">
+                <a:solidFill>
+                  <a:srgbClr val="53686C"/>
+                </a:solidFill>
+                <a:latin typeface="Arial"/>
+                <a:ea typeface="Arial"/>
+                <a:cs typeface="Arial"/>
+              </a:rPr>
+              <a:t>Add a folder with its own index.html</a:t>
+            </a:r>
+          </a:p>
+        </p:txBody>
+      </p:sp>
     </p:spTree>
     <p:extLst>
       <p:ext uri="{BB962C8B-B14F-4D97-AF65-F5344CB8AC3E}">
-        <p14:creationId xmlns:p14="http://schemas.microsoft.com/office/powerpoint/2010/main" val="1027706640"/>
+        <p14:creationId xmlns:p14="http://schemas.microsoft.com/office/powerpoint/2010/main" val="398891925"/>
       </p:ext>
     </p:extLst>
   </p:cSld>
@@ -2037,7 +2421,7 @@
                 <a:ea typeface="Arial"/>
                 <a:cs typeface="Arial"/>
               </a:rPr>
-              <a:t>AI CLUB</a:t>
+              <a:t>UConn AI Club</a:t>
             </a:r>
           </a:p>
         </p:txBody>
@@ -2077,7 +2461,7 @@
           <a:p xmlns:a="http://schemas.openxmlformats.org/drawingml/2006/main">
             <a:pPr algn="l">
               <a:buNone/>
-              <a:defRPr sz="3600" b="1">
+              <a:defRPr sz="3450" b="1">
                 <a:solidFill>
                   <a:srgbClr val="142D32"/>
                 </a:solidFill>
@@ -2087,7 +2471,7 @@
               </a:defRPr>
             </a:pPr>
             <a:r>
-              <a:rPr sz="3600" b="1">
+              <a:rPr sz="3450" b="1">
                 <a:solidFill>
                   <a:srgbClr val="142D32"/>
                 </a:solidFill>
@@ -2095,7 +2479,7 @@
                 <a:ea typeface="Arial"/>
                 <a:cs typeface="Arial"/>
               </a:rPr>
-              <a:t>Start with your GitHub website</a:t>
+              <a:t>Publish your GitHub website</a:t>
             </a:r>
           </a:p>
         </p:txBody>
@@ -2153,7 +2537,7 @@
                 <a:ea typeface="Arial"/>
                 <a:cs typeface="Arial"/>
               </a:rPr>
-              <a:t>Already published? Keep your site and add the demo files.</a:t>
+              <a:t>Already published? Open your site and continue.</a:t>
             </a:r>
           </a:p>
         </p:txBody>
@@ -2193,7 +2577,7 @@
           <a:p xmlns:a="http://schemas.openxmlformats.org/drawingml/2006/main">
             <a:pPr algn="r">
               <a:buNone/>
-              <a:defRPr sz="1350" b="0">
+              <a:defRPr sz="1200" b="0">
                 <a:solidFill>
                   <a:srgbClr val="53686C"/>
                 </a:solidFill>
@@ -2203,7 +2587,7 @@
               </a:defRPr>
             </a:pPr>
             <a:r>
-              <a:rPr sz="1350" b="0">
+              <a:rPr sz="1200" b="0">
                 <a:solidFill>
                   <a:srgbClr val="53686C"/>
                 </a:solidFill>
@@ -2309,7 +2693,7 @@
           <a:p xmlns:a="http://schemas.openxmlformats.org/drawingml/2006/main">
             <a:pPr algn="l">
               <a:buNone/>
-              <a:defRPr sz="1950" b="1">
+              <a:defRPr sz="1875" b="1">
                 <a:solidFill>
                   <a:srgbClr val="142D32"/>
                 </a:solidFill>
@@ -2319,7 +2703,7 @@
               </a:defRPr>
             </a:pPr>
             <a:r>
-              <a:rPr sz="1950" b="1">
+              <a:rPr sz="1875" b="1">
                 <a:solidFill>
                   <a:srgbClr val="142D32"/>
                 </a:solidFill>
@@ -2327,7 +2711,7 @@
                 <a:ea typeface="Arial"/>
                 <a:cs typeface="Arial"/>
               </a:rPr>
-              <a:t>Get the demo</a:t>
+              <a:t>Your own copy</a:t>
             </a:r>
           </a:p>
         </p:txBody>
@@ -2367,7 +2751,7 @@
           <a:p xmlns:a="http://schemas.openxmlformats.org/drawingml/2006/main">
             <a:pPr algn="l">
               <a:buNone/>
-              <a:defRPr sz="1800" b="0">
+              <a:defRPr sz="1725" b="0">
                 <a:solidFill>
                   <a:srgbClr val="53686C"/>
                 </a:solidFill>
@@ -2377,7 +2761,7 @@
               </a:defRPr>
             </a:pPr>
             <a:r>
-              <a:rPr sz="1800" b="0">
+              <a:rPr sz="1725" b="0">
                 <a:solidFill>
                   <a:srgbClr val="53686C"/>
                 </a:solidFill>
@@ -2483,7 +2867,7 @@
           <a:p xmlns:a="http://schemas.openxmlformats.org/drawingml/2006/main">
             <a:pPr algn="l">
               <a:buNone/>
-              <a:defRPr sz="1950" b="1">
+              <a:defRPr sz="1875" b="1">
                 <a:solidFill>
                   <a:srgbClr val="142D32"/>
                 </a:solidFill>
@@ -2493,7 +2877,7 @@
               </a:defRPr>
             </a:pPr>
             <a:r>
-              <a:rPr sz="1950" b="1">
+              <a:rPr sz="1875" b="1">
                 <a:solidFill>
                   <a:srgbClr val="142D32"/>
                 </a:solidFill>
@@ -2501,7 +2885,7 @@
                 <a:ea typeface="Arial"/>
                 <a:cs typeface="Arial"/>
               </a:rPr>
-              <a:t>Existing website</a:t>
+              <a:t>Open settings</a:t>
             </a:r>
           </a:p>
         </p:txBody>
@@ -2541,7 +2925,7 @@
           <a:p xmlns:a="http://schemas.openxmlformats.org/drawingml/2006/main">
             <a:pPr algn="l">
               <a:buNone/>
-              <a:defRPr sz="1800" b="0">
+              <a:defRPr sz="1725" b="0">
                 <a:solidFill>
                   <a:srgbClr val="53686C"/>
                 </a:solidFill>
@@ -2551,7 +2935,7 @@
               </a:defRPr>
             </a:pPr>
             <a:r>
-              <a:rPr sz="1800" b="0">
+              <a:rPr sz="1725" b="0">
                 <a:solidFill>
                   <a:srgbClr val="53686C"/>
                 </a:solidFill>
@@ -2559,7 +2943,7 @@
                 <a:ea typeface="Arial"/>
                 <a:cs typeface="Arial"/>
               </a:rPr>
-              <a:t>Copy ai-would-you-rather/ and .github/workflows/</a:t>
+              <a:t>Settings → Pages → Deploy from a branch</a:t>
             </a:r>
           </a:p>
         </p:txBody>
@@ -2657,7 +3041,7 @@
           <a:p xmlns:a="http://schemas.openxmlformats.org/drawingml/2006/main">
             <a:pPr algn="l">
               <a:buNone/>
-              <a:defRPr sz="1950" b="1">
+              <a:defRPr sz="1875" b="1">
                 <a:solidFill>
                   <a:srgbClr val="142D32"/>
                 </a:solidFill>
@@ -2667,7 +3051,7 @@
               </a:defRPr>
             </a:pPr>
             <a:r>
-              <a:rPr sz="1950" b="1">
+              <a:rPr sz="1875" b="1">
                 <a:solidFill>
                   <a:srgbClr val="142D32"/>
                 </a:solidFill>
@@ -2675,7 +3059,7 @@
                 <a:ea typeface="Arial"/>
                 <a:cs typeface="Arial"/>
               </a:rPr>
-              <a:t>Enable Pages</a:t>
+              <a:t>Choose the source</a:t>
             </a:r>
           </a:p>
         </p:txBody>
@@ -2715,7 +3099,7 @@
           <a:p xmlns:a="http://schemas.openxmlformats.org/drawingml/2006/main">
             <a:pPr algn="l">
               <a:buNone/>
-              <a:defRPr sz="1800" b="0">
+              <a:defRPr sz="1725" b="0">
                 <a:solidFill>
                   <a:srgbClr val="53686C"/>
                 </a:solidFill>
@@ -2725,7 +3109,7 @@
               </a:defRPr>
             </a:pPr>
             <a:r>
-              <a:rPr sz="1800" b="0">
+              <a:rPr sz="1725" b="0">
                 <a:solidFill>
                   <a:srgbClr val="53686C"/>
                 </a:solidFill>
@@ -2733,7 +3117,7 @@
                 <a:ea typeface="Arial"/>
                 <a:cs typeface="Arial"/>
               </a:rPr>
-              <a:t>Settings → Pages → Deploy from a branch</a:t>
+              <a:t>main → /(root) → Save</a:t>
             </a:r>
           </a:p>
         </p:txBody>
@@ -2831,7 +3215,7 @@
           <a:p xmlns:a="http://schemas.openxmlformats.org/drawingml/2006/main">
             <a:pPr algn="l">
               <a:buNone/>
-              <a:defRPr sz="1950" b="1">
+              <a:defRPr sz="1875" b="1">
                 <a:solidFill>
                   <a:srgbClr val="142D32"/>
                 </a:solidFill>
@@ -2841,7 +3225,7 @@
               </a:defRPr>
             </a:pPr>
             <a:r>
-              <a:rPr sz="1950" b="1">
+              <a:rPr sz="1875" b="1">
                 <a:solidFill>
                   <a:srgbClr val="142D32"/>
                 </a:solidFill>
@@ -2849,7 +3233,7 @@
                 <a:ea typeface="Arial"/>
                 <a:cs typeface="Arial"/>
               </a:rPr>
-              <a:t>Publish</a:t>
+              <a:t>Visit your site</a:t>
             </a:r>
           </a:p>
         </p:txBody>
@@ -2889,7 +3273,7 @@
           <a:p xmlns:a="http://schemas.openxmlformats.org/drawingml/2006/main">
             <a:pPr algn="l">
               <a:buNone/>
-              <a:defRPr sz="1800" b="0">
+              <a:defRPr sz="1725" b="0">
                 <a:solidFill>
                   <a:srgbClr val="53686C"/>
                 </a:solidFill>
@@ -2899,7 +3283,7 @@
               </a:defRPr>
             </a:pPr>
             <a:r>
-              <a:rPr sz="1800" b="0">
+              <a:rPr sz="1725" b="0">
                 <a:solidFill>
                   <a:srgbClr val="53686C"/>
                 </a:solidFill>
@@ -2907,7 +3291,7 @@
                 <a:ea typeface="Arial"/>
                 <a:cs typeface="Arial"/>
               </a:rPr>
-              <a:t>main → /(root) → Save → wait → Visit site</a:t>
+              <a:t>Wait for publication → Visit site → Say hello</a:t>
             </a:r>
           </a:p>
         </p:txBody>
@@ -2994,7 +3378,7 @@
                 <a:ea typeface="Arial"/>
                 <a:cs typeface="Arial"/>
               </a:rPr>
-              <a:t>AI CLUB</a:t>
+              <a:t>UConn AI Club</a:t>
             </a:r>
           </a:p>
         </p:txBody>
@@ -3034,7 +3418,7 @@
           <a:p xmlns:a="http://schemas.openxmlformats.org/drawingml/2006/main">
             <a:pPr algn="l">
               <a:buNone/>
-              <a:defRPr sz="3600" b="1">
+              <a:defRPr sz="3450" b="1">
                 <a:solidFill>
                   <a:srgbClr val="142D32"/>
                 </a:solidFill>
@@ -3044,7 +3428,7 @@
               </a:defRPr>
             </a:pPr>
             <a:r>
-              <a:rPr sz="3600" b="1">
+              <a:rPr sz="3450" b="1">
                 <a:solidFill>
                   <a:srgbClr val="142D32"/>
                 </a:solidFill>
@@ -3052,7 +3436,7 @@
                 <a:ea typeface="Arial"/>
                 <a:cs typeface="Arial"/>
               </a:rPr>
-              <a:t>Create accounts and save the keys</a:t>
+              <a:t>Change the original page</a:t>
             </a:r>
           </a:p>
         </p:txBody>
@@ -3110,7 +3494,7 @@
                 <a:ea typeface="Arial"/>
                 <a:cs typeface="Arial"/>
               </a:rPr>
-              <a:t>GitHub → Settings → Secrets and variables → Actions</a:t>
+              <a:t>Keep the HTML tags. Change the text between them.</a:t>
             </a:r>
           </a:p>
         </p:txBody>
@@ -3150,7 +3534,7 @@
           <a:p xmlns:a="http://schemas.openxmlformats.org/drawingml/2006/main">
             <a:pPr algn="r">
               <a:buNone/>
-              <a:defRPr sz="1350" b="0">
+              <a:defRPr sz="1200" b="0">
                 <a:solidFill>
                   <a:srgbClr val="53686C"/>
                 </a:solidFill>
@@ -3160,7 +3544,7 @@
               </a:defRPr>
             </a:pPr>
             <a:r>
-              <a:rPr sz="1350" b="0">
+              <a:rPr sz="1200" b="0">
                 <a:solidFill>
                   <a:srgbClr val="53686C"/>
                 </a:solidFill>
@@ -3266,7 +3650,7 @@
           <a:p xmlns:a="http://schemas.openxmlformats.org/drawingml/2006/main">
             <a:pPr algn="l">
               <a:buNone/>
-              <a:defRPr sz="1950" b="1">
+              <a:defRPr sz="1875" b="1">
                 <a:solidFill>
                   <a:srgbClr val="142D32"/>
                 </a:solidFill>
@@ -3276,7 +3660,7 @@
               </a:defRPr>
             </a:pPr>
             <a:r>
-              <a:rPr sz="1950" b="1">
+              <a:rPr sz="1875" b="1">
                 <a:solidFill>
                   <a:srgbClr val="142D32"/>
                 </a:solidFill>
@@ -3284,7 +3668,7 @@
                 <a:ea typeface="Arial"/>
                 <a:cs typeface="Arial"/>
               </a:rPr>
-              <a:t>OpenRouter</a:t>
+              <a:t>Open the file</a:t>
             </a:r>
           </a:p>
         </p:txBody>
@@ -3324,7 +3708,7 @@
           <a:p xmlns:a="http://schemas.openxmlformats.org/drawingml/2006/main">
             <a:pPr algn="l">
               <a:buNone/>
-              <a:defRPr sz="1800" b="0">
+              <a:defRPr sz="1725" b="0">
                 <a:solidFill>
                   <a:srgbClr val="53686C"/>
                 </a:solidFill>
@@ -3334,7 +3718,7 @@
               </a:defRPr>
             </a:pPr>
             <a:r>
-              <a:rPr sz="1800" b="0">
+              <a:rPr sz="1725" b="0">
                 <a:solidFill>
                   <a:srgbClr val="53686C"/>
                 </a:solidFill>
@@ -3342,7 +3726,7 @@
                 <a:ea typeface="Arial"/>
                 <a:cs typeface="Arial"/>
               </a:rPr>
-              <a:t>Sign up → settings/keys → Create Key</a:t>
+              <a:t>In your repository, click index.html</a:t>
             </a:r>
           </a:p>
         </p:txBody>
@@ -3440,7 +3824,7 @@
           <a:p xmlns:a="http://schemas.openxmlformats.org/drawingml/2006/main">
             <a:pPr algn="l">
               <a:buNone/>
-              <a:defRPr sz="1950" b="1">
+              <a:defRPr sz="1875" b="1">
                 <a:solidFill>
                   <a:srgbClr val="142D32"/>
                 </a:solidFill>
@@ -3450,7 +3834,7 @@
               </a:defRPr>
             </a:pPr>
             <a:r>
-              <a:rPr sz="1950" b="1">
+              <a:rPr sz="1875" b="1">
                 <a:solidFill>
                   <a:srgbClr val="142D32"/>
                 </a:solidFill>
@@ -3458,7 +3842,7 @@
                 <a:ea typeface="Arial"/>
                 <a:cs typeface="Arial"/>
               </a:rPr>
-              <a:t>Save its key</a:t>
+              <a:t>Edit the heading</a:t>
             </a:r>
           </a:p>
         </p:txBody>
@@ -3498,7 +3882,7 @@
           <a:p xmlns:a="http://schemas.openxmlformats.org/drawingml/2006/main">
             <a:pPr algn="l">
               <a:buNone/>
-              <a:defRPr sz="1800" b="0">
+              <a:defRPr sz="1725" b="0">
                 <a:solidFill>
                   <a:srgbClr val="53686C"/>
                 </a:solidFill>
@@ -3508,7 +3892,7 @@
               </a:defRPr>
             </a:pPr>
             <a:r>
-              <a:rPr sz="1800" b="0">
+              <a:rPr sz="1725" b="0">
                 <a:solidFill>
                   <a:srgbClr val="53686C"/>
                 </a:solidFill>
@@ -3516,7 +3900,7 @@
                 <a:ea typeface="Arial"/>
                 <a:cs typeface="Arial"/>
               </a:rPr>
-              <a:t>New repository secret: OPENROUTER_API_KEY</a:t>
+              <a:t>Click the pencil → find Hello, world.</a:t>
             </a:r>
           </a:p>
         </p:txBody>
@@ -3614,7 +3998,7 @@
           <a:p xmlns:a="http://schemas.openxmlformats.org/drawingml/2006/main">
             <a:pPr algn="l">
               <a:buNone/>
-              <a:defRPr sz="1950" b="1">
+              <a:defRPr sz="1875" b="1">
                 <a:solidFill>
                   <a:srgbClr val="142D32"/>
                 </a:solidFill>
@@ -3624,7 +4008,7 @@
               </a:defRPr>
             </a:pPr>
             <a:r>
-              <a:rPr sz="1950" b="1">
+              <a:rPr sz="1875" b="1">
                 <a:solidFill>
                   <a:srgbClr val="142D32"/>
                 </a:solidFill>
@@ -3632,7 +4016,7 @@
                 <a:ea typeface="Arial"/>
                 <a:cs typeface="Arial"/>
               </a:rPr>
-              <a:t>Cloudflare</a:t>
+              <a:t>Save your change</a:t>
             </a:r>
           </a:p>
         </p:txBody>
@@ -3672,7 +4056,7 @@
           <a:p xmlns:a="http://schemas.openxmlformats.org/drawingml/2006/main">
             <a:pPr algn="l">
               <a:buNone/>
-              <a:defRPr sz="1800" b="0">
+              <a:defRPr sz="1725" b="0">
                 <a:solidFill>
                   <a:srgbClr val="53686C"/>
                 </a:solidFill>
@@ -3682,7 +4066,7 @@
               </a:defRPr>
             </a:pPr>
             <a:r>
-              <a:rPr sz="1800" b="0">
+              <a:rPr sz="1725" b="0">
                 <a:solidFill>
                   <a:srgbClr val="53686C"/>
                 </a:solidFill>
@@ -3690,7 +4074,7 @@
                 <a:ea typeface="Arial"/>
                 <a:cs typeface="Arial"/>
               </a:rPr>
-              <a:t>Profile → API Tokens → Edit Cloudflare Workers</a:t>
+              <a:t>Write your own heading → Commit changes</a:t>
             </a:r>
           </a:p>
         </p:txBody>
@@ -3788,7 +4172,7 @@
           <a:p xmlns:a="http://schemas.openxmlformats.org/drawingml/2006/main">
             <a:pPr algn="l">
               <a:buNone/>
-              <a:defRPr sz="1950" b="1">
+              <a:defRPr sz="1875" b="1">
                 <a:solidFill>
                   <a:srgbClr val="142D32"/>
                 </a:solidFill>
@@ -3798,7 +4182,7 @@
               </a:defRPr>
             </a:pPr>
             <a:r>
-              <a:rPr sz="1950" b="1">
+              <a:rPr sz="1875" b="1">
                 <a:solidFill>
                   <a:srgbClr val="142D32"/>
                 </a:solidFill>
@@ -3806,7 +4190,7 @@
                 <a:ea typeface="Arial"/>
                 <a:cs typeface="Arial"/>
               </a:rPr>
-              <a:t>Save two more</a:t>
+              <a:t>Check your website</a:t>
             </a:r>
           </a:p>
         </p:txBody>
@@ -3846,7 +4230,7 @@
           <a:p xmlns:a="http://schemas.openxmlformats.org/drawingml/2006/main">
             <a:pPr algn="l">
               <a:buNone/>
-              <a:defRPr sz="1800" b="0">
+              <a:defRPr sz="1725" b="0">
                 <a:solidFill>
                   <a:srgbClr val="53686C"/>
                 </a:solidFill>
@@ -3856,7 +4240,7 @@
               </a:defRPr>
             </a:pPr>
             <a:r>
-              <a:rPr sz="1800" b="0">
+              <a:rPr sz="1725" b="0">
                 <a:solidFill>
                   <a:srgbClr val="53686C"/>
                 </a:solidFill>
@@ -3864,7 +4248,7 @@
                 <a:ea typeface="Arial"/>
                 <a:cs typeface="Arial"/>
               </a:rPr>
-              <a:t>CLOUDFLARE_API_TOKEN + CLOUDFLARE_ACCOUNT_ID</a:t>
+              <a:t>Wait for Pages → refresh → test Say hello</a:t>
             </a:r>
           </a:p>
         </p:txBody>
@@ -3951,7 +4335,7 @@
                 <a:ea typeface="Arial"/>
                 <a:cs typeface="Arial"/>
               </a:rPr>
-              <a:t>AI CLUB</a:t>
+              <a:t>UConn AI Club</a:t>
             </a:r>
           </a:p>
         </p:txBody>
@@ -3991,7 +4375,7 @@
           <a:p xmlns:a="http://schemas.openxmlformats.org/drawingml/2006/main">
             <a:pPr algn="l">
               <a:buNone/>
-              <a:defRPr sz="3600" b="1">
+              <a:defRPr sz="3450" b="1">
                 <a:solidFill>
                   <a:srgbClr val="142D32"/>
                 </a:solidFill>
@@ -4001,7 +4385,7 @@
               </a:defRPr>
             </a:pPr>
             <a:r>
-              <a:rPr sz="3600" b="1">
+              <a:rPr sz="3450" b="1">
                 <a:solidFill>
                   <a:srgbClr val="142D32"/>
                 </a:solidFill>
@@ -4009,7 +4393,7 @@
                 <a:ea typeface="Arial"/>
                 <a:cs typeface="Arial"/>
               </a:rPr>
-              <a:t>Deploy the private API</a:t>
+              <a:t>Make your own game questions</a:t>
             </a:r>
           </a:p>
         </p:txBody>
@@ -4067,7 +4451,7 @@
                 <a:ea typeface="Arial"/>
                 <a:cs typeface="Arial"/>
               </a:rPr>
-              <a:t>Open each file on GitHub → pencil → edit → Commit changes</a:t>
+              <a:t>Open game/index.html → pencil → find const questions</a:t>
             </a:r>
           </a:p>
         </p:txBody>
@@ -4107,7 +4491,7 @@
           <a:p xmlns:a="http://schemas.openxmlformats.org/drawingml/2006/main">
             <a:pPr algn="r">
               <a:buNone/>
-              <a:defRPr sz="1350" b="0">
+              <a:defRPr sz="1200" b="0">
                 <a:solidFill>
                   <a:srgbClr val="53686C"/>
                 </a:solidFill>
@@ -4117,7 +4501,7 @@
               </a:defRPr>
             </a:pPr>
             <a:r>
-              <a:rPr sz="1350" b="0">
+              <a:rPr sz="1200" b="0">
                 <a:solidFill>
                   <a:srgbClr val="53686C"/>
                 </a:solidFill>
@@ -4223,7 +4607,7 @@
           <a:p xmlns:a="http://schemas.openxmlformats.org/drawingml/2006/main">
             <a:pPr algn="l">
               <a:buNone/>
-              <a:defRPr sz="1950" b="1">
+              <a:defRPr sz="1875" b="1">
                 <a:solidFill>
                   <a:srgbClr val="142D32"/>
                 </a:solidFill>
@@ -4233,7 +4617,7 @@
               </a:defRPr>
             </a:pPr>
             <a:r>
-              <a:rPr sz="1950" b="1">
+              <a:rPr sz="1875" b="1">
                 <a:solidFill>
                   <a:srgbClr val="142D32"/>
                 </a:solidFill>
@@ -4241,7 +4625,7 @@
                 <a:ea typeface="Arial"/>
                 <a:cs typeface="Arial"/>
               </a:rPr>
-              <a:t>Allow your site</a:t>
+              <a:t>Choose a theme</a:t>
             </a:r>
           </a:p>
         </p:txBody>
@@ -4281,7 +4665,7 @@
           <a:p xmlns:a="http://schemas.openxmlformats.org/drawingml/2006/main">
             <a:pPr algn="l">
               <a:buNone/>
-              <a:defRPr sz="1800" b="0">
+              <a:defRPr sz="1725" b="0">
                 <a:solidFill>
                   <a:srgbClr val="53686C"/>
                 </a:solidFill>
@@ -4291,7 +4675,7 @@
               </a:defRPr>
             </a:pPr>
             <a:r>
-              <a:rPr sz="1800" b="0">
+              <a:rPr sz="1725" b="0">
                 <a:solidFill>
                   <a:srgbClr val="53686C"/>
                 </a:solidFill>
@@ -4299,7 +4683,7 @@
                 <a:ea typeface="Arial"/>
                 <a:cs typeface="Arial"/>
               </a:rPr>
-              <a:t>api/wrangler.jsonc → change ALLOWED_ORIGIN</a:t>
+              <a:t>Look for powers, campus, or food</a:t>
             </a:r>
           </a:p>
         </p:txBody>
@@ -4397,7 +4781,7 @@
           <a:p xmlns:a="http://schemas.openxmlformats.org/drawingml/2006/main">
             <a:pPr algn="l">
               <a:buNone/>
-              <a:defRPr sz="1950" b="1">
+              <a:defRPr sz="1875" b="1">
                 <a:solidFill>
                   <a:srgbClr val="142D32"/>
                 </a:solidFill>
@@ -4407,7 +4791,7 @@
               </a:defRPr>
             </a:pPr>
             <a:r>
-              <a:rPr sz="1950" b="1">
+              <a:rPr sz="1875" b="1">
                 <a:solidFill>
                   <a:srgbClr val="142D32"/>
                 </a:solidFill>
@@ -4415,7 +4799,7 @@
                 <a:ea typeface="Arial"/>
                 <a:cs typeface="Arial"/>
               </a:rPr>
-              <a:t>Use its hostname</a:t>
+              <a:t>Write two choices</a:t>
             </a:r>
           </a:p>
         </p:txBody>
@@ -4455,7 +4839,7 @@
           <a:p xmlns:a="http://schemas.openxmlformats.org/drawingml/2006/main">
             <a:pPr algn="l">
               <a:buNone/>
-              <a:defRPr sz="1800" b="0">
+              <a:defRPr sz="1725" b="0">
                 <a:solidFill>
                   <a:srgbClr val="53686C"/>
                 </a:solidFill>
@@ -4465,7 +4849,7 @@
               </a:defRPr>
             </a:pPr>
             <a:r>
-              <a:rPr sz="1800" b="0">
+              <a:rPr sz="1725" b="0">
                 <a:solidFill>
                   <a:srgbClr val="53686C"/>
                 </a:solidFill>
@@ -4473,7 +4857,7 @@
                 <a:ea typeface="Arial"/>
                 <a:cs typeface="Arial"/>
               </a:rPr>
-              <a:t>https://YOUR-USERNAME.github.io — no path</a:t>
+              <a:t>Replace one pair of questions with your own</a:t>
             </a:r>
           </a:p>
         </p:txBody>
@@ -4571,7 +4955,7 @@
           <a:p xmlns:a="http://schemas.openxmlformats.org/drawingml/2006/main">
             <a:pPr algn="l">
               <a:buNone/>
-              <a:defRPr sz="1950" b="1">
+              <a:defRPr sz="1875" b="1">
                 <a:solidFill>
                   <a:srgbClr val="142D32"/>
                 </a:solidFill>
@@ -4581,7 +4965,7 @@
               </a:defRPr>
             </a:pPr>
             <a:r>
-              <a:rPr sz="1950" b="1">
+              <a:rPr sz="1875" b="1">
                 <a:solidFill>
                   <a:srgbClr val="142D32"/>
                 </a:solidFill>
@@ -4589,7 +4973,7 @@
                 <a:ea typeface="Arial"/>
                 <a:cs typeface="Arial"/>
               </a:rPr>
-              <a:t>Run deployment</a:t>
+              <a:t>Keep the structure</a:t>
             </a:r>
           </a:p>
         </p:txBody>
@@ -4629,7 +5013,7 @@
           <a:p xmlns:a="http://schemas.openxmlformats.org/drawingml/2006/main">
             <a:pPr algn="l">
               <a:buNone/>
-              <a:defRPr sz="1800" b="0">
+              <a:defRPr sz="1725" b="0">
                 <a:solidFill>
                   <a:srgbClr val="53686C"/>
                 </a:solidFill>
@@ -4639,7 +5023,7 @@
               </a:defRPr>
             </a:pPr>
             <a:r>
-              <a:rPr sz="1800" b="0">
+              <a:rPr sz="1725" b="0">
                 <a:solidFill>
                   <a:srgbClr val="53686C"/>
                 </a:solidFill>
@@ -4647,7 +5031,7 @@
                 <a:ea typeface="Arial"/>
                 <a:cs typeface="Arial"/>
               </a:rPr>
-              <a:t>Actions → Deploy AI bot → Run workflow</a:t>
+              <a:t>Keep the quotation marks, commas, and brackets</a:t>
             </a:r>
           </a:p>
         </p:txBody>
@@ -4745,7 +5129,7 @@
           <a:p xmlns:a="http://schemas.openxmlformats.org/drawingml/2006/main">
             <a:pPr algn="l">
               <a:buNone/>
-              <a:defRPr sz="1950" b="1">
+              <a:defRPr sz="1875" b="1">
                 <a:solidFill>
                   <a:srgbClr val="142D32"/>
                 </a:solidFill>
@@ -4755,7 +5139,7 @@
               </a:defRPr>
             </a:pPr>
             <a:r>
-              <a:rPr sz="1950" b="1">
+              <a:rPr sz="1875" b="1">
                 <a:solidFill>
                   <a:srgbClr val="142D32"/>
                 </a:solidFill>
@@ -4763,7 +5147,7 @@
                 <a:ea typeface="Arial"/>
                 <a:cs typeface="Arial"/>
               </a:rPr>
-              <a:t>Copy the API URL</a:t>
+              <a:t>Publish and play</a:t>
             </a:r>
           </a:p>
         </p:txBody>
@@ -4803,7 +5187,7 @@
           <a:p xmlns:a="http://schemas.openxmlformats.org/drawingml/2006/main">
             <a:pPr algn="l">
               <a:buNone/>
-              <a:defRPr sz="1800" b="0">
+              <a:defRPr sz="1725" b="0">
                 <a:solidFill>
                   <a:srgbClr val="53686C"/>
                 </a:solidFill>
@@ -4813,7 +5197,7 @@
               </a:defRPr>
             </a:pPr>
             <a:r>
-              <a:rPr sz="1800" b="0">
+              <a:rPr sz="1725" b="0">
                 <a:solidFill>
                   <a:srgbClr val="53686C"/>
                 </a:solidFill>
@@ -4821,7 +5205,7 @@
                 <a:ea typeface="Arial"/>
                 <a:cs typeface="Arial"/>
               </a:rPr>
-              <a:t>Cloudflare → ai-club-game → workers.dev URL</a:t>
+              <a:t>Commit → wait → open game → choose A or B</a:t>
             </a:r>
           </a:p>
         </p:txBody>
@@ -4908,7 +5292,7 @@
                 <a:ea typeface="Arial"/>
                 <a:cs typeface="Arial"/>
               </a:rPr>
-              <a:t>AI CLUB</a:t>
+              <a:t>UConn AI Club</a:t>
             </a:r>
           </a:p>
         </p:txBody>
@@ -4948,7 +5332,7 @@
           <a:p xmlns:a="http://schemas.openxmlformats.org/drawingml/2006/main">
             <a:pPr algn="l">
               <a:buNone/>
-              <a:defRPr sz="3600" b="1">
+              <a:defRPr sz="3450" b="1">
                 <a:solidFill>
                   <a:srgbClr val="142D32"/>
                 </a:solidFill>
@@ -4958,7 +5342,7 @@
               </a:defRPr>
             </a:pPr>
             <a:r>
-              <a:rPr sz="3600" b="1">
+              <a:rPr sz="3450" b="1">
                 <a:solidFill>
                   <a:srgbClr val="142D32"/>
                 </a:solidFill>
@@ -4966,7 +5350,7 @@
                 <a:ea typeface="Arial"/>
                 <a:cs typeface="Arial"/>
               </a:rPr>
-              <a:t>Connect the page and play</a:t>
+              <a:t>Add another page to the website</a:t>
             </a:r>
           </a:p>
         </p:txBody>
@@ -5024,7 +5408,7 @@
                 <a:ea typeface="Arial"/>
                 <a:cs typeface="Arial"/>
               </a:rPr>
-              <a:t>In ai-would-you-rather/index.html, find const API_URL</a:t>
+              <a:t>A folder with index.html gives you a new static route.</a:t>
             </a:r>
           </a:p>
         </p:txBody>
@@ -5064,7 +5448,7 @@
           <a:p xmlns:a="http://schemas.openxmlformats.org/drawingml/2006/main">
             <a:pPr algn="r">
               <a:buNone/>
-              <a:defRPr sz="1350" b="0">
+              <a:defRPr sz="1200" b="0">
                 <a:solidFill>
                   <a:srgbClr val="53686C"/>
                 </a:solidFill>
@@ -5074,7 +5458,7 @@
               </a:defRPr>
             </a:pPr>
             <a:r>
-              <a:rPr sz="1350" b="0">
+              <a:rPr sz="1200" b="0">
                 <a:solidFill>
                   <a:srgbClr val="53686C"/>
                 </a:solidFill>
@@ -5180,7 +5564,7 @@
           <a:p xmlns:a="http://schemas.openxmlformats.org/drawingml/2006/main">
             <a:pPr algn="l">
               <a:buNone/>
-              <a:defRPr sz="1950" b="1">
+              <a:defRPr sz="1875" b="1">
                 <a:solidFill>
                   <a:srgbClr val="142D32"/>
                 </a:solidFill>
@@ -5190,7 +5574,7 @@
               </a:defRPr>
             </a:pPr>
             <a:r>
-              <a:rPr sz="1950" b="1">
+              <a:rPr sz="1875" b="1">
                 <a:solidFill>
                   <a:srgbClr val="142D32"/>
                 </a:solidFill>
@@ -5198,7 +5582,7 @@
                 <a:ea typeface="Arial"/>
                 <a:cs typeface="Arial"/>
               </a:rPr>
-              <a:t>Paste the URL</a:t>
+              <a:t>Create a file</a:t>
             </a:r>
           </a:p>
         </p:txBody>
@@ -5238,7 +5622,7 @@
           <a:p xmlns:a="http://schemas.openxmlformats.org/drawingml/2006/main">
             <a:pPr algn="l">
               <a:buNone/>
-              <a:defRPr sz="1800" b="0">
+              <a:defRPr sz="1725" b="0">
                 <a:solidFill>
                   <a:srgbClr val="53686C"/>
                 </a:solidFill>
@@ -5248,7 +5632,7 @@
               </a:defRPr>
             </a:pPr>
             <a:r>
-              <a:rPr sz="1800" b="0">
+              <a:rPr sz="1725" b="0">
                 <a:solidFill>
                   <a:srgbClr val="53686C"/>
                 </a:solidFill>
@@ -5256,7 +5640,7 @@
                 <a:ea typeface="Arial"/>
                 <a:cs typeface="Arial"/>
               </a:rPr>
-              <a:t>Your workers.dev URL + /api/chat</a:t>
+              <a:t>Add file → Create new file → my-page/index.html</a:t>
             </a:r>
           </a:p>
         </p:txBody>
@@ -5354,7 +5738,7 @@
           <a:p xmlns:a="http://schemas.openxmlformats.org/drawingml/2006/main">
             <a:pPr algn="l">
               <a:buNone/>
-              <a:defRPr sz="1950" b="1">
+              <a:defRPr sz="1875" b="1">
                 <a:solidFill>
                   <a:srgbClr val="142D32"/>
                 </a:solidFill>
@@ -5364,7 +5748,7 @@
               </a:defRPr>
             </a:pPr>
             <a:r>
-              <a:rPr sz="1950" b="1">
+              <a:rPr sz="1875" b="1">
                 <a:solidFill>
                   <a:srgbClr val="142D32"/>
                 </a:solidFill>
@@ -5372,7 +5756,7 @@
                 <a:ea typeface="Arial"/>
                 <a:cs typeface="Arial"/>
               </a:rPr>
-              <a:t>Publish the edit</a:t>
+              <a:t>Add your content</a:t>
             </a:r>
           </a:p>
         </p:txBody>
@@ -5412,7 +5796,7 @@
           <a:p xmlns:a="http://schemas.openxmlformats.org/drawingml/2006/main">
             <a:pPr algn="l">
               <a:buNone/>
-              <a:defRPr sz="1800" b="0">
+              <a:defRPr sz="1725" b="0">
                 <a:solidFill>
                   <a:srgbClr val="53686C"/>
                 </a:solidFill>
@@ -5422,7 +5806,7 @@
               </a:defRPr>
             </a:pPr>
             <a:r>
-              <a:rPr sz="1800" b="0">
+              <a:rPr sz="1725" b="0">
                 <a:solidFill>
                   <a:srgbClr val="53686C"/>
                 </a:solidFill>
@@ -5430,7 +5814,7 @@
                 <a:ea typeface="Arial"/>
                 <a:cs typeface="Arial"/>
               </a:rPr>
-              <a:t>Commit changes → wait for Pages → refresh</a:t>
+              <a:t>Copy the original HTML → change heading → Commit</a:t>
             </a:r>
           </a:p>
         </p:txBody>
@@ -5528,7 +5912,7 @@
           <a:p xmlns:a="http://schemas.openxmlformats.org/drawingml/2006/main">
             <a:pPr algn="l">
               <a:buNone/>
-              <a:defRPr sz="1950" b="1">
+              <a:defRPr sz="1875" b="1">
                 <a:solidFill>
                   <a:srgbClr val="142D32"/>
                 </a:solidFill>
@@ -5538,7 +5922,7 @@
               </a:defRPr>
             </a:pPr>
             <a:r>
-              <a:rPr sz="1950" b="1">
+              <a:rPr sz="1875" b="1">
                 <a:solidFill>
                   <a:srgbClr val="142D32"/>
                 </a:solidFill>
@@ -5546,7 +5930,7 @@
                 <a:ea typeface="Arial"/>
                 <a:cs typeface="Arial"/>
               </a:rPr>
-              <a:t>Try your bot</a:t>
+              <a:t>Link from home</a:t>
             </a:r>
           </a:p>
         </p:txBody>
@@ -5586,7 +5970,7 @@
           <a:p xmlns:a="http://schemas.openxmlformats.org/drawingml/2006/main">
             <a:pPr algn="l">
               <a:buNone/>
-              <a:defRPr sz="1800" b="0">
+              <a:defRPr sz="1725" b="0">
                 <a:solidFill>
                   <a:srgbClr val="53686C"/>
                 </a:solidFill>
@@ -5596,7 +5980,7 @@
               </a:defRPr>
             </a:pPr>
             <a:r>
-              <a:rPr sz="1800" b="0">
+              <a:rPr sz="1725" b="0">
                 <a:solidFill>
                   <a:srgbClr val="53686C"/>
                 </a:solidFill>
@@ -5604,7 +5988,7 @@
                 <a:ea typeface="Arial"/>
                 <a:cs typeface="Arial"/>
               </a:rPr>
-              <a:t>Give me a dilemma → type superpowers → Send</a:t>
+              <a:t>In root index.html: &lt;a href="my-page/"&gt;My page&lt;/a&gt;</a:t>
             </a:r>
           </a:p>
         </p:txBody>
@@ -5702,7 +6086,7 @@
           <a:p xmlns:a="http://schemas.openxmlformats.org/drawingml/2006/main">
             <a:pPr algn="l">
               <a:buNone/>
-              <a:defRPr sz="1950" b="1">
+              <a:defRPr sz="1875" b="1">
                 <a:solidFill>
                   <a:srgbClr val="142D32"/>
                 </a:solidFill>
@@ -5712,7 +6096,7 @@
               </a:defRPr>
             </a:pPr>
             <a:r>
-              <a:rPr sz="1950" b="1">
+              <a:rPr sz="1875" b="1">
                 <a:solidFill>
                   <a:srgbClr val="142D32"/>
                 </a:solidFill>
@@ -5720,7 +6104,7 @@
                 <a:ea typeface="Arial"/>
                 <a:cs typeface="Arial"/>
               </a:rPr>
-              <a:t>Try both layouts</a:t>
+              <a:t>Open your route</a:t>
             </a:r>
           </a:p>
         </p:txBody>
@@ -5760,7 +6144,7 @@
           <a:p xmlns:a="http://schemas.openxmlformats.org/drawingml/2006/main">
             <a:pPr algn="l">
               <a:buNone/>
-              <a:defRPr sz="1800" b="0">
+              <a:defRPr sz="1725" b="0">
                 <a:solidFill>
                   <a:srgbClr val="53686C"/>
                 </a:solidFill>
@@ -5770,7 +6154,7 @@
               </a:defRPr>
             </a:pPr>
             <a:r>
-              <a:rPr sz="1800" b="0">
+              <a:rPr sz="1725" b="0">
                 <a:solidFill>
                   <a:srgbClr val="53686C"/>
                 </a:solidFill>
@@ -5778,7 +6162,7 @@
                 <a:ea typeface="Arial"/>
                 <a:cs typeface="Arial"/>
               </a:rPr>
-              <a:t>Floating button or the Full-page game link</a:t>
+              <a:t>Visit YOUR-SITE-BASE/my-page/</a:t>
             </a:r>
           </a:p>
         </p:txBody>
@@ -5814,10 +6198,10 @@
       </p:grpSpPr>
       <p:sp>
         <p:nvSpPr>
-          <p:cNvPr id="15" name="club">
-            <a:extLst xmlns:a="http://schemas.openxmlformats.org/drawingml/2006/main">
-              <a:ext uri="{FF2B5EF4-FFF2-40B4-BE49-F238E27FC236}">
-                <a16:creationId xmlns:a16="http://schemas.microsoft.com/office/drawing/2014/main" id="{9E83BF3D-4E04-49A2-A99B-2303192D1937}"/>
+          <p:cNvPr id="21" name="club">
+            <a:extLst xmlns:a="http://schemas.openxmlformats.org/drawingml/2006/main">
+              <a:ext uri="{FF2B5EF4-FFF2-40B4-BE49-F238E27FC236}">
+                <a16:creationId xmlns:a16="http://schemas.microsoft.com/office/drawing/2014/main" id="{366D60CB-0E69-4059-85C5-9B5236F59499}"/>
               </a:ext>
             </a:extLst>
           </p:cNvPr>
@@ -5865,7 +6249,7 @@
                 <a:ea typeface="Arial"/>
                 <a:cs typeface="Arial"/>
               </a:rPr>
-              <a:t>AI CLUB</a:t>
+              <a:t>UConn AI Club</a:t>
             </a:r>
           </a:p>
         </p:txBody>
@@ -5875,7 +6259,7 @@
           <p:cNvPr id="3" name="title">
             <a:extLst xmlns:a="http://schemas.openxmlformats.org/drawingml/2006/main">
               <a:ext uri="{FF2B5EF4-FFF2-40B4-BE49-F238E27FC236}">
-                <a16:creationId xmlns:a16="http://schemas.microsoft.com/office/drawing/2014/main" id="{A66A34A4-4A81-42D5-B58A-9B73C21546DF}"/>
+                <a16:creationId xmlns:a16="http://schemas.microsoft.com/office/drawing/2014/main" id="{EF48F320-DD91-4BBA-B862-5084F2F45ADE}"/>
               </a:ext>
             </a:extLst>
           </p:cNvPr>
@@ -5905,7 +6289,7 @@
           <a:p xmlns:a="http://schemas.openxmlformats.org/drawingml/2006/main">
             <a:pPr algn="l">
               <a:buNone/>
-              <a:defRPr sz="3600" b="1">
+              <a:defRPr sz="3450" b="1">
                 <a:solidFill>
                   <a:srgbClr val="142D32"/>
                 </a:solidFill>
@@ -5915,7 +6299,7 @@
               </a:defRPr>
             </a:pPr>
             <a:r>
-              <a:rPr sz="3600" b="1">
+              <a:rPr sz="3450" b="1">
                 <a:solidFill>
                   <a:srgbClr val="142D32"/>
                 </a:solidFill>
@@ -5923,7 +6307,7 @@
                 <a:ea typeface="Arial"/>
                 <a:cs typeface="Arial"/>
               </a:rPr>
-              <a:t>Make the game yours</a:t>
+              <a:t>Explore further when you are ready</a:t>
             </a:r>
           </a:p>
         </p:txBody>
@@ -5933,7 +6317,7 @@
           <p:cNvPr id="4" name="subheader">
             <a:extLst xmlns:a="http://schemas.openxmlformats.org/drawingml/2006/main">
               <a:ext uri="{FF2B5EF4-FFF2-40B4-BE49-F238E27FC236}">
-                <a16:creationId xmlns:a16="http://schemas.microsoft.com/office/drawing/2014/main" id="{C1B0794C-E341-4380-9A7B-1FBF40F989AC}"/>
+                <a16:creationId xmlns:a16="http://schemas.microsoft.com/office/drawing/2014/main" id="{5D6446FB-4749-41AC-9A7B-5675002E5DC1}"/>
               </a:ext>
             </a:extLst>
           </p:cNvPr>
@@ -5981,7 +6365,7 @@
                 <a:ea typeface="Arial"/>
                 <a:cs typeface="Arial"/>
               </a:rPr>
-              <a:t>Change the title in index.html or INSTRUCTIONS in api/worker.mjs</a:t>
+              <a:t>The original page links to both the simple and advanced examples.</a:t>
             </a:r>
           </a:p>
         </p:txBody>
@@ -5991,7 +6375,7 @@
           <p:cNvPr id="8" name="footer-page">
             <a:extLst xmlns:a="http://schemas.openxmlformats.org/drawingml/2006/main">
               <a:ext uri="{FF2B5EF4-FFF2-40B4-BE49-F238E27FC236}">
-                <a16:creationId xmlns:a16="http://schemas.microsoft.com/office/drawing/2014/main" id="{28852A21-0BEF-4D32-B0EF-ED940BEFFFA1}"/>
+                <a16:creationId xmlns:a16="http://schemas.microsoft.com/office/drawing/2014/main" id="{C8408FA6-E463-4CDD-B6F5-5DA963C5DA59}"/>
               </a:ext>
             </a:extLst>
           </p:cNvPr>
@@ -6021,7 +6405,7 @@
           <a:p xmlns:a="http://schemas.openxmlformats.org/drawingml/2006/main">
             <a:pPr algn="r">
               <a:buNone/>
-              <a:defRPr sz="1350" b="0">
+              <a:defRPr sz="1200" b="0">
                 <a:solidFill>
                   <a:srgbClr val="53686C"/>
                 </a:solidFill>
@@ -6031,7 +6415,7 @@
               </a:defRPr>
             </a:pPr>
             <a:r>
-              <a:rPr sz="1350" b="0">
+              <a:rPr sz="1200" b="0">
                 <a:solidFill>
                   <a:srgbClr val="53686C"/>
                 </a:solidFill>
@@ -6046,40 +6430,156 @@
       </p:sp>
       <p:sp>
         <p:nvSpPr>
-          <p:cNvPr id="9" name="left-label">
-            <a:extLst xmlns:a="http://schemas.openxmlformats.org/drawingml/2006/main">
-              <a:ext uri="{FF2B5EF4-FFF2-40B4-BE49-F238E27FC236}">
-                <a16:creationId xmlns:a16="http://schemas.microsoft.com/office/drawing/2014/main" id="{14E39621-3B97-4313-AF9C-62C6D82598D7}"/>
-              </a:ext>
-            </a:extLst>
-          </p:cNvPr>
-          <p:cNvSpPr>
-            <a:spLocks xmlns:a="http://schemas.openxmlformats.org/drawingml/2006/main" noGrp="1"/>
-          </p:cNvSpPr>
-          <p:nvPr/>
-        </p:nvSpPr>
-        <p:spPr>
-          <a:xfrm xmlns:a="http://schemas.openxmlformats.org/drawingml/2006/main">
-            <a:off x="609600" y="2752725"/>
-            <a:ext cx="4991100" cy="304800"/>
-          </a:xfrm>
-          <a:prstGeom xmlns:a="http://schemas.openxmlformats.org/drawingml/2006/main" prst="rect">
-            <a:avLst/>
-          </a:prstGeom>
-          <a:noFill xmlns:a="http://schemas.openxmlformats.org/drawingml/2006/main"/>
-          <a:ln xmlns:a="http://schemas.openxmlformats.org/drawingml/2006/main" w="0">
-            <a:noFill/>
-          </a:ln>
-        </p:spPr>
-        <p:txBody>
-          <a:bodyPr xmlns:a="http://schemas.openxmlformats.org/drawingml/2006/main" wrap="none" lIns="0" tIns="0" rIns="0" bIns="0" anchor="t">
-            <a:noAutofit/>
-          </a:bodyPr>
-          <a:lstStyle xmlns:a="http://schemas.openxmlformats.org/drawingml/2006/main"/>
-          <a:p xmlns:a="http://schemas.openxmlformats.org/drawingml/2006/main">
-            <a:pPr algn="l">
-              <a:buNone/>
-              <a:defRPr sz="1425" b="1">
+          <p:cNvPr id="9" name="number-0">
+            <a:extLst xmlns:a="http://schemas.openxmlformats.org/drawingml/2006/main">
+              <a:ext uri="{FF2B5EF4-FFF2-40B4-BE49-F238E27FC236}">
+                <a16:creationId xmlns:a16="http://schemas.microsoft.com/office/drawing/2014/main" id="{51BDE694-C556-45C9-8B16-C8598B27536B}"/>
+              </a:ext>
+            </a:extLst>
+          </p:cNvPr>
+          <p:cNvSpPr>
+            <a:spLocks xmlns:a="http://schemas.openxmlformats.org/drawingml/2006/main" noGrp="1"/>
+          </p:cNvSpPr>
+          <p:nvPr/>
+        </p:nvSpPr>
+        <p:spPr>
+          <a:xfrm xmlns:a="http://schemas.openxmlformats.org/drawingml/2006/main">
+            <a:off x="609600" y="2762250"/>
+            <a:ext cx="800100" cy="438150"/>
+          </a:xfrm>
+          <a:prstGeom xmlns:a="http://schemas.openxmlformats.org/drawingml/2006/main" prst="rect">
+            <a:avLst/>
+          </a:prstGeom>
+          <a:noFill xmlns:a="http://schemas.openxmlformats.org/drawingml/2006/main"/>
+          <a:ln xmlns:a="http://schemas.openxmlformats.org/drawingml/2006/main" w="0">
+            <a:noFill/>
+          </a:ln>
+        </p:spPr>
+        <p:txBody>
+          <a:bodyPr xmlns:a="http://schemas.openxmlformats.org/drawingml/2006/main" wrap="none" lIns="0" tIns="0" rIns="0" bIns="0" anchor="t">
+            <a:noAutofit/>
+          </a:bodyPr>
+          <a:lstStyle xmlns:a="http://schemas.openxmlformats.org/drawingml/2006/main"/>
+          <a:p xmlns:a="http://schemas.openxmlformats.org/drawingml/2006/main">
+            <a:pPr algn="l">
+              <a:buNone/>
+              <a:defRPr sz="2400" b="1">
+                <a:solidFill>
+                  <a:srgbClr val="087E80"/>
+                </a:solidFill>
+                <a:latin typeface="Arial"/>
+                <a:ea typeface="Arial"/>
+                <a:cs typeface="Arial"/>
+              </a:defRPr>
+            </a:pPr>
+            <a:r>
+              <a:rPr sz="2400" b="1">
+                <a:solidFill>
+                  <a:srgbClr val="087E80"/>
+                </a:solidFill>
+                <a:latin typeface="Arial"/>
+                <a:ea typeface="Arial"/>
+                <a:cs typeface="Arial"/>
+              </a:rPr>
+              <a:t>01</a:t>
+            </a:r>
+          </a:p>
+        </p:txBody>
+      </p:sp>
+      <p:sp>
+        <p:nvSpPr>
+          <p:cNvPr id="10" name="label-0">
+            <a:extLst xmlns:a="http://schemas.openxmlformats.org/drawingml/2006/main">
+              <a:ext uri="{FF2B5EF4-FFF2-40B4-BE49-F238E27FC236}">
+                <a16:creationId xmlns:a16="http://schemas.microsoft.com/office/drawing/2014/main" id="{E901CE81-5B34-4D37-86AA-33C33C0D7159}"/>
+              </a:ext>
+            </a:extLst>
+          </p:cNvPr>
+          <p:cNvSpPr>
+            <a:spLocks xmlns:a="http://schemas.openxmlformats.org/drawingml/2006/main" noGrp="1"/>
+          </p:cNvSpPr>
+          <p:nvPr/>
+        </p:nvSpPr>
+        <p:spPr>
+          <a:xfrm xmlns:a="http://schemas.openxmlformats.org/drawingml/2006/main">
+            <a:off x="1638300" y="2762250"/>
+            <a:ext cx="2476500" cy="438150"/>
+          </a:xfrm>
+          <a:prstGeom xmlns:a="http://schemas.openxmlformats.org/drawingml/2006/main" prst="rect">
+            <a:avLst/>
+          </a:prstGeom>
+          <a:noFill xmlns:a="http://schemas.openxmlformats.org/drawingml/2006/main"/>
+          <a:ln xmlns:a="http://schemas.openxmlformats.org/drawingml/2006/main" w="0">
+            <a:noFill/>
+          </a:ln>
+        </p:spPr>
+        <p:txBody>
+          <a:bodyPr xmlns:a="http://schemas.openxmlformats.org/drawingml/2006/main" wrap="none" lIns="0" tIns="0" rIns="0" bIns="0" anchor="t">
+            <a:noAutofit/>
+          </a:bodyPr>
+          <a:lstStyle xmlns:a="http://schemas.openxmlformats.org/drawingml/2006/main"/>
+          <a:p xmlns:a="http://schemas.openxmlformats.org/drawingml/2006/main">
+            <a:pPr algn="l">
+              <a:buNone/>
+              <a:defRPr sz="1875" b="1">
+                <a:solidFill>
+                  <a:srgbClr val="142D32"/>
+                </a:solidFill>
+                <a:latin typeface="Arial"/>
+                <a:ea typeface="Arial"/>
+                <a:cs typeface="Arial"/>
+              </a:defRPr>
+            </a:pPr>
+            <a:r>
+              <a:rPr sz="1875" b="1">
+                <a:solidFill>
+                  <a:srgbClr val="142D32"/>
+                </a:solidFill>
+                <a:latin typeface="Arial"/>
+                <a:ea typeface="Arial"/>
+                <a:cs typeface="Arial"/>
+              </a:rPr>
+              <a:t>Try the chatbot</a:t>
+            </a:r>
+          </a:p>
+        </p:txBody>
+      </p:sp>
+      <p:sp>
+        <p:nvSpPr>
+          <p:cNvPr id="11" name="detail-0">
+            <a:extLst xmlns:a="http://schemas.openxmlformats.org/drawingml/2006/main">
+              <a:ext uri="{FF2B5EF4-FFF2-40B4-BE49-F238E27FC236}">
+                <a16:creationId xmlns:a16="http://schemas.microsoft.com/office/drawing/2014/main" id="{BD0ED1E0-713C-4C6D-929D-E0FBED8AF2E8}"/>
+              </a:ext>
+            </a:extLst>
+          </p:cNvPr>
+          <p:cNvSpPr>
+            <a:spLocks xmlns:a="http://schemas.openxmlformats.org/drawingml/2006/main" noGrp="1"/>
+          </p:cNvSpPr>
+          <p:nvPr/>
+        </p:nvSpPr>
+        <p:spPr>
+          <a:xfrm xmlns:a="http://schemas.openxmlformats.org/drawingml/2006/main">
+            <a:off x="4476750" y="2790825"/>
+            <a:ext cx="7067550" cy="409575"/>
+          </a:xfrm>
+          <a:prstGeom xmlns:a="http://schemas.openxmlformats.org/drawingml/2006/main" prst="rect">
+            <a:avLst/>
+          </a:prstGeom>
+          <a:noFill xmlns:a="http://schemas.openxmlformats.org/drawingml/2006/main"/>
+          <a:ln xmlns:a="http://schemas.openxmlformats.org/drawingml/2006/main" w="0">
+            <a:noFill/>
+          </a:ln>
+        </p:spPr>
+        <p:txBody>
+          <a:bodyPr xmlns:a="http://schemas.openxmlformats.org/drawingml/2006/main" wrap="none" lIns="0" tIns="0" rIns="0" bIns="0" anchor="t">
+            <a:noAutofit/>
+          </a:bodyPr>
+          <a:lstStyle xmlns:a="http://schemas.openxmlformats.org/drawingml/2006/main"/>
+          <a:p xmlns:a="http://schemas.openxmlformats.org/drawingml/2006/main">
+            <a:pPr algn="l">
+              <a:buNone/>
+              <a:defRPr sz="1725" b="0">
                 <a:solidFill>
                   <a:srgbClr val="53686C"/>
                 </a:solidFill>
@@ -6089,7 +6589,7 @@
               </a:defRPr>
             </a:pPr>
             <a:r>
-              <a:rPr sz="1425" b="1">
+              <a:rPr sz="1725" b="0">
                 <a:solidFill>
                   <a:srgbClr val="53686C"/>
                 </a:solidFill>
@@ -6097,47 +6597,105 @@
                 <a:ea typeface="Arial"/>
                 <a:cs typeface="Arial"/>
               </a:rPr>
-              <a:t>EDIT ON GITHUB</a:t>
-            </a:r>
-          </a:p>
-        </p:txBody>
-      </p:sp>
-      <p:sp>
-        <p:nvSpPr>
-          <p:cNvPr id="10" name="left-prompt">
-            <a:extLst xmlns:a="http://schemas.openxmlformats.org/drawingml/2006/main">
-              <a:ext uri="{FF2B5EF4-FFF2-40B4-BE49-F238E27FC236}">
-                <a16:creationId xmlns:a16="http://schemas.microsoft.com/office/drawing/2014/main" id="{F5C4BD44-0293-4300-88D1-582D0C509FBE}"/>
-              </a:ext>
-            </a:extLst>
-          </p:cNvPr>
-          <p:cNvSpPr>
-            <a:spLocks xmlns:a="http://schemas.openxmlformats.org/drawingml/2006/main" noGrp="1"/>
-          </p:cNvSpPr>
-          <p:nvPr/>
-        </p:nvSpPr>
-        <p:spPr>
-          <a:xfrm xmlns:a="http://schemas.openxmlformats.org/drawingml/2006/main">
-            <a:off x="609600" y="3314700"/>
-            <a:ext cx="5238750" cy="1733550"/>
-          </a:xfrm>
-          <a:prstGeom xmlns:a="http://schemas.openxmlformats.org/drawingml/2006/main" prst="rect">
-            <a:avLst/>
-          </a:prstGeom>
-          <a:noFill xmlns:a="http://schemas.openxmlformats.org/drawingml/2006/main"/>
-          <a:ln xmlns:a="http://schemas.openxmlformats.org/drawingml/2006/main" w="0">
-            <a:noFill/>
-          </a:ln>
-        </p:spPr>
-        <p:txBody>
-          <a:bodyPr xmlns:a="http://schemas.openxmlformats.org/drawingml/2006/main" wrap="none" lIns="0" tIns="0" rIns="0" bIns="0" anchor="t">
-            <a:noAutofit/>
-          </a:bodyPr>
-          <a:lstStyle xmlns:a="http://schemas.openxmlformats.org/drawingml/2006/main"/>
-          <a:p xmlns:a="http://schemas.openxmlformats.org/drawingml/2006/main">
-            <a:pPr algn="l">
-              <a:buNone/>
-              <a:defRPr sz="2025" b="1">
+              <a:t>Open Advanced chatbot → send a demo theme</a:t>
+            </a:r>
+          </a:p>
+        </p:txBody>
+      </p:sp>
+      <p:sp>
+        <p:nvSpPr>
+          <p:cNvPr id="12" name="number-1">
+            <a:extLst xmlns:a="http://schemas.openxmlformats.org/drawingml/2006/main">
+              <a:ext uri="{FF2B5EF4-FFF2-40B4-BE49-F238E27FC236}">
+                <a16:creationId xmlns:a16="http://schemas.microsoft.com/office/drawing/2014/main" id="{AD5A7334-AE57-4202-9AFA-95A3587926EB}"/>
+              </a:ext>
+            </a:extLst>
+          </p:cNvPr>
+          <p:cNvSpPr>
+            <a:spLocks xmlns:a="http://schemas.openxmlformats.org/drawingml/2006/main" noGrp="1"/>
+          </p:cNvSpPr>
+          <p:nvPr/>
+        </p:nvSpPr>
+        <p:spPr>
+          <a:xfrm xmlns:a="http://schemas.openxmlformats.org/drawingml/2006/main">
+            <a:off x="609600" y="3476625"/>
+            <a:ext cx="800100" cy="438150"/>
+          </a:xfrm>
+          <a:prstGeom xmlns:a="http://schemas.openxmlformats.org/drawingml/2006/main" prst="rect">
+            <a:avLst/>
+          </a:prstGeom>
+          <a:noFill xmlns:a="http://schemas.openxmlformats.org/drawingml/2006/main"/>
+          <a:ln xmlns:a="http://schemas.openxmlformats.org/drawingml/2006/main" w="0">
+            <a:noFill/>
+          </a:ln>
+        </p:spPr>
+        <p:txBody>
+          <a:bodyPr xmlns:a="http://schemas.openxmlformats.org/drawingml/2006/main" wrap="none" lIns="0" tIns="0" rIns="0" bIns="0" anchor="t">
+            <a:noAutofit/>
+          </a:bodyPr>
+          <a:lstStyle xmlns:a="http://schemas.openxmlformats.org/drawingml/2006/main"/>
+          <a:p xmlns:a="http://schemas.openxmlformats.org/drawingml/2006/main">
+            <a:pPr algn="l">
+              <a:buNone/>
+              <a:defRPr sz="2400" b="1">
+                <a:solidFill>
+                  <a:srgbClr val="087E80"/>
+                </a:solidFill>
+                <a:latin typeface="Arial"/>
+                <a:ea typeface="Arial"/>
+                <a:cs typeface="Arial"/>
+              </a:defRPr>
+            </a:pPr>
+            <a:r>
+              <a:rPr sz="2400" b="1">
+                <a:solidFill>
+                  <a:srgbClr val="087E80"/>
+                </a:solidFill>
+                <a:latin typeface="Arial"/>
+                <a:ea typeface="Arial"/>
+                <a:cs typeface="Arial"/>
+              </a:rPr>
+              <a:t>02</a:t>
+            </a:r>
+          </a:p>
+        </p:txBody>
+      </p:sp>
+      <p:sp>
+        <p:nvSpPr>
+          <p:cNvPr id="13" name="label-1">
+            <a:extLst xmlns:a="http://schemas.openxmlformats.org/drawingml/2006/main">
+              <a:ext uri="{FF2B5EF4-FFF2-40B4-BE49-F238E27FC236}">
+                <a16:creationId xmlns:a16="http://schemas.microsoft.com/office/drawing/2014/main" id="{103D2AB4-FD59-4411-8C36-0103588CA6F2}"/>
+              </a:ext>
+            </a:extLst>
+          </p:cNvPr>
+          <p:cNvSpPr>
+            <a:spLocks xmlns:a="http://schemas.openxmlformats.org/drawingml/2006/main" noGrp="1"/>
+          </p:cNvSpPr>
+          <p:nvPr/>
+        </p:nvSpPr>
+        <p:spPr>
+          <a:xfrm xmlns:a="http://schemas.openxmlformats.org/drawingml/2006/main">
+            <a:off x="1638300" y="3476625"/>
+            <a:ext cx="2476500" cy="438150"/>
+          </a:xfrm>
+          <a:prstGeom xmlns:a="http://schemas.openxmlformats.org/drawingml/2006/main" prst="rect">
+            <a:avLst/>
+          </a:prstGeom>
+          <a:noFill xmlns:a="http://schemas.openxmlformats.org/drawingml/2006/main"/>
+          <a:ln xmlns:a="http://schemas.openxmlformats.org/drawingml/2006/main" w="0">
+            <a:noFill/>
+          </a:ln>
+        </p:spPr>
+        <p:txBody>
+          <a:bodyPr xmlns:a="http://schemas.openxmlformats.org/drawingml/2006/main" wrap="none" lIns="0" tIns="0" rIns="0" bIns="0" anchor="t">
+            <a:noAutofit/>
+          </a:bodyPr>
+          <a:lstStyle xmlns:a="http://schemas.openxmlformats.org/drawingml/2006/main"/>
+          <a:p xmlns:a="http://schemas.openxmlformats.org/drawingml/2006/main">
+            <a:pPr algn="l">
+              <a:buNone/>
+              <a:defRPr sz="1875" b="1">
                 <a:solidFill>
                   <a:srgbClr val="142D32"/>
                 </a:solidFill>
@@ -6147,7 +6705,7 @@
               </a:defRPr>
             </a:pPr>
             <a:r>
-              <a:rPr sz="2025" b="1">
+              <a:rPr sz="1875" b="1">
                 <a:solidFill>
                   <a:srgbClr val="142D32"/>
                 </a:solidFill>
@@ -6155,13 +6713,163 @@
                 <a:ea typeface="Arial"/>
                 <a:cs typeface="Arial"/>
               </a:rPr>
-              <a:t>Open the file → pencil</a:t>
-            </a:r>
-          </a:p>
-          <a:p xmlns:a="http://schemas.openxmlformats.org/drawingml/2006/main">
-            <a:pPr algn="l">
-              <a:buNone/>
-              <a:defRPr sz="2700" b="1">
+              <a:t>Try a larger view</a:t>
+            </a:r>
+          </a:p>
+        </p:txBody>
+      </p:sp>
+      <p:sp>
+        <p:nvSpPr>
+          <p:cNvPr id="14" name="detail-1">
+            <a:extLst xmlns:a="http://schemas.openxmlformats.org/drawingml/2006/main">
+              <a:ext uri="{FF2B5EF4-FFF2-40B4-BE49-F238E27FC236}">
+                <a16:creationId xmlns:a16="http://schemas.microsoft.com/office/drawing/2014/main" id="{A5914C25-27E7-47D8-9ACC-EFCE8E16BC3D}"/>
+              </a:ext>
+            </a:extLst>
+          </p:cNvPr>
+          <p:cNvSpPr>
+            <a:spLocks xmlns:a="http://schemas.openxmlformats.org/drawingml/2006/main" noGrp="1"/>
+          </p:cNvSpPr>
+          <p:nvPr/>
+        </p:nvSpPr>
+        <p:spPr>
+          <a:xfrm xmlns:a="http://schemas.openxmlformats.org/drawingml/2006/main">
+            <a:off x="4476750" y="3505200"/>
+            <a:ext cx="7067550" cy="409575"/>
+          </a:xfrm>
+          <a:prstGeom xmlns:a="http://schemas.openxmlformats.org/drawingml/2006/main" prst="rect">
+            <a:avLst/>
+          </a:prstGeom>
+          <a:noFill xmlns:a="http://schemas.openxmlformats.org/drawingml/2006/main"/>
+          <a:ln xmlns:a="http://schemas.openxmlformats.org/drawingml/2006/main" w="0">
+            <a:noFill/>
+          </a:ln>
+        </p:spPr>
+        <p:txBody>
+          <a:bodyPr xmlns:a="http://schemas.openxmlformats.org/drawingml/2006/main" wrap="none" lIns="0" tIns="0" rIns="0" bIns="0" anchor="t">
+            <a:noAutofit/>
+          </a:bodyPr>
+          <a:lstStyle xmlns:a="http://schemas.openxmlformats.org/drawingml/2006/main"/>
+          <a:p xmlns:a="http://schemas.openxmlformats.org/drawingml/2006/main">
+            <a:pPr algn="l">
+              <a:buNone/>
+              <a:defRPr sz="1725" b="0">
+                <a:solidFill>
+                  <a:srgbClr val="53686C"/>
+                </a:solidFill>
+                <a:latin typeface="Arial"/>
+                <a:ea typeface="Arial"/>
+                <a:cs typeface="Arial"/>
+              </a:defRPr>
+            </a:pPr>
+            <a:r>
+              <a:rPr sz="1725" b="0">
+                <a:solidFill>
+                  <a:srgbClr val="53686C"/>
+                </a:solidFill>
+                <a:latin typeface="Arial"/>
+                <a:ea typeface="Arial"/>
+                <a:cs typeface="Arial"/>
+              </a:rPr>
+              <a:t>Click Full-page game to use the same interface</a:t>
+            </a:r>
+          </a:p>
+        </p:txBody>
+      </p:sp>
+      <p:sp>
+        <p:nvSpPr>
+          <p:cNvPr id="15" name="number-2">
+            <a:extLst xmlns:a="http://schemas.openxmlformats.org/drawingml/2006/main">
+              <a:ext uri="{FF2B5EF4-FFF2-40B4-BE49-F238E27FC236}">
+                <a16:creationId xmlns:a16="http://schemas.microsoft.com/office/drawing/2014/main" id="{48C15E34-16CE-4F28-B10B-104872F8D180}"/>
+              </a:ext>
+            </a:extLst>
+          </p:cNvPr>
+          <p:cNvSpPr>
+            <a:spLocks xmlns:a="http://schemas.openxmlformats.org/drawingml/2006/main" noGrp="1"/>
+          </p:cNvSpPr>
+          <p:nvPr/>
+        </p:nvSpPr>
+        <p:spPr>
+          <a:xfrm xmlns:a="http://schemas.openxmlformats.org/drawingml/2006/main">
+            <a:off x="609600" y="4191000"/>
+            <a:ext cx="800100" cy="438150"/>
+          </a:xfrm>
+          <a:prstGeom xmlns:a="http://schemas.openxmlformats.org/drawingml/2006/main" prst="rect">
+            <a:avLst/>
+          </a:prstGeom>
+          <a:noFill xmlns:a="http://schemas.openxmlformats.org/drawingml/2006/main"/>
+          <a:ln xmlns:a="http://schemas.openxmlformats.org/drawingml/2006/main" w="0">
+            <a:noFill/>
+          </a:ln>
+        </p:spPr>
+        <p:txBody>
+          <a:bodyPr xmlns:a="http://schemas.openxmlformats.org/drawingml/2006/main" wrap="none" lIns="0" tIns="0" rIns="0" bIns="0" anchor="t">
+            <a:noAutofit/>
+          </a:bodyPr>
+          <a:lstStyle xmlns:a="http://schemas.openxmlformats.org/drawingml/2006/main"/>
+          <a:p xmlns:a="http://schemas.openxmlformats.org/drawingml/2006/main">
+            <a:pPr algn="l">
+              <a:buNone/>
+              <a:defRPr sz="2400" b="1">
+                <a:solidFill>
+                  <a:srgbClr val="087E80"/>
+                </a:solidFill>
+                <a:latin typeface="Arial"/>
+                <a:ea typeface="Arial"/>
+                <a:cs typeface="Arial"/>
+              </a:defRPr>
+            </a:pPr>
+            <a:r>
+              <a:rPr sz="2400" b="1">
+                <a:solidFill>
+                  <a:srgbClr val="087E80"/>
+                </a:solidFill>
+                <a:latin typeface="Arial"/>
+                <a:ea typeface="Arial"/>
+                <a:cs typeface="Arial"/>
+              </a:rPr>
+              <a:t>03</a:t>
+            </a:r>
+          </a:p>
+        </p:txBody>
+      </p:sp>
+      <p:sp>
+        <p:nvSpPr>
+          <p:cNvPr id="16" name="label-2">
+            <a:extLst xmlns:a="http://schemas.openxmlformats.org/drawingml/2006/main">
+              <a:ext uri="{FF2B5EF4-FFF2-40B4-BE49-F238E27FC236}">
+                <a16:creationId xmlns:a16="http://schemas.microsoft.com/office/drawing/2014/main" id="{2D9E683A-398A-4AB2-AA79-A9276DCE23D4}"/>
+              </a:ext>
+            </a:extLst>
+          </p:cNvPr>
+          <p:cNvSpPr>
+            <a:spLocks xmlns:a="http://schemas.openxmlformats.org/drawingml/2006/main" noGrp="1"/>
+          </p:cNvSpPr>
+          <p:nvPr/>
+        </p:nvSpPr>
+        <p:spPr>
+          <a:xfrm xmlns:a="http://schemas.openxmlformats.org/drawingml/2006/main">
+            <a:off x="1638300" y="4191000"/>
+            <a:ext cx="2476500" cy="438150"/>
+          </a:xfrm>
+          <a:prstGeom xmlns:a="http://schemas.openxmlformats.org/drawingml/2006/main" prst="rect">
+            <a:avLst/>
+          </a:prstGeom>
+          <a:noFill xmlns:a="http://schemas.openxmlformats.org/drawingml/2006/main"/>
+          <a:ln xmlns:a="http://schemas.openxmlformats.org/drawingml/2006/main" w="0">
+            <a:noFill/>
+          </a:ln>
+        </p:spPr>
+        <p:txBody>
+          <a:bodyPr xmlns:a="http://schemas.openxmlformats.org/drawingml/2006/main" wrap="none" lIns="0" tIns="0" rIns="0" bIns="0" anchor="t">
+            <a:noAutofit/>
+          </a:bodyPr>
+          <a:lstStyle xmlns:a="http://schemas.openxmlformats.org/drawingml/2006/main"/>
+          <a:p xmlns:a="http://schemas.openxmlformats.org/drawingml/2006/main">
+            <a:pPr algn="l">
+              <a:buNone/>
+              <a:defRPr sz="1875" b="1">
                 <a:solidFill>
                   <a:srgbClr val="142D32"/>
                 </a:solidFill>
@@ -6171,7 +6879,7 @@
               </a:defRPr>
             </a:pPr>
             <a:r>
-              <a:rPr sz="2700" b="1">
+              <a:rPr sz="1875" b="1">
                 <a:solidFill>
                   <a:srgbClr val="142D32"/>
                 </a:solidFill>
@@ -6179,13 +6887,163 @@
                 <a:ea typeface="Arial"/>
                 <a:cs typeface="Arial"/>
               </a:rPr>
-              <a:t/>
-            </a:r>
-          </a:p>
-          <a:p xmlns:a="http://schemas.openxmlformats.org/drawingml/2006/main">
-            <a:pPr algn="l">
-              <a:buNone/>
-              <a:defRPr sz="2025" b="1">
+              <a:t>Edit locally, too</a:t>
+            </a:r>
+          </a:p>
+        </p:txBody>
+      </p:sp>
+      <p:sp>
+        <p:nvSpPr>
+          <p:cNvPr id="17" name="detail-2">
+            <a:extLst xmlns:a="http://schemas.openxmlformats.org/drawingml/2006/main">
+              <a:ext uri="{FF2B5EF4-FFF2-40B4-BE49-F238E27FC236}">
+                <a16:creationId xmlns:a16="http://schemas.microsoft.com/office/drawing/2014/main" id="{86AC9DF9-265A-4051-90FA-C86F9F89C9A9}"/>
+              </a:ext>
+            </a:extLst>
+          </p:cNvPr>
+          <p:cNvSpPr>
+            <a:spLocks xmlns:a="http://schemas.openxmlformats.org/drawingml/2006/main" noGrp="1"/>
+          </p:cNvSpPr>
+          <p:nvPr/>
+        </p:nvSpPr>
+        <p:spPr>
+          <a:xfrm xmlns:a="http://schemas.openxmlformats.org/drawingml/2006/main">
+            <a:off x="4476750" y="4219575"/>
+            <a:ext cx="7067550" cy="409575"/>
+          </a:xfrm>
+          <a:prstGeom xmlns:a="http://schemas.openxmlformats.org/drawingml/2006/main" prst="rect">
+            <a:avLst/>
+          </a:prstGeom>
+          <a:noFill xmlns:a="http://schemas.openxmlformats.org/drawingml/2006/main"/>
+          <a:ln xmlns:a="http://schemas.openxmlformats.org/drawingml/2006/main" w="0">
+            <a:noFill/>
+          </a:ln>
+        </p:spPr>
+        <p:txBody>
+          <a:bodyPr xmlns:a="http://schemas.openxmlformats.org/drawingml/2006/main" wrap="none" lIns="0" tIns="0" rIns="0" bIns="0" anchor="t">
+            <a:noAutofit/>
+          </a:bodyPr>
+          <a:lstStyle xmlns:a="http://schemas.openxmlformats.org/drawingml/2006/main"/>
+          <a:p xmlns:a="http://schemas.openxmlformats.org/drawingml/2006/main">
+            <a:pPr algn="l">
+              <a:buNone/>
+              <a:defRPr sz="1725" b="0">
+                <a:solidFill>
+                  <a:srgbClr val="53686C"/>
+                </a:solidFill>
+                <a:latin typeface="Arial"/>
+                <a:ea typeface="Arial"/>
+                <a:cs typeface="Arial"/>
+              </a:defRPr>
+            </a:pPr>
+            <a:r>
+              <a:rPr sz="1725" b="0">
+                <a:solidFill>
+                  <a:srgbClr val="53686C"/>
+                </a:solidFill>
+                <a:latin typeface="Arial"/>
+                <a:ea typeface="Arial"/>
+                <a:cs typeface="Arial"/>
+              </a:rPr>
+              <a:t>GitHub Desktop → Clone → edit files → Save</a:t>
+            </a:r>
+          </a:p>
+        </p:txBody>
+      </p:sp>
+      <p:sp>
+        <p:nvSpPr>
+          <p:cNvPr id="18" name="number-3">
+            <a:extLst xmlns:a="http://schemas.openxmlformats.org/drawingml/2006/main">
+              <a:ext uri="{FF2B5EF4-FFF2-40B4-BE49-F238E27FC236}">
+                <a16:creationId xmlns:a16="http://schemas.microsoft.com/office/drawing/2014/main" id="{B815891C-F9E3-4E7E-9B17-326932EE6564}"/>
+              </a:ext>
+            </a:extLst>
+          </p:cNvPr>
+          <p:cNvSpPr>
+            <a:spLocks xmlns:a="http://schemas.openxmlformats.org/drawingml/2006/main" noGrp="1"/>
+          </p:cNvSpPr>
+          <p:nvPr/>
+        </p:nvSpPr>
+        <p:spPr>
+          <a:xfrm xmlns:a="http://schemas.openxmlformats.org/drawingml/2006/main">
+            <a:off x="609600" y="4905375"/>
+            <a:ext cx="800100" cy="438150"/>
+          </a:xfrm>
+          <a:prstGeom xmlns:a="http://schemas.openxmlformats.org/drawingml/2006/main" prst="rect">
+            <a:avLst/>
+          </a:prstGeom>
+          <a:noFill xmlns:a="http://schemas.openxmlformats.org/drawingml/2006/main"/>
+          <a:ln xmlns:a="http://schemas.openxmlformats.org/drawingml/2006/main" w="0">
+            <a:noFill/>
+          </a:ln>
+        </p:spPr>
+        <p:txBody>
+          <a:bodyPr xmlns:a="http://schemas.openxmlformats.org/drawingml/2006/main" wrap="none" lIns="0" tIns="0" rIns="0" bIns="0" anchor="t">
+            <a:noAutofit/>
+          </a:bodyPr>
+          <a:lstStyle xmlns:a="http://schemas.openxmlformats.org/drawingml/2006/main"/>
+          <a:p xmlns:a="http://schemas.openxmlformats.org/drawingml/2006/main">
+            <a:pPr algn="l">
+              <a:buNone/>
+              <a:defRPr sz="2400" b="1">
+                <a:solidFill>
+                  <a:srgbClr val="087E80"/>
+                </a:solidFill>
+                <a:latin typeface="Arial"/>
+                <a:ea typeface="Arial"/>
+                <a:cs typeface="Arial"/>
+              </a:defRPr>
+            </a:pPr>
+            <a:r>
+              <a:rPr sz="2400" b="1">
+                <a:solidFill>
+                  <a:srgbClr val="087E80"/>
+                </a:solidFill>
+                <a:latin typeface="Arial"/>
+                <a:ea typeface="Arial"/>
+                <a:cs typeface="Arial"/>
+              </a:rPr>
+              <a:t>04</a:t>
+            </a:r>
+          </a:p>
+        </p:txBody>
+      </p:sp>
+      <p:sp>
+        <p:nvSpPr>
+          <p:cNvPr id="19" name="label-3">
+            <a:extLst xmlns:a="http://schemas.openxmlformats.org/drawingml/2006/main">
+              <a:ext uri="{FF2B5EF4-FFF2-40B4-BE49-F238E27FC236}">
+                <a16:creationId xmlns:a16="http://schemas.microsoft.com/office/drawing/2014/main" id="{D16D2124-C19D-4287-BA72-4BAFA52DD5C6}"/>
+              </a:ext>
+            </a:extLst>
+          </p:cNvPr>
+          <p:cNvSpPr>
+            <a:spLocks xmlns:a="http://schemas.openxmlformats.org/drawingml/2006/main" noGrp="1"/>
+          </p:cNvSpPr>
+          <p:nvPr/>
+        </p:nvSpPr>
+        <p:spPr>
+          <a:xfrm xmlns:a="http://schemas.openxmlformats.org/drawingml/2006/main">
+            <a:off x="1638300" y="4905375"/>
+            <a:ext cx="2476500" cy="438150"/>
+          </a:xfrm>
+          <a:prstGeom xmlns:a="http://schemas.openxmlformats.org/drawingml/2006/main" prst="rect">
+            <a:avLst/>
+          </a:prstGeom>
+          <a:noFill xmlns:a="http://schemas.openxmlformats.org/drawingml/2006/main"/>
+          <a:ln xmlns:a="http://schemas.openxmlformats.org/drawingml/2006/main" w="0">
+            <a:noFill/>
+          </a:ln>
+        </p:spPr>
+        <p:txBody>
+          <a:bodyPr xmlns:a="http://schemas.openxmlformats.org/drawingml/2006/main" wrap="none" lIns="0" tIns="0" rIns="0" bIns="0" anchor="t">
+            <a:noAutofit/>
+          </a:bodyPr>
+          <a:lstStyle xmlns:a="http://schemas.openxmlformats.org/drawingml/2006/main"/>
+          <a:p xmlns:a="http://schemas.openxmlformats.org/drawingml/2006/main">
+            <a:pPr algn="l">
+              <a:buNone/>
+              <a:defRPr sz="1875" b="1">
                 <a:solidFill>
                   <a:srgbClr val="142D32"/>
                 </a:solidFill>
@@ -6195,7 +7053,7 @@
               </a:defRPr>
             </a:pPr>
             <a:r>
-              <a:rPr sz="2025" b="1">
+              <a:rPr sz="1875" b="1">
                 <a:solidFill>
                   <a:srgbClr val="142D32"/>
                 </a:solidFill>
@@ -6203,77 +7061,29 @@
                 <a:ea typeface="Arial"/>
                 <a:cs typeface="Arial"/>
               </a:rPr>
-              <a:t>Try: “Only use food themes.”</a:t>
-            </a:r>
-          </a:p>
-          <a:p xmlns:a="http://schemas.openxmlformats.org/drawingml/2006/main">
-            <a:pPr algn="l">
-              <a:buNone/>
-              <a:defRPr sz="2700" b="1">
-                <a:solidFill>
-                  <a:srgbClr val="142D32"/>
-                </a:solidFill>
-                <a:latin typeface="Arial"/>
-                <a:ea typeface="Arial"/>
-                <a:cs typeface="Arial"/>
-              </a:defRPr>
-            </a:pPr>
-            <a:r>
-              <a:rPr sz="2700" b="1">
-                <a:solidFill>
-                  <a:srgbClr val="142D32"/>
-                </a:solidFill>
-                <a:latin typeface="Arial"/>
-                <a:ea typeface="Arial"/>
-                <a:cs typeface="Arial"/>
-              </a:rPr>
-              <a:t/>
-            </a:r>
-          </a:p>
-          <a:p xmlns:a="http://schemas.openxmlformats.org/drawingml/2006/main">
-            <a:pPr algn="l">
-              <a:buNone/>
-              <a:defRPr sz="2025" b="1">
-                <a:solidFill>
-                  <a:srgbClr val="142D32"/>
-                </a:solidFill>
-                <a:latin typeface="Arial"/>
-                <a:ea typeface="Arial"/>
-                <a:cs typeface="Arial"/>
-              </a:defRPr>
-            </a:pPr>
-            <a:r>
-              <a:rPr sz="2025" b="1">
-                <a:solidFill>
-                  <a:srgbClr val="142D32"/>
-                </a:solidFill>
-                <a:latin typeface="Arial"/>
-                <a:ea typeface="Arial"/>
-                <a:cs typeface="Arial"/>
-              </a:rPr>
-              <a:t>Commit changes</a:t>
-            </a:r>
-          </a:p>
-        </p:txBody>
-      </p:sp>
-      <p:sp>
-        <p:nvSpPr>
-          <p:cNvPr id="11" name="left-caption">
-            <a:extLst xmlns:a="http://schemas.openxmlformats.org/drawingml/2006/main">
-              <a:ext uri="{FF2B5EF4-FFF2-40B4-BE49-F238E27FC236}">
-                <a16:creationId xmlns:a16="http://schemas.microsoft.com/office/drawing/2014/main" id="{25D8FBD5-2925-42B1-A10D-32015BA93D47}"/>
-              </a:ext>
-            </a:extLst>
-          </p:cNvPr>
-          <p:cNvSpPr>
-            <a:spLocks xmlns:a="http://schemas.openxmlformats.org/drawingml/2006/main" noGrp="1"/>
-          </p:cNvSpPr>
-          <p:nvPr/>
-        </p:nvSpPr>
-        <p:spPr>
-          <a:xfrm xmlns:a="http://schemas.openxmlformats.org/drawingml/2006/main">
-            <a:off x="609600" y="5524500"/>
-            <a:ext cx="5334000" cy="542925"/>
+              <a:t>Publish local edits</a:t>
+            </a:r>
+          </a:p>
+        </p:txBody>
+      </p:sp>
+      <p:sp>
+        <p:nvSpPr>
+          <p:cNvPr id="20" name="detail-3">
+            <a:extLst xmlns:a="http://schemas.openxmlformats.org/drawingml/2006/main">
+              <a:ext uri="{FF2B5EF4-FFF2-40B4-BE49-F238E27FC236}">
+                <a16:creationId xmlns:a16="http://schemas.microsoft.com/office/drawing/2014/main" id="{9219B99F-90F8-4C32-9F2B-5F01F554F722}"/>
+              </a:ext>
+            </a:extLst>
+          </p:cNvPr>
+          <p:cNvSpPr>
+            <a:spLocks xmlns:a="http://schemas.openxmlformats.org/drawingml/2006/main" noGrp="1"/>
+          </p:cNvSpPr>
+          <p:nvPr/>
+        </p:nvSpPr>
+        <p:spPr>
+          <a:xfrm xmlns:a="http://schemas.openxmlformats.org/drawingml/2006/main">
+            <a:off x="4476750" y="4933950"/>
+            <a:ext cx="7067550" cy="409575"/>
           </a:xfrm>
           <a:prstGeom xmlns:a="http://schemas.openxmlformats.org/drawingml/2006/main" prst="rect">
             <a:avLst/>
@@ -6309,277 +7119,7 @@
                 <a:ea typeface="Arial"/>
                 <a:cs typeface="Arial"/>
               </a:rPr>
-              <a:t>Wait for deployment. Ask the same theme again.</a:t>
-            </a:r>
-          </a:p>
-        </p:txBody>
-      </p:sp>
-      <p:sp>
-        <p:nvSpPr>
-          <p:cNvPr id="12" name="right-label">
-            <a:extLst xmlns:a="http://schemas.openxmlformats.org/drawingml/2006/main">
-              <a:ext uri="{FF2B5EF4-FFF2-40B4-BE49-F238E27FC236}">
-                <a16:creationId xmlns:a16="http://schemas.microsoft.com/office/drawing/2014/main" id="{03B0C3C5-AB47-47C5-86F9-888C436E1B3E}"/>
-              </a:ext>
-            </a:extLst>
-          </p:cNvPr>
-          <p:cNvSpPr>
-            <a:spLocks xmlns:a="http://schemas.openxmlformats.org/drawingml/2006/main" noGrp="1"/>
-          </p:cNvSpPr>
-          <p:nvPr/>
-        </p:nvSpPr>
-        <p:spPr>
-          <a:xfrm xmlns:a="http://schemas.openxmlformats.org/drawingml/2006/main">
-            <a:off x="6610350" y="2752725"/>
-            <a:ext cx="4972050" cy="304800"/>
-          </a:xfrm>
-          <a:prstGeom xmlns:a="http://schemas.openxmlformats.org/drawingml/2006/main" prst="rect">
-            <a:avLst/>
-          </a:prstGeom>
-          <a:noFill xmlns:a="http://schemas.openxmlformats.org/drawingml/2006/main"/>
-          <a:ln xmlns:a="http://schemas.openxmlformats.org/drawingml/2006/main" w="0">
-            <a:noFill/>
-          </a:ln>
-        </p:spPr>
-        <p:txBody>
-          <a:bodyPr xmlns:a="http://schemas.openxmlformats.org/drawingml/2006/main" wrap="none" lIns="0" tIns="0" rIns="0" bIns="0" anchor="t">
-            <a:noAutofit/>
-          </a:bodyPr>
-          <a:lstStyle xmlns:a="http://schemas.openxmlformats.org/drawingml/2006/main"/>
-          <a:p xmlns:a="http://schemas.openxmlformats.org/drawingml/2006/main">
-            <a:pPr algn="l">
-              <a:buNone/>
-              <a:defRPr sz="1425" b="1">
-                <a:solidFill>
-                  <a:srgbClr val="087E80"/>
-                </a:solidFill>
-                <a:latin typeface="Arial"/>
-                <a:ea typeface="Arial"/>
-                <a:cs typeface="Arial"/>
-              </a:defRPr>
-            </a:pPr>
-            <a:r>
-              <a:rPr sz="1425" b="1">
-                <a:solidFill>
-                  <a:srgbClr val="087E80"/>
-                </a:solidFill>
-                <a:latin typeface="Arial"/>
-                <a:ea typeface="Arial"/>
-                <a:cs typeface="Arial"/>
-              </a:rPr>
-              <a:t>OR USE A LOCAL FOLDER</a:t>
-            </a:r>
-          </a:p>
-        </p:txBody>
-      </p:sp>
-      <p:sp>
-        <p:nvSpPr>
-          <p:cNvPr id="13" name="right-prompt">
-            <a:extLst xmlns:a="http://schemas.openxmlformats.org/drawingml/2006/main">
-              <a:ext uri="{FF2B5EF4-FFF2-40B4-BE49-F238E27FC236}">
-                <a16:creationId xmlns:a16="http://schemas.microsoft.com/office/drawing/2014/main" id="{59F90D52-9B1C-4538-8AA2-B3B63DC2FB4F}"/>
-              </a:ext>
-            </a:extLst>
-          </p:cNvPr>
-          <p:cNvSpPr>
-            <a:spLocks xmlns:a="http://schemas.openxmlformats.org/drawingml/2006/main" noGrp="1"/>
-          </p:cNvSpPr>
-          <p:nvPr/>
-        </p:nvSpPr>
-        <p:spPr>
-          <a:xfrm xmlns:a="http://schemas.openxmlformats.org/drawingml/2006/main">
-            <a:off x="6610350" y="3314700"/>
-            <a:ext cx="4972050" cy="1733550"/>
-          </a:xfrm>
-          <a:prstGeom xmlns:a="http://schemas.openxmlformats.org/drawingml/2006/main" prst="rect">
-            <a:avLst/>
-          </a:prstGeom>
-          <a:noFill xmlns:a="http://schemas.openxmlformats.org/drawingml/2006/main"/>
-          <a:ln xmlns:a="http://schemas.openxmlformats.org/drawingml/2006/main" w="0">
-            <a:noFill/>
-          </a:ln>
-        </p:spPr>
-        <p:txBody>
-          <a:bodyPr xmlns:a="http://schemas.openxmlformats.org/drawingml/2006/main" wrap="none" lIns="0" tIns="0" rIns="0" bIns="0" anchor="t">
-            <a:noAutofit/>
-          </a:bodyPr>
-          <a:lstStyle xmlns:a="http://schemas.openxmlformats.org/drawingml/2006/main"/>
-          <a:p xmlns:a="http://schemas.openxmlformats.org/drawingml/2006/main">
-            <a:pPr algn="l">
-              <a:buNone/>
-              <a:defRPr sz="1875" b="1">
-                <a:solidFill>
-                  <a:srgbClr val="142D32"/>
-                </a:solidFill>
-                <a:latin typeface="Arial"/>
-                <a:ea typeface="Arial"/>
-                <a:cs typeface="Arial"/>
-              </a:defRPr>
-            </a:pPr>
-            <a:r>
-              <a:rPr sz="1875" b="1">
-                <a:solidFill>
-                  <a:srgbClr val="142D32"/>
-                </a:solidFill>
-                <a:latin typeface="Arial"/>
-                <a:ea typeface="Arial"/>
-                <a:cs typeface="Arial"/>
-              </a:rPr>
-              <a:t>GitHub Desktop → Clone your fork</a:t>
-            </a:r>
-          </a:p>
-          <a:p xmlns:a="http://schemas.openxmlformats.org/drawingml/2006/main">
-            <a:pPr algn="l">
-              <a:buNone/>
-              <a:defRPr sz="2400" b="1">
-                <a:solidFill>
-                  <a:srgbClr val="142D32"/>
-                </a:solidFill>
-                <a:latin typeface="Arial"/>
-                <a:ea typeface="Arial"/>
-                <a:cs typeface="Arial"/>
-              </a:defRPr>
-            </a:pPr>
-            <a:r>
-              <a:rPr sz="2400" b="1">
-                <a:solidFill>
-                  <a:srgbClr val="142D32"/>
-                </a:solidFill>
-                <a:latin typeface="Arial"/>
-                <a:ea typeface="Arial"/>
-                <a:cs typeface="Arial"/>
-              </a:rPr>
-              <a:t/>
-            </a:r>
-          </a:p>
-          <a:p xmlns:a="http://schemas.openxmlformats.org/drawingml/2006/main">
-            <a:pPr algn="l">
-              <a:buNone/>
-              <a:defRPr sz="1875" b="1">
-                <a:solidFill>
-                  <a:srgbClr val="142D32"/>
-                </a:solidFill>
-                <a:latin typeface="Arial"/>
-                <a:ea typeface="Arial"/>
-                <a:cs typeface="Arial"/>
-              </a:defRPr>
-            </a:pPr>
-            <a:r>
-              <a:rPr sz="1875" b="1">
-                <a:solidFill>
-                  <a:srgbClr val="142D32"/>
-                </a:solidFill>
-                <a:latin typeface="Arial"/>
-                <a:ea typeface="Arial"/>
-                <a:cs typeface="Arial"/>
-              </a:rPr>
-              <a:t>Edit the file in your folder → Save</a:t>
-            </a:r>
-          </a:p>
-          <a:p xmlns:a="http://schemas.openxmlformats.org/drawingml/2006/main">
-            <a:pPr algn="l">
-              <a:buNone/>
-              <a:defRPr sz="2400" b="1">
-                <a:solidFill>
-                  <a:srgbClr val="142D32"/>
-                </a:solidFill>
-                <a:latin typeface="Arial"/>
-                <a:ea typeface="Arial"/>
-                <a:cs typeface="Arial"/>
-              </a:defRPr>
-            </a:pPr>
-            <a:r>
-              <a:rPr sz="2400" b="1">
-                <a:solidFill>
-                  <a:srgbClr val="142D32"/>
-                </a:solidFill>
-                <a:latin typeface="Arial"/>
-                <a:ea typeface="Arial"/>
-                <a:cs typeface="Arial"/>
-              </a:rPr>
-              <a:t/>
-            </a:r>
-          </a:p>
-          <a:p xmlns:a="http://schemas.openxmlformats.org/drawingml/2006/main">
-            <a:pPr algn="l">
-              <a:buNone/>
-              <a:defRPr sz="1875" b="1">
-                <a:solidFill>
-                  <a:srgbClr val="142D32"/>
-                </a:solidFill>
-                <a:latin typeface="Arial"/>
-                <a:ea typeface="Arial"/>
-                <a:cs typeface="Arial"/>
-              </a:defRPr>
-            </a:pPr>
-            <a:r>
-              <a:rPr sz="1875" b="1">
-                <a:solidFill>
-                  <a:srgbClr val="142D32"/>
-                </a:solidFill>
-                <a:latin typeface="Arial"/>
-                <a:ea typeface="Arial"/>
-                <a:cs typeface="Arial"/>
-              </a:rPr>
-              <a:t>Commit to main → Push origin</a:t>
-            </a:r>
-          </a:p>
-        </p:txBody>
-      </p:sp>
-      <p:sp>
-        <p:nvSpPr>
-          <p:cNvPr id="14" name="right-caption">
-            <a:extLst xmlns:a="http://schemas.openxmlformats.org/drawingml/2006/main">
-              <a:ext uri="{FF2B5EF4-FFF2-40B4-BE49-F238E27FC236}">
-                <a16:creationId xmlns:a16="http://schemas.microsoft.com/office/drawing/2014/main" id="{5B07DFD3-E43F-4008-8F22-CC5D5DF20D5C}"/>
-              </a:ext>
-            </a:extLst>
-          </p:cNvPr>
-          <p:cNvSpPr>
-            <a:spLocks xmlns:a="http://schemas.openxmlformats.org/drawingml/2006/main" noGrp="1"/>
-          </p:cNvSpPr>
-          <p:nvPr/>
-        </p:nvSpPr>
-        <p:spPr>
-          <a:xfrm xmlns:a="http://schemas.openxmlformats.org/drawingml/2006/main">
-            <a:off x="6610350" y="5524500"/>
-            <a:ext cx="4972050" cy="542925"/>
-          </a:xfrm>
-          <a:prstGeom xmlns:a="http://schemas.openxmlformats.org/drawingml/2006/main" prst="rect">
-            <a:avLst/>
-          </a:prstGeom>
-          <a:noFill xmlns:a="http://schemas.openxmlformats.org/drawingml/2006/main"/>
-          <a:ln xmlns:a="http://schemas.openxmlformats.org/drawingml/2006/main" w="0">
-            <a:noFill/>
-          </a:ln>
-        </p:spPr>
-        <p:txBody>
-          <a:bodyPr xmlns:a="http://schemas.openxmlformats.org/drawingml/2006/main" wrap="none" lIns="0" tIns="0" rIns="0" bIns="0" anchor="t">
-            <a:noAutofit/>
-          </a:bodyPr>
-          <a:lstStyle xmlns:a="http://schemas.openxmlformats.org/drawingml/2006/main"/>
-          <a:p xmlns:a="http://schemas.openxmlformats.org/drawingml/2006/main">
-            <a:pPr algn="l">
-              <a:buNone/>
-              <a:defRPr sz="1725" b="0">
-                <a:solidFill>
-                  <a:srgbClr val="53686C"/>
-                </a:solidFill>
-                <a:latin typeface="Arial"/>
-                <a:ea typeface="Arial"/>
-                <a:cs typeface="Arial"/>
-              </a:defRPr>
-            </a:pPr>
-            <a:r>
-              <a:rPr sz="1725" b="0">
-                <a:solidFill>
-                  <a:srgbClr val="53686C"/>
-                </a:solidFill>
-                <a:latin typeface="Arial"/>
-                <a:ea typeface="Arial"/>
-                <a:cs typeface="Arial"/>
-              </a:rPr>
-              <a:t>New folder? Add local repository → Publish repository.</a:t>
+              <a:t>Commit to main → Push origin → wait → refresh</a:t>
             </a:r>
           </a:p>
         </p:txBody>
@@ -6587,7 +7127,7 @@
     </p:spTree>
     <p:extLst>
       <p:ext uri="{BB962C8B-B14F-4D97-AF65-F5344CB8AC3E}">
-        <p14:creationId xmlns:p14="http://schemas.microsoft.com/office/powerpoint/2010/main" val="1499610271"/>
+        <p14:creationId xmlns:p14="http://schemas.microsoft.com/office/powerpoint/2010/main" val="398891925"/>
       </p:ext>
     </p:extLst>
   </p:cSld>

</xml_diff>